<commit_message>
Add InferenceX ingestion layer
</commit_message>
<xml_diff>
--- a/llm_token_capacity_project/outputs/reports/llm_token_capacity_2026_2030.pptx
+++ b/llm_token_capacity_project/outputs/reports/llm_token_capacity_2026_2030.pptx
@@ -21,6 +21,7 @@
     <p:sldId id="269" r:id="rId20"/>
     <p:sldId id="270" r:id="rId21"/>
     <p:sldId id="271" r:id="rId22"/>
+    <p:sldId id="272" r:id="rId23"/>
   </p:sldIdLst>
   <p:sldSz cx="12191695" cy="6858000" type="screen4x3"/>
   <p:notesSz cx="6858000" cy="9144000"/>
@@ -7793,7 +7794,7 @@
               </a:defRPr>
             </a:pPr>
             <a:r>
-              <a:t>Hallucination 체크리스트</a:t>
+              <a:t>InferenceX는 benchmark DB로 별도 수집한다</a:t>
             </a:r>
           </a:p>
         </p:txBody>
@@ -7828,7 +7829,7 @@
               </a:defRPr>
             </a:pPr>
             <a:r>
-              <a:t>임원 보고 전 숫자와 문구가 fact/proxy/scenario를 혼동하지 않는지 확인합니다.</a:t>
+              <a:t>대시보드 DOM이 아니라 GitHub release dump와 app schema를 기준으로 A08/A09 sensitivity를 갱신한다.</a:t>
             </a:r>
           </a:p>
         </p:txBody>
@@ -7841,8 +7842,8 @@
         </p:nvSpPr>
         <p:spPr>
           <a:xfrm>
-            <a:off x="685800" y="1143000"/>
-            <a:ext cx="5166360" cy="749808"/>
+            <a:off x="731520" y="1234440"/>
+            <a:ext cx="5166360" cy="960120"/>
           </a:xfrm>
           <a:prstGeom prst="rect">
             <a:avLst/>
@@ -7882,7 +7883,7 @@
               </a:defRPr>
             </a:pPr>
             <a:r>
-              <a:t>출처 존재</a:t>
+              <a:t>최신 dump</a:t>
             </a:r>
           </a:p>
           <a:p>
@@ -7893,6 +7894,9 @@
                 </a:solidFill>
               </a:defRPr>
             </a:pPr>
+            <a:r>
+              <a:t>db-dump/2026-05-11</a:t>
+            </a:r>
           </a:p>
           <a:p>
             <a:pPr>
@@ -7903,7 +7907,7 @@
               </a:defRPr>
             </a:pPr>
             <a:r>
-              <a:t>URL/title/date 직접 확인</a:t>
+              <a:t>inferencex-dump-2026-05-11.zip</a:t>
             </a:r>
           </a:p>
         </p:txBody>
@@ -7916,8 +7920,8 @@
         </p:nvSpPr>
         <p:spPr>
           <a:xfrm>
-            <a:off x="6309360" y="1143000"/>
-            <a:ext cx="5166360" cy="749808"/>
+            <a:off x="6309359" y="1234440"/>
+            <a:ext cx="5166360" cy="960120"/>
           </a:xfrm>
           <a:prstGeom prst="rect">
             <a:avLst/>
@@ -7957,7 +7961,7 @@
               </a:defRPr>
             </a:pPr>
             <a:r>
-              <a:t>숫자 직접 인용</a:t>
+              <a:t>수집 row</a:t>
             </a:r>
           </a:p>
           <a:p>
@@ -7968,6 +7972,9 @@
                 </a:solidFill>
               </a:defRPr>
             </a:pPr>
+            <a:r>
+              <a:t>10</a:t>
+            </a:r>
           </a:p>
           <a:p>
             <a:pPr>
@@ -7978,7 +7985,7 @@
               </a:defRPr>
             </a:pPr>
             <a:r>
-              <a:t>4.5GW, 671B/37B 등 원문 매칭</a:t>
+              <a:t>raw README, changelog, app docs, release metadata</a:t>
             </a:r>
           </a:p>
         </p:txBody>
@@ -7991,8 +7998,8 @@
         </p:nvSpPr>
         <p:spPr>
           <a:xfrm>
-            <a:off x="685800" y="2194560"/>
-            <a:ext cx="5166360" cy="749808"/>
+            <a:off x="731520" y="2743200"/>
+            <a:ext cx="5166360" cy="960120"/>
           </a:xfrm>
           <a:prstGeom prst="rect">
             <a:avLst/>
@@ -8032,7 +8039,7 @@
               </a:defRPr>
             </a:pPr>
             <a:r>
-              <a:t>Fact/Estimate 분리</a:t>
+              <a:t>Evidence class</a:t>
             </a:r>
           </a:p>
           <a:p>
@@ -8043,6 +8050,9 @@
                 </a:solidFill>
               </a:defRPr>
             </a:pPr>
+            <a:r>
+              <a:t>Proxy / Benchmark</a:t>
+            </a:r>
           </a:p>
           <a:p>
             <a:pPr>
@@ -8053,7 +8063,7 @@
               </a:defRPr>
             </a:pPr>
             <a:r>
-              <a:t>active GW·utilization은 scenario</a:t>
+              <a:t>company production telemetry로 직접 사용 금지</a:t>
             </a:r>
           </a:p>
         </p:txBody>
@@ -8066,8 +8076,8 @@
         </p:nvSpPr>
         <p:spPr>
           <a:xfrm>
-            <a:off x="6309360" y="2194560"/>
-            <a:ext cx="5166360" cy="749808"/>
+            <a:off x="6309359" y="2743200"/>
+            <a:ext cx="5166360" cy="960120"/>
           </a:xfrm>
           <a:prstGeom prst="rect">
             <a:avLst/>
@@ -8107,7 +8117,7 @@
               </a:defRPr>
             </a:pPr>
             <a:r>
-              <a:t>Closed model</a:t>
+              <a:t>Workbook sheets</a:t>
             </a:r>
           </a:p>
           <a:p>
@@ -8118,6 +8128,9 @@
                 </a:solidFill>
               </a:defRPr>
             </a:pPr>
+            <a:r>
+              <a:t>12 / 12a / 12b</a:t>
+            </a:r>
           </a:p>
           <a:p>
             <a:pPr>
@@ -8128,20 +8141,221 @@
               </a:defRPr>
             </a:pPr>
             <a:r>
-              <a:t>precise parameter 금지</a:t>
-            </a:r>
-          </a:p>
-        </p:txBody>
-      </p:sp>
-      <p:sp>
-        <p:nvSpPr>
-          <p:cNvPr id="8" name="Rectangle 7"/>
+              <a:t>source index, schema, dashboard tab rules</a:t>
+            </a:r>
+          </a:p>
+        </p:txBody>
+      </p:sp>
+      <p:sp>
+        <p:nvSpPr>
+          <p:cNvPr id="8" name="TextBox 7"/>
+          <p:cNvSpPr txBox="1"/>
+          <p:nvPr/>
+        </p:nvSpPr>
+        <p:spPr>
+          <a:xfrm>
+            <a:off x="822960" y="4709160"/>
+            <a:ext cx="10561320" cy="777240"/>
+          </a:xfrm>
+          <a:prstGeom prst="rect">
+            <a:avLst/>
+          </a:prstGeom>
+          <a:noFill/>
+        </p:spPr>
+        <p:txBody>
+          <a:bodyPr wrap="none" lIns="0" rIns="0" tIns="0" bIns="0">
+            <a:spAutoFit/>
+          </a:bodyPr>
+          <a:lstStyle/>
+          <a:p>
+            <a:pPr algn="l">
+              <a:defRPr sz="1200" b="1">
+                <a:solidFill>
+                  <a:srgbClr val="122037"/>
+                </a:solidFill>
+              </a:defRPr>
+            </a:pPr>
+            <a:r>
+              <a:t>Inference Performance → tokens/MW, latency | Accuracy Evals → precision quality guardrail | Historical Trends → software improvement CAGR | TCO/GPU Specs → cost/token and hardware sanity</a:t>
+            </a:r>
+          </a:p>
+        </p:txBody>
+      </p:sp>
+      <p:sp>
+        <p:nvSpPr>
+          <p:cNvPr id="9" name="TextBox 8"/>
+          <p:cNvSpPr txBox="1"/>
+          <p:nvPr/>
+        </p:nvSpPr>
+        <p:spPr>
+          <a:xfrm>
+            <a:off x="822960" y="5559552"/>
+            <a:ext cx="10561320" cy="411480"/>
+          </a:xfrm>
+          <a:prstGeom prst="rect">
+            <a:avLst/>
+          </a:prstGeom>
+          <a:noFill/>
+        </p:spPr>
+        <p:txBody>
+          <a:bodyPr wrap="none" lIns="0" rIns="0" tIns="0" bIns="0">
+            <a:spAutoFit/>
+          </a:bodyPr>
+          <a:lstStyle/>
+          <a:p>
+            <a:pPr algn="l">
+              <a:defRPr sz="1100" b="0">
+                <a:solidFill>
+                  <a:srgbClr val="64748B"/>
+                </a:solidFill>
+              </a:defRPr>
+            </a:pPr>
+            <a:r>
+              <a:t>대용량 DB dump는 기본 실행에서 받지 않고 `fetch_inferencex_data.py --download-latest-dump`로 명시 실행합니다.</a:t>
+            </a:r>
+          </a:p>
+        </p:txBody>
+      </p:sp>
+      <p:sp>
+        <p:nvSpPr>
+          <p:cNvPr id="10" name="TextBox 9"/>
+          <p:cNvSpPr txBox="1"/>
+          <p:nvPr/>
+        </p:nvSpPr>
+        <p:spPr>
+          <a:xfrm>
+            <a:off x="502920" y="6446520"/>
+            <a:ext cx="11201400" cy="219456"/>
+          </a:xfrm>
+          <a:prstGeom prst="rect">
+            <a:avLst/>
+          </a:prstGeom>
+          <a:noFill/>
+        </p:spPr>
+        <p:txBody>
+          <a:bodyPr wrap="none">
+            <a:spAutoFit/>
+          </a:bodyPr>
+          <a:lstStyle/>
+          <a:p>
+            <a:pPr>
+              <a:defRPr sz="750">
+                <a:solidFill>
+                  <a:srgbClr val="64748B"/>
+                </a:solidFill>
+              </a:defRPr>
+            </a:pPr>
+            <a:r>
+              <a:t>출처 기반 시뮬레이션 | Fact / Estimate / Scenario 분리 | 생성일 2026-05-18</a:t>
+            </a:r>
+          </a:p>
+        </p:txBody>
+      </p:sp>
+    </p:spTree>
+  </p:cSld>
+  <p:clrMapOvr>
+    <a:masterClrMapping/>
+  </p:clrMapOvr>
+</p:sld>
+</file>
+
+<file path=ppt/slides/slide16.xml><?xml version="1.0" encoding="utf-8"?>
+<p:sld xmlns:a="http://schemas.openxmlformats.org/drawingml/2006/main" xmlns:p="http://schemas.openxmlformats.org/presentationml/2006/main" xmlns:r="http://schemas.openxmlformats.org/officeDocument/2006/relationships">
+  <p:cSld>
+    <p:bg>
+      <p:bgPr>
+        <a:solidFill>
+          <a:srgbClr val="F7F9FC"/>
+        </a:solidFill>
+        <a:effectLst/>
+      </p:bgPr>
+    </p:bg>
+    <p:spTree>
+      <p:nvGrpSpPr>
+        <p:cNvPr id="1" name=""/>
+        <p:cNvGrpSpPr/>
+        <p:nvPr/>
+      </p:nvGrpSpPr>
+      <p:grpSpPr/>
+      <p:sp>
+        <p:nvSpPr>
+          <p:cNvPr id="2" name="TextBox 1"/>
+          <p:cNvSpPr txBox="1"/>
+          <p:nvPr/>
+        </p:nvSpPr>
+        <p:spPr>
+          <a:xfrm>
+            <a:off x="502920" y="310896"/>
+            <a:ext cx="11109960" cy="502920"/>
+          </a:xfrm>
+          <a:prstGeom prst="rect">
+            <a:avLst/>
+          </a:prstGeom>
+          <a:noFill/>
+        </p:spPr>
+        <p:txBody>
+          <a:bodyPr wrap="none">
+            <a:spAutoFit/>
+          </a:bodyPr>
+          <a:lstStyle/>
+          <a:p>
+            <a:pPr>
+              <a:defRPr sz="2300" b="1">
+                <a:solidFill>
+                  <a:srgbClr val="122037"/>
+                </a:solidFill>
+              </a:defRPr>
+            </a:pPr>
+            <a:r>
+              <a:t>Hallucination 체크리스트</a:t>
+            </a:r>
+          </a:p>
+        </p:txBody>
+      </p:sp>
+      <p:sp>
+        <p:nvSpPr>
+          <p:cNvPr id="3" name="TextBox 2"/>
+          <p:cNvSpPr txBox="1"/>
+          <p:nvPr/>
+        </p:nvSpPr>
+        <p:spPr>
+          <a:xfrm>
+            <a:off x="530352" y="804672"/>
+            <a:ext cx="10881360" cy="310896"/>
+          </a:xfrm>
+          <a:prstGeom prst="rect">
+            <a:avLst/>
+          </a:prstGeom>
+          <a:noFill/>
+        </p:spPr>
+        <p:txBody>
+          <a:bodyPr wrap="none">
+            <a:spAutoFit/>
+          </a:bodyPr>
+          <a:lstStyle/>
+          <a:p>
+            <a:pPr>
+              <a:defRPr sz="1000">
+                <a:solidFill>
+                  <a:srgbClr val="64748B"/>
+                </a:solidFill>
+              </a:defRPr>
+            </a:pPr>
+            <a:r>
+              <a:t>임원 보고 전 숫자와 문구가 fact/proxy/scenario를 혼동하지 않는지 확인합니다.</a:t>
+            </a:r>
+          </a:p>
+        </p:txBody>
+      </p:sp>
+      <p:sp>
+        <p:nvSpPr>
+          <p:cNvPr id="4" name="Rectangle 3"/>
           <p:cNvSpPr/>
           <p:nvPr/>
         </p:nvSpPr>
         <p:spPr>
           <a:xfrm>
-            <a:off x="685800" y="3246120"/>
+            <a:off x="685800" y="1143000"/>
             <a:ext cx="5166360" cy="749808"/>
           </a:xfrm>
           <a:prstGeom prst="rect">
@@ -8182,7 +8396,7 @@
               </a:defRPr>
             </a:pPr>
             <a:r>
-              <a:t>Host attribution</a:t>
+              <a:t>출처 존재</a:t>
             </a:r>
           </a:p>
           <a:p>
@@ -8203,20 +8417,20 @@
               </a:defRPr>
             </a:pPr>
             <a:r>
-              <a:t>AWS/Oracle/Google host와 model owner 분리</a:t>
-            </a:r>
-          </a:p>
-        </p:txBody>
-      </p:sp>
-      <p:sp>
-        <p:nvSpPr>
-          <p:cNvPr id="9" name="Rectangle 8"/>
+              <a:t>URL/title/date 직접 확인</a:t>
+            </a:r>
+          </a:p>
+        </p:txBody>
+      </p:sp>
+      <p:sp>
+        <p:nvSpPr>
+          <p:cNvPr id="5" name="Rectangle 4"/>
           <p:cNvSpPr/>
           <p:nvPr/>
         </p:nvSpPr>
         <p:spPr>
           <a:xfrm>
-            <a:off x="6309360" y="3246120"/>
+            <a:off x="6309360" y="1143000"/>
             <a:ext cx="5166360" cy="749808"/>
           </a:xfrm>
           <a:prstGeom prst="rect">
@@ -8257,7 +8471,7 @@
               </a:defRPr>
             </a:pPr>
             <a:r>
-              <a:t>Benchmark proxy</a:t>
+              <a:t>숫자 직접 인용</a:t>
             </a:r>
           </a:p>
           <a:p>
@@ -8278,20 +8492,20 @@
               </a:defRPr>
             </a:pPr>
             <a:r>
-              <a:t>closed model 결론이 아니라 sanity check</a:t>
-            </a:r>
-          </a:p>
-        </p:txBody>
-      </p:sp>
-      <p:sp>
-        <p:nvSpPr>
-          <p:cNvPr id="10" name="Rectangle 9"/>
+              <a:t>4.5GW, 671B/37B 등 원문 매칭</a:t>
+            </a:r>
+          </a:p>
+        </p:txBody>
+      </p:sp>
+      <p:sp>
+        <p:nvSpPr>
+          <p:cNvPr id="6" name="Rectangle 5"/>
           <p:cNvSpPr/>
           <p:nvPr/>
         </p:nvSpPr>
         <p:spPr>
           <a:xfrm>
-            <a:off x="685800" y="4297679"/>
+            <a:off x="685800" y="2194560"/>
             <a:ext cx="5166360" cy="749808"/>
           </a:xfrm>
           <a:prstGeom prst="rect">
@@ -8332,7 +8546,7 @@
               </a:defRPr>
             </a:pPr>
             <a:r>
-              <a:t>단위</a:t>
+              <a:t>Fact/Estimate 분리</a:t>
             </a:r>
           </a:p>
           <a:p>
@@ -8353,20 +8567,20 @@
               </a:defRPr>
             </a:pPr>
             <a:r>
-              <a:t>daily vs annual token 혼동 금지</a:t>
-            </a:r>
-          </a:p>
-        </p:txBody>
-      </p:sp>
-      <p:sp>
-        <p:nvSpPr>
-          <p:cNvPr id="11" name="Rectangle 10"/>
+              <a:t>active GW·utilization은 scenario</a:t>
+            </a:r>
+          </a:p>
+        </p:txBody>
+      </p:sp>
+      <p:sp>
+        <p:nvSpPr>
+          <p:cNvPr id="7" name="Rectangle 6"/>
           <p:cNvSpPr/>
           <p:nvPr/>
         </p:nvSpPr>
         <p:spPr>
           <a:xfrm>
-            <a:off x="6309360" y="4297679"/>
+            <a:off x="6309360" y="2194560"/>
             <a:ext cx="5166360" cy="749808"/>
           </a:xfrm>
           <a:prstGeom prst="rect">
@@ -8407,6 +8621,306 @@
               </a:defRPr>
             </a:pPr>
             <a:r>
+              <a:t>Closed model</a:t>
+            </a:r>
+          </a:p>
+          <a:p>
+            <a:pPr>
+              <a:defRPr sz="2000" b="1">
+                <a:solidFill>
+                  <a:srgbClr val="122037"/>
+                </a:solidFill>
+              </a:defRPr>
+            </a:pPr>
+          </a:p>
+          <a:p>
+            <a:pPr>
+              <a:defRPr sz="850">
+                <a:solidFill>
+                  <a:srgbClr val="64748B"/>
+                </a:solidFill>
+              </a:defRPr>
+            </a:pPr>
+            <a:r>
+              <a:t>precise parameter 금지</a:t>
+            </a:r>
+          </a:p>
+        </p:txBody>
+      </p:sp>
+      <p:sp>
+        <p:nvSpPr>
+          <p:cNvPr id="8" name="Rectangle 7"/>
+          <p:cNvSpPr/>
+          <p:nvPr/>
+        </p:nvSpPr>
+        <p:spPr>
+          <a:xfrm>
+            <a:off x="685800" y="3246120"/>
+            <a:ext cx="5166360" cy="749808"/>
+          </a:xfrm>
+          <a:prstGeom prst="rect">
+            <a:avLst/>
+          </a:prstGeom>
+          <a:solidFill>
+            <a:srgbClr val="EBF2FF"/>
+          </a:solidFill>
+          <a:ln>
+            <a:solidFill>
+              <a:srgbClr val="DAE2EC"/>
+            </a:solidFill>
+          </a:ln>
+        </p:spPr>
+        <p:style>
+          <a:lnRef idx="1">
+            <a:schemeClr val="accent1"/>
+          </a:lnRef>
+          <a:fillRef idx="3">
+            <a:schemeClr val="accent1"/>
+          </a:fillRef>
+          <a:effectRef idx="2">
+            <a:schemeClr val="accent1"/>
+          </a:effectRef>
+          <a:fontRef idx="minor">
+            <a:schemeClr val="lt1"/>
+          </a:fontRef>
+        </p:style>
+        <p:txBody>
+          <a:bodyPr rtlCol="0" anchor="ctr" lIns="146304" rIns="109728" tIns="109728"/>
+          <a:lstStyle/>
+          <a:p>
+            <a:pPr algn="ctr">
+              <a:defRPr sz="900">
+                <a:solidFill>
+                  <a:srgbClr val="64748B"/>
+                </a:solidFill>
+              </a:defRPr>
+            </a:pPr>
+            <a:r>
+              <a:t>Host attribution</a:t>
+            </a:r>
+          </a:p>
+          <a:p>
+            <a:pPr>
+              <a:defRPr sz="2000" b="1">
+                <a:solidFill>
+                  <a:srgbClr val="122037"/>
+                </a:solidFill>
+              </a:defRPr>
+            </a:pPr>
+          </a:p>
+          <a:p>
+            <a:pPr>
+              <a:defRPr sz="850">
+                <a:solidFill>
+                  <a:srgbClr val="64748B"/>
+                </a:solidFill>
+              </a:defRPr>
+            </a:pPr>
+            <a:r>
+              <a:t>AWS/Oracle/Google host와 model owner 분리</a:t>
+            </a:r>
+          </a:p>
+        </p:txBody>
+      </p:sp>
+      <p:sp>
+        <p:nvSpPr>
+          <p:cNvPr id="9" name="Rectangle 8"/>
+          <p:cNvSpPr/>
+          <p:nvPr/>
+        </p:nvSpPr>
+        <p:spPr>
+          <a:xfrm>
+            <a:off x="6309360" y="3246120"/>
+            <a:ext cx="5166360" cy="749808"/>
+          </a:xfrm>
+          <a:prstGeom prst="rect">
+            <a:avLst/>
+          </a:prstGeom>
+          <a:solidFill>
+            <a:srgbClr val="E8F8F0"/>
+          </a:solidFill>
+          <a:ln>
+            <a:solidFill>
+              <a:srgbClr val="DAE2EC"/>
+            </a:solidFill>
+          </a:ln>
+        </p:spPr>
+        <p:style>
+          <a:lnRef idx="1">
+            <a:schemeClr val="accent1"/>
+          </a:lnRef>
+          <a:fillRef idx="3">
+            <a:schemeClr val="accent1"/>
+          </a:fillRef>
+          <a:effectRef idx="2">
+            <a:schemeClr val="accent1"/>
+          </a:effectRef>
+          <a:fontRef idx="minor">
+            <a:schemeClr val="lt1"/>
+          </a:fontRef>
+        </p:style>
+        <p:txBody>
+          <a:bodyPr rtlCol="0" anchor="ctr" lIns="146304" rIns="109728" tIns="109728"/>
+          <a:lstStyle/>
+          <a:p>
+            <a:pPr algn="ctr">
+              <a:defRPr sz="900">
+                <a:solidFill>
+                  <a:srgbClr val="64748B"/>
+                </a:solidFill>
+              </a:defRPr>
+            </a:pPr>
+            <a:r>
+              <a:t>Benchmark proxy</a:t>
+            </a:r>
+          </a:p>
+          <a:p>
+            <a:pPr>
+              <a:defRPr sz="2000" b="1">
+                <a:solidFill>
+                  <a:srgbClr val="122037"/>
+                </a:solidFill>
+              </a:defRPr>
+            </a:pPr>
+          </a:p>
+          <a:p>
+            <a:pPr>
+              <a:defRPr sz="850">
+                <a:solidFill>
+                  <a:srgbClr val="64748B"/>
+                </a:solidFill>
+              </a:defRPr>
+            </a:pPr>
+            <a:r>
+              <a:t>closed model 결론이 아니라 sanity check</a:t>
+            </a:r>
+          </a:p>
+        </p:txBody>
+      </p:sp>
+      <p:sp>
+        <p:nvSpPr>
+          <p:cNvPr id="10" name="Rectangle 9"/>
+          <p:cNvSpPr/>
+          <p:nvPr/>
+        </p:nvSpPr>
+        <p:spPr>
+          <a:xfrm>
+            <a:off x="685800" y="4297679"/>
+            <a:ext cx="5166360" cy="749808"/>
+          </a:xfrm>
+          <a:prstGeom prst="rect">
+            <a:avLst/>
+          </a:prstGeom>
+          <a:solidFill>
+            <a:srgbClr val="FFF7E5"/>
+          </a:solidFill>
+          <a:ln>
+            <a:solidFill>
+              <a:srgbClr val="DAE2EC"/>
+            </a:solidFill>
+          </a:ln>
+        </p:spPr>
+        <p:style>
+          <a:lnRef idx="1">
+            <a:schemeClr val="accent1"/>
+          </a:lnRef>
+          <a:fillRef idx="3">
+            <a:schemeClr val="accent1"/>
+          </a:fillRef>
+          <a:effectRef idx="2">
+            <a:schemeClr val="accent1"/>
+          </a:effectRef>
+          <a:fontRef idx="minor">
+            <a:schemeClr val="lt1"/>
+          </a:fontRef>
+        </p:style>
+        <p:txBody>
+          <a:bodyPr rtlCol="0" anchor="ctr" lIns="146304" rIns="109728" tIns="109728"/>
+          <a:lstStyle/>
+          <a:p>
+            <a:pPr algn="ctr">
+              <a:defRPr sz="900">
+                <a:solidFill>
+                  <a:srgbClr val="64748B"/>
+                </a:solidFill>
+              </a:defRPr>
+            </a:pPr>
+            <a:r>
+              <a:t>단위</a:t>
+            </a:r>
+          </a:p>
+          <a:p>
+            <a:pPr>
+              <a:defRPr sz="2000" b="1">
+                <a:solidFill>
+                  <a:srgbClr val="122037"/>
+                </a:solidFill>
+              </a:defRPr>
+            </a:pPr>
+          </a:p>
+          <a:p>
+            <a:pPr>
+              <a:defRPr sz="850">
+                <a:solidFill>
+                  <a:srgbClr val="64748B"/>
+                </a:solidFill>
+              </a:defRPr>
+            </a:pPr>
+            <a:r>
+              <a:t>daily vs annual token 혼동 금지</a:t>
+            </a:r>
+          </a:p>
+        </p:txBody>
+      </p:sp>
+      <p:sp>
+        <p:nvSpPr>
+          <p:cNvPr id="11" name="Rectangle 10"/>
+          <p:cNvSpPr/>
+          <p:nvPr/>
+        </p:nvSpPr>
+        <p:spPr>
+          <a:xfrm>
+            <a:off x="6309360" y="4297679"/>
+            <a:ext cx="5166360" cy="749808"/>
+          </a:xfrm>
+          <a:prstGeom prst="rect">
+            <a:avLst/>
+          </a:prstGeom>
+          <a:solidFill>
+            <a:srgbClr val="F0F4F8"/>
+          </a:solidFill>
+          <a:ln>
+            <a:solidFill>
+              <a:srgbClr val="DAE2EC"/>
+            </a:solidFill>
+          </a:ln>
+        </p:spPr>
+        <p:style>
+          <a:lnRef idx="1">
+            <a:schemeClr val="accent1"/>
+          </a:lnRef>
+          <a:fillRef idx="3">
+            <a:schemeClr val="accent1"/>
+          </a:fillRef>
+          <a:effectRef idx="2">
+            <a:schemeClr val="accent1"/>
+          </a:effectRef>
+          <a:fontRef idx="minor">
+            <a:schemeClr val="lt1"/>
+          </a:fontRef>
+        </p:style>
+        <p:txBody>
+          <a:bodyPr rtlCol="0" anchor="ctr" lIns="146304" rIns="109728" tIns="109728"/>
+          <a:lstStyle/>
+          <a:p>
+            <a:pPr algn="ctr">
+              <a:defRPr sz="900">
+                <a:solidFill>
+                  <a:srgbClr val="64748B"/>
+                </a:solidFill>
+              </a:defRPr>
+            </a:pPr>
+            <a:r>
               <a:t>Outlier</a:t>
             </a:r>
           </a:p>
@@ -8511,7 +9025,7 @@
 </p:sld>
 </file>
 
-<file path=ppt/slides/slide16.xml><?xml version="1.0" encoding="utf-8"?>
+<file path=ppt/slides/slide17.xml><?xml version="1.0" encoding="utf-8"?>
 <p:sld xmlns:a="http://schemas.openxmlformats.org/drawingml/2006/main" xmlns:p="http://schemas.openxmlformats.org/presentationml/2006/main" xmlns:r="http://schemas.openxmlformats.org/officeDocument/2006/relationships">
   <p:cSld>
     <p:bg>

</xml_diff>

<commit_message>
Process InferenceX dump benchmarks
</commit_message>
<xml_diff>
--- a/llm_token_capacity_project/outputs/reports/llm_token_capacity_2026_2030.pptx
+++ b/llm_token_capacity_project/outputs/reports/llm_token_capacity_2026_2030.pptx
@@ -7961,7 +7961,7 @@
               </a:defRPr>
             </a:pPr>
             <a:r>
-              <a:t>수집 row</a:t>
+              <a:t>Benchmark rows</a:t>
             </a:r>
           </a:p>
           <a:p>
@@ -7973,7 +7973,7 @@
               </a:defRPr>
             </a:pPr>
             <a:r>
-              <a:t>10</a:t>
+              <a:t>72091</a:t>
             </a:r>
           </a:p>
           <a:p>
@@ -7985,7 +7985,7 @@
               </a:defRPr>
             </a:pPr>
             <a:r>
-              <a:t>raw README, changelog, app docs, release metadata</a:t>
+              <a:t>profile 298 / eval 1048</a:t>
             </a:r>
           </a:p>
         </p:txBody>
@@ -8129,7 +8129,7 @@
               </a:defRPr>
             </a:pPr>
             <a:r>
-              <a:t>12 / 12a / 12b</a:t>
+              <a:t>12d / 12e / 12f</a:t>
             </a:r>
           </a:p>
           <a:p>
@@ -8141,7 +8141,7 @@
               </a:defRPr>
             </a:pPr>
             <a:r>
-              <a:t>source index, schema, dashboard tab rules</a:t>
+              <a:t>benchmark, metric profile, accuracy evals</a:t>
             </a:r>
           </a:p>
         </p:txBody>
@@ -8211,7 +8211,7 @@
               </a:defRPr>
             </a:pPr>
             <a:r>
-              <a:t>대용량 DB dump는 기본 실행에서 받지 않고 `fetch_inferencex_data.py --download-latest-dump`로 명시 실행합니다.</a:t>
+              <a:t>검증 digest: 3f59aa2b4db7a0449a7bb030... / 원천 dump는 git ignore, 정규화 CSV만 산출물화.</a:t>
             </a:r>
           </a:p>
         </p:txBody>

</xml_diff>

<commit_message>
Add traceable assumptions for LLM token capacity model
</commit_message>
<xml_diff>
--- a/llm_token_capacity_project/outputs/reports/llm_token_capacity_2026_2030.pptx
+++ b/llm_token_capacity_project/outputs/reports/llm_token_capacity_2026_2030.pptx
@@ -186,16 +186,16 @@
                   <c:v>0.586840240711296</c:v>
                 </c:pt>
                 <c:pt idx="1">
-                  <c:v>0.53513286253056</c:v>
+                  <c:v>0.5462989080192</c:v>
                 </c:pt>
                 <c:pt idx="2">
-                  <c:v>0.4022866197504</c:v>
+                  <c:v>0.4271839955712</c:v>
                 </c:pt>
                 <c:pt idx="3">
-                  <c:v>0.372288096107136</c:v>
+                  <c:v>0.391550950429056</c:v>
                 </c:pt>
                 <c:pt idx="4">
-                  <c:v>0.31830324515136</c:v>
+                  <c:v>0.325393026336</c:v>
                 </c:pt>
                 <c:pt idx="5">
                   <c:v>0.259801314859008</c:v>
@@ -435,19 +435,19 @@
                 <c:formatCode>General</c:formatCode>
                 <c:ptCount val="5"/>
                 <c:pt idx="0">
-                  <c:v>0.05455296</c:v>
+                  <c:v>0.05455470569472</c:v>
                 </c:pt>
                 <c:pt idx="1">
-                  <c:v>0.112223664</c:v>
+                  <c:v>0.1128117920832</c:v>
                 </c:pt>
                 <c:pt idx="2">
-                  <c:v>0.201888587376</c:v>
+                  <c:v>0.203998065026112</c:v>
                 </c:pt>
                 <c:pt idx="3">
-                  <c:v>0.3368973037752</c:v>
+                  <c:v>0.34217223772536</c:v>
                 </c:pt>
                 <c:pt idx="4">
-                  <c:v>0.53513286253056</c:v>
+                  <c:v>0.5462989080192</c:v>
                 </c:pt>
               </c:numCache>
             </c:numRef>
@@ -498,19 +498,19 @@
                 <c:formatCode>General</c:formatCode>
                 <c:ptCount val="5"/>
                 <c:pt idx="0">
-                  <c:v>0.0358186752</c:v>
+                  <c:v>0.03581880312384</c:v>
                 </c:pt>
                 <c:pt idx="1">
-                  <c:v>0.0798642561024</c:v>
+                  <c:v>0.08110014808896</c:v>
                 </c:pt>
                 <c:pt idx="2">
-                  <c:v>0.148440563712</c:v>
+                  <c:v>0.15303422016</c:v>
                 </c:pt>
                 <c:pt idx="3">
-                  <c:v>0.251379069811661</c:v>
+                  <c:v>0.263047420517875</c:v>
                 </c:pt>
                 <c:pt idx="4">
-                  <c:v>0.4022866197504</c:v>
+                  <c:v>0.4271839955712</c:v>
                 </c:pt>
               </c:numCache>
             </c:numRef>
@@ -561,19 +561,19 @@
                 <c:formatCode>General</c:formatCode>
                 <c:ptCount val="5"/>
                 <c:pt idx="0">
-                  <c:v>0.034782048</c:v>
+                  <c:v>0.03478261113792</c:v>
                 </c:pt>
                 <c:pt idx="1">
-                  <c:v>0.07545626928</c:v>
+                  <c:v>0.07643329787016</c:v>
                 </c:pt>
                 <c:pt idx="2">
-                  <c:v>0.13872722846976</c:v>
+                  <c:v>0.142317358121088</c:v>
                 </c:pt>
                 <c:pt idx="3">
-                  <c:v>0.233726019458832</c:v>
+                  <c:v>0.242797026069648</c:v>
                 </c:pt>
                 <c:pt idx="4">
-                  <c:v>0.372288096107136</c:v>
+                  <c:v>0.391550950429056</c:v>
                 </c:pt>
               </c:numCache>
             </c:numRef>
@@ -624,19 +624,19 @@
                 <c:formatCode>General</c:formatCode>
                 <c:ptCount val="5"/>
                 <c:pt idx="0">
-                  <c:v>0.0176498784</c:v>
+                  <c:v>0.0176500585008</c:v>
                 </c:pt>
                 <c:pt idx="1">
-                  <c:v>0.05145799228416</c:v>
+                  <c:v>0.051744931247117</c:v>
                 </c:pt>
                 <c:pt idx="2">
-                  <c:v>0.106244054784</c:v>
+                  <c:v>0.107427840408</c:v>
                 </c:pt>
                 <c:pt idx="3">
-                  <c:v>0.191084027600794</c:v>
+                  <c:v>0.194276677019443</c:v>
                 </c:pt>
                 <c:pt idx="4">
-                  <c:v>0.31830324515136</c:v>
+                  <c:v>0.325393026336</c:v>
                 </c:pt>
               </c:numCache>
             </c:numRef>
@@ -1800,16 +1800,16 @@
                   <c:v>1.967582</c:v>
                 </c:pt>
                 <c:pt idx="1">
-                  <c:v>2.423472</c:v>
+                  <c:v>2.47404</c:v>
                 </c:pt>
                 <c:pt idx="2">
-                  <c:v>2.027916</c:v>
+                  <c:v>2.153423</c:v>
                 </c:pt>
                 <c:pt idx="3">
-                  <c:v>1.901171</c:v>
+                  <c:v>1.999541</c:v>
                 </c:pt>
                 <c:pt idx="4">
-                  <c:v>1.774427</c:v>
+                  <c:v>1.81395</c:v>
                 </c:pt>
                 <c:pt idx="5">
                   <c:v>2.529748</c:v>
@@ -1990,16 +1990,16 @@
                   <c:v>0.117</c:v>
                 </c:pt>
                 <c:pt idx="1">
-                  <c:v>0.286</c:v>
+                  <c:v>0.287</c:v>
                 </c:pt>
                 <c:pt idx="2">
-                  <c:v>0.546</c:v>
+                  <c:v>0.552</c:v>
                 </c:pt>
                 <c:pt idx="3">
-                  <c:v>0.934</c:v>
+                  <c:v>0.95</c:v>
                 </c:pt>
                 <c:pt idx="4">
-                  <c:v>1.494</c:v>
+                  <c:v>1.527</c:v>
                 </c:pt>
               </c:numCache>
             </c:numRef>
@@ -2053,16 +2053,16 @@
                   <c:v>0.208</c:v>
                 </c:pt>
                 <c:pt idx="1">
-                  <c:v>0.516</c:v>
+                  <c:v>0.519</c:v>
                 </c:pt>
                 <c:pt idx="2">
-                  <c:v>1.006</c:v>
+                  <c:v>1.018</c:v>
                 </c:pt>
                 <c:pt idx="3">
-                  <c:v>1.757</c:v>
+                  <c:v>1.786</c:v>
                 </c:pt>
                 <c:pt idx="4">
-                  <c:v>2.872</c:v>
+                  <c:v>2.934</c:v>
                 </c:pt>
               </c:numCache>
             </c:numRef>
@@ -2116,16 +2116,16 @@
                   <c:v>0.302</c:v>
                 </c:pt>
                 <c:pt idx="1">
-                  <c:v>0.779</c:v>
+                  <c:v>0.784</c:v>
                 </c:pt>
                 <c:pt idx="2">
-                  <c:v>1.575</c:v>
+                  <c:v>1.592</c:v>
                 </c:pt>
                 <c:pt idx="3">
-                  <c:v>2.84</c:v>
+                  <c:v>2.887</c:v>
                 </c:pt>
                 <c:pt idx="4">
-                  <c:v>4.79</c:v>
+                  <c:v>4.892</c:v>
                 </c:pt>
               </c:numCache>
             </c:numRef>
@@ -5605,7 +5605,7 @@
               </a:defRPr>
             </a:pPr>
             <a:r>
-              <a:t>2.87Q</a:t>
+              <a:t>2.93Q</a:t>
             </a:r>
           </a:p>
         </p:txBody>
@@ -5710,7 +5710,7 @@
               </a:defRPr>
             </a:pPr>
             <a:r>
-              <a:t>2026-05-18</a:t>
+              <a:t>2026-05-26</a:t>
             </a:r>
           </a:p>
         </p:txBody>
@@ -6139,7 +6139,7 @@
                         </a:defRPr>
                       </a:pPr>
                       <a:r>
-                        <a:t>0.37</a:t>
+                        <a:t>0.39</a:t>
                       </a:r>
                     </a:p>
                   </a:txBody>
@@ -6256,7 +6256,7 @@
                         </a:defRPr>
                       </a:pPr>
                       <a:r>
-                        <a:t>DeepSeek</a:t>
+                        <a:t>OpenAI</a:t>
                       </a:r>
                     </a:p>
                   </a:txBody>
@@ -6279,7 +6279,7 @@
                         </a:defRPr>
                       </a:pPr>
                       <a:r>
-                        <a:t>0.10</a:t>
+                        <a:t>0.59</a:t>
                       </a:r>
                     </a:p>
                   </a:txBody>
@@ -6302,7 +6302,7 @@
                         </a:defRPr>
                       </a:pPr>
                       <a:r>
-                        <a:t>0.7</a:t>
+                        <a:t>4.9</a:t>
                       </a:r>
                     </a:p>
                   </a:txBody>
@@ -6325,7 +6325,7 @@
                         </a:defRPr>
                       </a:pPr>
                       <a:r>
-                        <a:t>33%</a:t>
+                        <a:t>29%</a:t>
                       </a:r>
                     </a:p>
                   </a:txBody>
@@ -6348,7 +6348,7 @@
                         </a:defRPr>
                       </a:pPr>
                       <a:r>
-                        <a:t>Deployment gap</a:t>
+                        <a:t>Serving efficiency</a:t>
                       </a:r>
                     </a:p>
                   </a:txBody>
@@ -6371,7 +6371,7 @@
                         </a:defRPr>
                       </a:pPr>
                       <a:r>
-                        <a:t>site energization, rack deployment, accelerator delivery</a:t>
+                        <a:t>model routing, precision, batching, TTFT/TPOT target</a:t>
                       </a:r>
                     </a:p>
                   </a:txBody>
@@ -6419,7 +6419,7 @@
                         </a:defRPr>
                       </a:pPr>
                       <a:r>
-                        <a:t>0.32</a:t>
+                        <a:t>0.33</a:t>
                       </a:r>
                     </a:p>
                   </a:txBody>
@@ -6536,7 +6536,7 @@
                         </a:defRPr>
                       </a:pPr>
                       <a:r>
-                        <a:t>OpenAI</a:t>
+                        <a:t>DeepSeek</a:t>
                       </a:r>
                     </a:p>
                   </a:txBody>
@@ -6559,7 +6559,7 @@
                         </a:defRPr>
                       </a:pPr>
                       <a:r>
-                        <a:t>0.59</a:t>
+                        <a:t>0.10</a:t>
                       </a:r>
                     </a:p>
                   </a:txBody>
@@ -6582,7 +6582,7 @@
                         </a:defRPr>
                       </a:pPr>
                       <a:r>
-                        <a:t>4.9</a:t>
+                        <a:t>0.7</a:t>
                       </a:r>
                     </a:p>
                   </a:txBody>
@@ -6605,7 +6605,7 @@
                         </a:defRPr>
                       </a:pPr>
                       <a:r>
-                        <a:t>29%</a:t>
+                        <a:t>33%</a:t>
                       </a:r>
                     </a:p>
                   </a:txBody>
@@ -6628,7 +6628,7 @@
                         </a:defRPr>
                       </a:pPr>
                       <a:r>
-                        <a:t>Serving efficiency</a:t>
+                        <a:t>Deployment gap</a:t>
                       </a:r>
                     </a:p>
                   </a:txBody>
@@ -6651,7 +6651,7 @@
                         </a:defRPr>
                       </a:pPr>
                       <a:r>
-                        <a:t>model routing, precision, batching, TTFT/TPOT target</a:t>
+                        <a:t>site energization, rack deployment, accelerator delivery</a:t>
                       </a:r>
                     </a:p>
                   </a:txBody>
@@ -7119,7 +7119,7 @@
                         </a:defRPr>
                       </a:pPr>
                       <a:r>
-                        <a:t>0.54</a:t>
+                        <a:t>0.55</a:t>
                       </a:r>
                     </a:p>
                   </a:txBody>
@@ -7259,7 +7259,7 @@
                         </a:defRPr>
                       </a:pPr>
                       <a:r>
-                        <a:t>0.40</a:t>
+                        <a:t>0.43</a:t>
                       </a:r>
                     </a:p>
                   </a:txBody>
@@ -7511,7 +7511,7 @@
               </a:defRPr>
             </a:pPr>
             <a:r>
-              <a:t>2026-05-18</a:t>
+              <a:t>2026-05-26</a:t>
             </a:r>
           </a:p>
         </p:txBody>
@@ -7945,7 +7945,7 @@
                         </a:defRPr>
                       </a:pPr>
                       <a:r>
-                        <a:t>1.49</a:t>
+                        <a:t>1.53</a:t>
                       </a:r>
                     </a:p>
                   </a:txBody>
@@ -8039,7 +8039,7 @@
                         </a:defRPr>
                       </a:pPr>
                       <a:r>
-                        <a:t>2.87</a:t>
+                        <a:t>2.93</a:t>
                       </a:r>
                     </a:p>
                   </a:txBody>
@@ -8133,7 +8133,7 @@
                         </a:defRPr>
                       </a:pPr>
                       <a:r>
-                        <a:t>4.79</a:t>
+                        <a:t>4.89</a:t>
                       </a:r>
                     </a:p>
                   </a:txBody>
@@ -8327,7 +8327,7 @@
               </a:defRPr>
             </a:pPr>
             <a:r>
-              <a:t>Base growth: 13.8x, 2026-2030</a:t>
+              <a:t>Base growth: 14.1x, 2026-2030</a:t>
             </a:r>
           </a:p>
         </p:txBody>
@@ -8477,7 +8477,7 @@
               </a:defRPr>
             </a:pPr>
             <a:r>
-              <a:t>2026-05-18</a:t>
+              <a:t>2026-05-26</a:t>
             </a:r>
           </a:p>
         </p:txBody>
@@ -9308,7 +9308,7 @@
               </a:defRPr>
             </a:pPr>
             <a:r>
-              <a:t>Workbook appendix: formula assumptions, company-year forecast, scenario sensitivity, source registry, and InferenceX benchmark tables.</a:t>
+              <a:t>Workbook appendix: 02b number trace, 04 numeric accelerator mix, 05 efficiency bridge, formula assumptions, source registry, and InferenceX benchmark tables.</a:t>
             </a:r>
           </a:p>
         </p:txBody>
@@ -9458,7 +9458,7 @@
               </a:defRPr>
             </a:pPr>
             <a:r>
-              <a:t>2026-05-18</a:t>
+              <a:t>2026-05-26</a:t>
             </a:r>
           </a:p>
         </p:txBody>
@@ -10314,7 +10314,7 @@
               </a:defRPr>
             </a:pPr>
             <a:r>
-              <a:t>2026-05-18</a:t>
+              <a:t>2026-05-26</a:t>
             </a:r>
           </a:p>
         </p:txBody>
@@ -11508,7 +11508,7 @@
               </a:defRPr>
             </a:pPr>
             <a:r>
-              <a:t>2026-05-18</a:t>
+              <a:t>2026-05-26</a:t>
             </a:r>
           </a:p>
         </p:txBody>
@@ -12036,7 +12036,7 @@
                         </a:defRPr>
                       </a:pPr>
                       <a:r>
-                        <a:t>0.54</a:t>
+                        <a:t>0.55</a:t>
                       </a:r>
                     </a:p>
                   </a:txBody>
@@ -12130,7 +12130,7 @@
                         </a:defRPr>
                       </a:pPr>
                       <a:r>
-                        <a:t>0.40</a:t>
+                        <a:t>0.43</a:t>
                       </a:r>
                     </a:p>
                   </a:txBody>
@@ -12224,7 +12224,7 @@
                         </a:defRPr>
                       </a:pPr>
                       <a:r>
-                        <a:t>0.37</a:t>
+                        <a:t>0.39</a:t>
                       </a:r>
                     </a:p>
                   </a:txBody>
@@ -12318,7 +12318,7 @@
                         </a:defRPr>
                       </a:pPr>
                       <a:r>
-                        <a:t>0.32</a:t>
+                        <a:t>0.33</a:t>
                       </a:r>
                     </a:p>
                   </a:txBody>
@@ -12629,7 +12629,7 @@
               </a:defRPr>
             </a:pPr>
             <a:r>
-              <a:t>2026-05-18</a:t>
+              <a:t>2026-05-26</a:t>
             </a:r>
           </a:p>
         </p:txBody>
@@ -13250,7 +13250,7 @@
                         </a:defRPr>
                       </a:pPr>
                       <a:r>
-                        <a:t>0.54</a:t>
+                        <a:t>0.55</a:t>
                       </a:r>
                     </a:p>
                   </a:txBody>
@@ -13273,7 +13273,7 @@
                         </a:defRPr>
                       </a:pPr>
                       <a:r>
-                        <a:t>9.8x</a:t>
+                        <a:t>10.0x</a:t>
                       </a:r>
                     </a:p>
                   </a:txBody>
@@ -13367,7 +13367,7 @@
                         </a:defRPr>
                       </a:pPr>
                       <a:r>
-                        <a:t>0.40</a:t>
+                        <a:t>0.43</a:t>
                       </a:r>
                     </a:p>
                   </a:txBody>
@@ -13390,7 +13390,7 @@
                         </a:defRPr>
                       </a:pPr>
                       <a:r>
-                        <a:t>11.2x</a:t>
+                        <a:t>11.9x</a:t>
                       </a:r>
                     </a:p>
                   </a:txBody>
@@ -13484,7 +13484,7 @@
                         </a:defRPr>
                       </a:pPr>
                       <a:r>
-                        <a:t>0.37</a:t>
+                        <a:t>0.39</a:t>
                       </a:r>
                     </a:p>
                   </a:txBody>
@@ -13507,7 +13507,7 @@
                         </a:defRPr>
                       </a:pPr>
                       <a:r>
-                        <a:t>10.7x</a:t>
+                        <a:t>11.3x</a:t>
                       </a:r>
                     </a:p>
                   </a:txBody>
@@ -13601,7 +13601,7 @@
                         </a:defRPr>
                       </a:pPr>
                       <a:r>
-                        <a:t>0.32</a:t>
+                        <a:t>0.33</a:t>
                       </a:r>
                     </a:p>
                   </a:txBody>
@@ -13624,7 +13624,7 @@
                         </a:defRPr>
                       </a:pPr>
                       <a:r>
-                        <a:t>18.0x</a:t>
+                        <a:t>18.4x</a:t>
                       </a:r>
                     </a:p>
                   </a:txBody>
@@ -14252,7 +14252,7 @@
               </a:defRPr>
             </a:pPr>
             <a:r>
-              <a:t>2026-05-18</a:t>
+              <a:t>2026-05-26</a:t>
             </a:r>
           </a:p>
         </p:txBody>
@@ -15875,7 +15875,7 @@
               </a:defRPr>
             </a:pPr>
             <a:r>
-              <a:t>2026-05-18</a:t>
+              <a:t>2026-05-26</a:t>
             </a:r>
           </a:p>
         </p:txBody>
@@ -16738,7 +16738,7 @@
               </a:defRPr>
             </a:pPr>
             <a:r>
-              <a:t>2026-05-18</a:t>
+              <a:t>2026-05-26</a:t>
             </a:r>
           </a:p>
         </p:txBody>
@@ -17789,7 +17789,7 @@
               </a:defRPr>
             </a:pPr>
             <a:r>
-              <a:t>2026-05-18</a:t>
+              <a:t>2026-05-26</a:t>
             </a:r>
           </a:p>
         </p:txBody>
@@ -18200,7 +18200,7 @@
                         </a:defRPr>
                       </a:pPr>
                       <a:r>
-                        <a:t>Anthropic</a:t>
+                        <a:t>xAI</a:t>
                       </a:r>
                     </a:p>
                   </a:txBody>
@@ -18246,7 +18246,7 @@
                         </a:defRPr>
                       </a:pPr>
                       <a:r>
-                        <a:t>70%</a:t>
+                        <a:t>67%</a:t>
                       </a:r>
                     </a:p>
                   </a:txBody>
@@ -18294,7 +18294,7 @@
                         </a:defRPr>
                       </a:pPr>
                       <a:r>
-                        <a:t>xAI</a:t>
+                        <a:t>Anthropic</a:t>
                       </a:r>
                     </a:p>
                   </a:txBody>
@@ -18340,7 +18340,7 @@
                         </a:defRPr>
                       </a:pPr>
                       <a:r>
-                        <a:t>67%</a:t>
+                        <a:t>70%</a:t>
                       </a:r>
                     </a:p>
                   </a:txBody>
@@ -18388,7 +18388,7 @@
                         </a:defRPr>
                       </a:pPr>
                       <a:r>
-                        <a:t>Microsoft</a:t>
+                        <a:t>OpenAI</a:t>
                       </a:r>
                     </a:p>
                   </a:txBody>
@@ -18411,7 +18411,7 @@
                         </a:defRPr>
                       </a:pPr>
                       <a:r>
-                        <a:t>1.9</a:t>
+                        <a:t>2.0</a:t>
                       </a:r>
                     </a:p>
                   </a:txBody>
@@ -18434,7 +18434,7 @@
                         </a:defRPr>
                       </a:pPr>
                       <a:r>
-                        <a:t>68%</a:t>
+                        <a:t>71%</a:t>
                       </a:r>
                     </a:p>
                   </a:txBody>
@@ -18457,7 +18457,7 @@
                         </a:defRPr>
                       </a:pPr>
                       <a:r>
-                        <a:t>Training allocation</a:t>
+                        <a:t>Serving efficiency</a:t>
                       </a:r>
                     </a:p>
                   </a:txBody>
@@ -18482,7 +18482,7 @@
                         </a:defRPr>
                       </a:pPr>
                       <a:r>
-                        <a:t>OpenAI</a:t>
+                        <a:t>Microsoft</a:t>
                       </a:r>
                     </a:p>
                   </a:txBody>
@@ -18528,7 +18528,7 @@
                         </a:defRPr>
                       </a:pPr>
                       <a:r>
-                        <a:t>71%</a:t>
+                        <a:t>68%</a:t>
                       </a:r>
                     </a:p>
                   </a:txBody>
@@ -18551,7 +18551,7 @@
                         </a:defRPr>
                       </a:pPr>
                       <a:r>
-                        <a:t>Serving efficiency</a:t>
+                        <a:t>Training allocation</a:t>
                       </a:r>
                     </a:p>
                   </a:txBody>
@@ -18599,7 +18599,7 @@
                         </a:defRPr>
                       </a:pPr>
                       <a:r>
-                        <a:t>2.0</a:t>
+                        <a:t>2.2</a:t>
                       </a:r>
                     </a:p>
                   </a:txBody>
@@ -18840,7 +18840,7 @@
               </a:defRPr>
             </a:pPr>
             <a:r>
-              <a:t>2026-05-18</a:t>
+              <a:t>2026-05-26</a:t>
             </a:r>
           </a:p>
         </p:txBody>

</xml_diff>

<commit_message>
Simplify token capacity outputs to formula-driven logic
</commit_message>
<xml_diff>
--- a/llm_token_capacity_project/outputs/reports/llm_token_capacity_2026_2030.pptx
+++ b/llm_token_capacity_project/outputs/reports/llm_token_capacity_2026_2030.pptx
@@ -153,22 +153,22 @@
                   <c:v>Google</c:v>
                 </c:pt>
                 <c:pt idx="2">
+                  <c:v>Microsoft</c:v>
+                </c:pt>
+                <c:pt idx="3">
+                  <c:v>Anthropic</c:v>
+                </c:pt>
+                <c:pt idx="4">
+                  <c:v>Tencent</c:v>
+                </c:pt>
+                <c:pt idx="5">
                   <c:v>Meta</c:v>
                 </c:pt>
-                <c:pt idx="3">
-                  <c:v>Microsoft</c:v>
-                </c:pt>
-                <c:pt idx="4">
-                  <c:v>Anthropic</c:v>
-                </c:pt>
-                <c:pt idx="5">
+                <c:pt idx="6">
+                  <c:v>xAI</c:v>
+                </c:pt>
+                <c:pt idx="7">
                   <c:v>Alibaba</c:v>
-                </c:pt>
-                <c:pt idx="6">
-                  <c:v>Tencent</c:v>
-                </c:pt>
-                <c:pt idx="7">
-                  <c:v>xAI</c:v>
                 </c:pt>
                 <c:pt idx="8">
                   <c:v>DeepSeek</c:v>
@@ -183,31 +183,31 @@
                 <c:formatCode>General</c:formatCode>
                 <c:ptCount val="9"/>
                 <c:pt idx="0">
-                  <c:v>0.586840240711296</c:v>
+                  <c:v>0.304530475392</c:v>
                 </c:pt>
                 <c:pt idx="1">
-                  <c:v>0.5462989080192</c:v>
+                  <c:v>0.228679713216</c:v>
                 </c:pt>
                 <c:pt idx="2">
-                  <c:v>0.4271839955712</c:v>
+                  <c:v>0.208761841728</c:v>
                 </c:pt>
                 <c:pt idx="3">
-                  <c:v>0.391550950429056</c:v>
+                  <c:v>0.185774864256</c:v>
                 </c:pt>
                 <c:pt idx="4">
-                  <c:v>0.325393026336</c:v>
+                  <c:v>0.082114243776</c:v>
                 </c:pt>
                 <c:pt idx="5">
-                  <c:v>0.259801314859008</c:v>
+                  <c:v>0.08016026112</c:v>
                 </c:pt>
                 <c:pt idx="6">
-                  <c:v>0.167354927293824</c:v>
+                  <c:v>0.076351840704</c:v>
                 </c:pt>
                 <c:pt idx="7">
-                  <c:v>0.125620159296096</c:v>
+                  <c:v>0.027055767744</c:v>
                 </c:pt>
                 <c:pt idx="8">
-                  <c:v>0.104360160022272</c:v>
+                  <c:v>0.005694666768</c:v>
                 </c:pt>
               </c:numCache>
             </c:numRef>
@@ -372,19 +372,19 @@
                 <c:formatCode>General</c:formatCode>
                 <c:ptCount val="5"/>
                 <c:pt idx="0">
-                  <c:v>0.030767688</c:v>
+                  <c:v>0.03726771552</c:v>
                 </c:pt>
                 <c:pt idx="1">
-                  <c:v>0.094205094984</c:v>
+                  <c:v>0.091885275072</c:v>
                 </c:pt>
                 <c:pt idx="2">
-                  <c:v>0.19615523106816</c:v>
+                  <c:v>0.154582725888</c:v>
                 </c:pt>
                 <c:pt idx="3">
-                  <c:v>0.353075018688</c:v>
+                  <c:v>0.2254853376</c:v>
                 </c:pt>
                 <c:pt idx="4">
-                  <c:v>0.586840240711296</c:v>
+                  <c:v>0.304530475392</c:v>
                 </c:pt>
               </c:numCache>
             </c:numRef>
@@ -435,19 +435,19 @@
                 <c:formatCode>General</c:formatCode>
                 <c:ptCount val="5"/>
                 <c:pt idx="0">
-                  <c:v>0.05455470569472</c:v>
+                  <c:v>0.056496604032</c:v>
                 </c:pt>
                 <c:pt idx="1">
-                  <c:v>0.1128117920832</c:v>
+                  <c:v>0.09269952768</c:v>
                 </c:pt>
                 <c:pt idx="2">
-                  <c:v>0.203998065026112</c:v>
+                  <c:v>0.133474792896</c:v>
                 </c:pt>
                 <c:pt idx="3">
-                  <c:v>0.34217223772536</c:v>
+                  <c:v>0.17882239968</c:v>
                 </c:pt>
                 <c:pt idx="4">
-                  <c:v>0.5462989080192</c:v>
+                  <c:v>0.228679713216</c:v>
                 </c:pt>
               </c:numCache>
             </c:numRef>
@@ -463,7 +463,7 @@
               <c:strCache>
                 <c:ptCount val="1"/>
                 <c:pt idx="0">
-                  <c:v>Meta</c:v>
+                  <c:v>Microsoft</c:v>
                 </c:pt>
               </c:strCache>
             </c:strRef>
@@ -498,19 +498,19 @@
                 <c:formatCode>General</c:formatCode>
                 <c:ptCount val="5"/>
                 <c:pt idx="0">
-                  <c:v>0.03581880312384</c:v>
+                  <c:v>0.04447071936</c:v>
                 </c:pt>
                 <c:pt idx="1">
-                  <c:v>0.08110014808896</c:v>
+                  <c:v>0.078105615552</c:v>
                 </c:pt>
                 <c:pt idx="2">
-                  <c:v>0.15303422016</c:v>
+                  <c:v>0.116688662208</c:v>
                 </c:pt>
                 <c:pt idx="3">
-                  <c:v>0.263047420517875</c:v>
+                  <c:v>0.160282494144</c:v>
                 </c:pt>
                 <c:pt idx="4">
-                  <c:v>0.4271839955712</c:v>
+                  <c:v>0.208761841728</c:v>
                 </c:pt>
               </c:numCache>
             </c:numRef>
@@ -526,7 +526,7 @@
               <c:strCache>
                 <c:ptCount val="1"/>
                 <c:pt idx="0">
-                  <c:v>Microsoft</c:v>
+                  <c:v>Anthropic</c:v>
                 </c:pt>
               </c:strCache>
             </c:strRef>
@@ -561,19 +561,19 @@
                 <c:formatCode>General</c:formatCode>
                 <c:ptCount val="5"/>
                 <c:pt idx="0">
-                  <c:v>0.03478261113792</c:v>
+                  <c:v>0.023738595264</c:v>
                 </c:pt>
                 <c:pt idx="1">
-                  <c:v>0.07643329787016</c:v>
+                  <c:v>0.055807621056</c:v>
                 </c:pt>
                 <c:pt idx="2">
-                  <c:v>0.142317358121088</c:v>
+                  <c:v>0.093451145472</c:v>
                 </c:pt>
                 <c:pt idx="3">
-                  <c:v>0.242797026069648</c:v>
+                  <c:v>0.136794438144</c:v>
                 </c:pt>
                 <c:pt idx="4">
-                  <c:v>0.391550950429056</c:v>
+                  <c:v>0.185774864256</c:v>
                 </c:pt>
               </c:numCache>
             </c:numRef>
@@ -589,7 +589,7 @@
               <c:strCache>
                 <c:ptCount val="1"/>
                 <c:pt idx="0">
-                  <c:v>Anthropic</c:v>
+                  <c:v>Tencent</c:v>
                 </c:pt>
               </c:strCache>
             </c:strRef>
@@ -624,19 +624,19 @@
                 <c:formatCode>General</c:formatCode>
                 <c:ptCount val="5"/>
                 <c:pt idx="0">
-                  <c:v>0.0176500585008</c:v>
+                  <c:v>0.011524806144</c:v>
                 </c:pt>
                 <c:pt idx="1">
-                  <c:v>0.051744931247117</c:v>
+                  <c:v>0.026056083456</c:v>
                 </c:pt>
                 <c:pt idx="2">
-                  <c:v>0.107427840408</c:v>
+                  <c:v>0.042654309696</c:v>
                 </c:pt>
                 <c:pt idx="3">
-                  <c:v>0.194276677019443</c:v>
+                  <c:v>0.06138211968</c:v>
                 </c:pt>
                 <c:pt idx="4">
-                  <c:v>0.325393026336</c:v>
+                  <c:v>0.082114243776</c:v>
                 </c:pt>
               </c:numCache>
             </c:numRef>
@@ -879,7 +879,7 @@
               <c:strCache>
                 <c:ptCount val="1"/>
                 <c:pt idx="0">
-                  <c:v>Meta</c:v>
+                  <c:v>Microsoft</c:v>
                 </c:pt>
               </c:strCache>
             </c:strRef>
@@ -914,19 +914,19 @@
                 <c:formatCode>General</c:formatCode>
                 <c:ptCount val="5"/>
                 <c:pt idx="0">
-                  <c:v>0.673</c:v>
+                  <c:v>0.71</c:v>
                 </c:pt>
                 <c:pt idx="1">
-                  <c:v>1.21</c:v>
+                  <c:v>1.247</c:v>
                 </c:pt>
                 <c:pt idx="2">
-                  <c:v>1.824</c:v>
+                  <c:v>1.863</c:v>
                 </c:pt>
                 <c:pt idx="3">
-                  <c:v>2.514</c:v>
+                  <c:v>2.559</c:v>
                 </c:pt>
                 <c:pt idx="4">
-                  <c:v>3.28</c:v>
+                  <c:v>3.333</c:v>
                 </c:pt>
               </c:numCache>
             </c:numRef>
@@ -942,7 +942,7 @@
               <c:strCache>
                 <c:ptCount val="1"/>
                 <c:pt idx="0">
-                  <c:v>Microsoft</c:v>
+                  <c:v>Anthropic</c:v>
                 </c:pt>
               </c:strCache>
             </c:strRef>
@@ -977,19 +977,19 @@
                 <c:formatCode>General</c:formatCode>
                 <c:ptCount val="5"/>
                 <c:pt idx="0">
-                  <c:v>0.71</c:v>
+                  <c:v>0.379</c:v>
                 </c:pt>
                 <c:pt idx="1">
-                  <c:v>1.247</c:v>
+                  <c:v>0.891</c:v>
                 </c:pt>
                 <c:pt idx="2">
-                  <c:v>1.863</c:v>
+                  <c:v>1.492</c:v>
                 </c:pt>
                 <c:pt idx="3">
-                  <c:v>2.559</c:v>
+                  <c:v>2.184</c:v>
                 </c:pt>
                 <c:pt idx="4">
-                  <c:v>3.333</c:v>
+                  <c:v>2.966</c:v>
                 </c:pt>
               </c:numCache>
             </c:numRef>
@@ -1005,7 +1005,7 @@
               <c:strCache>
                 <c:ptCount val="1"/>
                 <c:pt idx="0">
-                  <c:v>Anthropic</c:v>
+                  <c:v>Tencent</c:v>
                 </c:pt>
               </c:strCache>
             </c:strRef>
@@ -1040,19 +1040,19 @@
                 <c:formatCode>General</c:formatCode>
                 <c:ptCount val="5"/>
                 <c:pt idx="0">
-                  <c:v>0.379</c:v>
+                  <c:v>0.184</c:v>
                 </c:pt>
                 <c:pt idx="1">
-                  <c:v>0.891</c:v>
+                  <c:v>0.416</c:v>
                 </c:pt>
                 <c:pt idx="2">
-                  <c:v>1.492</c:v>
+                  <c:v>0.681</c:v>
                 </c:pt>
                 <c:pt idx="3">
-                  <c:v>2.184</c:v>
+                  <c:v>0.98</c:v>
                 </c:pt>
                 <c:pt idx="4">
-                  <c:v>2.966</c:v>
+                  <c:v>1.311</c:v>
                 </c:pt>
               </c:numCache>
             </c:numRef>
@@ -1186,22 +1186,22 @@
                   <c:v>Google</c:v>
                 </c:pt>
                 <c:pt idx="2">
+                  <c:v>Microsoft</c:v>
+                </c:pt>
+                <c:pt idx="3">
+                  <c:v>Anthropic</c:v>
+                </c:pt>
+                <c:pt idx="4">
+                  <c:v>Tencent</c:v>
+                </c:pt>
+                <c:pt idx="5">
                   <c:v>Meta</c:v>
                 </c:pt>
-                <c:pt idx="3">
-                  <c:v>Microsoft</c:v>
-                </c:pt>
-                <c:pt idx="4">
-                  <c:v>Anthropic</c:v>
-                </c:pt>
-                <c:pt idx="5">
+                <c:pt idx="6">
+                  <c:v>xAI</c:v>
+                </c:pt>
+                <c:pt idx="7">
                   <c:v>Alibaba</c:v>
-                </c:pt>
-                <c:pt idx="6">
-                  <c:v>Tencent</c:v>
-                </c:pt>
-                <c:pt idx="7">
-                  <c:v>xAI</c:v>
                 </c:pt>
                 <c:pt idx="8">
                   <c:v>DeepSeek</c:v>
@@ -1222,22 +1222,22 @@
                   <c:v>8.0</c:v>
                 </c:pt>
                 <c:pt idx="2">
+                  <c:v>9.0</c:v>
+                </c:pt>
+                <c:pt idx="3">
                   <c:v>7.0</c:v>
                 </c:pt>
-                <c:pt idx="3">
-                  <c:v>9.0</c:v>
-                </c:pt>
                 <c:pt idx="4">
+                  <c:v>3.0</c:v>
+                </c:pt>
+                <c:pt idx="5">
                   <c:v>7.0</c:v>
-                </c:pt>
-                <c:pt idx="5">
-                  <c:v>4.0</c:v>
                 </c:pt>
                 <c:pt idx="6">
                   <c:v>3.0</c:v>
                 </c:pt>
                 <c:pt idx="7">
-                  <c:v>3.0</c:v>
+                  <c:v>4.0</c:v>
                 </c:pt>
                 <c:pt idx="8">
                   <c:v>1.8</c:v>
@@ -1272,22 +1272,22 @@
                   <c:v>Google</c:v>
                 </c:pt>
                 <c:pt idx="2">
+                  <c:v>Microsoft</c:v>
+                </c:pt>
+                <c:pt idx="3">
+                  <c:v>Anthropic</c:v>
+                </c:pt>
+                <c:pt idx="4">
+                  <c:v>Tencent</c:v>
+                </c:pt>
+                <c:pt idx="5">
                   <c:v>Meta</c:v>
                 </c:pt>
-                <c:pt idx="3">
-                  <c:v>Microsoft</c:v>
-                </c:pt>
-                <c:pt idx="4">
-                  <c:v>Anthropic</c:v>
-                </c:pt>
-                <c:pt idx="5">
+                <c:pt idx="6">
+                  <c:v>xAI</c:v>
+                </c:pt>
+                <c:pt idx="7">
                   <c:v>Alibaba</c:v>
-                </c:pt>
-                <c:pt idx="6">
-                  <c:v>Tencent</c:v>
-                </c:pt>
-                <c:pt idx="7">
-                  <c:v>xAI</c:v>
                 </c:pt>
                 <c:pt idx="8">
                   <c:v>DeepSeek</c:v>
@@ -1308,22 +1308,22 @@
                   <c:v>6.8</c:v>
                 </c:pt>
                 <c:pt idx="2">
+                  <c:v>6.2</c:v>
+                </c:pt>
+                <c:pt idx="3">
+                  <c:v>5.5</c:v>
+                </c:pt>
+                <c:pt idx="4">
+                  <c:v>2.4</c:v>
+                </c:pt>
+                <c:pt idx="5">
                   <c:v>5.8</c:v>
                 </c:pt>
-                <c:pt idx="3">
-                  <c:v>6.2</c:v>
-                </c:pt>
-                <c:pt idx="4">
-                  <c:v>5.5</c:v>
-                </c:pt>
-                <c:pt idx="5">
+                <c:pt idx="6">
+                  <c:v>2.5</c:v>
+                </c:pt>
+                <c:pt idx="7">
                   <c:v>3.2</c:v>
-                </c:pt>
-                <c:pt idx="6">
-                  <c:v>2.4</c:v>
-                </c:pt>
-                <c:pt idx="7">
-                  <c:v>2.5</c:v>
                 </c:pt>
                 <c:pt idx="8">
                   <c:v>1.2</c:v>
@@ -1476,22 +1476,22 @@
                   <c:v>Google</c:v>
                 </c:pt>
                 <c:pt idx="2">
+                  <c:v>Microsoft</c:v>
+                </c:pt>
+                <c:pt idx="3">
+                  <c:v>Anthropic</c:v>
+                </c:pt>
+                <c:pt idx="4">
+                  <c:v>Tencent</c:v>
+                </c:pt>
+                <c:pt idx="5">
                   <c:v>Meta</c:v>
                 </c:pt>
-                <c:pt idx="3">
-                  <c:v>Microsoft</c:v>
-                </c:pt>
-                <c:pt idx="4">
-                  <c:v>Anthropic</c:v>
-                </c:pt>
-                <c:pt idx="5">
+                <c:pt idx="6">
+                  <c:v>xAI</c:v>
+                </c:pt>
+                <c:pt idx="7">
                   <c:v>Alibaba</c:v>
-                </c:pt>
-                <c:pt idx="6">
-                  <c:v>Tencent</c:v>
-                </c:pt>
-                <c:pt idx="7">
-                  <c:v>xAI</c:v>
                 </c:pt>
                 <c:pt idx="8">
                   <c:v>DeepSeek</c:v>
@@ -1512,22 +1512,22 @@
                   <c:v>3.651</c:v>
                 </c:pt>
                 <c:pt idx="2">
+                  <c:v>3.333</c:v>
+                </c:pt>
+                <c:pt idx="3">
+                  <c:v>2.966</c:v>
+                </c:pt>
+                <c:pt idx="4">
+                  <c:v>1.311</c:v>
+                </c:pt>
+                <c:pt idx="5">
                   <c:v>3.28</c:v>
                 </c:pt>
-                <c:pt idx="3">
-                  <c:v>3.333</c:v>
-                </c:pt>
-                <c:pt idx="4">
-                  <c:v>2.966</c:v>
-                </c:pt>
-                <c:pt idx="5">
+                <c:pt idx="6">
+                  <c:v>1.219</c:v>
+                </c:pt>
+                <c:pt idx="7">
                   <c:v>1.748</c:v>
-                </c:pt>
-                <c:pt idx="6">
-                  <c:v>1.311</c:v>
-                </c:pt>
-                <c:pt idx="7">
-                  <c:v>1.219</c:v>
                 </c:pt>
                 <c:pt idx="8">
                   <c:v>0.651</c:v>
@@ -1562,22 +1562,22 @@
                   <c:v>Google</c:v>
                 </c:pt>
                 <c:pt idx="2">
+                  <c:v>Microsoft</c:v>
+                </c:pt>
+                <c:pt idx="3">
+                  <c:v>Anthropic</c:v>
+                </c:pt>
+                <c:pt idx="4">
+                  <c:v>Tencent</c:v>
+                </c:pt>
+                <c:pt idx="5">
                   <c:v>Meta</c:v>
                 </c:pt>
-                <c:pt idx="3">
-                  <c:v>Microsoft</c:v>
-                </c:pt>
-                <c:pt idx="4">
-                  <c:v>Anthropic</c:v>
-                </c:pt>
-                <c:pt idx="5">
+                <c:pt idx="6">
+                  <c:v>xAI</c:v>
+                </c:pt>
+                <c:pt idx="7">
                   <c:v>Alibaba</c:v>
-                </c:pt>
-                <c:pt idx="6">
-                  <c:v>Tencent</c:v>
-                </c:pt>
-                <c:pt idx="7">
-                  <c:v>xAI</c:v>
                 </c:pt>
                 <c:pt idx="8">
                   <c:v>DeepSeek</c:v>
@@ -1598,22 +1598,22 @@
                   <c:v>1.42</c:v>
                 </c:pt>
                 <c:pt idx="2">
+                  <c:v>1.111</c:v>
+                </c:pt>
+                <c:pt idx="3">
+                  <c:v>1.042</c:v>
+                </c:pt>
+                <c:pt idx="4">
+                  <c:v>0.328</c:v>
+                </c:pt>
+                <c:pt idx="5">
                   <c:v>0.925</c:v>
                 </c:pt>
-                <c:pt idx="3">
-                  <c:v>1.111</c:v>
-                </c:pt>
-                <c:pt idx="4">
-                  <c:v>1.042</c:v>
-                </c:pt>
-                <c:pt idx="5">
+                <c:pt idx="6">
+                  <c:v>0.523</c:v>
+                </c:pt>
+                <c:pt idx="7">
                   <c:v>0.437</c:v>
-                </c:pt>
-                <c:pt idx="6">
-                  <c:v>0.328</c:v>
-                </c:pt>
-                <c:pt idx="7">
-                  <c:v>0.523</c:v>
                 </c:pt>
                 <c:pt idx="8">
                   <c:v>0.143</c:v>
@@ -1767,22 +1767,22 @@
                   <c:v>Google</c:v>
                 </c:pt>
                 <c:pt idx="2">
+                  <c:v>Microsoft</c:v>
+                </c:pt>
+                <c:pt idx="3">
+                  <c:v>Anthropic</c:v>
+                </c:pt>
+                <c:pt idx="4">
+                  <c:v>Tencent</c:v>
+                </c:pt>
+                <c:pt idx="5">
                   <c:v>Meta</c:v>
                 </c:pt>
-                <c:pt idx="3">
-                  <c:v>Microsoft</c:v>
-                </c:pt>
-                <c:pt idx="4">
-                  <c:v>Anthropic</c:v>
-                </c:pt>
-                <c:pt idx="5">
+                <c:pt idx="6">
+                  <c:v>xAI</c:v>
+                </c:pt>
+                <c:pt idx="7">
                   <c:v>Alibaba</c:v>
-                </c:pt>
-                <c:pt idx="6">
-                  <c:v>Tencent</c:v>
-                </c:pt>
-                <c:pt idx="7">
-                  <c:v>xAI</c:v>
                 </c:pt>
                 <c:pt idx="8">
                   <c:v>DeepSeek</c:v>
@@ -1797,31 +1797,31 @@
                 <c:formatCode>General</c:formatCode>
                 <c:ptCount val="9"/>
                 <c:pt idx="0">
-                  <c:v>1.967582</c:v>
+                  <c:v>0.72494</c:v>
                 </c:pt>
                 <c:pt idx="1">
-                  <c:v>2.47404</c:v>
+                  <c:v>0.72494</c:v>
                 </c:pt>
                 <c:pt idx="2">
-                  <c:v>2.153423</c:v>
+                  <c:v>0.72494</c:v>
                 </c:pt>
                 <c:pt idx="3">
-                  <c:v>1.999541</c:v>
+                  <c:v>0.72494</c:v>
                 </c:pt>
                 <c:pt idx="4">
-                  <c:v>1.81395</c:v>
+                  <c:v>0.72494</c:v>
                 </c:pt>
                 <c:pt idx="5">
-                  <c:v>2.529748</c:v>
+                  <c:v>0.28286</c:v>
                 </c:pt>
                 <c:pt idx="6">
-                  <c:v>2.172767</c:v>
+                  <c:v>0.72494</c:v>
                 </c:pt>
                 <c:pt idx="7">
-                  <c:v>1.780193</c:v>
+                  <c:v>0.179145</c:v>
                 </c:pt>
                 <c:pt idx="8">
-                  <c:v>2.811228</c:v>
+                  <c:v>0.101245</c:v>
                 </c:pt>
               </c:numCache>
             </c:numRef>
@@ -1987,19 +1987,19 @@
                 <c:formatCode>General</c:formatCode>
                 <c:ptCount val="5"/>
                 <c:pt idx="0">
-                  <c:v>0.117</c:v>
+                  <c:v>0.155</c:v>
                 </c:pt>
                 <c:pt idx="1">
-                  <c:v>0.287</c:v>
+                  <c:v>0.306</c:v>
                 </c:pt>
                 <c:pt idx="2">
-                  <c:v>0.552</c:v>
+                  <c:v>0.473</c:v>
                 </c:pt>
                 <c:pt idx="3">
-                  <c:v>0.95</c:v>
+                  <c:v>0.656</c:v>
                 </c:pt>
                 <c:pt idx="4">
-                  <c:v>1.527</c:v>
+                  <c:v>0.853</c:v>
                 </c:pt>
               </c:numCache>
             </c:numRef>
@@ -2050,19 +2050,19 @@
                 <c:formatCode>General</c:formatCode>
                 <c:ptCount val="5"/>
                 <c:pt idx="0">
-                  <c:v>0.208</c:v>
+                  <c:v>0.201</c:v>
                 </c:pt>
                 <c:pt idx="1">
-                  <c:v>0.519</c:v>
+                  <c:v>0.404</c:v>
                 </c:pt>
                 <c:pt idx="2">
-                  <c:v>1.018</c:v>
+                  <c:v>0.638</c:v>
                 </c:pt>
                 <c:pt idx="3">
-                  <c:v>1.786</c:v>
+                  <c:v>0.903</c:v>
                 </c:pt>
                 <c:pt idx="4">
-                  <c:v>2.934</c:v>
+                  <c:v>1.199</c:v>
                 </c:pt>
               </c:numCache>
             </c:numRef>
@@ -2113,19 +2113,19 @@
                 <c:formatCode>General</c:formatCode>
                 <c:ptCount val="5"/>
                 <c:pt idx="0">
-                  <c:v>0.302</c:v>
+                  <c:v>0.231</c:v>
                 </c:pt>
                 <c:pt idx="1">
-                  <c:v>0.784</c:v>
+                  <c:v>0.48</c:v>
                 </c:pt>
                 <c:pt idx="2">
-                  <c:v>1.592</c:v>
+                  <c:v>0.783</c:v>
                 </c:pt>
                 <c:pt idx="3">
-                  <c:v>2.887</c:v>
+                  <c:v>1.143</c:v>
                 </c:pt>
                 <c:pt idx="4">
-                  <c:v>4.892</c:v>
+                  <c:v>1.565</c:v>
                 </c:pt>
               </c:numCache>
             </c:numRef>
@@ -5605,7 +5605,7 @@
               </a:defRPr>
             </a:pPr>
             <a:r>
-              <a:t>2.93Q</a:t>
+              <a:t>1.20Q</a:t>
             </a:r>
           </a:p>
         </p:txBody>
@@ -5710,7 +5710,7 @@
               </a:defRPr>
             </a:pPr>
             <a:r>
-              <a:t>2026-05-26</a:t>
+              <a:t>2026-05-27</a:t>
             </a:r>
           </a:p>
         </p:txBody>
@@ -5886,7 +5886,7 @@
               </a:defRPr>
             </a:pPr>
             <a:r>
-              <a:t>The score is a directional operating index using deployment gap, inference share, tokens/MW, and utilization versus the peer set.</a:t>
+              <a:t>The score is a directional operating index using deployment gap, inference share, and selected TPS/MW versus the peer set.</a:t>
             </a:r>
           </a:p>
         </p:txBody>
@@ -6116,7 +6116,7 @@
                         </a:defRPr>
                       </a:pPr>
                       <a:r>
-                        <a:t>Microsoft</a:t>
+                        <a:t>DeepSeek</a:t>
                       </a:r>
                     </a:p>
                   </a:txBody>
@@ -6139,7 +6139,7 @@
                         </a:defRPr>
                       </a:pPr>
                       <a:r>
-                        <a:t>0.39</a:t>
+                        <a:t>0.01</a:t>
                       </a:r>
                     </a:p>
                   </a:txBody>
@@ -6162,7 +6162,7 @@
                         </a:defRPr>
                       </a:pPr>
                       <a:r>
-                        <a:t>3.3</a:t>
+                        <a:t>0.7</a:t>
                       </a:r>
                     </a:p>
                   </a:txBody>
@@ -6185,7 +6185,7 @@
                         </a:defRPr>
                       </a:pPr>
                       <a:r>
-                        <a:t>31%</a:t>
+                        <a:t>33%</a:t>
                       </a:r>
                     </a:p>
                   </a:txBody>
@@ -6208,7 +6208,7 @@
                         </a:defRPr>
                       </a:pPr>
                       <a:r>
-                        <a:t>Training allocation</a:t>
+                        <a:t>Deployment gap</a:t>
                       </a:r>
                     </a:p>
                   </a:txBody>
@@ -6231,7 +6231,7 @@
                         </a:defRPr>
                       </a:pPr>
                       <a:r>
-                        <a:t>training cadence, launch schedule, commercial serving ramp</a:t>
+                        <a:t>site energization, rack deployment, accelerator delivery</a:t>
                       </a:r>
                     </a:p>
                   </a:txBody>
@@ -6256,7 +6256,7 @@
                         </a:defRPr>
                       </a:pPr>
                       <a:r>
-                        <a:t>OpenAI</a:t>
+                        <a:t>Alibaba</a:t>
                       </a:r>
                     </a:p>
                   </a:txBody>
@@ -6279,7 +6279,7 @@
                         </a:defRPr>
                       </a:pPr>
                       <a:r>
-                        <a:t>0.59</a:t>
+                        <a:t>0.03</a:t>
                       </a:r>
                     </a:p>
                   </a:txBody>
@@ -6302,7 +6302,7 @@
                         </a:defRPr>
                       </a:pPr>
                       <a:r>
-                        <a:t>4.9</a:t>
+                        <a:t>1.7</a:t>
                       </a:r>
                     </a:p>
                   </a:txBody>
@@ -6325,7 +6325,7 @@
                         </a:defRPr>
                       </a:pPr>
                       <a:r>
-                        <a:t>29%</a:t>
+                        <a:t>20%</a:t>
                       </a:r>
                     </a:p>
                   </a:txBody>
@@ -6396,7 +6396,7 @@
                         </a:defRPr>
                       </a:pPr>
                       <a:r>
-                        <a:t>Anthropic</a:t>
+                        <a:t>Meta</a:t>
                       </a:r>
                     </a:p>
                   </a:txBody>
@@ -6419,7 +6419,7 @@
                         </a:defRPr>
                       </a:pPr>
                       <a:r>
-                        <a:t>0.33</a:t>
+                        <a:t>0.08</a:t>
                       </a:r>
                     </a:p>
                   </a:txBody>
@@ -6442,7 +6442,7 @@
                         </a:defRPr>
                       </a:pPr>
                       <a:r>
-                        <a:t>3.0</a:t>
+                        <a:t>3.3</a:t>
                       </a:r>
                     </a:p>
                   </a:txBody>
@@ -6465,7 +6465,7 @@
                         </a:defRPr>
                       </a:pPr>
                       <a:r>
-                        <a:t>21%</a:t>
+                        <a:t>17%</a:t>
                       </a:r>
                     </a:p>
                   </a:txBody>
@@ -6488,7 +6488,7 @@
                         </a:defRPr>
                       </a:pPr>
                       <a:r>
-                        <a:t>Training allocation</a:t>
+                        <a:t>Serving efficiency</a:t>
                       </a:r>
                     </a:p>
                   </a:txBody>
@@ -6511,7 +6511,7 @@
                         </a:defRPr>
                       </a:pPr>
                       <a:r>
-                        <a:t>training cadence, launch schedule, commercial serving ramp</a:t>
+                        <a:t>model routing, precision, batching, TTFT/TPOT target</a:t>
                       </a:r>
                     </a:p>
                   </a:txBody>
@@ -6536,7 +6536,7 @@
                         </a:defRPr>
                       </a:pPr>
                       <a:r>
-                        <a:t>DeepSeek</a:t>
+                        <a:t>Microsoft</a:t>
                       </a:r>
                     </a:p>
                   </a:txBody>
@@ -6559,7 +6559,7 @@
                         </a:defRPr>
                       </a:pPr>
                       <a:r>
-                        <a:t>0.10</a:t>
+                        <a:t>0.21</a:t>
                       </a:r>
                     </a:p>
                   </a:txBody>
@@ -6582,7 +6582,7 @@
                         </a:defRPr>
                       </a:pPr>
                       <a:r>
-                        <a:t>0.7</a:t>
+                        <a:t>3.3</a:t>
                       </a:r>
                     </a:p>
                   </a:txBody>
@@ -6605,7 +6605,7 @@
                         </a:defRPr>
                       </a:pPr>
                       <a:r>
-                        <a:t>33%</a:t>
+                        <a:t>31%</a:t>
                       </a:r>
                     </a:p>
                   </a:txBody>
@@ -6628,7 +6628,7 @@
                         </a:defRPr>
                       </a:pPr>
                       <a:r>
-                        <a:t>Deployment gap</a:t>
+                        <a:t>Training allocation</a:t>
                       </a:r>
                     </a:p>
                   </a:txBody>
@@ -6651,7 +6651,7 @@
                         </a:defRPr>
                       </a:pPr>
                       <a:r>
-                        <a:t>site energization, rack deployment, accelerator delivery</a:t>
+                        <a:t>training cadence, launch schedule, commercial serving ramp</a:t>
                       </a:r>
                     </a:p>
                   </a:txBody>
@@ -6676,7 +6676,7 @@
                         </a:defRPr>
                       </a:pPr>
                       <a:r>
-                        <a:t>xAI</a:t>
+                        <a:t>OpenAI</a:t>
                       </a:r>
                     </a:p>
                   </a:txBody>
@@ -6699,7 +6699,7 @@
                         </a:defRPr>
                       </a:pPr>
                       <a:r>
-                        <a:t>0.13</a:t>
+                        <a:t>0.30</a:t>
                       </a:r>
                     </a:p>
                   </a:txBody>
@@ -6722,7 +6722,7 @@
                         </a:defRPr>
                       </a:pPr>
                       <a:r>
-                        <a:t>1.2</a:t>
+                        <a:t>4.9</a:t>
                       </a:r>
                     </a:p>
                   </a:txBody>
@@ -6745,7 +6745,7 @@
                         </a:defRPr>
                       </a:pPr>
                       <a:r>
-                        <a:t>17%</a:t>
+                        <a:t>29%</a:t>
                       </a:r>
                     </a:p>
                   </a:txBody>
@@ -6768,7 +6768,7 @@
                         </a:defRPr>
                       </a:pPr>
                       <a:r>
-                        <a:t>Training allocation</a:t>
+                        <a:t>Scale absorption</a:t>
                       </a:r>
                     </a:p>
                   </a:txBody>
@@ -6791,7 +6791,7 @@
                         </a:defRPr>
                       </a:pPr>
                       <a:r>
-                        <a:t>training cadence, launch schedule, commercial serving ramp</a:t>
+                        <a:t>demand absorption and product surface expansion</a:t>
                       </a:r>
                     </a:p>
                   </a:txBody>
@@ -6816,7 +6816,7 @@
                         </a:defRPr>
                       </a:pPr>
                       <a:r>
-                        <a:t>Alibaba</a:t>
+                        <a:t>Anthropic</a:t>
                       </a:r>
                     </a:p>
                   </a:txBody>
@@ -6839,7 +6839,7 @@
                         </a:defRPr>
                       </a:pPr>
                       <a:r>
-                        <a:t>0.26</a:t>
+                        <a:t>0.19</a:t>
                       </a:r>
                     </a:p>
                   </a:txBody>
@@ -6862,7 +6862,7 @@
                         </a:defRPr>
                       </a:pPr>
                       <a:r>
-                        <a:t>1.7</a:t>
+                        <a:t>3.0</a:t>
                       </a:r>
                     </a:p>
                   </a:txBody>
@@ -6885,7 +6885,7 @@
                         </a:defRPr>
                       </a:pPr>
                       <a:r>
-                        <a:t>20%</a:t>
+                        <a:t>21%</a:t>
                       </a:r>
                     </a:p>
                   </a:txBody>
@@ -6908,7 +6908,7 @@
                         </a:defRPr>
                       </a:pPr>
                       <a:r>
-                        <a:t>Scale absorption</a:t>
+                        <a:t>Training allocation</a:t>
                       </a:r>
                     </a:p>
                   </a:txBody>
@@ -6931,7 +6931,7 @@
                         </a:defRPr>
                       </a:pPr>
                       <a:r>
-                        <a:t>demand absorption and product surface expansion</a:t>
+                        <a:t>training cadence, launch schedule, commercial serving ramp</a:t>
                       </a:r>
                     </a:p>
                   </a:txBody>
@@ -6956,7 +6956,7 @@
                         </a:defRPr>
                       </a:pPr>
                       <a:r>
-                        <a:t>Tencent</a:t>
+                        <a:t>xAI</a:t>
                       </a:r>
                     </a:p>
                   </a:txBody>
@@ -6979,7 +6979,7 @@
                         </a:defRPr>
                       </a:pPr>
                       <a:r>
-                        <a:t>0.17</a:t>
+                        <a:t>0.08</a:t>
                       </a:r>
                     </a:p>
                   </a:txBody>
@@ -7002,7 +7002,7 @@
                         </a:defRPr>
                       </a:pPr>
                       <a:r>
-                        <a:t>1.3</a:t>
+                        <a:t>1.2</a:t>
                       </a:r>
                     </a:p>
                   </a:txBody>
@@ -7025,7 +7025,7 @@
                         </a:defRPr>
                       </a:pPr>
                       <a:r>
-                        <a:t>20%</a:t>
+                        <a:t>17%</a:t>
                       </a:r>
                     </a:p>
                   </a:txBody>
@@ -7048,7 +7048,7 @@
                         </a:defRPr>
                       </a:pPr>
                       <a:r>
-                        <a:t>Scale absorption</a:t>
+                        <a:t>Training allocation</a:t>
                       </a:r>
                     </a:p>
                   </a:txBody>
@@ -7071,7 +7071,7 @@
                         </a:defRPr>
                       </a:pPr>
                       <a:r>
-                        <a:t>demand absorption and product surface expansion</a:t>
+                        <a:t>training cadence, launch schedule, commercial serving ramp</a:t>
                       </a:r>
                     </a:p>
                   </a:txBody>
@@ -7096,7 +7096,7 @@
                         </a:defRPr>
                       </a:pPr>
                       <a:r>
-                        <a:t>Google</a:t>
+                        <a:t>Tencent</a:t>
                       </a:r>
                     </a:p>
                   </a:txBody>
@@ -7119,7 +7119,7 @@
                         </a:defRPr>
                       </a:pPr>
                       <a:r>
-                        <a:t>0.55</a:t>
+                        <a:t>0.08</a:t>
                       </a:r>
                     </a:p>
                   </a:txBody>
@@ -7142,7 +7142,7 @@
                         </a:defRPr>
                       </a:pPr>
                       <a:r>
-                        <a:t>3.7</a:t>
+                        <a:t>1.3</a:t>
                       </a:r>
                     </a:p>
                   </a:txBody>
@@ -7165,7 +7165,7 @@
                         </a:defRPr>
                       </a:pPr>
                       <a:r>
-                        <a:t>15%</a:t>
+                        <a:t>20%</a:t>
                       </a:r>
                     </a:p>
                   </a:txBody>
@@ -7188,7 +7188,7 @@
                         </a:defRPr>
                       </a:pPr>
                       <a:r>
-                        <a:t>Training allocation</a:t>
+                        <a:t>Scale absorption</a:t>
                       </a:r>
                     </a:p>
                   </a:txBody>
@@ -7211,7 +7211,7 @@
                         </a:defRPr>
                       </a:pPr>
                       <a:r>
-                        <a:t>training cadence, launch schedule, commercial serving ramp</a:t>
+                        <a:t>demand absorption and product surface expansion</a:t>
                       </a:r>
                     </a:p>
                   </a:txBody>
@@ -7236,7 +7236,7 @@
                         </a:defRPr>
                       </a:pPr>
                       <a:r>
-                        <a:t>Meta</a:t>
+                        <a:t>Google</a:t>
                       </a:r>
                     </a:p>
                   </a:txBody>
@@ -7259,7 +7259,7 @@
                         </a:defRPr>
                       </a:pPr>
                       <a:r>
-                        <a:t>0.43</a:t>
+                        <a:t>0.23</a:t>
                       </a:r>
                     </a:p>
                   </a:txBody>
@@ -7282,7 +7282,7 @@
                         </a:defRPr>
                       </a:pPr>
                       <a:r>
-                        <a:t>3.3</a:t>
+                        <a:t>3.7</a:t>
                       </a:r>
                     </a:p>
                   </a:txBody>
@@ -7305,7 +7305,7 @@
                         </a:defRPr>
                       </a:pPr>
                       <a:r>
-                        <a:t>17%</a:t>
+                        <a:t>15%</a:t>
                       </a:r>
                     </a:p>
                   </a:txBody>
@@ -7328,7 +7328,7 @@
                         </a:defRPr>
                       </a:pPr>
                       <a:r>
-                        <a:t>Scale absorption</a:t>
+                        <a:t>Training allocation</a:t>
                       </a:r>
                     </a:p>
                   </a:txBody>
@@ -7351,7 +7351,7 @@
                         </a:defRPr>
                       </a:pPr>
                       <a:r>
-                        <a:t>demand absorption and product surface expansion</a:t>
+                        <a:t>training cadence, launch schedule, commercial serving ramp</a:t>
                       </a:r>
                     </a:p>
                   </a:txBody>
@@ -7511,7 +7511,7 @@
               </a:defRPr>
             </a:pPr>
             <a:r>
-              <a:t>2026-05-26</a:t>
+              <a:t>2026-05-27</a:t>
             </a:r>
           </a:p>
         </p:txBody>
@@ -7687,7 +7687,7 @@
               </a:defRPr>
             </a:pPr>
             <a:r>
-              <a:t>Bull and Bear cases are not alternate stories; they are operating ranges around deployment, inference mix, MoE optimization, and utilization.</a:t>
+              <a:t>Bull and Bear cases move operational deployment and inference allocation only; TPS/MW is held to the selected benchmark proxy.</a:t>
             </a:r>
           </a:p>
         </p:txBody>
@@ -7945,7 +7945,7 @@
                         </a:defRPr>
                       </a:pPr>
                       <a:r>
-                        <a:t>1.53</a:t>
+                        <a:t>0.85</a:t>
                       </a:r>
                     </a:p>
                   </a:txBody>
@@ -8039,7 +8039,7 @@
                         </a:defRPr>
                       </a:pPr>
                       <a:r>
-                        <a:t>2.93</a:t>
+                        <a:t>1.20</a:t>
                       </a:r>
                     </a:p>
                   </a:txBody>
@@ -8133,7 +8133,7 @@
                         </a:defRPr>
                       </a:pPr>
                       <a:r>
-                        <a:t>4.89</a:t>
+                        <a:t>1.56</a:t>
                       </a:r>
                     </a:p>
                   </a:txBody>
@@ -8277,7 +8277,7 @@
               </a:defRPr>
             </a:pPr>
             <a:r>
-              <a:t>MoE and serving-stack optimization</a:t>
+              <a:t>Selected benchmark TPS/MW held constant</a:t>
             </a:r>
           </a:p>
           <a:p>
@@ -8327,7 +8327,7 @@
               </a:defRPr>
             </a:pPr>
             <a:r>
-              <a:t>Base growth: 14.1x, 2026-2030</a:t>
+              <a:t>Base growth: 6.0x, 2026-2030</a:t>
             </a:r>
           </a:p>
         </p:txBody>
@@ -8477,7 +8477,7 @@
               </a:defRPr>
             </a:pPr>
             <a:r>
-              <a:t>2026-05-26</a:t>
+              <a:t>2026-05-27</a:t>
             </a:r>
           </a:p>
         </p:txBody>
@@ -9308,7 +9308,7 @@
               </a:defRPr>
             </a:pPr>
             <a:r>
-              <a:t>Workbook appendix: 02b number trace, 04 numeric accelerator mix, 05 efficiency bridge, formula assumptions, source registry, and InferenceX benchmark tables.</a:t>
+              <a:t>Workbook tabs: Logic, Benchmark Input, Inputs, Calculation, Output, Checks. Derived output cells use Excel formulas.</a:t>
             </a:r>
           </a:p>
         </p:txBody>
@@ -9388,7 +9388,7 @@
               </a:defRPr>
             </a:pPr>
             <a:r>
-              <a:t>Update the model by bottleneck type: deployment, allocation, architecture, efficiency, or demand absorption.</a:t>
+              <a:t>Update only visible inputs; the workbook recalculates token supply through the same core formula.</a:t>
             </a:r>
           </a:p>
         </p:txBody>
@@ -9458,7 +9458,7 @@
               </a:defRPr>
             </a:pPr>
             <a:r>
-              <a:t>2026-05-26</a:t>
+              <a:t>2026-05-27</a:t>
             </a:r>
           </a:p>
         </p:txBody>
@@ -10129,7 +10129,7 @@
               </a:defRPr>
             </a:pPr>
             <a:r>
-              <a:t>Top 3 providers account for 53% of modeled 2030 generated-token supply.</a:t>
+              <a:t>Top 3 providers account for 62% of modeled 2030 generated-token supply.</a:t>
             </a:r>
           </a:p>
         </p:txBody>
@@ -10314,7 +10314,7 @@
               </a:defRPr>
             </a:pPr>
             <a:r>
-              <a:t>2026-05-26</a:t>
+              <a:t>2026-05-27</a:t>
             </a:r>
           </a:p>
         </p:txBody>
@@ -11270,7 +11270,7 @@
               </a:defRPr>
             </a:pPr>
             <a:r>
-              <a:t>Output tokens/sec/MW x utilization</a:t>
+              <a:t>Selected output tokens/sec/MW</a:t>
             </a:r>
           </a:p>
         </p:txBody>
@@ -11305,7 +11305,7 @@
               </a:defRPr>
             </a:pPr>
             <a:r>
-              <a:t>generated output tokens/day = inference GW x 1,000 x output tokens/sec/MW x utilization x 86,400</a:t>
+              <a:t>generated output tokens/day = inference GW x 1,000 x selected output tokens/sec/MW x 86,400</a:t>
             </a:r>
           </a:p>
         </p:txBody>
@@ -11508,7 +11508,7 @@
               </a:defRPr>
             </a:pPr>
             <a:r>
-              <a:t>2026-05-26</a:t>
+              <a:t>2026-05-27</a:t>
             </a:r>
           </a:p>
         </p:txBody>
@@ -11942,7 +11942,7 @@
                         </a:defRPr>
                       </a:pPr>
                       <a:r>
-                        <a:t>0.59</a:t>
+                        <a:t>0.30</a:t>
                       </a:r>
                     </a:p>
                   </a:txBody>
@@ -12036,7 +12036,7 @@
                         </a:defRPr>
                       </a:pPr>
                       <a:r>
-                        <a:t>0.55</a:t>
+                        <a:t>0.23</a:t>
                       </a:r>
                     </a:p>
                   </a:txBody>
@@ -12107,7 +12107,7 @@
                         </a:defRPr>
                       </a:pPr>
                       <a:r>
-                        <a:t>Meta</a:t>
+                        <a:t>Microsoft</a:t>
                       </a:r>
                     </a:p>
                   </a:txBody>
@@ -12130,7 +12130,7 @@
                         </a:defRPr>
                       </a:pPr>
                       <a:r>
-                        <a:t>0.43</a:t>
+                        <a:t>0.21</a:t>
                       </a:r>
                     </a:p>
                   </a:txBody>
@@ -12176,7 +12176,7 @@
                         </a:defRPr>
                       </a:pPr>
                       <a:r>
-                        <a:t>5.8</a:t>
+                        <a:t>6.2</a:t>
                       </a:r>
                     </a:p>
                   </a:txBody>
@@ -12201,7 +12201,7 @@
                         </a:defRPr>
                       </a:pPr>
                       <a:r>
-                        <a:t>Microsoft</a:t>
+                        <a:t>Anthropic</a:t>
                       </a:r>
                     </a:p>
                   </a:txBody>
@@ -12224,7 +12224,7 @@
                         </a:defRPr>
                       </a:pPr>
                       <a:r>
-                        <a:t>0.39</a:t>
+                        <a:t>0.19</a:t>
                       </a:r>
                     </a:p>
                   </a:txBody>
@@ -12247,7 +12247,7 @@
                         </a:defRPr>
                       </a:pPr>
                       <a:r>
-                        <a:t>3.3</a:t>
+                        <a:t>3.0</a:t>
                       </a:r>
                     </a:p>
                   </a:txBody>
@@ -12270,7 +12270,7 @@
                         </a:defRPr>
                       </a:pPr>
                       <a:r>
-                        <a:t>6.2</a:t>
+                        <a:t>5.5</a:t>
                       </a:r>
                     </a:p>
                   </a:txBody>
@@ -12295,7 +12295,7 @@
                         </a:defRPr>
                       </a:pPr>
                       <a:r>
-                        <a:t>Anthropic</a:t>
+                        <a:t>Tencent</a:t>
                       </a:r>
                     </a:p>
                   </a:txBody>
@@ -12318,7 +12318,7 @@
                         </a:defRPr>
                       </a:pPr>
                       <a:r>
-                        <a:t>0.33</a:t>
+                        <a:t>0.08</a:t>
                       </a:r>
                     </a:p>
                   </a:txBody>
@@ -12341,7 +12341,7 @@
                         </a:defRPr>
                       </a:pPr>
                       <a:r>
-                        <a:t>3.0</a:t>
+                        <a:t>1.3</a:t>
                       </a:r>
                     </a:p>
                   </a:txBody>
@@ -12364,7 +12364,7 @@
                         </a:defRPr>
                       </a:pPr>
                       <a:r>
-                        <a:t>5.5</a:t>
+                        <a:t>2.4</a:t>
                       </a:r>
                     </a:p>
                   </a:txBody>
@@ -12444,7 +12444,7 @@
               </a:defRPr>
             </a:pPr>
             <a:r>
-              <a:t>53%</a:t>
+              <a:t>62%</a:t>
             </a:r>
           </a:p>
         </p:txBody>
@@ -12629,7 +12629,7 @@
               </a:defRPr>
             </a:pPr>
             <a:r>
-              <a:t>2026-05-26</a:t>
+              <a:t>2026-05-27</a:t>
             </a:r>
           </a:p>
         </p:txBody>
@@ -13087,7 +13087,7 @@
                         </a:defRPr>
                       </a:pPr>
                       <a:r>
-                        <a:t>0.03</a:t>
+                        <a:t>0.04</a:t>
                       </a:r>
                     </a:p>
                   </a:txBody>
@@ -13110,7 +13110,7 @@
                         </a:defRPr>
                       </a:pPr>
                       <a:r>
-                        <a:t>0.20</a:t>
+                        <a:t>0.15</a:t>
                       </a:r>
                     </a:p>
                   </a:txBody>
@@ -13133,7 +13133,7 @@
                         </a:defRPr>
                       </a:pPr>
                       <a:r>
-                        <a:t>0.59</a:t>
+                        <a:t>0.30</a:t>
                       </a:r>
                     </a:p>
                   </a:txBody>
@@ -13156,7 +13156,7 @@
                         </a:defRPr>
                       </a:pPr>
                       <a:r>
-                        <a:t>19.1x</a:t>
+                        <a:t>8.2x</a:t>
                       </a:r>
                     </a:p>
                   </a:txBody>
@@ -13204,7 +13204,7 @@
                         </a:defRPr>
                       </a:pPr>
                       <a:r>
-                        <a:t>0.05</a:t>
+                        <a:t>0.06</a:t>
                       </a:r>
                     </a:p>
                   </a:txBody>
@@ -13227,7 +13227,7 @@
                         </a:defRPr>
                       </a:pPr>
                       <a:r>
-                        <a:t>0.20</a:t>
+                        <a:t>0.13</a:t>
                       </a:r>
                     </a:p>
                   </a:txBody>
@@ -13250,7 +13250,7 @@
                         </a:defRPr>
                       </a:pPr>
                       <a:r>
-                        <a:t>0.55</a:t>
+                        <a:t>0.23</a:t>
                       </a:r>
                     </a:p>
                   </a:txBody>
@@ -13273,7 +13273,7 @@
                         </a:defRPr>
                       </a:pPr>
                       <a:r>
-                        <a:t>10.0x</a:t>
+                        <a:t>4.0x</a:t>
                       </a:r>
                     </a:p>
                   </a:txBody>
@@ -13298,7 +13298,7 @@
                         </a:defRPr>
                       </a:pPr>
                       <a:r>
-                        <a:t>Meta</a:t>
+                        <a:t>Microsoft</a:t>
                       </a:r>
                     </a:p>
                   </a:txBody>
@@ -13344,7 +13344,7 @@
                         </a:defRPr>
                       </a:pPr>
                       <a:r>
-                        <a:t>0.15</a:t>
+                        <a:t>0.12</a:t>
                       </a:r>
                     </a:p>
                   </a:txBody>
@@ -13367,7 +13367,7 @@
                         </a:defRPr>
                       </a:pPr>
                       <a:r>
-                        <a:t>0.43</a:t>
+                        <a:t>0.21</a:t>
                       </a:r>
                     </a:p>
                   </a:txBody>
@@ -13390,7 +13390,7 @@
                         </a:defRPr>
                       </a:pPr>
                       <a:r>
-                        <a:t>11.9x</a:t>
+                        <a:t>4.7x</a:t>
                       </a:r>
                     </a:p>
                   </a:txBody>
@@ -13415,7 +13415,7 @@
                         </a:defRPr>
                       </a:pPr>
                       <a:r>
-                        <a:t>Microsoft</a:t>
+                        <a:t>Anthropic</a:t>
                       </a:r>
                     </a:p>
                   </a:txBody>
@@ -13438,7 +13438,7 @@
                         </a:defRPr>
                       </a:pPr>
                       <a:r>
-                        <a:t>0.03</a:t>
+                        <a:t>0.02</a:t>
                       </a:r>
                     </a:p>
                   </a:txBody>
@@ -13461,7 +13461,7 @@
                         </a:defRPr>
                       </a:pPr>
                       <a:r>
-                        <a:t>0.14</a:t>
+                        <a:t>0.09</a:t>
                       </a:r>
                     </a:p>
                   </a:txBody>
@@ -13484,7 +13484,7 @@
                         </a:defRPr>
                       </a:pPr>
                       <a:r>
-                        <a:t>0.39</a:t>
+                        <a:t>0.19</a:t>
                       </a:r>
                     </a:p>
                   </a:txBody>
@@ -13507,7 +13507,7 @@
                         </a:defRPr>
                       </a:pPr>
                       <a:r>
-                        <a:t>11.3x</a:t>
+                        <a:t>7.8x</a:t>
                       </a:r>
                     </a:p>
                   </a:txBody>
@@ -13532,7 +13532,7 @@
                         </a:defRPr>
                       </a:pPr>
                       <a:r>
-                        <a:t>Anthropic</a:t>
+                        <a:t>Tencent</a:t>
                       </a:r>
                     </a:p>
                   </a:txBody>
@@ -13555,7 +13555,7 @@
                         </a:defRPr>
                       </a:pPr>
                       <a:r>
-                        <a:t>0.02</a:t>
+                        <a:t>0.01</a:t>
                       </a:r>
                     </a:p>
                   </a:txBody>
@@ -13578,7 +13578,7 @@
                         </a:defRPr>
                       </a:pPr>
                       <a:r>
-                        <a:t>0.11</a:t>
+                        <a:t>0.04</a:t>
                       </a:r>
                     </a:p>
                   </a:txBody>
@@ -13601,7 +13601,7 @@
                         </a:defRPr>
                       </a:pPr>
                       <a:r>
-                        <a:t>0.33</a:t>
+                        <a:t>0.08</a:t>
                       </a:r>
                     </a:p>
                   </a:txBody>
@@ -13624,7 +13624,7 @@
                         </a:defRPr>
                       </a:pPr>
                       <a:r>
-                        <a:t>18.4x</a:t>
+                        <a:t>7.1x</a:t>
                       </a:r>
                     </a:p>
                   </a:txBody>
@@ -13649,7 +13649,7 @@
                         </a:defRPr>
                       </a:pPr>
                       <a:r>
-                        <a:t>Alibaba</a:t>
+                        <a:t>Meta</a:t>
                       </a:r>
                     </a:p>
                   </a:txBody>
@@ -13695,7 +13695,7 @@
                         </a:defRPr>
                       </a:pPr>
                       <a:r>
-                        <a:t>0.09</a:t>
+                        <a:t>0.04</a:t>
                       </a:r>
                     </a:p>
                   </a:txBody>
@@ -13718,7 +13718,7 @@
                         </a:defRPr>
                       </a:pPr>
                       <a:r>
-                        <a:t>0.26</a:t>
+                        <a:t>0.08</a:t>
                       </a:r>
                     </a:p>
                   </a:txBody>
@@ -13741,7 +13741,7 @@
                         </a:defRPr>
                       </a:pPr>
                       <a:r>
-                        <a:t>16.1x</a:t>
+                        <a:t>4.9x</a:t>
                       </a:r>
                     </a:p>
                   </a:txBody>
@@ -13766,7 +13766,7 @@
                         </a:defRPr>
                       </a:pPr>
                       <a:r>
-                        <a:t>Tencent</a:t>
+                        <a:t>xAI</a:t>
                       </a:r>
                     </a:p>
                   </a:txBody>
@@ -13812,7 +13812,7 @@
                         </a:defRPr>
                       </a:pPr>
                       <a:r>
-                        <a:t>0.06</a:t>
+                        <a:t>0.04</a:t>
                       </a:r>
                     </a:p>
                   </a:txBody>
@@ -13835,7 +13835,7 @@
                         </a:defRPr>
                       </a:pPr>
                       <a:r>
-                        <a:t>0.17</a:t>
+                        <a:t>0.08</a:t>
                       </a:r>
                     </a:p>
                   </a:txBody>
@@ -13858,7 +13858,7 @@
                         </a:defRPr>
                       </a:pPr>
                       <a:r>
-                        <a:t>16.9x</a:t>
+                        <a:t>11.1x</a:t>
                       </a:r>
                     </a:p>
                   </a:txBody>
@@ -13883,7 +13883,7 @@
                         </a:defRPr>
                       </a:pPr>
                       <a:r>
-                        <a:t>xAI</a:t>
+                        <a:t>Alibaba</a:t>
                       </a:r>
                     </a:p>
                   </a:txBody>
@@ -13929,7 +13929,7 @@
                         </a:defRPr>
                       </a:pPr>
                       <a:r>
-                        <a:t>0.04</a:t>
+                        <a:t>0.01</a:t>
                       </a:r>
                     </a:p>
                   </a:txBody>
@@ -13952,7 +13952,7 @@
                         </a:defRPr>
                       </a:pPr>
                       <a:r>
-                        <a:t>0.13</a:t>
+                        <a:t>0.03</a:t>
                       </a:r>
                     </a:p>
                   </a:txBody>
@@ -13975,7 +13975,7 @@
                         </a:defRPr>
                       </a:pPr>
                       <a:r>
-                        <a:t>27.8x</a:t>
+                        <a:t>6.6x</a:t>
                       </a:r>
                     </a:p>
                   </a:txBody>
@@ -14046,7 +14046,7 @@
                         </a:defRPr>
                       </a:pPr>
                       <a:r>
-                        <a:t>0.03</a:t>
+                        <a:t>0.00</a:t>
                       </a:r>
                     </a:p>
                   </a:txBody>
@@ -14069,7 +14069,7 @@
                         </a:defRPr>
                       </a:pPr>
                       <a:r>
-                        <a:t>0.10</a:t>
+                        <a:t>0.01</a:t>
                       </a:r>
                     </a:p>
                   </a:txBody>
@@ -14092,7 +14092,7 @@
                         </a:defRPr>
                       </a:pPr>
                       <a:r>
-                        <a:t>28.4x</a:t>
+                        <a:t>10.7x</a:t>
                       </a:r>
                     </a:p>
                   </a:txBody>
@@ -14252,7 +14252,7 @@
               </a:defRPr>
             </a:pPr>
             <a:r>
-              <a:t>2026-05-26</a:t>
+              <a:t>2026-05-27</a:t>
             </a:r>
           </a:p>
         </p:txBody>
@@ -14428,7 +14428,7 @@
               </a:defRPr>
             </a:pPr>
             <a:r>
-              <a:t>If token supply rises faster than inference GW, the driver is serving efficiency or utilization; if both rise together, deployment is the driver.</a:t>
+              <a:t>The core model changes token supply through operational inference GW; TPS/MW is held to the selected InferenceX proxy unless explicitly stress-tested.</a:t>
             </a:r>
           </a:p>
         </p:txBody>
@@ -14921,7 +14921,7 @@
                         </a:defRPr>
                       </a:pPr>
                       <a:r>
-                        <a:t>Meta</a:t>
+                        <a:t>Microsoft</a:t>
                       </a:r>
                     </a:p>
                   </a:txBody>
@@ -14967,7 +14967,7 @@
                         </a:defRPr>
                       </a:pPr>
                       <a:r>
-                        <a:t>1.8</a:t>
+                        <a:t>1.9</a:t>
                       </a:r>
                     </a:p>
                   </a:txBody>
@@ -15013,7 +15013,7 @@
                         </a:defRPr>
                       </a:pPr>
                       <a:r>
-                        <a:t>78%</a:t>
+                        <a:t>75%</a:t>
                       </a:r>
                     </a:p>
                   </a:txBody>
@@ -15038,7 +15038,7 @@
                         </a:defRPr>
                       </a:pPr>
                       <a:r>
-                        <a:t>Microsoft</a:t>
+                        <a:t>Anthropic</a:t>
                       </a:r>
                     </a:p>
                   </a:txBody>
@@ -15061,7 +15061,7 @@
                         </a:defRPr>
                       </a:pPr>
                       <a:r>
-                        <a:t>0.7</a:t>
+                        <a:t>0.4</a:t>
                       </a:r>
                     </a:p>
                   </a:txBody>
@@ -15084,7 +15084,7 @@
                         </a:defRPr>
                       </a:pPr>
                       <a:r>
-                        <a:t>1.9</a:t>
+                        <a:t>1.5</a:t>
                       </a:r>
                     </a:p>
                   </a:txBody>
@@ -15107,7 +15107,7 @@
                         </a:defRPr>
                       </a:pPr>
                       <a:r>
-                        <a:t>3.3</a:t>
+                        <a:t>3.0</a:t>
                       </a:r>
                     </a:p>
                   </a:txBody>
@@ -15130,7 +15130,7 @@
                         </a:defRPr>
                       </a:pPr>
                       <a:r>
-                        <a:t>75%</a:t>
+                        <a:t>74%</a:t>
                       </a:r>
                     </a:p>
                   </a:txBody>
@@ -15155,7 +15155,7 @@
                         </a:defRPr>
                       </a:pPr>
                       <a:r>
-                        <a:t>Anthropic</a:t>
+                        <a:t>Tencent</a:t>
                       </a:r>
                     </a:p>
                   </a:txBody>
@@ -15178,7 +15178,7 @@
                         </a:defRPr>
                       </a:pPr>
                       <a:r>
-                        <a:t>0.4</a:t>
+                        <a:t>0.2</a:t>
                       </a:r>
                     </a:p>
                   </a:txBody>
@@ -15201,7 +15201,7 @@
                         </a:defRPr>
                       </a:pPr>
                       <a:r>
-                        <a:t>1.5</a:t>
+                        <a:t>0.7</a:t>
                       </a:r>
                     </a:p>
                   </a:txBody>
@@ -15224,7 +15224,7 @@
                         </a:defRPr>
                       </a:pPr>
                       <a:r>
-                        <a:t>3.0</a:t>
+                        <a:t>1.3</a:t>
                       </a:r>
                     </a:p>
                   </a:txBody>
@@ -15247,7 +15247,7 @@
                         </a:defRPr>
                       </a:pPr>
                       <a:r>
-                        <a:t>74%</a:t>
+                        <a:t>80%</a:t>
                       </a:r>
                     </a:p>
                   </a:txBody>
@@ -15272,7 +15272,7 @@
                         </a:defRPr>
                       </a:pPr>
                       <a:r>
-                        <a:t>Alibaba</a:t>
+                        <a:t>Meta</a:t>
                       </a:r>
                     </a:p>
                   </a:txBody>
@@ -15295,7 +15295,7 @@
                         </a:defRPr>
                       </a:pPr>
                       <a:r>
-                        <a:t>0.3</a:t>
+                        <a:t>0.7</a:t>
                       </a:r>
                     </a:p>
                   </a:txBody>
@@ -15318,7 +15318,7 @@
                         </a:defRPr>
                       </a:pPr>
                       <a:r>
-                        <a:t>0.9</a:t>
+                        <a:t>1.8</a:t>
                       </a:r>
                     </a:p>
                   </a:txBody>
@@ -15341,7 +15341,7 @@
                         </a:defRPr>
                       </a:pPr>
                       <a:r>
-                        <a:t>1.7</a:t>
+                        <a:t>3.3</a:t>
                       </a:r>
                     </a:p>
                   </a:txBody>
@@ -15364,7 +15364,7 @@
                         </a:defRPr>
                       </a:pPr>
                       <a:r>
-                        <a:t>80%</a:t>
+                        <a:t>78%</a:t>
                       </a:r>
                     </a:p>
                   </a:txBody>
@@ -15389,7 +15389,7 @@
                         </a:defRPr>
                       </a:pPr>
                       <a:r>
-                        <a:t>Tencent</a:t>
+                        <a:t>xAI</a:t>
                       </a:r>
                     </a:p>
                   </a:txBody>
@@ -15412,7 +15412,7 @@
                         </a:defRPr>
                       </a:pPr>
                       <a:r>
-                        <a:t>0.2</a:t>
+                        <a:t>0.1</a:t>
                       </a:r>
                     </a:p>
                   </a:txBody>
@@ -15435,7 +15435,7 @@
                         </a:defRPr>
                       </a:pPr>
                       <a:r>
-                        <a:t>0.7</a:t>
+                        <a:t>0.6</a:t>
                       </a:r>
                     </a:p>
                   </a:txBody>
@@ -15458,7 +15458,7 @@
                         </a:defRPr>
                       </a:pPr>
                       <a:r>
-                        <a:t>1.3</a:t>
+                        <a:t>1.2</a:t>
                       </a:r>
                     </a:p>
                   </a:txBody>
@@ -15481,7 +15481,7 @@
                         </a:defRPr>
                       </a:pPr>
                       <a:r>
-                        <a:t>80%</a:t>
+                        <a:t>70%</a:t>
                       </a:r>
                     </a:p>
                   </a:txBody>
@@ -15506,7 +15506,7 @@
                         </a:defRPr>
                       </a:pPr>
                       <a:r>
-                        <a:t>xAI</a:t>
+                        <a:t>Alibaba</a:t>
                       </a:r>
                     </a:p>
                   </a:txBody>
@@ -15529,7 +15529,7 @@
                         </a:defRPr>
                       </a:pPr>
                       <a:r>
-                        <a:t>0.1</a:t>
+                        <a:t>0.3</a:t>
                       </a:r>
                     </a:p>
                   </a:txBody>
@@ -15552,7 +15552,7 @@
                         </a:defRPr>
                       </a:pPr>
                       <a:r>
-                        <a:t>0.6</a:t>
+                        <a:t>0.9</a:t>
                       </a:r>
                     </a:p>
                   </a:txBody>
@@ -15575,7 +15575,7 @@
                         </a:defRPr>
                       </a:pPr>
                       <a:r>
-                        <a:t>1.2</a:t>
+                        <a:t>1.7</a:t>
                       </a:r>
                     </a:p>
                   </a:txBody>
@@ -15598,7 +15598,7 @@
                         </a:defRPr>
                       </a:pPr>
                       <a:r>
-                        <a:t>70%</a:t>
+                        <a:t>80%</a:t>
                       </a:r>
                     </a:p>
                   </a:txBody>
@@ -15875,7 +15875,7 @@
               </a:defRPr>
             </a:pPr>
             <a:r>
-              <a:t>2026-05-26</a:t>
+              <a:t>2026-05-27</a:t>
             </a:r>
           </a:p>
         </p:txBody>
@@ -16738,7 +16738,7 @@
               </a:defRPr>
             </a:pPr>
             <a:r>
-              <a:t>2026-05-26</a:t>
+              <a:t>2026-05-27</a:t>
             </a:r>
           </a:p>
         </p:txBody>
@@ -17337,7 +17337,7 @@
                         </a:defRPr>
                       </a:pPr>
                       <a:r>
-                        <a:t>Meta</a:t>
+                        <a:t>Microsoft</a:t>
                       </a:r>
                     </a:p>
                   </a:txBody>
@@ -17383,7 +17383,7 @@
                         </a:defRPr>
                       </a:pPr>
                       <a:r>
-                        <a:t>0.9</a:t>
+                        <a:t>1.1</a:t>
                       </a:r>
                     </a:p>
                   </a:txBody>
@@ -17406,7 +17406,7 @@
                         </a:defRPr>
                       </a:pPr>
                       <a:r>
-                        <a:t>78%</a:t>
+                        <a:t>75%</a:t>
                       </a:r>
                     </a:p>
                   </a:txBody>
@@ -17431,7 +17431,7 @@
                         </a:defRPr>
                       </a:pPr>
                       <a:r>
-                        <a:t>Microsoft</a:t>
+                        <a:t>Anthropic</a:t>
                       </a:r>
                     </a:p>
                   </a:txBody>
@@ -17454,7 +17454,7 @@
                         </a:defRPr>
                       </a:pPr>
                       <a:r>
-                        <a:t>3.3</a:t>
+                        <a:t>3.0</a:t>
                       </a:r>
                     </a:p>
                   </a:txBody>
@@ -17477,7 +17477,7 @@
                         </a:defRPr>
                       </a:pPr>
                       <a:r>
-                        <a:t>1.1</a:t>
+                        <a:t>1.0</a:t>
                       </a:r>
                     </a:p>
                   </a:txBody>
@@ -17500,7 +17500,7 @@
                         </a:defRPr>
                       </a:pPr>
                       <a:r>
-                        <a:t>75%</a:t>
+                        <a:t>74%</a:t>
                       </a:r>
                     </a:p>
                   </a:txBody>
@@ -17525,7 +17525,7 @@
                         </a:defRPr>
                       </a:pPr>
                       <a:r>
-                        <a:t>Anthropic</a:t>
+                        <a:t>Tencent</a:t>
                       </a:r>
                     </a:p>
                   </a:txBody>
@@ -17548,7 +17548,7 @@
                         </a:defRPr>
                       </a:pPr>
                       <a:r>
-                        <a:t>3.0</a:t>
+                        <a:t>1.3</a:t>
                       </a:r>
                     </a:p>
                   </a:txBody>
@@ -17571,7 +17571,7 @@
                         </a:defRPr>
                       </a:pPr>
                       <a:r>
-                        <a:t>1.0</a:t>
+                        <a:t>0.3</a:t>
                       </a:r>
                     </a:p>
                   </a:txBody>
@@ -17594,7 +17594,7 @@
                         </a:defRPr>
                       </a:pPr>
                       <a:r>
-                        <a:t>74%</a:t>
+                        <a:t>80%</a:t>
                       </a:r>
                     </a:p>
                   </a:txBody>
@@ -17789,7 +17789,7 @@
               </a:defRPr>
             </a:pPr>
             <a:r>
-              <a:t>2026-05-26</a:t>
+              <a:t>2026-05-27</a:t>
             </a:r>
           </a:p>
         </p:txBody>
@@ -17930,7 +17930,7 @@
               </a:defRPr>
             </a:pPr>
             <a:r>
-              <a:t>The third constraint is serving efficiency: tokens per MW and real utilization</a:t>
+              <a:t>The third input is a transparent InferenceX output-token TPS/MW selection</a:t>
             </a:r>
           </a:p>
         </p:txBody>
@@ -17965,7 +17965,7 @@
               </a:defRPr>
             </a:pPr>
             <a:r>
-              <a:t>InferenceX and model architecture assumptions are used to calibrate the conversion from inference GW to output tokens.</a:t>
+              <a:t>A fixed B200, single_turn, ISL/OSL 1024/1024 output-throughput median is selected by proxy model; no hidden uplift is applied.</a:t>
             </a:r>
           </a:p>
         </p:txBody>
@@ -18063,7 +18063,7 @@
               </a:defRPr>
             </a:pPr>
             <a:r>
-              <a:t>Lowest tokens/MW and utilization</a:t>
+              <a:t>Selected proxy mapping</a:t>
             </a:r>
           </a:p>
         </p:txBody>
@@ -18078,7 +18078,7 @@
         </p:nvGraphicFramePr>
         <p:xfrm>
           <a:off x="7479792" y="2103120"/>
-          <a:ext cx="3694176" cy="2148840"/>
+          <a:ext cx="3703320" cy="2148840"/>
         </p:xfrm>
         <a:graphic>
           <a:graphicData uri="http://schemas.openxmlformats.org/drawingml/2006/table">
@@ -18087,10 +18087,10 @@
                 <a:tableStyleId>{5C22544A-7EE6-4342-B048-85BDC9FD1C3A}</a:tableStyleId>
               </a:tblPr>
               <a:tblGrid>
-                <a:gridCol w="1097280"/>
+                <a:gridCol w="960120"/>
                 <a:gridCol w="914400"/>
-                <a:gridCol w="566928"/>
-                <a:gridCol w="1115568"/>
+                <a:gridCol w="914400"/>
+                <a:gridCol w="914400"/>
               </a:tblGrid>
               <a:tr h="358140">
                 <a:tc>
@@ -18129,30 +18129,30 @@
                         </a:defRPr>
                       </a:pPr>
                       <a:r>
+                        <a:t>Proxy</a:t>
+                      </a:r>
+                    </a:p>
+                  </a:txBody>
+                  <a:tcPr marL="50292" marR="50292" marT="32004" marB="32004">
+                    <a:solidFill>
+                      <a:srgbClr val="1428A0"/>
+                    </a:solidFill>
+                  </a:tcPr>
+                </a:tc>
+                <a:tc>
+                  <a:txBody>
+                    <a:bodyPr/>
+                    <a:lstStyle/>
+                    <a:p>
+                      <a:pPr>
+                        <a:defRPr sz="819" b="1">
+                          <a:solidFill>
+                            <a:srgbClr val="FFFFFF"/>
+                          </a:solidFill>
+                        </a:defRPr>
+                      </a:pPr>
+                      <a:r>
                         <a:t>M tok/s/MW</a:t>
-                      </a:r>
-                    </a:p>
-                  </a:txBody>
-                  <a:tcPr marL="50292" marR="50292" marT="32004" marB="32004">
-                    <a:solidFill>
-                      <a:srgbClr val="1428A0"/>
-                    </a:solidFill>
-                  </a:tcPr>
-                </a:tc>
-                <a:tc>
-                  <a:txBody>
-                    <a:bodyPr/>
-                    <a:lstStyle/>
-                    <a:p>
-                      <a:pPr>
-                        <a:defRPr sz="819" b="1">
-                          <a:solidFill>
-                            <a:srgbClr val="FFFFFF"/>
-                          </a:solidFill>
-                        </a:defRPr>
-                      </a:pPr>
-                      <a:r>
-                        <a:t>Util.</a:t>
                       </a:r>
                     </a:p>
                   </a:txBody>
@@ -18200,7 +18200,7 @@
                         </a:defRPr>
                       </a:pPr>
                       <a:r>
-                        <a:t>xAI</a:t>
+                        <a:t>DeepSeek</a:t>
                       </a:r>
                     </a:p>
                   </a:txBody>
@@ -18223,7 +18223,7 @@
                         </a:defRPr>
                       </a:pPr>
                       <a:r>
-                        <a:t>1.8</a:t>
+                        <a:t>dsr1</a:t>
                       </a:r>
                     </a:p>
                   </a:txBody>
@@ -18246,7 +18246,7 @@
                         </a:defRPr>
                       </a:pPr>
                       <a:r>
-                        <a:t>67%</a:t>
+                        <a:t>0.10</a:t>
                       </a:r>
                     </a:p>
                   </a:txBody>
@@ -18269,7 +18269,7 @@
                         </a:defRPr>
                       </a:pPr>
                       <a:r>
-                        <a:t>Training allocation</a:t>
+                        <a:t>Deployment gap</a:t>
                       </a:r>
                     </a:p>
                   </a:txBody>
@@ -18294,7 +18294,7 @@
                         </a:defRPr>
                       </a:pPr>
                       <a:r>
-                        <a:t>Anthropic</a:t>
+                        <a:t>Alibaba</a:t>
                       </a:r>
                     </a:p>
                   </a:txBody>
@@ -18317,7 +18317,7 @@
                         </a:defRPr>
                       </a:pPr>
                       <a:r>
-                        <a:t>1.8</a:t>
+                        <a:t>qwen3.5</a:t>
                       </a:r>
                     </a:p>
                   </a:txBody>
@@ -18340,7 +18340,7 @@
                         </a:defRPr>
                       </a:pPr>
                       <a:r>
-                        <a:t>70%</a:t>
+                        <a:t>0.18</a:t>
                       </a:r>
                     </a:p>
                   </a:txBody>
@@ -18363,7 +18363,7 @@
                         </a:defRPr>
                       </a:pPr>
                       <a:r>
-                        <a:t>Training allocation</a:t>
+                        <a:t>Serving efficiency</a:t>
                       </a:r>
                     </a:p>
                   </a:txBody>
@@ -18388,7 +18388,7 @@
                         </a:defRPr>
                       </a:pPr>
                       <a:r>
-                        <a:t>OpenAI</a:t>
+                        <a:t>Meta</a:t>
                       </a:r>
                     </a:p>
                   </a:txBody>
@@ -18411,7 +18411,7 @@
                         </a:defRPr>
                       </a:pPr>
                       <a:r>
-                        <a:t>2.0</a:t>
+                        <a:t>llama70b</a:t>
                       </a:r>
                     </a:p>
                   </a:txBody>
@@ -18434,7 +18434,7 @@
                         </a:defRPr>
                       </a:pPr>
                       <a:r>
-                        <a:t>71%</a:t>
+                        <a:t>0.28</a:t>
                       </a:r>
                     </a:p>
                   </a:txBody>
@@ -18482,7 +18482,7 @@
                         </a:defRPr>
                       </a:pPr>
                       <a:r>
-                        <a:t>Microsoft</a:t>
+                        <a:t>OpenAI</a:t>
                       </a:r>
                     </a:p>
                   </a:txBody>
@@ -18505,7 +18505,7 @@
                         </a:defRPr>
                       </a:pPr>
                       <a:r>
-                        <a:t>2.0</a:t>
+                        <a:t>gptoss120b</a:t>
                       </a:r>
                     </a:p>
                   </a:txBody>
@@ -18528,7 +18528,7 @@
                         </a:defRPr>
                       </a:pPr>
                       <a:r>
-                        <a:t>68%</a:t>
+                        <a:t>0.72</a:t>
                       </a:r>
                     </a:p>
                   </a:txBody>
@@ -18551,7 +18551,7 @@
                         </a:defRPr>
                       </a:pPr>
                       <a:r>
-                        <a:t>Training allocation</a:t>
+                        <a:t>Scale absorption</a:t>
                       </a:r>
                     </a:p>
                   </a:txBody>
@@ -18576,7 +18576,7 @@
                         </a:defRPr>
                       </a:pPr>
                       <a:r>
-                        <a:t>Meta</a:t>
+                        <a:t>Google</a:t>
                       </a:r>
                     </a:p>
                   </a:txBody>
@@ -18599,7 +18599,7 @@
                         </a:defRPr>
                       </a:pPr>
                       <a:r>
-                        <a:t>2.2</a:t>
+                        <a:t>gptoss120b</a:t>
                       </a:r>
                     </a:p>
                   </a:txBody>
@@ -18622,7 +18622,7 @@
                         </a:defRPr>
                       </a:pPr>
                       <a:r>
-                        <a:t>70%</a:t>
+                        <a:t>0.72</a:t>
                       </a:r>
                     </a:p>
                   </a:txBody>
@@ -18645,7 +18645,7 @@
                         </a:defRPr>
                       </a:pPr>
                       <a:r>
-                        <a:t>Scale absorption</a:t>
+                        <a:t>Training allocation</a:t>
                       </a:r>
                     </a:p>
                   </a:txBody>
@@ -18690,7 +18690,7 @@
               </a:defRPr>
             </a:pPr>
             <a:r>
-              <a:t>Low utilization can reflect reserve capacity, SLO headroom, uneven traffic, and failover requirements.</a:t>
+              <a:t>Purpose-built accelerator mix is visible, but no efficiency uplift is applied until a comparable output-token benchmark exists.</a:t>
             </a:r>
           </a:p>
         </p:txBody>
@@ -18770,7 +18770,7 @@
               </a:defRPr>
             </a:pPr>
             <a:r>
-              <a:t>Tokens/MW sets the theoretical ceiling; utilization determines how much of that ceiling becomes supply.</a:t>
+              <a:t>Selected TPS/MW is a readable benchmark proxy, not a compounded estimate.</a:t>
             </a:r>
           </a:p>
         </p:txBody>
@@ -18840,7 +18840,7 @@
               </a:defRPr>
             </a:pPr>
             <a:r>
-              <a:t>2026-05-26</a:t>
+              <a:t>2026-05-27</a:t>
             </a:r>
           </a:p>
         </p:txBody>

</xml_diff>

<commit_message>
Adjust token benchmark to commercial workload fit
</commit_message>
<xml_diff>
--- a/llm_token_capacity_project/outputs/reports/llm_token_capacity_2026_2030.pptx
+++ b/llm_token_capacity_project/outputs/reports/llm_token_capacity_2026_2030.pptx
@@ -159,10 +159,10 @@
                   <c:v>Anthropic</c:v>
                 </c:pt>
                 <c:pt idx="4">
+                  <c:v>Meta</c:v>
+                </c:pt>
+                <c:pt idx="5">
                   <c:v>Tencent</c:v>
-                </c:pt>
-                <c:pt idx="5">
-                  <c:v>Meta</c:v>
                 </c:pt>
                 <c:pt idx="6">
                   <c:v>xAI</c:v>
@@ -183,31 +183,31 @@
                 <c:formatCode>General</c:formatCode>
                 <c:ptCount val="9"/>
                 <c:pt idx="0">
-                  <c:v>0.304530475392</c:v>
+                  <c:v>0.152265237696</c:v>
                 </c:pt>
                 <c:pt idx="1">
-                  <c:v>0.228679713216</c:v>
+                  <c:v>0.1372078279296</c:v>
                 </c:pt>
                 <c:pt idx="2">
-                  <c:v>0.208761841728</c:v>
+                  <c:v>0.1252571050368</c:v>
                 </c:pt>
                 <c:pt idx="3">
-                  <c:v>0.185774864256</c:v>
+                  <c:v>0.092887432128</c:v>
                 </c:pt>
                 <c:pt idx="4">
-                  <c:v>0.082114243776</c:v>
+                  <c:v>0.072144235008</c:v>
                 </c:pt>
                 <c:pt idx="5">
-                  <c:v>0.08016026112</c:v>
+                  <c:v>0.0492685462656</c:v>
                 </c:pt>
                 <c:pt idx="6">
-                  <c:v>0.076351840704</c:v>
+                  <c:v>0.0419935123872</c:v>
                 </c:pt>
                 <c:pt idx="7">
-                  <c:v>0.027055767744</c:v>
+                  <c:v>0.024350115456</c:v>
                 </c:pt>
                 <c:pt idx="8">
-                  <c:v>0.005694666768</c:v>
+                  <c:v>0.0048404526912</c:v>
                 </c:pt>
               </c:numCache>
             </c:numRef>
@@ -372,19 +372,19 @@
                 <c:formatCode>General</c:formatCode>
                 <c:ptCount val="5"/>
                 <c:pt idx="0">
-                  <c:v>0.03726771552</c:v>
+                  <c:v>0.01863385776</c:v>
                 </c:pt>
                 <c:pt idx="1">
-                  <c:v>0.091885275072</c:v>
+                  <c:v>0.045942637536</c:v>
                 </c:pt>
                 <c:pt idx="2">
-                  <c:v>0.154582725888</c:v>
+                  <c:v>0.077291362944</c:v>
                 </c:pt>
                 <c:pt idx="3">
-                  <c:v>0.2254853376</c:v>
+                  <c:v>0.1127426688</c:v>
                 </c:pt>
                 <c:pt idx="4">
-                  <c:v>0.304530475392</c:v>
+                  <c:v>0.152265237696</c:v>
                 </c:pt>
               </c:numCache>
             </c:numRef>
@@ -435,19 +435,19 @@
                 <c:formatCode>General</c:formatCode>
                 <c:ptCount val="5"/>
                 <c:pt idx="0">
-                  <c:v>0.056496604032</c:v>
+                  <c:v>0.0338979624192</c:v>
                 </c:pt>
                 <c:pt idx="1">
-                  <c:v>0.09269952768</c:v>
+                  <c:v>0.055619716608</c:v>
                 </c:pt>
                 <c:pt idx="2">
-                  <c:v>0.133474792896</c:v>
+                  <c:v>0.0800848757376</c:v>
                 </c:pt>
                 <c:pt idx="3">
-                  <c:v>0.17882239968</c:v>
+                  <c:v>0.107293439808</c:v>
                 </c:pt>
                 <c:pt idx="4">
-                  <c:v>0.228679713216</c:v>
+                  <c:v>0.1372078279296</c:v>
                 </c:pt>
               </c:numCache>
             </c:numRef>
@@ -498,19 +498,19 @@
                 <c:formatCode>General</c:formatCode>
                 <c:ptCount val="5"/>
                 <c:pt idx="0">
-                  <c:v>0.04447071936</c:v>
+                  <c:v>0.026682431616</c:v>
                 </c:pt>
                 <c:pt idx="1">
-                  <c:v>0.078105615552</c:v>
+                  <c:v>0.0468633693312</c:v>
                 </c:pt>
                 <c:pt idx="2">
-                  <c:v>0.116688662208</c:v>
+                  <c:v>0.0700131973248</c:v>
                 </c:pt>
                 <c:pt idx="3">
-                  <c:v>0.160282494144</c:v>
+                  <c:v>0.0961694964864</c:v>
                 </c:pt>
                 <c:pt idx="4">
-                  <c:v>0.208761841728</c:v>
+                  <c:v>0.1252571050368</c:v>
                 </c:pt>
               </c:numCache>
             </c:numRef>
@@ -561,19 +561,19 @@
                 <c:formatCode>General</c:formatCode>
                 <c:ptCount val="5"/>
                 <c:pt idx="0">
-                  <c:v>0.023738595264</c:v>
+                  <c:v>0.011869297632</c:v>
                 </c:pt>
                 <c:pt idx="1">
-                  <c:v>0.055807621056</c:v>
+                  <c:v>0.027903810528</c:v>
                 </c:pt>
                 <c:pt idx="2">
-                  <c:v>0.093451145472</c:v>
+                  <c:v>0.046725572736</c:v>
                 </c:pt>
                 <c:pt idx="3">
-                  <c:v>0.136794438144</c:v>
+                  <c:v>0.068397219072</c:v>
                 </c:pt>
                 <c:pt idx="4">
-                  <c:v>0.185774864256</c:v>
+                  <c:v>0.092887432128</c:v>
                 </c:pt>
               </c:numCache>
             </c:numRef>
@@ -589,7 +589,7 @@
               <c:strCache>
                 <c:ptCount val="1"/>
                 <c:pt idx="0">
-                  <c:v>Tencent</c:v>
+                  <c:v>Meta</c:v>
                 </c:pt>
               </c:strCache>
             </c:strRef>
@@ -624,19 +624,19 @@
                 <c:formatCode>General</c:formatCode>
                 <c:ptCount val="5"/>
                 <c:pt idx="0">
-                  <c:v>0.011524806144</c:v>
+                  <c:v>0.0148027652928</c:v>
                 </c:pt>
                 <c:pt idx="1">
-                  <c:v>0.026056083456</c:v>
+                  <c:v>0.026614184256</c:v>
                 </c:pt>
                 <c:pt idx="2">
-                  <c:v>0.042654309696</c:v>
+                  <c:v>0.0401192331264</c:v>
                 </c:pt>
                 <c:pt idx="3">
-                  <c:v>0.06138211968</c:v>
+                  <c:v>0.0552959167104</c:v>
                 </c:pt>
                 <c:pt idx="4">
-                  <c:v>0.082114243776</c:v>
+                  <c:v>0.072144235008</c:v>
                 </c:pt>
               </c:numCache>
             </c:numRef>
@@ -1005,7 +1005,7 @@
               <c:strCache>
                 <c:ptCount val="1"/>
                 <c:pt idx="0">
-                  <c:v>Tencent</c:v>
+                  <c:v>Meta</c:v>
                 </c:pt>
               </c:strCache>
             </c:strRef>
@@ -1040,19 +1040,19 @@
                 <c:formatCode>General</c:formatCode>
                 <c:ptCount val="5"/>
                 <c:pt idx="0">
-                  <c:v>0.184</c:v>
+                  <c:v>0.673</c:v>
                 </c:pt>
                 <c:pt idx="1">
-                  <c:v>0.416</c:v>
+                  <c:v>1.21</c:v>
                 </c:pt>
                 <c:pt idx="2">
-                  <c:v>0.681</c:v>
+                  <c:v>1.824</c:v>
                 </c:pt>
                 <c:pt idx="3">
-                  <c:v>0.98</c:v>
+                  <c:v>2.514</c:v>
                 </c:pt>
                 <c:pt idx="4">
-                  <c:v>1.311</c:v>
+                  <c:v>3.28</c:v>
                 </c:pt>
               </c:numCache>
             </c:numRef>
@@ -1192,10 +1192,10 @@
                   <c:v>Anthropic</c:v>
                 </c:pt>
                 <c:pt idx="4">
+                  <c:v>Meta</c:v>
+                </c:pt>
+                <c:pt idx="5">
                   <c:v>Tencent</c:v>
-                </c:pt>
-                <c:pt idx="5">
-                  <c:v>Meta</c:v>
                 </c:pt>
                 <c:pt idx="6">
                   <c:v>xAI</c:v>
@@ -1228,10 +1228,10 @@
                   <c:v>7.0</c:v>
                 </c:pt>
                 <c:pt idx="4">
+                  <c:v>7.0</c:v>
+                </c:pt>
+                <c:pt idx="5">
                   <c:v>3.0</c:v>
-                </c:pt>
-                <c:pt idx="5">
-                  <c:v>7.0</c:v>
                 </c:pt>
                 <c:pt idx="6">
                   <c:v>3.0</c:v>
@@ -1278,10 +1278,10 @@
                   <c:v>Anthropic</c:v>
                 </c:pt>
                 <c:pt idx="4">
+                  <c:v>Meta</c:v>
+                </c:pt>
+                <c:pt idx="5">
                   <c:v>Tencent</c:v>
-                </c:pt>
-                <c:pt idx="5">
-                  <c:v>Meta</c:v>
                 </c:pt>
                 <c:pt idx="6">
                   <c:v>xAI</c:v>
@@ -1314,10 +1314,10 @@
                   <c:v>5.5</c:v>
                 </c:pt>
                 <c:pt idx="4">
+                  <c:v>5.8</c:v>
+                </c:pt>
+                <c:pt idx="5">
                   <c:v>2.4</c:v>
-                </c:pt>
-                <c:pt idx="5">
-                  <c:v>5.8</c:v>
                 </c:pt>
                 <c:pt idx="6">
                   <c:v>2.5</c:v>
@@ -1482,10 +1482,10 @@
                   <c:v>Anthropic</c:v>
                 </c:pt>
                 <c:pt idx="4">
+                  <c:v>Meta</c:v>
+                </c:pt>
+                <c:pt idx="5">
                   <c:v>Tencent</c:v>
-                </c:pt>
-                <c:pt idx="5">
-                  <c:v>Meta</c:v>
                 </c:pt>
                 <c:pt idx="6">
                   <c:v>xAI</c:v>
@@ -1518,10 +1518,10 @@
                   <c:v>2.966</c:v>
                 </c:pt>
                 <c:pt idx="4">
+                  <c:v>3.28</c:v>
+                </c:pt>
+                <c:pt idx="5">
                   <c:v>1.311</c:v>
-                </c:pt>
-                <c:pt idx="5">
-                  <c:v>3.28</c:v>
                 </c:pt>
                 <c:pt idx="6">
                   <c:v>1.219</c:v>
@@ -1568,10 +1568,10 @@
                   <c:v>Anthropic</c:v>
                 </c:pt>
                 <c:pt idx="4">
+                  <c:v>Meta</c:v>
+                </c:pt>
+                <c:pt idx="5">
                   <c:v>Tencent</c:v>
-                </c:pt>
-                <c:pt idx="5">
-                  <c:v>Meta</c:v>
                 </c:pt>
                 <c:pt idx="6">
                   <c:v>xAI</c:v>
@@ -1604,10 +1604,10 @@
                   <c:v>1.042</c:v>
                 </c:pt>
                 <c:pt idx="4">
+                  <c:v>0.925</c:v>
+                </c:pt>
+                <c:pt idx="5">
                   <c:v>0.328</c:v>
-                </c:pt>
-                <c:pt idx="5">
-                  <c:v>0.925</c:v>
                 </c:pt>
                 <c:pt idx="6">
                   <c:v>0.523</c:v>
@@ -1773,10 +1773,10 @@
                   <c:v>Anthropic</c:v>
                 </c:pt>
                 <c:pt idx="4">
+                  <c:v>Meta</c:v>
+                </c:pt>
+                <c:pt idx="5">
                   <c:v>Tencent</c:v>
-                </c:pt>
-                <c:pt idx="5">
-                  <c:v>Meta</c:v>
                 </c:pt>
                 <c:pt idx="6">
                   <c:v>xAI</c:v>
@@ -1797,31 +1797,31 @@
                 <c:formatCode>General</c:formatCode>
                 <c:ptCount val="9"/>
                 <c:pt idx="0">
-                  <c:v>0.72494</c:v>
+                  <c:v>0.36247</c:v>
                 </c:pt>
                 <c:pt idx="1">
-                  <c:v>0.72494</c:v>
+                  <c:v>0.434964</c:v>
                 </c:pt>
                 <c:pt idx="2">
-                  <c:v>0.72494</c:v>
+                  <c:v>0.434964</c:v>
                 </c:pt>
                 <c:pt idx="3">
-                  <c:v>0.72494</c:v>
+                  <c:v>0.36247</c:v>
                 </c:pt>
                 <c:pt idx="4">
-                  <c:v>0.72494</c:v>
+                  <c:v>0.254574</c:v>
                 </c:pt>
                 <c:pt idx="5">
-                  <c:v>0.28286</c:v>
+                  <c:v>0.434964</c:v>
                 </c:pt>
                 <c:pt idx="6">
-                  <c:v>0.72494</c:v>
+                  <c:v>0.398717</c:v>
                 </c:pt>
                 <c:pt idx="7">
-                  <c:v>0.179145</c:v>
+                  <c:v>0.16123</c:v>
                 </c:pt>
                 <c:pt idx="8">
-                  <c:v>0.101245</c:v>
+                  <c:v>0.086058</c:v>
                 </c:pt>
               </c:numCache>
             </c:numRef>
@@ -1987,19 +1987,19 @@
                 <c:formatCode>General</c:formatCode>
                 <c:ptCount val="5"/>
                 <c:pt idx="0">
-                  <c:v>0.155</c:v>
+                  <c:v>0.063</c:v>
                 </c:pt>
                 <c:pt idx="1">
-                  <c:v>0.306</c:v>
+                  <c:v>0.121</c:v>
                 </c:pt>
                 <c:pt idx="2">
-                  <c:v>0.473</c:v>
+                  <c:v>0.185</c:v>
                 </c:pt>
                 <c:pt idx="3">
-                  <c:v>0.656</c:v>
+                  <c:v>0.255</c:v>
                 </c:pt>
                 <c:pt idx="4">
-                  <c:v>0.853</c:v>
+                  <c:v>0.33</c:v>
                 </c:pt>
               </c:numCache>
             </c:numRef>
@@ -2050,19 +2050,19 @@
                 <c:formatCode>General</c:formatCode>
                 <c:ptCount val="5"/>
                 <c:pt idx="0">
-                  <c:v>0.201</c:v>
+                  <c:v>0.121</c:v>
                 </c:pt>
                 <c:pt idx="1">
-                  <c:v>0.404</c:v>
+                  <c:v>0.239</c:v>
                 </c:pt>
                 <c:pt idx="2">
-                  <c:v>0.638</c:v>
+                  <c:v>0.375</c:v>
                 </c:pt>
                 <c:pt idx="3">
-                  <c:v>0.903</c:v>
+                  <c:v>0.529</c:v>
                 </c:pt>
                 <c:pt idx="4">
-                  <c:v>1.199</c:v>
+                  <c:v>0.7</c:v>
                 </c:pt>
               </c:numCache>
             </c:numRef>
@@ -2113,19 +2113,19 @@
                 <c:formatCode>General</c:formatCode>
                 <c:ptCount val="5"/>
                 <c:pt idx="0">
-                  <c:v>0.231</c:v>
+                  <c:v>0.182</c:v>
                 </c:pt>
                 <c:pt idx="1">
-                  <c:v>0.48</c:v>
+                  <c:v>0.374</c:v>
                 </c:pt>
                 <c:pt idx="2">
-                  <c:v>0.783</c:v>
+                  <c:v>0.608</c:v>
                 </c:pt>
                 <c:pt idx="3">
-                  <c:v>1.143</c:v>
+                  <c:v>0.887</c:v>
                 </c:pt>
                 <c:pt idx="4">
-                  <c:v>1.565</c:v>
+                  <c:v>1.212</c:v>
                 </c:pt>
               </c:numCache>
             </c:numRef>
@@ -5605,7 +5605,7 @@
               </a:defRPr>
             </a:pPr>
             <a:r>
-              <a:t>1.20Q</a:t>
+              <a:t>0.70Q</a:t>
             </a:r>
           </a:p>
         </p:txBody>
@@ -6139,7 +6139,7 @@
                         </a:defRPr>
                       </a:pPr>
                       <a:r>
-                        <a:t>0.01</a:t>
+                        <a:t>0.00</a:t>
                       </a:r>
                     </a:p>
                   </a:txBody>
@@ -6279,7 +6279,7 @@
                         </a:defRPr>
                       </a:pPr>
                       <a:r>
-                        <a:t>0.03</a:t>
+                        <a:t>0.02</a:t>
                       </a:r>
                     </a:p>
                   </a:txBody>
@@ -6419,7 +6419,7 @@
                         </a:defRPr>
                       </a:pPr>
                       <a:r>
-                        <a:t>0.08</a:t>
+                        <a:t>0.07</a:t>
                       </a:r>
                     </a:p>
                   </a:txBody>
@@ -6559,7 +6559,7 @@
                         </a:defRPr>
                       </a:pPr>
                       <a:r>
-                        <a:t>0.21</a:t>
+                        <a:t>0.13</a:t>
                       </a:r>
                     </a:p>
                   </a:txBody>
@@ -6699,7 +6699,7 @@
                         </a:defRPr>
                       </a:pPr>
                       <a:r>
-                        <a:t>0.30</a:t>
+                        <a:t>0.15</a:t>
                       </a:r>
                     </a:p>
                   </a:txBody>
@@ -6839,7 +6839,7 @@
                         </a:defRPr>
                       </a:pPr>
                       <a:r>
-                        <a:t>0.19</a:t>
+                        <a:t>0.09</a:t>
                       </a:r>
                     </a:p>
                   </a:txBody>
@@ -6979,7 +6979,7 @@
                         </a:defRPr>
                       </a:pPr>
                       <a:r>
-                        <a:t>0.08</a:t>
+                        <a:t>0.04</a:t>
                       </a:r>
                     </a:p>
                   </a:txBody>
@@ -7119,7 +7119,7 @@
                         </a:defRPr>
                       </a:pPr>
                       <a:r>
-                        <a:t>0.08</a:t>
+                        <a:t>0.05</a:t>
                       </a:r>
                     </a:p>
                   </a:txBody>
@@ -7259,7 +7259,7 @@
                         </a:defRPr>
                       </a:pPr>
                       <a:r>
-                        <a:t>0.23</a:t>
+                        <a:t>0.14</a:t>
                       </a:r>
                     </a:p>
                   </a:txBody>
@@ -7687,7 +7687,7 @@
               </a:defRPr>
             </a:pPr>
             <a:r>
-              <a:t>Bull and Bear cases move operational deployment and inference allocation only; TPS/MW is held to the selected benchmark proxy.</a:t>
+              <a:t>Bull and Bear cases move operational deployment, inference allocation and the explicit commercial-workload fit to the public reference.</a:t>
             </a:r>
           </a:p>
         </p:txBody>
@@ -7945,7 +7945,7 @@
                         </a:defRPr>
                       </a:pPr>
                       <a:r>
-                        <a:t>0.85</a:t>
+                        <a:t>0.33</a:t>
                       </a:r>
                     </a:p>
                   </a:txBody>
@@ -8039,7 +8039,7 @@
                         </a:defRPr>
                       </a:pPr>
                       <a:r>
-                        <a:t>1.20</a:t>
+                        <a:t>0.70</a:t>
                       </a:r>
                     </a:p>
                   </a:txBody>
@@ -8133,7 +8133,7 @@
                         </a:defRPr>
                       </a:pPr>
                       <a:r>
-                        <a:t>1.56</a:t>
+                        <a:t>1.21</a:t>
                       </a:r>
                     </a:p>
                   </a:txBody>
@@ -8277,7 +8277,7 @@
               </a:defRPr>
             </a:pPr>
             <a:r>
-              <a:t>Selected benchmark TPS/MW held constant</a:t>
+              <a:t>Commercial workload fit to public TPS/MW reference</a:t>
             </a:r>
           </a:p>
           <a:p>
@@ -8327,7 +8327,7 @@
               </a:defRPr>
             </a:pPr>
             <a:r>
-              <a:t>Base growth: 6.0x, 2026-2030</a:t>
+              <a:t>Base growth: 5.8x, 2026-2030</a:t>
             </a:r>
           </a:p>
         </p:txBody>
@@ -9308,7 +9308,7 @@
               </a:defRPr>
             </a:pPr>
             <a:r>
-              <a:t>Workbook tabs: Logic, Benchmark Input, Inputs, Calculation, Output, Checks. Derived output cells use Excel formulas.</a:t>
+              <a:t>Workbook tabs: Logic, Benchmark Input, Inputs, Calculation, Output, Checks, Aggressive View. Derived output cells use Excel formulas.</a:t>
             </a:r>
           </a:p>
         </p:txBody>
@@ -10129,7 +10129,7 @@
               </a:defRPr>
             </a:pPr>
             <a:r>
-              <a:t>Top 3 providers account for 62% of modeled 2030 generated-token supply.</a:t>
+              <a:t>Top 3 providers account for 59% of modeled 2030 generated-token supply.</a:t>
             </a:r>
           </a:p>
         </p:txBody>
@@ -11942,7 +11942,7 @@
                         </a:defRPr>
                       </a:pPr>
                       <a:r>
-                        <a:t>0.30</a:t>
+                        <a:t>0.15</a:t>
                       </a:r>
                     </a:p>
                   </a:txBody>
@@ -12036,7 +12036,7 @@
                         </a:defRPr>
                       </a:pPr>
                       <a:r>
-                        <a:t>0.23</a:t>
+                        <a:t>0.14</a:t>
                       </a:r>
                     </a:p>
                   </a:txBody>
@@ -12130,7 +12130,7 @@
                         </a:defRPr>
                       </a:pPr>
                       <a:r>
-                        <a:t>0.21</a:t>
+                        <a:t>0.13</a:t>
                       </a:r>
                     </a:p>
                   </a:txBody>
@@ -12224,7 +12224,7 @@
                         </a:defRPr>
                       </a:pPr>
                       <a:r>
-                        <a:t>0.19</a:t>
+                        <a:t>0.09</a:t>
                       </a:r>
                     </a:p>
                   </a:txBody>
@@ -12295,7 +12295,7 @@
                         </a:defRPr>
                       </a:pPr>
                       <a:r>
-                        <a:t>Tencent</a:t>
+                        <a:t>Meta</a:t>
                       </a:r>
                     </a:p>
                   </a:txBody>
@@ -12318,7 +12318,7 @@
                         </a:defRPr>
                       </a:pPr>
                       <a:r>
-                        <a:t>0.08</a:t>
+                        <a:t>0.07</a:t>
                       </a:r>
                     </a:p>
                   </a:txBody>
@@ -12341,7 +12341,7 @@
                         </a:defRPr>
                       </a:pPr>
                       <a:r>
-                        <a:t>1.3</a:t>
+                        <a:t>3.3</a:t>
                       </a:r>
                     </a:p>
                   </a:txBody>
@@ -12364,7 +12364,7 @@
                         </a:defRPr>
                       </a:pPr>
                       <a:r>
-                        <a:t>2.4</a:t>
+                        <a:t>5.8</a:t>
                       </a:r>
                     </a:p>
                   </a:txBody>
@@ -12444,7 +12444,7 @@
               </a:defRPr>
             </a:pPr>
             <a:r>
-              <a:t>62%</a:t>
+              <a:t>59%</a:t>
             </a:r>
           </a:p>
         </p:txBody>
@@ -13087,7 +13087,7 @@
                         </a:defRPr>
                       </a:pPr>
                       <a:r>
-                        <a:t>0.04</a:t>
+                        <a:t>0.02</a:t>
                       </a:r>
                     </a:p>
                   </a:txBody>
@@ -13110,30 +13110,30 @@
                         </a:defRPr>
                       </a:pPr>
                       <a:r>
+                        <a:t>0.08</a:t>
+                      </a:r>
+                    </a:p>
+                  </a:txBody>
+                  <a:tcPr marL="50292" marR="50292" marT="32004" marB="32004">
+                    <a:solidFill>
+                      <a:srgbClr val="FFFFFF"/>
+                    </a:solidFill>
+                  </a:tcPr>
+                </a:tc>
+                <a:tc>
+                  <a:txBody>
+                    <a:bodyPr/>
+                    <a:lstStyle/>
+                    <a:p>
+                      <a:pPr>
+                        <a:defRPr sz="650" b="0">
+                          <a:solidFill>
+                            <a:srgbClr val="3A4252"/>
+                          </a:solidFill>
+                        </a:defRPr>
+                      </a:pPr>
+                      <a:r>
                         <a:t>0.15</a:t>
-                      </a:r>
-                    </a:p>
-                  </a:txBody>
-                  <a:tcPr marL="50292" marR="50292" marT="32004" marB="32004">
-                    <a:solidFill>
-                      <a:srgbClr val="FFFFFF"/>
-                    </a:solidFill>
-                  </a:tcPr>
-                </a:tc>
-                <a:tc>
-                  <a:txBody>
-                    <a:bodyPr/>
-                    <a:lstStyle/>
-                    <a:p>
-                      <a:pPr>
-                        <a:defRPr sz="650" b="0">
-                          <a:solidFill>
-                            <a:srgbClr val="3A4252"/>
-                          </a:solidFill>
-                        </a:defRPr>
-                      </a:pPr>
-                      <a:r>
-                        <a:t>0.30</a:t>
                       </a:r>
                     </a:p>
                   </a:txBody>
@@ -13204,7 +13204,7 @@
                         </a:defRPr>
                       </a:pPr>
                       <a:r>
-                        <a:t>0.06</a:t>
+                        <a:t>0.03</a:t>
                       </a:r>
                     </a:p>
                   </a:txBody>
@@ -13227,7 +13227,7 @@
                         </a:defRPr>
                       </a:pPr>
                       <a:r>
-                        <a:t>0.13</a:t>
+                        <a:t>0.08</a:t>
                       </a:r>
                     </a:p>
                   </a:txBody>
@@ -13250,7 +13250,7 @@
                         </a:defRPr>
                       </a:pPr>
                       <a:r>
-                        <a:t>0.23</a:t>
+                        <a:t>0.14</a:t>
                       </a:r>
                     </a:p>
                   </a:txBody>
@@ -13321,7 +13321,7 @@
                         </a:defRPr>
                       </a:pPr>
                       <a:r>
-                        <a:t>0.04</a:t>
+                        <a:t>0.03</a:t>
                       </a:r>
                     </a:p>
                   </a:txBody>
@@ -13344,7 +13344,7 @@
                         </a:defRPr>
                       </a:pPr>
                       <a:r>
-                        <a:t>0.12</a:t>
+                        <a:t>0.07</a:t>
                       </a:r>
                     </a:p>
                   </a:txBody>
@@ -13367,7 +13367,7 @@
                         </a:defRPr>
                       </a:pPr>
                       <a:r>
-                        <a:t>0.21</a:t>
+                        <a:t>0.13</a:t>
                       </a:r>
                     </a:p>
                   </a:txBody>
@@ -13438,7 +13438,7 @@
                         </a:defRPr>
                       </a:pPr>
                       <a:r>
-                        <a:t>0.02</a:t>
+                        <a:t>0.01</a:t>
                       </a:r>
                     </a:p>
                   </a:txBody>
@@ -13461,30 +13461,30 @@
                         </a:defRPr>
                       </a:pPr>
                       <a:r>
+                        <a:t>0.05</a:t>
+                      </a:r>
+                    </a:p>
+                  </a:txBody>
+                  <a:tcPr marL="50292" marR="50292" marT="32004" marB="32004">
+                    <a:solidFill>
+                      <a:srgbClr val="F7F9FC"/>
+                    </a:solidFill>
+                  </a:tcPr>
+                </a:tc>
+                <a:tc>
+                  <a:txBody>
+                    <a:bodyPr/>
+                    <a:lstStyle/>
+                    <a:p>
+                      <a:pPr>
+                        <a:defRPr sz="650" b="0">
+                          <a:solidFill>
+                            <a:srgbClr val="3A4252"/>
+                          </a:solidFill>
+                        </a:defRPr>
+                      </a:pPr>
+                      <a:r>
                         <a:t>0.09</a:t>
-                      </a:r>
-                    </a:p>
-                  </a:txBody>
-                  <a:tcPr marL="50292" marR="50292" marT="32004" marB="32004">
-                    <a:solidFill>
-                      <a:srgbClr val="F7F9FC"/>
-                    </a:solidFill>
-                  </a:tcPr>
-                </a:tc>
-                <a:tc>
-                  <a:txBody>
-                    <a:bodyPr/>
-                    <a:lstStyle/>
-                    <a:p>
-                      <a:pPr>
-                        <a:defRPr sz="650" b="0">
-                          <a:solidFill>
-                            <a:srgbClr val="3A4252"/>
-                          </a:solidFill>
-                        </a:defRPr>
-                      </a:pPr>
-                      <a:r>
-                        <a:t>0.19</a:t>
                       </a:r>
                     </a:p>
                   </a:txBody>
@@ -13532,7 +13532,7 @@
                         </a:defRPr>
                       </a:pPr>
                       <a:r>
-                        <a:t>Tencent</a:t>
+                        <a:t>Meta</a:t>
                       </a:r>
                     </a:p>
                   </a:txBody>
@@ -13601,7 +13601,7 @@
                         </a:defRPr>
                       </a:pPr>
                       <a:r>
-                        <a:t>0.08</a:t>
+                        <a:t>0.07</a:t>
                       </a:r>
                     </a:p>
                   </a:txBody>
@@ -13624,7 +13624,7 @@
                         </a:defRPr>
                       </a:pPr>
                       <a:r>
-                        <a:t>7.1x</a:t>
+                        <a:t>4.9x</a:t>
                       </a:r>
                     </a:p>
                   </a:txBody>
@@ -13649,7 +13649,7 @@
                         </a:defRPr>
                       </a:pPr>
                       <a:r>
-                        <a:t>Meta</a:t>
+                        <a:t>Tencent</a:t>
                       </a:r>
                     </a:p>
                   </a:txBody>
@@ -13672,7 +13672,7 @@
                         </a:defRPr>
                       </a:pPr>
                       <a:r>
-                        <a:t>0.02</a:t>
+                        <a:t>0.01</a:t>
                       </a:r>
                     </a:p>
                   </a:txBody>
@@ -13695,7 +13695,7 @@
                         </a:defRPr>
                       </a:pPr>
                       <a:r>
-                        <a:t>0.04</a:t>
+                        <a:t>0.03</a:t>
                       </a:r>
                     </a:p>
                   </a:txBody>
@@ -13718,7 +13718,7 @@
                         </a:defRPr>
                       </a:pPr>
                       <a:r>
-                        <a:t>0.08</a:t>
+                        <a:t>0.05</a:t>
                       </a:r>
                     </a:p>
                   </a:txBody>
@@ -13741,7 +13741,7 @@
                         </a:defRPr>
                       </a:pPr>
                       <a:r>
-                        <a:t>4.9x</a:t>
+                        <a:t>7.1x</a:t>
                       </a:r>
                     </a:p>
                   </a:txBody>
@@ -13789,7 +13789,7 @@
                         </a:defRPr>
                       </a:pPr>
                       <a:r>
-                        <a:t>0.01</a:t>
+                        <a:t>0.00</a:t>
                       </a:r>
                     </a:p>
                   </a:txBody>
@@ -13812,30 +13812,30 @@
                         </a:defRPr>
                       </a:pPr>
                       <a:r>
+                        <a:t>0.02</a:t>
+                      </a:r>
+                    </a:p>
+                  </a:txBody>
+                  <a:tcPr marL="50292" marR="50292" marT="32004" marB="32004">
+                    <a:solidFill>
+                      <a:srgbClr val="FFFFFF"/>
+                    </a:solidFill>
+                  </a:tcPr>
+                </a:tc>
+                <a:tc>
+                  <a:txBody>
+                    <a:bodyPr/>
+                    <a:lstStyle/>
+                    <a:p>
+                      <a:pPr>
+                        <a:defRPr sz="650" b="0">
+                          <a:solidFill>
+                            <a:srgbClr val="3A4252"/>
+                          </a:solidFill>
+                        </a:defRPr>
+                      </a:pPr>
+                      <a:r>
                         <a:t>0.04</a:t>
-                      </a:r>
-                    </a:p>
-                  </a:txBody>
-                  <a:tcPr marL="50292" marR="50292" marT="32004" marB="32004">
-                    <a:solidFill>
-                      <a:srgbClr val="FFFFFF"/>
-                    </a:solidFill>
-                  </a:tcPr>
-                </a:tc>
-                <a:tc>
-                  <a:txBody>
-                    <a:bodyPr/>
-                    <a:lstStyle/>
-                    <a:p>
-                      <a:pPr>
-                        <a:defRPr sz="650" b="0">
-                          <a:solidFill>
-                            <a:srgbClr val="3A4252"/>
-                          </a:solidFill>
-                        </a:defRPr>
-                      </a:pPr>
-                      <a:r>
-                        <a:t>0.08</a:t>
                       </a:r>
                     </a:p>
                   </a:txBody>
@@ -13952,7 +13952,7 @@
                         </a:defRPr>
                       </a:pPr>
                       <a:r>
-                        <a:t>0.03</a:t>
+                        <a:t>0.02</a:t>
                       </a:r>
                     </a:p>
                   </a:txBody>
@@ -14069,7 +14069,7 @@
                         </a:defRPr>
                       </a:pPr>
                       <a:r>
-                        <a:t>0.01</a:t>
+                        <a:t>0.00</a:t>
                       </a:r>
                     </a:p>
                   </a:txBody>
@@ -14428,7 +14428,7 @@
               </a:defRPr>
             </a:pPr>
             <a:r>
-              <a:t>The core model changes token supply through operational inference GW; TPS/MW is held to the selected InferenceX proxy unless explicitly stress-tested.</a:t>
+              <a:t>The core model changes token supply through operational inference GW and a workload-adjusted serving reference derived from InferenceX.</a:t>
             </a:r>
           </a:p>
         </p:txBody>
@@ -15155,7 +15155,7 @@
                         </a:defRPr>
                       </a:pPr>
                       <a:r>
-                        <a:t>Tencent</a:t>
+                        <a:t>Meta</a:t>
                       </a:r>
                     </a:p>
                   </a:txBody>
@@ -15178,7 +15178,7 @@
                         </a:defRPr>
                       </a:pPr>
                       <a:r>
-                        <a:t>0.2</a:t>
+                        <a:t>0.7</a:t>
                       </a:r>
                     </a:p>
                   </a:txBody>
@@ -15201,7 +15201,7 @@
                         </a:defRPr>
                       </a:pPr>
                       <a:r>
-                        <a:t>0.7</a:t>
+                        <a:t>1.8</a:t>
                       </a:r>
                     </a:p>
                   </a:txBody>
@@ -15224,7 +15224,7 @@
                         </a:defRPr>
                       </a:pPr>
                       <a:r>
-                        <a:t>1.3</a:t>
+                        <a:t>3.3</a:t>
                       </a:r>
                     </a:p>
                   </a:txBody>
@@ -15247,7 +15247,7 @@
                         </a:defRPr>
                       </a:pPr>
                       <a:r>
-                        <a:t>80%</a:t>
+                        <a:t>78%</a:t>
                       </a:r>
                     </a:p>
                   </a:txBody>
@@ -15272,7 +15272,7 @@
                         </a:defRPr>
                       </a:pPr>
                       <a:r>
-                        <a:t>Meta</a:t>
+                        <a:t>Tencent</a:t>
                       </a:r>
                     </a:p>
                   </a:txBody>
@@ -15295,6 +15295,29 @@
                         </a:defRPr>
                       </a:pPr>
                       <a:r>
+                        <a:t>0.2</a:t>
+                      </a:r>
+                    </a:p>
+                  </a:txBody>
+                  <a:tcPr marL="50292" marR="50292" marT="32004" marB="32004">
+                    <a:solidFill>
+                      <a:srgbClr val="F7F9FC"/>
+                    </a:solidFill>
+                  </a:tcPr>
+                </a:tc>
+                <a:tc>
+                  <a:txBody>
+                    <a:bodyPr/>
+                    <a:lstStyle/>
+                    <a:p>
+                      <a:pPr>
+                        <a:defRPr sz="650" b="0">
+                          <a:solidFill>
+                            <a:srgbClr val="3A4252"/>
+                          </a:solidFill>
+                        </a:defRPr>
+                      </a:pPr>
+                      <a:r>
                         <a:t>0.7</a:t>
                       </a:r>
                     </a:p>
@@ -15318,7 +15341,7 @@
                         </a:defRPr>
                       </a:pPr>
                       <a:r>
-                        <a:t>1.8</a:t>
+                        <a:t>1.3</a:t>
                       </a:r>
                     </a:p>
                   </a:txBody>
@@ -15341,30 +15364,7 @@
                         </a:defRPr>
                       </a:pPr>
                       <a:r>
-                        <a:t>3.3</a:t>
-                      </a:r>
-                    </a:p>
-                  </a:txBody>
-                  <a:tcPr marL="50292" marR="50292" marT="32004" marB="32004">
-                    <a:solidFill>
-                      <a:srgbClr val="F7F9FC"/>
-                    </a:solidFill>
-                  </a:tcPr>
-                </a:tc>
-                <a:tc>
-                  <a:txBody>
-                    <a:bodyPr/>
-                    <a:lstStyle/>
-                    <a:p>
-                      <a:pPr>
-                        <a:defRPr sz="650" b="0">
-                          <a:solidFill>
-                            <a:srgbClr val="3A4252"/>
-                          </a:solidFill>
-                        </a:defRPr>
-                      </a:pPr>
-                      <a:r>
-                        <a:t>78%</a:t>
+                        <a:t>80%</a:t>
                       </a:r>
                     </a:p>
                   </a:txBody>
@@ -17525,7 +17525,7 @@
                         </a:defRPr>
                       </a:pPr>
                       <a:r>
-                        <a:t>Tencent</a:t>
+                        <a:t>Meta</a:t>
                       </a:r>
                     </a:p>
                   </a:txBody>
@@ -17548,7 +17548,7 @@
                         </a:defRPr>
                       </a:pPr>
                       <a:r>
-                        <a:t>1.3</a:t>
+                        <a:t>3.3</a:t>
                       </a:r>
                     </a:p>
                   </a:txBody>
@@ -17571,7 +17571,7 @@
                         </a:defRPr>
                       </a:pPr>
                       <a:r>
-                        <a:t>0.3</a:t>
+                        <a:t>0.9</a:t>
                       </a:r>
                     </a:p>
                   </a:txBody>
@@ -17594,7 +17594,7 @@
                         </a:defRPr>
                       </a:pPr>
                       <a:r>
-                        <a:t>80%</a:t>
+                        <a:t>78%</a:t>
                       </a:r>
                     </a:p>
                   </a:txBody>
@@ -17930,7 +17930,7 @@
               </a:defRPr>
             </a:pPr>
             <a:r>
-              <a:t>The third input is a transparent InferenceX output-token TPS/MW selection</a:t>
+              <a:t>The third input adjusts a public InferenceX reference to commercial workload reality</a:t>
             </a:r>
           </a:p>
         </p:txBody>
@@ -17965,7 +17965,7 @@
               </a:defRPr>
             </a:pPr>
             <a:r>
-              <a:t>A fixed B200, single_turn, ISL/OSL 1024/1024 output-throughput median is selected by proxy model; no hidden uplift is applied.</a:t>
+              <a:t>A fixed B200 output-throughput median is the public reference ceiling; explicit workload-fit assumptions account for closed, reasoning and long-context serving.</a:t>
             </a:r>
           </a:p>
         </p:txBody>
@@ -18063,7 +18063,7 @@
               </a:defRPr>
             </a:pPr>
             <a:r>
-              <a:t>Selected proxy mapping</a:t>
+              <a:t>Commercial serving reference</a:t>
             </a:r>
           </a:p>
         </p:txBody>
@@ -18152,30 +18152,30 @@
                         </a:defRPr>
                       </a:pPr>
                       <a:r>
+                        <a:t>Fit</a:t>
+                      </a:r>
+                    </a:p>
+                  </a:txBody>
+                  <a:tcPr marL="50292" marR="50292" marT="32004" marB="32004">
+                    <a:solidFill>
+                      <a:srgbClr val="1428A0"/>
+                    </a:solidFill>
+                  </a:tcPr>
+                </a:tc>
+                <a:tc>
+                  <a:txBody>
+                    <a:bodyPr/>
+                    <a:lstStyle/>
+                    <a:p>
+                      <a:pPr>
+                        <a:defRPr sz="819" b="1">
+                          <a:solidFill>
+                            <a:srgbClr val="FFFFFF"/>
+                          </a:solidFill>
+                        </a:defRPr>
+                      </a:pPr>
+                      <a:r>
                         <a:t>M tok/s/MW</a:t>
-                      </a:r>
-                    </a:p>
-                  </a:txBody>
-                  <a:tcPr marL="50292" marR="50292" marT="32004" marB="32004">
-                    <a:solidFill>
-                      <a:srgbClr val="1428A0"/>
-                    </a:solidFill>
-                  </a:tcPr>
-                </a:tc>
-                <a:tc>
-                  <a:txBody>
-                    <a:bodyPr/>
-                    <a:lstStyle/>
-                    <a:p>
-                      <a:pPr>
-                        <a:defRPr sz="819" b="1">
-                          <a:solidFill>
-                            <a:srgbClr val="FFFFFF"/>
-                          </a:solidFill>
-                        </a:defRPr>
-                      </a:pPr>
-                      <a:r>
-                        <a:t>Constraint</a:t>
                       </a:r>
                     </a:p>
                   </a:txBody>
@@ -18246,7 +18246,7 @@
                         </a:defRPr>
                       </a:pPr>
                       <a:r>
-                        <a:t>0.10</a:t>
+                        <a:t>85%</a:t>
                       </a:r>
                     </a:p>
                   </a:txBody>
@@ -18269,7 +18269,7 @@
                         </a:defRPr>
                       </a:pPr>
                       <a:r>
-                        <a:t>Deployment gap</a:t>
+                        <a:t>0.09</a:t>
                       </a:r>
                     </a:p>
                   </a:txBody>
@@ -18340,7 +18340,7 @@
                         </a:defRPr>
                       </a:pPr>
                       <a:r>
-                        <a:t>0.18</a:t>
+                        <a:t>90%</a:t>
                       </a:r>
                     </a:p>
                   </a:txBody>
@@ -18363,7 +18363,7 @@
                         </a:defRPr>
                       </a:pPr>
                       <a:r>
-                        <a:t>Serving efficiency</a:t>
+                        <a:t>0.16</a:t>
                       </a:r>
                     </a:p>
                   </a:txBody>
@@ -18434,7 +18434,7 @@
                         </a:defRPr>
                       </a:pPr>
                       <a:r>
-                        <a:t>0.28</a:t>
+                        <a:t>90%</a:t>
                       </a:r>
                     </a:p>
                   </a:txBody>
@@ -18457,7 +18457,7 @@
                         </a:defRPr>
                       </a:pPr>
                       <a:r>
-                        <a:t>Serving efficiency</a:t>
+                        <a:t>0.25</a:t>
                       </a:r>
                     </a:p>
                   </a:txBody>
@@ -18528,7 +18528,7 @@
                         </a:defRPr>
                       </a:pPr>
                       <a:r>
-                        <a:t>0.72</a:t>
+                        <a:t>50%</a:t>
                       </a:r>
                     </a:p>
                   </a:txBody>
@@ -18551,7 +18551,7 @@
                         </a:defRPr>
                       </a:pPr>
                       <a:r>
-                        <a:t>Scale absorption</a:t>
+                        <a:t>0.36</a:t>
                       </a:r>
                     </a:p>
                   </a:txBody>
@@ -18576,7 +18576,7 @@
                         </a:defRPr>
                       </a:pPr>
                       <a:r>
-                        <a:t>Google</a:t>
+                        <a:t>Anthropic</a:t>
                       </a:r>
                     </a:p>
                   </a:txBody>
@@ -18622,7 +18622,7 @@
                         </a:defRPr>
                       </a:pPr>
                       <a:r>
-                        <a:t>0.72</a:t>
+                        <a:t>50%</a:t>
                       </a:r>
                     </a:p>
                   </a:txBody>
@@ -18645,7 +18645,7 @@
                         </a:defRPr>
                       </a:pPr>
                       <a:r>
-                        <a:t>Training allocation</a:t>
+                        <a:t>0.36</a:t>
                       </a:r>
                     </a:p>
                   </a:txBody>
@@ -18669,7 +18669,7 @@
         <p:spPr>
           <a:xfrm>
             <a:off x="7479792" y="4553712"/>
-            <a:ext cx="3703320" cy="493776"/>
+            <a:ext cx="3703320" cy="548640"/>
           </a:xfrm>
           <a:prstGeom prst="rect">
             <a:avLst/>
@@ -18690,7 +18690,7 @@
               </a:defRPr>
             </a:pPr>
             <a:r>
-              <a:t>Purpose-built accelerator mix is visible, but no efficiency uplift is applied until a comparable output-token benchmark exists.</a:t>
+              <a:t>Purpose-built mix remains visible, but no hardware premium is added without a comparable output-token benchmark.</a:t>
             </a:r>
           </a:p>
         </p:txBody>
@@ -18770,7 +18770,7 @@
               </a:defRPr>
             </a:pPr>
             <a:r>
-              <a:t>Selected TPS/MW is a readable benchmark proxy, not a compounded estimate.</a:t>
+              <a:t>Base TPS/MW is a workload-adjusted serving reference, while the raw public benchmark defines upside ceiling.</a:t>
             </a:r>
           </a:p>
         </p:txBody>

</xml_diff>

<commit_message>
Add editable GPU generation mix to token capacity model
</commit_message>
<xml_diff>
--- a/llm_token_capacity_project/outputs/reports/llm_token_capacity_2026_2030.pptx
+++ b/llm_token_capacity_project/outputs/reports/llm_token_capacity_2026_2030.pptx
@@ -183,31 +183,31 @@
                 <c:formatCode>General</c:formatCode>
                 <c:ptCount val="9"/>
                 <c:pt idx="0">
-                  <c:v>0.152265237696</c:v>
+                  <c:v>0.144796272192</c:v>
                 </c:pt>
                 <c:pt idx="1">
-                  <c:v>0.1372078279296</c:v>
+                  <c:v>0.136534665312</c:v>
                 </c:pt>
                 <c:pt idx="2">
-                  <c:v>0.1252571050368</c:v>
+                  <c:v>0.121878050976</c:v>
                 </c:pt>
                 <c:pt idx="3">
-                  <c:v>0.092887432128</c:v>
+                  <c:v>0.0922039803072</c:v>
                 </c:pt>
                 <c:pt idx="4">
-                  <c:v>0.072144235008</c:v>
+                  <c:v>0.072169173504</c:v>
                 </c:pt>
                 <c:pt idx="5">
-                  <c:v>0.0492685462656</c:v>
+                  <c:v>0.0468519222816</c:v>
                 </c:pt>
                 <c:pt idx="6">
-                  <c:v>0.0419935123872</c:v>
+                  <c:v>0.039933737856</c:v>
                 </c:pt>
                 <c:pt idx="7">
                   <c:v>0.024350115456</c:v>
                 </c:pt>
                 <c:pt idx="8">
-                  <c:v>0.0048404526912</c:v>
+                  <c:v>0.0212140609632</c:v>
                 </c:pt>
               </c:numCache>
             </c:numRef>
@@ -372,19 +372,19 @@
                 <c:formatCode>General</c:formatCode>
                 <c:ptCount val="5"/>
                 <c:pt idx="0">
-                  <c:v>0.01863385776</c:v>
+                  <c:v>0.013606875072</c:v>
                 </c:pt>
                 <c:pt idx="1">
-                  <c:v>0.045942637536</c:v>
+                  <c:v>0.0360722014848</c:v>
                 </c:pt>
                 <c:pt idx="2">
-                  <c:v>0.077291362944</c:v>
+                  <c:v>0.0649699933824</c:v>
                 </c:pt>
                 <c:pt idx="3">
-                  <c:v>0.1127426688</c:v>
+                  <c:v>0.100963584</c:v>
                 </c:pt>
                 <c:pt idx="4">
-                  <c:v>0.152265237696</c:v>
+                  <c:v>0.144796272192</c:v>
                 </c:pt>
               </c:numCache>
             </c:numRef>
@@ -435,19 +435,19 @@
                 <c:formatCode>General</c:formatCode>
                 <c:ptCount val="5"/>
                 <c:pt idx="0">
-                  <c:v>0.0338979624192</c:v>
+                  <c:v>0.032068957536</c:v>
                 </c:pt>
                 <c:pt idx="1">
-                  <c:v>0.055619716608</c:v>
+                  <c:v>0.053519035392</c:v>
                 </c:pt>
                 <c:pt idx="2">
-                  <c:v>0.0800848757376</c:v>
+                  <c:v>0.078160101984</c:v>
                 </c:pt>
                 <c:pt idx="3">
-                  <c:v>0.107293439808</c:v>
+                  <c:v>0.105872362416</c:v>
                 </c:pt>
                 <c:pt idx="4">
-                  <c:v>0.1372078279296</c:v>
+                  <c:v>0.136534665312</c:v>
                 </c:pt>
               </c:numCache>
             </c:numRef>
@@ -498,19 +498,19 @@
                 <c:formatCode>General</c:formatCode>
                 <c:ptCount val="5"/>
                 <c:pt idx="0">
-                  <c:v>0.026682431616</c:v>
+                  <c:v>0.020203891776</c:v>
                 </c:pt>
                 <c:pt idx="1">
-                  <c:v>0.0468633693312</c:v>
+                  <c:v>0.0387030811392</c:v>
                 </c:pt>
                 <c:pt idx="2">
-                  <c:v>0.0700131973248</c:v>
+                  <c:v>0.0619085392416</c:v>
                 </c:pt>
                 <c:pt idx="3">
-                  <c:v>0.0961694964864</c:v>
+                  <c:v>0.0898014434112</c:v>
                 </c:pt>
                 <c:pt idx="4">
-                  <c:v>0.1252571050368</c:v>
+                  <c:v>0.121878050976</c:v>
                 </c:pt>
               </c:numCache>
             </c:numRef>
@@ -561,19 +561,19 @@
                 <c:formatCode>General</c:formatCode>
                 <c:ptCount val="5"/>
                 <c:pt idx="0">
-                  <c:v>0.011869297632</c:v>
+                  <c:v>0.0107456651136</c:v>
                 </c:pt>
                 <c:pt idx="1">
-                  <c:v>0.027903810528</c:v>
+                  <c:v>0.0261108134496</c:v>
                 </c:pt>
                 <c:pt idx="2">
-                  <c:v>0.046725572736</c:v>
+                  <c:v>0.0448690281984</c:v>
                 </c:pt>
                 <c:pt idx="3">
-                  <c:v>0.068397219072</c:v>
+                  <c:v>0.06695462592</c:v>
                 </c:pt>
                 <c:pt idx="4">
-                  <c:v>0.092887432128</c:v>
+                  <c:v>0.0922039803072</c:v>
                 </c:pt>
               </c:numCache>
             </c:numRef>
@@ -624,19 +624,19 @@
                 <c:formatCode>General</c:formatCode>
                 <c:ptCount val="5"/>
                 <c:pt idx="0">
-                  <c:v>0.0148027652928</c:v>
+                  <c:v>0.0148488760224</c:v>
                 </c:pt>
                 <c:pt idx="1">
-                  <c:v>0.026614184256</c:v>
+                  <c:v>0.026673669792</c:v>
                 </c:pt>
                 <c:pt idx="2">
-                  <c:v>0.0401192331264</c:v>
+                  <c:v>0.0401788035072</c:v>
                 </c:pt>
                 <c:pt idx="3">
-                  <c:v>0.0552959167104</c:v>
+                  <c:v>0.055342833984</c:v>
                 </c:pt>
                 <c:pt idx="4">
-                  <c:v>0.072144235008</c:v>
+                  <c:v>0.072169173504</c:v>
                 </c:pt>
               </c:numCache>
             </c:numRef>
@@ -1797,31 +1797,31 @@
                 <c:formatCode>General</c:formatCode>
                 <c:ptCount val="9"/>
                 <c:pt idx="0">
-                  <c:v>0.36247</c:v>
+                  <c:v>0.34469</c:v>
                 </c:pt>
                 <c:pt idx="1">
-                  <c:v>0.434964</c:v>
+                  <c:v>0.43283</c:v>
                 </c:pt>
                 <c:pt idx="2">
-                  <c:v>0.434964</c:v>
+                  <c:v>0.42323</c:v>
                 </c:pt>
                 <c:pt idx="3">
-                  <c:v>0.36247</c:v>
+                  <c:v>0.359803</c:v>
                 </c:pt>
                 <c:pt idx="4">
-                  <c:v>0.254574</c:v>
+                  <c:v>0.254662</c:v>
                 </c:pt>
                 <c:pt idx="5">
-                  <c:v>0.434964</c:v>
+                  <c:v>0.413629</c:v>
                 </c:pt>
                 <c:pt idx="6">
-                  <c:v>0.398717</c:v>
+                  <c:v>0.37916</c:v>
                 </c:pt>
                 <c:pt idx="7">
                   <c:v>0.16123</c:v>
                 </c:pt>
                 <c:pt idx="8">
-                  <c:v>0.086058</c:v>
+                  <c:v>0.377163</c:v>
                 </c:pt>
               </c:numCache>
             </c:numRef>
@@ -1987,19 +1987,19 @@
                 <c:formatCode>General</c:formatCode>
                 <c:ptCount val="5"/>
                 <c:pt idx="0">
-                  <c:v>0.063</c:v>
+                  <c:v>0.054</c:v>
                 </c:pt>
                 <c:pt idx="1">
-                  <c:v>0.121</c:v>
+                  <c:v>0.108</c:v>
                 </c:pt>
                 <c:pt idx="2">
-                  <c:v>0.185</c:v>
+                  <c:v>0.173</c:v>
                 </c:pt>
                 <c:pt idx="3">
-                  <c:v>0.255</c:v>
+                  <c:v>0.247</c:v>
                 </c:pt>
                 <c:pt idx="4">
-                  <c:v>0.33</c:v>
+                  <c:v>0.332</c:v>
                 </c:pt>
               </c:numCache>
             </c:numRef>
@@ -2050,16 +2050,16 @@
                 <c:formatCode>General</c:formatCode>
                 <c:ptCount val="5"/>
                 <c:pt idx="0">
-                  <c:v>0.121</c:v>
+                  <c:v>0.103</c:v>
                 </c:pt>
                 <c:pt idx="1">
-                  <c:v>0.239</c:v>
+                  <c:v>0.212</c:v>
                 </c:pt>
                 <c:pt idx="2">
-                  <c:v>0.375</c:v>
+                  <c:v>0.347</c:v>
                 </c:pt>
                 <c:pt idx="3">
-                  <c:v>0.529</c:v>
+                  <c:v>0.51</c:v>
                 </c:pt>
                 <c:pt idx="4">
                   <c:v>0.7</c:v>
@@ -2113,19 +2113,19 @@
                 <c:formatCode>General</c:formatCode>
                 <c:ptCount val="5"/>
                 <c:pt idx="0">
-                  <c:v>0.182</c:v>
+                  <c:v>0.155</c:v>
                 </c:pt>
                 <c:pt idx="1">
-                  <c:v>0.374</c:v>
+                  <c:v>0.332</c:v>
                 </c:pt>
                 <c:pt idx="2">
-                  <c:v>0.608</c:v>
+                  <c:v>0.562</c:v>
                 </c:pt>
                 <c:pt idx="3">
-                  <c:v>0.887</c:v>
+                  <c:v>0.852</c:v>
                 </c:pt>
                 <c:pt idx="4">
-                  <c:v>1.212</c:v>
+                  <c:v>1.207</c:v>
                 </c:pt>
               </c:numCache>
             </c:numRef>
@@ -6116,7 +6116,7 @@
                         </a:defRPr>
                       </a:pPr>
                       <a:r>
-                        <a:t>DeepSeek</a:t>
+                        <a:t>Alibaba</a:t>
                       </a:r>
                     </a:p>
                   </a:txBody>
@@ -6139,7 +6139,7 @@
                         </a:defRPr>
                       </a:pPr>
                       <a:r>
-                        <a:t>0.00</a:t>
+                        <a:t>0.02</a:t>
                       </a:r>
                     </a:p>
                   </a:txBody>
@@ -6162,7 +6162,7 @@
                         </a:defRPr>
                       </a:pPr>
                       <a:r>
-                        <a:t>0.7</a:t>
+                        <a:t>1.7</a:t>
                       </a:r>
                     </a:p>
                   </a:txBody>
@@ -6185,7 +6185,7 @@
                         </a:defRPr>
                       </a:pPr>
                       <a:r>
-                        <a:t>33%</a:t>
+                        <a:t>20%</a:t>
                       </a:r>
                     </a:p>
                   </a:txBody>
@@ -6208,7 +6208,7 @@
                         </a:defRPr>
                       </a:pPr>
                       <a:r>
-                        <a:t>Deployment gap</a:t>
+                        <a:t>Serving efficiency</a:t>
                       </a:r>
                     </a:p>
                   </a:txBody>
@@ -6231,7 +6231,7 @@
                         </a:defRPr>
                       </a:pPr>
                       <a:r>
-                        <a:t>site energization, rack deployment, accelerator delivery</a:t>
+                        <a:t>model routing, precision, batching, TTFT/TPOT target</a:t>
                       </a:r>
                     </a:p>
                   </a:txBody>
@@ -6256,7 +6256,7 @@
                         </a:defRPr>
                       </a:pPr>
                       <a:r>
-                        <a:t>Alibaba</a:t>
+                        <a:t>Meta</a:t>
                       </a:r>
                     </a:p>
                   </a:txBody>
@@ -6279,7 +6279,7 @@
                         </a:defRPr>
                       </a:pPr>
                       <a:r>
-                        <a:t>0.02</a:t>
+                        <a:t>0.07</a:t>
                       </a:r>
                     </a:p>
                   </a:txBody>
@@ -6302,7 +6302,7 @@
                         </a:defRPr>
                       </a:pPr>
                       <a:r>
-                        <a:t>1.7</a:t>
+                        <a:t>3.3</a:t>
                       </a:r>
                     </a:p>
                   </a:txBody>
@@ -6325,7 +6325,7 @@
                         </a:defRPr>
                       </a:pPr>
                       <a:r>
-                        <a:t>20%</a:t>
+                        <a:t>17%</a:t>
                       </a:r>
                     </a:p>
                   </a:txBody>
@@ -6396,7 +6396,7 @@
                         </a:defRPr>
                       </a:pPr>
                       <a:r>
-                        <a:t>Meta</a:t>
+                        <a:t>OpenAI</a:t>
                       </a:r>
                     </a:p>
                   </a:txBody>
@@ -6419,7 +6419,7 @@
                         </a:defRPr>
                       </a:pPr>
                       <a:r>
-                        <a:t>0.07</a:t>
+                        <a:t>0.14</a:t>
                       </a:r>
                     </a:p>
                   </a:txBody>
@@ -6442,7 +6442,7 @@
                         </a:defRPr>
                       </a:pPr>
                       <a:r>
-                        <a:t>3.3</a:t>
+                        <a:t>4.9</a:t>
                       </a:r>
                     </a:p>
                   </a:txBody>
@@ -6465,7 +6465,7 @@
                         </a:defRPr>
                       </a:pPr>
                       <a:r>
-                        <a:t>17%</a:t>
+                        <a:t>29%</a:t>
                       </a:r>
                     </a:p>
                   </a:txBody>
@@ -6559,7 +6559,7 @@
                         </a:defRPr>
                       </a:pPr>
                       <a:r>
-                        <a:t>0.13</a:t>
+                        <a:t>0.12</a:t>
                       </a:r>
                     </a:p>
                   </a:txBody>
@@ -6676,7 +6676,7 @@
                         </a:defRPr>
                       </a:pPr>
                       <a:r>
-                        <a:t>OpenAI</a:t>
+                        <a:t>DeepSeek</a:t>
                       </a:r>
                     </a:p>
                   </a:txBody>
@@ -6699,7 +6699,7 @@
                         </a:defRPr>
                       </a:pPr>
                       <a:r>
-                        <a:t>0.15</a:t>
+                        <a:t>0.02</a:t>
                       </a:r>
                     </a:p>
                   </a:txBody>
@@ -6722,7 +6722,7 @@
                         </a:defRPr>
                       </a:pPr>
                       <a:r>
-                        <a:t>4.9</a:t>
+                        <a:t>0.7</a:t>
                       </a:r>
                     </a:p>
                   </a:txBody>
@@ -6745,7 +6745,7 @@
                         </a:defRPr>
                       </a:pPr>
                       <a:r>
-                        <a:t>29%</a:t>
+                        <a:t>33%</a:t>
                       </a:r>
                     </a:p>
                   </a:txBody>
@@ -6768,7 +6768,7 @@
                         </a:defRPr>
                       </a:pPr>
                       <a:r>
-                        <a:t>Scale absorption</a:t>
+                        <a:t>Deployment gap</a:t>
                       </a:r>
                     </a:p>
                   </a:txBody>
@@ -6791,7 +6791,7 @@
                         </a:defRPr>
                       </a:pPr>
                       <a:r>
-                        <a:t>demand absorption and product surface expansion</a:t>
+                        <a:t>site energization, rack deployment, accelerator delivery</a:t>
                       </a:r>
                     </a:p>
                   </a:txBody>
@@ -8327,7 +8327,7 @@
               </a:defRPr>
             </a:pPr>
             <a:r>
-              <a:t>Base growth: 5.8x, 2026-2030</a:t>
+              <a:t>Base growth: 6.8x, 2026-2030</a:t>
             </a:r>
           </a:p>
         </p:txBody>
@@ -9308,7 +9308,7 @@
               </a:defRPr>
             </a:pPr>
             <a:r>
-              <a:t>Workbook tabs: Logic, Benchmark Input, Inputs, Calculation, Output, Checks, Aggressive View. Derived output cells use Excel formulas.</a:t>
+              <a:t>Workbook tabs: Logic, Benchmark Input, Inputs, GPU Mix Input, Calculation, Output, Checks, Aggressive View. Derived output cells use Excel formulas.</a:t>
             </a:r>
           </a:p>
         </p:txBody>
@@ -10129,7 +10129,7 @@
               </a:defRPr>
             </a:pPr>
             <a:r>
-              <a:t>Top 3 providers account for 59% of modeled 2030 generated-token supply.</a:t>
+              <a:t>Top 3 providers account for 58% of modeled 2030 generated-token supply.</a:t>
             </a:r>
           </a:p>
         </p:txBody>
@@ -11305,7 +11305,7 @@
               </a:defRPr>
             </a:pPr>
             <a:r>
-              <a:t>generated output tokens/day = inference GW x 1,000 x selected output tokens/sec/MW x 86,400</a:t>
+              <a:t>generated output tokens/day = inference GW x 1,000 x fleet-weighted serving tokens/sec/MW x 86,400</a:t>
             </a:r>
           </a:p>
         </p:txBody>
@@ -11942,7 +11942,7 @@
                         </a:defRPr>
                       </a:pPr>
                       <a:r>
-                        <a:t>0.15</a:t>
+                        <a:t>0.14</a:t>
                       </a:r>
                     </a:p>
                   </a:txBody>
@@ -12130,7 +12130,7 @@
                         </a:defRPr>
                       </a:pPr>
                       <a:r>
-                        <a:t>0.13</a:t>
+                        <a:t>0.12</a:t>
                       </a:r>
                     </a:p>
                   </a:txBody>
@@ -12444,7 +12444,7 @@
               </a:defRPr>
             </a:pPr>
             <a:r>
-              <a:t>59%</a:t>
+              <a:t>58%</a:t>
             </a:r>
           </a:p>
         </p:txBody>
@@ -13087,7 +13087,7 @@
                         </a:defRPr>
                       </a:pPr>
                       <a:r>
-                        <a:t>0.02</a:t>
+                        <a:t>0.01</a:t>
                       </a:r>
                     </a:p>
                   </a:txBody>
@@ -13110,7 +13110,7 @@
                         </a:defRPr>
                       </a:pPr>
                       <a:r>
-                        <a:t>0.08</a:t>
+                        <a:t>0.06</a:t>
                       </a:r>
                     </a:p>
                   </a:txBody>
@@ -13133,7 +13133,7 @@
                         </a:defRPr>
                       </a:pPr>
                       <a:r>
-                        <a:t>0.15</a:t>
+                        <a:t>0.14</a:t>
                       </a:r>
                     </a:p>
                   </a:txBody>
@@ -13156,7 +13156,7 @@
                         </a:defRPr>
                       </a:pPr>
                       <a:r>
-                        <a:t>8.2x</a:t>
+                        <a:t>10.6x</a:t>
                       </a:r>
                     </a:p>
                   </a:txBody>
@@ -13273,7 +13273,7 @@
                         </a:defRPr>
                       </a:pPr>
                       <a:r>
-                        <a:t>4.0x</a:t>
+                        <a:t>4.3x</a:t>
                       </a:r>
                     </a:p>
                   </a:txBody>
@@ -13321,7 +13321,7 @@
                         </a:defRPr>
                       </a:pPr>
                       <a:r>
-                        <a:t>0.03</a:t>
+                        <a:t>0.02</a:t>
                       </a:r>
                     </a:p>
                   </a:txBody>
@@ -13344,7 +13344,7 @@
                         </a:defRPr>
                       </a:pPr>
                       <a:r>
-                        <a:t>0.07</a:t>
+                        <a:t>0.06</a:t>
                       </a:r>
                     </a:p>
                   </a:txBody>
@@ -13367,7 +13367,7 @@
                         </a:defRPr>
                       </a:pPr>
                       <a:r>
-                        <a:t>0.13</a:t>
+                        <a:t>0.12</a:t>
                       </a:r>
                     </a:p>
                   </a:txBody>
@@ -13390,7 +13390,7 @@
                         </a:defRPr>
                       </a:pPr>
                       <a:r>
-                        <a:t>4.7x</a:t>
+                        <a:t>6.0x</a:t>
                       </a:r>
                     </a:p>
                   </a:txBody>
@@ -13461,7 +13461,7 @@
                         </a:defRPr>
                       </a:pPr>
                       <a:r>
-                        <a:t>0.05</a:t>
+                        <a:t>0.04</a:t>
                       </a:r>
                     </a:p>
                   </a:txBody>
@@ -13507,7 +13507,7 @@
                         </a:defRPr>
                       </a:pPr>
                       <a:r>
-                        <a:t>7.8x</a:t>
+                        <a:t>8.6x</a:t>
                       </a:r>
                     </a:p>
                   </a:txBody>
@@ -13695,7 +13695,7 @@
                         </a:defRPr>
                       </a:pPr>
                       <a:r>
-                        <a:t>0.03</a:t>
+                        <a:t>0.02</a:t>
                       </a:r>
                     </a:p>
                   </a:txBody>
@@ -13741,7 +13741,7 @@
                         </a:defRPr>
                       </a:pPr>
                       <a:r>
-                        <a:t>7.1x</a:t>
+                        <a:t>9.3x</a:t>
                       </a:r>
                     </a:p>
                   </a:txBody>
@@ -13858,7 +13858,7 @@
                         </a:defRPr>
                       </a:pPr>
                       <a:r>
-                        <a:t>11.1x</a:t>
+                        <a:t>14.4x</a:t>
                       </a:r>
                     </a:p>
                   </a:txBody>
@@ -14046,7 +14046,7 @@
                         </a:defRPr>
                       </a:pPr>
                       <a:r>
-                        <a:t>0.00</a:t>
+                        <a:t>0.01</a:t>
                       </a:r>
                     </a:p>
                   </a:txBody>
@@ -14069,7 +14069,7 @@
                         </a:defRPr>
                       </a:pPr>
                       <a:r>
-                        <a:t>0.00</a:t>
+                        <a:t>0.02</a:t>
                       </a:r>
                     </a:p>
                   </a:txBody>
@@ -14092,7 +14092,7 @@
                         </a:defRPr>
                       </a:pPr>
                       <a:r>
-                        <a:t>10.7x</a:t>
+                        <a:t>42.9x</a:t>
                       </a:r>
                     </a:p>
                   </a:txBody>
@@ -17930,7 +17930,7 @@
               </a:defRPr>
             </a:pPr>
             <a:r>
-              <a:t>The third input adjusts a public InferenceX reference to commercial workload reality</a:t>
+              <a:t>The third input weights H200, B200, GB200 and purpose-built capacity into serving throughput</a:t>
             </a:r>
           </a:p>
         </p:txBody>
@@ -17965,7 +17965,7 @@
               </a:defRPr>
             </a:pPr>
             <a:r>
-              <a:t>A fixed B200 output-throughput median is the public reference ceiling; explicit workload-fit assumptions account for closed, reasoning and long-context serving.</a:t>
+              <a:t>GPU-generation mix is an editable scenario input; public reference rows are then adjusted for commercial workload fit.</a:t>
             </a:r>
           </a:p>
         </p:txBody>
@@ -18129,7 +18129,7 @@
                         </a:defRPr>
                       </a:pPr>
                       <a:r>
-                        <a:t>Proxy</a:t>
+                        <a:t>H/B/GB</a:t>
                       </a:r>
                     </a:p>
                   </a:txBody>
@@ -18200,7 +18200,7 @@
                         </a:defRPr>
                       </a:pPr>
                       <a:r>
-                        <a:t>DeepSeek</a:t>
+                        <a:t>Alibaba</a:t>
                       </a:r>
                     </a:p>
                   </a:txBody>
@@ -18223,7 +18223,7 @@
                         </a:defRPr>
                       </a:pPr>
                       <a:r>
-                        <a:t>dsr1</a:t>
+                        <a:t>10%/35%/55%</a:t>
                       </a:r>
                     </a:p>
                   </a:txBody>
@@ -18246,7 +18246,7 @@
                         </a:defRPr>
                       </a:pPr>
                       <a:r>
-                        <a:t>85%</a:t>
+                        <a:t>90%</a:t>
                       </a:r>
                     </a:p>
                   </a:txBody>
@@ -18269,7 +18269,7 @@
                         </a:defRPr>
                       </a:pPr>
                       <a:r>
-                        <a:t>0.09</a:t>
+                        <a:t>0.16</a:t>
                       </a:r>
                     </a:p>
                   </a:txBody>
@@ -18294,7 +18294,7 @@
                         </a:defRPr>
                       </a:pPr>
                       <a:r>
-                        <a:t>Alibaba</a:t>
+                        <a:t>Meta</a:t>
                       </a:r>
                     </a:p>
                   </a:txBody>
@@ -18317,7 +18317,7 @@
                         </a:defRPr>
                       </a:pPr>
                       <a:r>
-                        <a:t>qwen3.5</a:t>
+                        <a:t>6%/19%/30%</a:t>
                       </a:r>
                     </a:p>
                   </a:txBody>
@@ -18363,7 +18363,7 @@
                         </a:defRPr>
                       </a:pPr>
                       <a:r>
-                        <a:t>0.16</a:t>
+                        <a:t>0.25</a:t>
                       </a:r>
                     </a:p>
                   </a:txBody>
@@ -18388,7 +18388,7 @@
                         </a:defRPr>
                       </a:pPr>
                       <a:r>
-                        <a:t>Meta</a:t>
+                        <a:t>OpenAI</a:t>
                       </a:r>
                     </a:p>
                   </a:txBody>
@@ -18411,7 +18411,7 @@
                         </a:defRPr>
                       </a:pPr>
                       <a:r>
-                        <a:t>llama70b</a:t>
+                        <a:t>10%/35%/55%</a:t>
                       </a:r>
                     </a:p>
                   </a:txBody>
@@ -18434,7 +18434,7 @@
                         </a:defRPr>
                       </a:pPr>
                       <a:r>
-                        <a:t>90%</a:t>
+                        <a:t>50%</a:t>
                       </a:r>
                     </a:p>
                   </a:txBody>
@@ -18457,7 +18457,7 @@
                         </a:defRPr>
                       </a:pPr>
                       <a:r>
-                        <a:t>0.25</a:t>
+                        <a:t>0.34</a:t>
                       </a:r>
                     </a:p>
                   </a:txBody>
@@ -18482,7 +18482,7 @@
                         </a:defRPr>
                       </a:pPr>
                       <a:r>
-                        <a:t>OpenAI</a:t>
+                        <a:t>Anthropic</a:t>
                       </a:r>
                     </a:p>
                   </a:txBody>
@@ -18505,7 +18505,7 @@
                         </a:defRPr>
                       </a:pPr>
                       <a:r>
-                        <a:t>gptoss120b</a:t>
+                        <a:t>2%/5%/8%</a:t>
                       </a:r>
                     </a:p>
                   </a:txBody>
@@ -18576,7 +18576,7 @@
                         </a:defRPr>
                       </a:pPr>
                       <a:r>
-                        <a:t>Anthropic</a:t>
+                        <a:t>DeepSeek</a:t>
                       </a:r>
                     </a:p>
                   </a:txBody>
@@ -18599,7 +18599,7 @@
                         </a:defRPr>
                       </a:pPr>
                       <a:r>
-                        <a:t>gptoss120b</a:t>
+                        <a:t>10%/35%/55%</a:t>
                       </a:r>
                     </a:p>
                   </a:txBody>
@@ -18622,7 +18622,7 @@
                         </a:defRPr>
                       </a:pPr>
                       <a:r>
-                        <a:t>50%</a:t>
+                        <a:t>85%</a:t>
                       </a:r>
                     </a:p>
                   </a:txBody>
@@ -18645,7 +18645,7 @@
                         </a:defRPr>
                       </a:pPr>
                       <a:r>
-                        <a:t>0.36</a:t>
+                        <a:t>0.38</a:t>
                       </a:r>
                     </a:p>
                   </a:txBody>
@@ -18770,7 +18770,7 @@
               </a:defRPr>
             </a:pPr>
             <a:r>
-              <a:t>Base TPS/MW is a workload-adjusted serving reference, while the raw public benchmark defines upside ceiling.</a:t>
+              <a:t>Base TPS/MW reflects an editable GPU-generation mix and workload fit; public benchmark values define the reference layer.</a:t>
             </a:r>
           </a:p>
         </p:txBody>

</xml_diff>

<commit_message>
Refresh InferenceX database and main config filters
</commit_message>
<xml_diff>
--- a/llm_token_capacity_project/outputs/reports/llm_token_capacity_2026_2030.pptx
+++ b/llm_token_capacity_project/outputs/reports/llm_token_capacity_2026_2030.pptx
@@ -183,31 +183,31 @@
                 <c:formatCode>General</c:formatCode>
                 <c:ptCount val="9"/>
                 <c:pt idx="0">
-                  <c:v>0.144796272192</c:v>
+                  <c:v>0.1445198616576</c:v>
                 </c:pt>
                 <c:pt idx="1">
-                  <c:v>0.136534665312</c:v>
+                  <c:v>0.1362573879264</c:v>
                 </c:pt>
                 <c:pt idx="2">
-                  <c:v>0.121878050976</c:v>
+                  <c:v>0.121637595024</c:v>
                 </c:pt>
                 <c:pt idx="3">
-                  <c:v>0.0922039803072</c:v>
+                  <c:v>0.0920171650176</c:v>
                 </c:pt>
                 <c:pt idx="4">
-                  <c:v>0.072169173504</c:v>
+                  <c:v>0.051255410688</c:v>
                 </c:pt>
                 <c:pt idx="5">
-                  <c:v>0.0468519222816</c:v>
+                  <c:v>0.0467623253952</c:v>
                 </c:pt>
                 <c:pt idx="6">
-                  <c:v>0.039933737856</c:v>
+                  <c:v>0.039857379696</c:v>
                 </c:pt>
                 <c:pt idx="7">
-                  <c:v>0.024350115456</c:v>
+                  <c:v>0.0230393503872</c:v>
                 </c:pt>
                 <c:pt idx="8">
-                  <c:v>0.0212140609632</c:v>
+                  <c:v>0.0030995703648</c:v>
                 </c:pt>
               </c:numCache>
             </c:numRef>
@@ -372,19 +372,19 @@
                 <c:formatCode>General</c:formatCode>
                 <c:ptCount val="5"/>
                 <c:pt idx="0">
-                  <c:v>0.013606875072</c:v>
+                  <c:v>0.013592069568</c:v>
                 </c:pt>
                 <c:pt idx="1">
-                  <c:v>0.0360722014848</c:v>
+                  <c:v>0.0360240369408</c:v>
                 </c:pt>
                 <c:pt idx="2">
-                  <c:v>0.0649699933824</c:v>
+                  <c:v>0.0648691331328</c:v>
                 </c:pt>
                 <c:pt idx="3">
-                  <c:v>0.100963584</c:v>
+                  <c:v>0.10078753536</c:v>
                 </c:pt>
                 <c:pt idx="4">
-                  <c:v>0.144796272192</c:v>
+                  <c:v>0.1445198616576</c:v>
                 </c:pt>
               </c:numCache>
             </c:numRef>
@@ -435,19 +435,19 @@
                 <c:formatCode>General</c:formatCode>
                 <c:ptCount val="5"/>
                 <c:pt idx="0">
-                  <c:v>0.032068957536</c:v>
+                  <c:v>0.032008169952</c:v>
                 </c:pt>
                 <c:pt idx="1">
-                  <c:v>0.053519035392</c:v>
+                  <c:v>0.053415075456</c:v>
                 </c:pt>
                 <c:pt idx="2">
-                  <c:v>0.078160101984</c:v>
+                  <c:v>0.0780052584096</c:v>
                 </c:pt>
                 <c:pt idx="3">
-                  <c:v>0.105872362416</c:v>
+                  <c:v>0.105659731152</c:v>
                 </c:pt>
                 <c:pt idx="4">
-                  <c:v>0.136534665312</c:v>
+                  <c:v>0.1362573879264</c:v>
                 </c:pt>
               </c:numCache>
             </c:numRef>
@@ -498,19 +498,19 @@
                 <c:formatCode>General</c:formatCode>
                 <c:ptCount val="5"/>
                 <c:pt idx="0">
-                  <c:v>0.020203891776</c:v>
+                  <c:v>0.02017941552</c:v>
                 </c:pt>
                 <c:pt idx="1">
-                  <c:v>0.0387030811392</c:v>
+                  <c:v>0.038645008848</c:v>
                 </c:pt>
                 <c:pt idx="2">
-                  <c:v>0.0619085392416</c:v>
+                  <c:v>0.0618029473824</c:v>
                 </c:pt>
                 <c:pt idx="3">
-                  <c:v>0.0898014434112</c:v>
+                  <c:v>0.0896342936256</c:v>
                 </c:pt>
                 <c:pt idx="4">
-                  <c:v>0.121878050976</c:v>
+                  <c:v>0.121637595024</c:v>
                 </c:pt>
               </c:numCache>
             </c:numRef>
@@ -561,19 +561,19 @@
                 <c:formatCode>General</c:formatCode>
                 <c:ptCount val="5"/>
                 <c:pt idx="0">
-                  <c:v>0.0107456651136</c:v>
+                  <c:v>0.0107266071744</c:v>
                 </c:pt>
                 <c:pt idx="1">
-                  <c:v>0.0261108134496</c:v>
+                  <c:v>0.0260620835904</c:v>
                 </c:pt>
                 <c:pt idx="2">
-                  <c:v>0.0448690281984</c:v>
+                  <c:v>0.0447821436672</c:v>
                 </c:pt>
                 <c:pt idx="3">
-                  <c:v>0.06695462592</c:v>
+                  <c:v>0.066821594112</c:v>
                 </c:pt>
                 <c:pt idx="4">
-                  <c:v>0.0922039803072</c:v>
+                  <c:v>0.0920171650176</c:v>
                 </c:pt>
               </c:numCache>
             </c:numRef>
@@ -624,19 +624,19 @@
                 <c:formatCode>General</c:formatCode>
                 <c:ptCount val="5"/>
                 <c:pt idx="0">
-                  <c:v>0.0148488760224</c:v>
+                  <c:v>0.0105596478144</c:v>
                 </c:pt>
                 <c:pt idx="1">
-                  <c:v>0.026673669792</c:v>
+                  <c:v>0.018960831648</c:v>
                 </c:pt>
                 <c:pt idx="2">
-                  <c:v>0.0401788035072</c:v>
+                  <c:v>0.0285507597312</c:v>
                 </c:pt>
                 <c:pt idx="3">
-                  <c:v>0.055342833984</c:v>
+                  <c:v>0.0393145031808</c:v>
                 </c:pt>
                 <c:pt idx="4">
-                  <c:v>0.072169173504</c:v>
+                  <c:v>0.051255410688</c:v>
                 </c:pt>
               </c:numCache>
             </c:numRef>
@@ -1797,31 +1797,31 @@
                 <c:formatCode>General</c:formatCode>
                 <c:ptCount val="9"/>
                 <c:pt idx="0">
-                  <c:v>0.34469</c:v>
+                  <c:v>0.344032</c:v>
                 </c:pt>
                 <c:pt idx="1">
-                  <c:v>0.43283</c:v>
+                  <c:v>0.431951</c:v>
                 </c:pt>
                 <c:pt idx="2">
-                  <c:v>0.42323</c:v>
+                  <c:v>0.422395</c:v>
                 </c:pt>
                 <c:pt idx="3">
-                  <c:v>0.359803</c:v>
+                  <c:v>0.359074</c:v>
                 </c:pt>
                 <c:pt idx="4">
-                  <c:v>0.254662</c:v>
+                  <c:v>0.180864</c:v>
                 </c:pt>
                 <c:pt idx="5">
-                  <c:v>0.413629</c:v>
+                  <c:v>0.412838</c:v>
                 </c:pt>
                 <c:pt idx="6">
-                  <c:v>0.37916</c:v>
+                  <c:v>0.378435</c:v>
                 </c:pt>
                 <c:pt idx="7">
-                  <c:v>0.16123</c:v>
+                  <c:v>0.152551</c:v>
                 </c:pt>
                 <c:pt idx="8">
-                  <c:v>0.377163</c:v>
+                  <c:v>0.055107</c:v>
                 </c:pt>
               </c:numCache>
             </c:numRef>
@@ -1987,19 +1987,19 @@
                 <c:formatCode>General</c:formatCode>
                 <c:ptCount val="5"/>
                 <c:pt idx="0">
-                  <c:v>0.054</c:v>
+                  <c:v>0.051</c:v>
                 </c:pt>
                 <c:pt idx="1">
-                  <c:v>0.108</c:v>
+                  <c:v>0.101</c:v>
                 </c:pt>
                 <c:pt idx="2">
-                  <c:v>0.173</c:v>
+                  <c:v>0.161</c:v>
                 </c:pt>
                 <c:pt idx="3">
-                  <c:v>0.247</c:v>
+                  <c:v>0.23</c:v>
                 </c:pt>
                 <c:pt idx="4">
-                  <c:v>0.332</c:v>
+                  <c:v>0.308</c:v>
                 </c:pt>
               </c:numCache>
             </c:numRef>
@@ -2050,19 +2050,19 @@
                 <c:formatCode>General</c:formatCode>
                 <c:ptCount val="5"/>
                 <c:pt idx="0">
-                  <c:v>0.103</c:v>
+                  <c:v>0.098</c:v>
                 </c:pt>
                 <c:pt idx="1">
-                  <c:v>0.212</c:v>
+                  <c:v>0.201</c:v>
                 </c:pt>
                 <c:pt idx="2">
-                  <c:v>0.347</c:v>
+                  <c:v>0.328</c:v>
                 </c:pt>
                 <c:pt idx="3">
-                  <c:v>0.51</c:v>
+                  <c:v>0.481</c:v>
                 </c:pt>
                 <c:pt idx="4">
-                  <c:v>0.7</c:v>
+                  <c:v>0.658</c:v>
                 </c:pt>
               </c:numCache>
             </c:numRef>
@@ -2113,19 +2113,19 @@
                 <c:formatCode>General</c:formatCode>
                 <c:ptCount val="5"/>
                 <c:pt idx="0">
-                  <c:v>0.155</c:v>
+                  <c:v>0.148</c:v>
                 </c:pt>
                 <c:pt idx="1">
-                  <c:v>0.332</c:v>
+                  <c:v>0.316</c:v>
                 </c:pt>
                 <c:pt idx="2">
-                  <c:v>0.562</c:v>
+                  <c:v>0.535</c:v>
                 </c:pt>
                 <c:pt idx="3">
-                  <c:v>0.852</c:v>
+                  <c:v>0.81</c:v>
                 </c:pt>
                 <c:pt idx="4">
-                  <c:v>1.207</c:v>
+                  <c:v>1.145</c:v>
                 </c:pt>
               </c:numCache>
             </c:numRef>
@@ -5605,7 +5605,7 @@
               </a:defRPr>
             </a:pPr>
             <a:r>
-              <a:t>0.70Q</a:t>
+              <a:t>0.66Q</a:t>
             </a:r>
           </a:p>
         </p:txBody>
@@ -6116,7 +6116,7 @@
                         </a:defRPr>
                       </a:pPr>
                       <a:r>
-                        <a:t>Alibaba</a:t>
+                        <a:t>DeepSeek</a:t>
                       </a:r>
                     </a:p>
                   </a:txBody>
@@ -6139,7 +6139,7 @@
                         </a:defRPr>
                       </a:pPr>
                       <a:r>
-                        <a:t>0.02</a:t>
+                        <a:t>0.00</a:t>
                       </a:r>
                     </a:p>
                   </a:txBody>
@@ -6162,7 +6162,7 @@
                         </a:defRPr>
                       </a:pPr>
                       <a:r>
-                        <a:t>1.7</a:t>
+                        <a:t>0.7</a:t>
                       </a:r>
                     </a:p>
                   </a:txBody>
@@ -6185,7 +6185,7 @@
                         </a:defRPr>
                       </a:pPr>
                       <a:r>
-                        <a:t>20%</a:t>
+                        <a:t>33%</a:t>
                       </a:r>
                     </a:p>
                   </a:txBody>
@@ -6208,7 +6208,7 @@
                         </a:defRPr>
                       </a:pPr>
                       <a:r>
-                        <a:t>Serving efficiency</a:t>
+                        <a:t>Deployment gap</a:t>
                       </a:r>
                     </a:p>
                   </a:txBody>
@@ -6231,7 +6231,7 @@
                         </a:defRPr>
                       </a:pPr>
                       <a:r>
-                        <a:t>model routing, precision, batching, TTFT/TPOT target</a:t>
+                        <a:t>site energization, rack deployment, accelerator delivery</a:t>
                       </a:r>
                     </a:p>
                   </a:txBody>
@@ -6256,7 +6256,7 @@
                         </a:defRPr>
                       </a:pPr>
                       <a:r>
-                        <a:t>Meta</a:t>
+                        <a:t>Alibaba</a:t>
                       </a:r>
                     </a:p>
                   </a:txBody>
@@ -6279,7 +6279,7 @@
                         </a:defRPr>
                       </a:pPr>
                       <a:r>
-                        <a:t>0.07</a:t>
+                        <a:t>0.02</a:t>
                       </a:r>
                     </a:p>
                   </a:txBody>
@@ -6302,7 +6302,7 @@
                         </a:defRPr>
                       </a:pPr>
                       <a:r>
-                        <a:t>3.3</a:t>
+                        <a:t>1.7</a:t>
                       </a:r>
                     </a:p>
                   </a:txBody>
@@ -6325,7 +6325,7 @@
                         </a:defRPr>
                       </a:pPr>
                       <a:r>
-                        <a:t>17%</a:t>
+                        <a:t>20%</a:t>
                       </a:r>
                     </a:p>
                   </a:txBody>
@@ -6396,7 +6396,7 @@
                         </a:defRPr>
                       </a:pPr>
                       <a:r>
-                        <a:t>OpenAI</a:t>
+                        <a:t>Meta</a:t>
                       </a:r>
                     </a:p>
                   </a:txBody>
@@ -6419,7 +6419,7 @@
                         </a:defRPr>
                       </a:pPr>
                       <a:r>
-                        <a:t>0.14</a:t>
+                        <a:t>0.05</a:t>
                       </a:r>
                     </a:p>
                   </a:txBody>
@@ -6442,7 +6442,7 @@
                         </a:defRPr>
                       </a:pPr>
                       <a:r>
-                        <a:t>4.9</a:t>
+                        <a:t>3.3</a:t>
                       </a:r>
                     </a:p>
                   </a:txBody>
@@ -6465,7 +6465,7 @@
                         </a:defRPr>
                       </a:pPr>
                       <a:r>
-                        <a:t>29%</a:t>
+                        <a:t>17%</a:t>
                       </a:r>
                     </a:p>
                   </a:txBody>
@@ -6676,7 +6676,7 @@
                         </a:defRPr>
                       </a:pPr>
                       <a:r>
-                        <a:t>DeepSeek</a:t>
+                        <a:t>OpenAI</a:t>
                       </a:r>
                     </a:p>
                   </a:txBody>
@@ -6699,7 +6699,7 @@
                         </a:defRPr>
                       </a:pPr>
                       <a:r>
-                        <a:t>0.02</a:t>
+                        <a:t>0.14</a:t>
                       </a:r>
                     </a:p>
                   </a:txBody>
@@ -6722,7 +6722,7 @@
                         </a:defRPr>
                       </a:pPr>
                       <a:r>
-                        <a:t>0.7</a:t>
+                        <a:t>4.9</a:t>
                       </a:r>
                     </a:p>
                   </a:txBody>
@@ -6745,7 +6745,7 @@
                         </a:defRPr>
                       </a:pPr>
                       <a:r>
-                        <a:t>33%</a:t>
+                        <a:t>29%</a:t>
                       </a:r>
                     </a:p>
                   </a:txBody>
@@ -6768,7 +6768,7 @@
                         </a:defRPr>
                       </a:pPr>
                       <a:r>
-                        <a:t>Deployment gap</a:t>
+                        <a:t>Serving efficiency</a:t>
                       </a:r>
                     </a:p>
                   </a:txBody>
@@ -6791,7 +6791,7 @@
                         </a:defRPr>
                       </a:pPr>
                       <a:r>
-                        <a:t>site energization, rack deployment, accelerator delivery</a:t>
+                        <a:t>model routing, precision, batching, TTFT/TPOT target</a:t>
                       </a:r>
                     </a:p>
                   </a:txBody>
@@ -7945,7 +7945,7 @@
                         </a:defRPr>
                       </a:pPr>
                       <a:r>
-                        <a:t>0.33</a:t>
+                        <a:t>0.31</a:t>
                       </a:r>
                     </a:p>
                   </a:txBody>
@@ -8039,7 +8039,7 @@
                         </a:defRPr>
                       </a:pPr>
                       <a:r>
-                        <a:t>0.70</a:t>
+                        <a:t>0.66</a:t>
                       </a:r>
                     </a:p>
                   </a:txBody>
@@ -8133,7 +8133,7 @@
                         </a:defRPr>
                       </a:pPr>
                       <a:r>
-                        <a:t>1.21</a:t>
+                        <a:t>1.15</a:t>
                       </a:r>
                     </a:p>
                   </a:txBody>
@@ -8327,7 +8327,7 @@
               </a:defRPr>
             </a:pPr>
             <a:r>
-              <a:t>Base growth: 6.8x, 2026-2030</a:t>
+              <a:t>Base growth: 6.7x, 2026-2030</a:t>
             </a:r>
           </a:p>
         </p:txBody>
@@ -10129,7 +10129,7 @@
               </a:defRPr>
             </a:pPr>
             <a:r>
-              <a:t>Top 3 providers account for 58% of modeled 2030 generated-token supply.</a:t>
+              <a:t>Top 3 providers account for 61% of modeled 2030 generated-token supply.</a:t>
             </a:r>
           </a:p>
         </p:txBody>
@@ -12318,7 +12318,7 @@
                         </a:defRPr>
                       </a:pPr>
                       <a:r>
-                        <a:t>0.07</a:t>
+                        <a:t>0.05</a:t>
                       </a:r>
                     </a:p>
                   </a:txBody>
@@ -12444,7 +12444,7 @@
               </a:defRPr>
             </a:pPr>
             <a:r>
-              <a:t>58%</a:t>
+              <a:t>61%</a:t>
             </a:r>
           </a:p>
         </p:txBody>
@@ -13578,7 +13578,7 @@
                         </a:defRPr>
                       </a:pPr>
                       <a:r>
-                        <a:t>0.04</a:t>
+                        <a:t>0.03</a:t>
                       </a:r>
                     </a:p>
                   </a:txBody>
@@ -13601,7 +13601,7 @@
                         </a:defRPr>
                       </a:pPr>
                       <a:r>
-                        <a:t>0.07</a:t>
+                        <a:t>0.05</a:t>
                       </a:r>
                     </a:p>
                   </a:txBody>
@@ -13975,7 +13975,7 @@
                         </a:defRPr>
                       </a:pPr>
                       <a:r>
-                        <a:t>6.6x</a:t>
+                        <a:t>8.6x</a:t>
                       </a:r>
                     </a:p>
                   </a:txBody>
@@ -14046,7 +14046,7 @@
                         </a:defRPr>
                       </a:pPr>
                       <a:r>
-                        <a:t>0.01</a:t>
+                        <a:t>0.00</a:t>
                       </a:r>
                     </a:p>
                   </a:txBody>
@@ -14069,7 +14069,7 @@
                         </a:defRPr>
                       </a:pPr>
                       <a:r>
-                        <a:t>0.02</a:t>
+                        <a:t>0.00</a:t>
                       </a:r>
                     </a:p>
                   </a:txBody>
@@ -14092,7 +14092,7 @@
                         </a:defRPr>
                       </a:pPr>
                       <a:r>
-                        <a:t>42.9x</a:t>
+                        <a:t>10.9x</a:t>
                       </a:r>
                     </a:p>
                   </a:txBody>
@@ -18200,7 +18200,7 @@
                         </a:defRPr>
                       </a:pPr>
                       <a:r>
-                        <a:t>Alibaba</a:t>
+                        <a:t>DeepSeek</a:t>
                       </a:r>
                     </a:p>
                   </a:txBody>
@@ -18246,7 +18246,7 @@
                         </a:defRPr>
                       </a:pPr>
                       <a:r>
-                        <a:t>90%</a:t>
+                        <a:t>85%</a:t>
                       </a:r>
                     </a:p>
                   </a:txBody>
@@ -18269,7 +18269,7 @@
                         </a:defRPr>
                       </a:pPr>
                       <a:r>
-                        <a:t>0.16</a:t>
+                        <a:t>0.06</a:t>
                       </a:r>
                     </a:p>
                   </a:txBody>
@@ -18294,7 +18294,7 @@
                         </a:defRPr>
                       </a:pPr>
                       <a:r>
-                        <a:t>Meta</a:t>
+                        <a:t>Alibaba</a:t>
                       </a:r>
                     </a:p>
                   </a:txBody>
@@ -18317,7 +18317,7 @@
                         </a:defRPr>
                       </a:pPr>
                       <a:r>
-                        <a:t>6%/19%/30%</a:t>
+                        <a:t>10%/35%/55%</a:t>
                       </a:r>
                     </a:p>
                   </a:txBody>
@@ -18363,7 +18363,7 @@
                         </a:defRPr>
                       </a:pPr>
                       <a:r>
-                        <a:t>0.25</a:t>
+                        <a:t>0.15</a:t>
                       </a:r>
                     </a:p>
                   </a:txBody>
@@ -18388,7 +18388,7 @@
                         </a:defRPr>
                       </a:pPr>
                       <a:r>
-                        <a:t>OpenAI</a:t>
+                        <a:t>Meta</a:t>
                       </a:r>
                     </a:p>
                   </a:txBody>
@@ -18411,7 +18411,7 @@
                         </a:defRPr>
                       </a:pPr>
                       <a:r>
-                        <a:t>10%/35%/55%</a:t>
+                        <a:t>6%/19%/30%</a:t>
                       </a:r>
                     </a:p>
                   </a:txBody>
@@ -18434,7 +18434,7 @@
                         </a:defRPr>
                       </a:pPr>
                       <a:r>
-                        <a:t>50%</a:t>
+                        <a:t>90%</a:t>
                       </a:r>
                     </a:p>
                   </a:txBody>
@@ -18457,7 +18457,7 @@
                         </a:defRPr>
                       </a:pPr>
                       <a:r>
-                        <a:t>0.34</a:t>
+                        <a:t>0.18</a:t>
                       </a:r>
                     </a:p>
                   </a:txBody>
@@ -18482,7 +18482,7 @@
                         </a:defRPr>
                       </a:pPr>
                       <a:r>
-                        <a:t>Anthropic</a:t>
+                        <a:t>OpenAI</a:t>
                       </a:r>
                     </a:p>
                   </a:txBody>
@@ -18505,7 +18505,7 @@
                         </a:defRPr>
                       </a:pPr>
                       <a:r>
-                        <a:t>2%/5%/8%</a:t>
+                        <a:t>10%/35%/55%</a:t>
                       </a:r>
                     </a:p>
                   </a:txBody>
@@ -18551,7 +18551,7 @@
                         </a:defRPr>
                       </a:pPr>
                       <a:r>
-                        <a:t>0.36</a:t>
+                        <a:t>0.34</a:t>
                       </a:r>
                     </a:p>
                   </a:txBody>
@@ -18576,7 +18576,7 @@
                         </a:defRPr>
                       </a:pPr>
                       <a:r>
-                        <a:t>DeepSeek</a:t>
+                        <a:t>Anthropic</a:t>
                       </a:r>
                     </a:p>
                   </a:txBody>
@@ -18599,7 +18599,7 @@
                         </a:defRPr>
                       </a:pPr>
                       <a:r>
-                        <a:t>10%/35%/55%</a:t>
+                        <a:t>2%/5%/8%</a:t>
                       </a:r>
                     </a:p>
                   </a:txBody>
@@ -18622,7 +18622,7 @@
                         </a:defRPr>
                       </a:pPr>
                       <a:r>
-                        <a:t>85%</a:t>
+                        <a:t>50%</a:t>
                       </a:r>
                     </a:p>
                   </a:txBody>
@@ -18645,7 +18645,7 @@
                         </a:defRPr>
                       </a:pPr>
                       <a:r>
-                        <a:t>0.38</a:t>
+                        <a:t>0.36</a:t>
                       </a:r>
                     </a:p>
                   </a:txBody>

</xml_diff>

<commit_message>
Add Epoch AI chip sales analysis report
</commit_message>
<xml_diff>
--- a/llm_token_capacity_project/outputs/reports/llm_token_capacity_2026_2030.pptx
+++ b/llm_token_capacity_project/outputs/reports/llm_token_capacity_2026_2030.pptx
@@ -17,6 +17,7 @@
     <p:sldId id="265" r:id="rId16"/>
     <p:sldId id="266" r:id="rId17"/>
     <p:sldId id="267" r:id="rId18"/>
+    <p:sldId id="268" r:id="rId19"/>
   </p:sldIdLst>
   <p:sldSz cx="12191695" cy="6858000" type="screen4x3"/>
   <p:notesSz cx="6858000" cy="9144000"/>
@@ -8618,7 +8619,7 @@
               </a:defRPr>
             </a:pPr>
             <a:r>
-              <a:t>The operating agenda is to verify the bottleneck, then update the provider model</a:t>
+              <a:t>Evidence base now separates official submissions, serving proxies, and provenance</a:t>
             </a:r>
           </a:p>
         </p:txBody>
@@ -8653,7 +8654,7 @@
               </a:defRPr>
             </a:pPr>
             <a:r>
-              <a:t>This is the checklist that keeps the simulation tied to facts as new capacity, model, and benchmark data arrives.</a:t>
+              <a:t>The workbook carries the source registry and number-level provenance so benchmark evidence is visible without changing the headline formula.</a:t>
             </a:r>
           </a:p>
         </p:txBody>
@@ -8703,16 +8704,469 @@
           </a:p>
         </p:txBody>
       </p:sp>
-      <p:sp>
-        <p:nvSpPr>
-          <p:cNvPr id="7" name="TextBox 6"/>
+      <p:graphicFrame>
+        <p:nvGraphicFramePr>
+          <p:cNvPr id="7" name="Table 6"/>
+          <p:cNvGraphicFramePr>
+            <a:graphicFrameLocks noGrp="1"/>
+          </p:cNvGraphicFramePr>
+          <p:nvPr/>
+        </p:nvGraphicFramePr>
+        <p:xfrm>
+          <a:off x="749808" y="1737360"/>
+          <a:ext cx="10698479" cy="3063240"/>
+        </p:xfrm>
+        <a:graphic>
+          <a:graphicData uri="http://schemas.openxmlformats.org/drawingml/2006/table">
+            <a:tbl>
+              <a:tblPr firstRow="1" bandRow="1">
+                <a:tableStyleId>{5C22544A-7EE6-4342-B048-85BDC9FD1C3A}</a:tableStyleId>
+              </a:tblPr>
+              <a:tblGrid>
+                <a:gridCol w="1874519"/>
+                <a:gridCol w="3246120"/>
+                <a:gridCol w="5577840"/>
+              </a:tblGrid>
+              <a:tr h="510540">
+                <a:tc>
+                  <a:txBody>
+                    <a:bodyPr/>
+                    <a:lstStyle/>
+                    <a:p>
+                      <a:pPr>
+                        <a:defRPr sz="819" b="1">
+                          <a:solidFill>
+                            <a:srgbClr val="FFFFFF"/>
+                          </a:solidFill>
+                        </a:defRPr>
+                      </a:pPr>
+                      <a:r>
+                        <a:t>Layer</a:t>
+                      </a:r>
+                    </a:p>
+                  </a:txBody>
+                  <a:tcPr marL="50292" marR="50292" marT="32004" marB="32004">
+                    <a:solidFill>
+                      <a:srgbClr val="1428A0"/>
+                    </a:solidFill>
+                  </a:tcPr>
+                </a:tc>
+                <a:tc>
+                  <a:txBody>
+                    <a:bodyPr/>
+                    <a:lstStyle/>
+                    <a:p>
+                      <a:pPr>
+                        <a:defRPr sz="819" b="1">
+                          <a:solidFill>
+                            <a:srgbClr val="FFFFFF"/>
+                          </a:solidFill>
+                        </a:defRPr>
+                      </a:pPr>
+                      <a:r>
+                        <a:t>Source set</a:t>
+                      </a:r>
+                    </a:p>
+                  </a:txBody>
+                  <a:tcPr marL="50292" marR="50292" marT="32004" marB="32004">
+                    <a:solidFill>
+                      <a:srgbClr val="1428A0"/>
+                    </a:solidFill>
+                  </a:tcPr>
+                </a:tc>
+                <a:tc>
+                  <a:txBody>
+                    <a:bodyPr/>
+                    <a:lstStyle/>
+                    <a:p>
+                      <a:pPr>
+                        <a:defRPr sz="819" b="1">
+                          <a:solidFill>
+                            <a:srgbClr val="FFFFFF"/>
+                          </a:solidFill>
+                        </a:defRPr>
+                      </a:pPr>
+                      <a:r>
+                        <a:t>How it is used</a:t>
+                      </a:r>
+                    </a:p>
+                  </a:txBody>
+                  <a:tcPr marL="50292" marR="50292" marT="32004" marB="32004">
+                    <a:solidFill>
+                      <a:srgbClr val="1428A0"/>
+                    </a:solidFill>
+                  </a:tcPr>
+                </a:tc>
+              </a:tr>
+              <a:tr h="510540">
+                <a:tc>
+                  <a:txBody>
+                    <a:bodyPr/>
+                    <a:lstStyle/>
+                    <a:p>
+                      <a:pPr>
+                        <a:defRPr sz="800" b="0">
+                          <a:solidFill>
+                            <a:srgbClr val="3A4252"/>
+                          </a:solidFill>
+                        </a:defRPr>
+                      </a:pPr>
+                      <a:r>
+                        <a:t>Official benchmark</a:t>
+                      </a:r>
+                    </a:p>
+                  </a:txBody>
+                  <a:tcPr marL="50292" marR="50292" marT="32004" marB="32004">
+                    <a:solidFill>
+                      <a:srgbClr val="FFFFFF"/>
+                    </a:solidFill>
+                  </a:tcPr>
+                </a:tc>
+                <a:tc>
+                  <a:txBody>
+                    <a:bodyPr/>
+                    <a:lstStyle/>
+                    <a:p>
+                      <a:pPr>
+                        <a:defRPr sz="800" b="0">
+                          <a:solidFill>
+                            <a:srgbClr val="3A4252"/>
+                          </a:solidFill>
+                        </a:defRPr>
+                      </a:pPr>
+                      <a:r>
+                        <a:t>MLPerf Inference / MLPerf Power</a:t>
+                      </a:r>
+                    </a:p>
+                  </a:txBody>
+                  <a:tcPr marL="50292" marR="50292" marT="32004" marB="32004">
+                    <a:solidFill>
+                      <a:srgbClr val="FFFFFF"/>
+                    </a:solidFill>
+                  </a:tcPr>
+                </a:tc>
+                <a:tc>
+                  <a:txBody>
+                    <a:bodyPr/>
+                    <a:lstStyle/>
+                    <a:p>
+                      <a:pPr>
+                        <a:defRPr sz="800" b="0">
+                          <a:solidFill>
+                            <a:srgbClr val="3A4252"/>
+                          </a:solidFill>
+                        </a:defRPr>
+                      </a:pPr>
+                      <a:r>
+                        <a:t>hardware and power/performance anchor; not production telemetry</a:t>
+                      </a:r>
+                    </a:p>
+                  </a:txBody>
+                  <a:tcPr marL="50292" marR="50292" marT="32004" marB="32004">
+                    <a:solidFill>
+                      <a:srgbClr val="FFFFFF"/>
+                    </a:solidFill>
+                  </a:tcPr>
+                </a:tc>
+              </a:tr>
+              <a:tr h="510540">
+                <a:tc>
+                  <a:txBody>
+                    <a:bodyPr/>
+                    <a:lstStyle/>
+                    <a:p>
+                      <a:pPr>
+                        <a:defRPr sz="800" b="0">
+                          <a:solidFill>
+                            <a:srgbClr val="3A4252"/>
+                          </a:solidFill>
+                        </a:defRPr>
+                      </a:pPr>
+                      <a:r>
+                        <a:t>LLM serving proxy</a:t>
+                      </a:r>
+                    </a:p>
+                  </a:txBody>
+                  <a:tcPr marL="50292" marR="50292" marT="32004" marB="32004">
+                    <a:solidFill>
+                      <a:srgbClr val="F7F9FC"/>
+                    </a:solidFill>
+                  </a:tcPr>
+                </a:tc>
+                <a:tc>
+                  <a:txBody>
+                    <a:bodyPr/>
+                    <a:lstStyle/>
+                    <a:p>
+                      <a:pPr>
+                        <a:defRPr sz="800" b="0">
+                          <a:solidFill>
+                            <a:srgbClr val="3A4252"/>
+                          </a:solidFill>
+                        </a:defRPr>
+                      </a:pPr>
+                      <a:r>
+                        <a:t>InferenceX DB dump</a:t>
+                      </a:r>
+                    </a:p>
+                  </a:txBody>
+                  <a:tcPr marL="50292" marR="50292" marT="32004" marB="32004">
+                    <a:solidFill>
+                      <a:srgbClr val="F7F9FC"/>
+                    </a:solidFill>
+                  </a:tcPr>
+                </a:tc>
+                <a:tc>
+                  <a:txBody>
+                    <a:bodyPr/>
+                    <a:lstStyle/>
+                    <a:p>
+                      <a:pPr>
+                        <a:defRPr sz="800" b="0">
+                          <a:solidFill>
+                            <a:srgbClr val="3A4252"/>
+                          </a:solidFill>
+                        </a:defRPr>
+                      </a:pPr>
+                      <a:r>
+                        <a:t>model x GPU x precision x ISL/OSL output TPS/MW reference</a:t>
+                      </a:r>
+                    </a:p>
+                  </a:txBody>
+                  <a:tcPr marL="50292" marR="50292" marT="32004" marB="32004">
+                    <a:solidFill>
+                      <a:srgbClr val="F7F9FC"/>
+                    </a:solidFill>
+                  </a:tcPr>
+                </a:tc>
+              </a:tr>
+              <a:tr h="510540">
+                <a:tc>
+                  <a:txBody>
+                    <a:bodyPr/>
+                    <a:lstStyle/>
+                    <a:p>
+                      <a:pPr>
+                        <a:defRPr sz="800" b="0">
+                          <a:solidFill>
+                            <a:srgbClr val="3A4252"/>
+                          </a:solidFill>
+                        </a:defRPr>
+                      </a:pPr>
+                      <a:r>
+                        <a:t>Serving stack</a:t>
+                      </a:r>
+                    </a:p>
+                  </a:txBody>
+                  <a:tcPr marL="50292" marR="50292" marT="32004" marB="32004">
+                    <a:solidFill>
+                      <a:srgbClr val="FFFFFF"/>
+                    </a:solidFill>
+                  </a:tcPr>
+                </a:tc>
+                <a:tc>
+                  <a:txBody>
+                    <a:bodyPr/>
+                    <a:lstStyle/>
+                    <a:p>
+                      <a:pPr>
+                        <a:defRPr sz="800" b="0">
+                          <a:solidFill>
+                            <a:srgbClr val="3A4252"/>
+                          </a:solidFill>
+                        </a:defRPr>
+                      </a:pPr>
+                      <a:r>
+                        <a:t>vLLM / SGLang / TensorRT-LLM / FlashInfer</a:t>
+                      </a:r>
+                    </a:p>
+                  </a:txBody>
+                  <a:tcPr marL="50292" marR="50292" marT="32004" marB="32004">
+                    <a:solidFill>
+                      <a:srgbClr val="FFFFFF"/>
+                    </a:solidFill>
+                  </a:tcPr>
+                </a:tc>
+                <a:tc>
+                  <a:txBody>
+                    <a:bodyPr/>
+                    <a:lstStyle/>
+                    <a:p>
+                      <a:pPr>
+                        <a:defRPr sz="800" b="0">
+                          <a:solidFill>
+                            <a:srgbClr val="3A4252"/>
+                          </a:solidFill>
+                        </a:defRPr>
+                      </a:pPr>
+                      <a:r>
+                        <a:t>mechanism layer for batching, KV cache, kernel and runtime behavior</a:t>
+                      </a:r>
+                    </a:p>
+                  </a:txBody>
+                  <a:tcPr marL="50292" marR="50292" marT="32004" marB="32004">
+                    <a:solidFill>
+                      <a:srgbClr val="FFFFFF"/>
+                    </a:solidFill>
+                  </a:tcPr>
+                </a:tc>
+              </a:tr>
+              <a:tr h="510540">
+                <a:tc>
+                  <a:txBody>
+                    <a:bodyPr/>
+                    <a:lstStyle/>
+                    <a:p>
+                      <a:pPr>
+                        <a:defRPr sz="800" b="0">
+                          <a:solidFill>
+                            <a:srgbClr val="3A4252"/>
+                          </a:solidFill>
+                        </a:defRPr>
+                      </a:pPr>
+                      <a:r>
+                        <a:t>Scheduling papers</a:t>
+                      </a:r>
+                    </a:p>
+                  </a:txBody>
+                  <a:tcPr marL="50292" marR="50292" marT="32004" marB="32004">
+                    <a:solidFill>
+                      <a:srgbClr val="F7F9FC"/>
+                    </a:solidFill>
+                  </a:tcPr>
+                </a:tc>
+                <a:tc>
+                  <a:txBody>
+                    <a:bodyPr/>
+                    <a:lstStyle/>
+                    <a:p>
+                      <a:pPr>
+                        <a:defRPr sz="800" b="0">
+                          <a:solidFill>
+                            <a:srgbClr val="3A4252"/>
+                          </a:solidFill>
+                        </a:defRPr>
+                      </a:pPr>
+                      <a:r>
+                        <a:t>Orca / Sarathi / DistServe / Splitwise</a:t>
+                      </a:r>
+                    </a:p>
+                  </a:txBody>
+                  <a:tcPr marL="50292" marR="50292" marT="32004" marB="32004">
+                    <a:solidFill>
+                      <a:srgbClr val="F7F9FC"/>
+                    </a:solidFill>
+                  </a:tcPr>
+                </a:tc>
+                <a:tc>
+                  <a:txBody>
+                    <a:bodyPr/>
+                    <a:lstStyle/>
+                    <a:p>
+                      <a:pPr>
+                        <a:defRPr sz="800" b="0">
+                          <a:solidFill>
+                            <a:srgbClr val="3A4252"/>
+                          </a:solidFill>
+                        </a:defRPr>
+                      </a:pPr>
+                      <a:r>
+                        <a:t>utilization, prefill/decode and TTFT/TPOT sensitivity</a:t>
+                      </a:r>
+                    </a:p>
+                  </a:txBody>
+                  <a:tcPr marL="50292" marR="50292" marT="32004" marB="32004">
+                    <a:solidFill>
+                      <a:srgbClr val="F7F9FC"/>
+                    </a:solidFill>
+                  </a:tcPr>
+                </a:tc>
+              </a:tr>
+              <a:tr h="510540">
+                <a:tc>
+                  <a:txBody>
+                    <a:bodyPr/>
+                    <a:lstStyle/>
+                    <a:p>
+                      <a:pPr>
+                        <a:defRPr sz="800" b="0">
+                          <a:solidFill>
+                            <a:srgbClr val="3A4252"/>
+                          </a:solidFill>
+                        </a:defRPr>
+                      </a:pPr>
+                      <a:r>
+                        <a:t>Trend context</a:t>
+                      </a:r>
+                    </a:p>
+                  </a:txBody>
+                  <a:tcPr marL="50292" marR="50292" marT="32004" marB="32004">
+                    <a:solidFill>
+                      <a:srgbClr val="FFFFFF"/>
+                    </a:solidFill>
+                  </a:tcPr>
+                </a:tc>
+                <a:tc>
+                  <a:txBody>
+                    <a:bodyPr/>
+                    <a:lstStyle/>
+                    <a:p>
+                      <a:pPr>
+                        <a:defRPr sz="800" b="0">
+                          <a:solidFill>
+                            <a:srgbClr val="3A4252"/>
+                          </a:solidFill>
+                        </a:defRPr>
+                      </a:pPr>
+                      <a:r>
+                        <a:t>Epoch AI</a:t>
+                      </a:r>
+                    </a:p>
+                  </a:txBody>
+                  <a:tcPr marL="50292" marR="50292" marT="32004" marB="32004">
+                    <a:solidFill>
+                      <a:srgbClr val="FFFFFF"/>
+                    </a:solidFill>
+                  </a:tcPr>
+                </a:tc>
+                <a:tc>
+                  <a:txBody>
+                    <a:bodyPr/>
+                    <a:lstStyle/>
+                    <a:p>
+                      <a:pPr>
+                        <a:defRPr sz="800" b="0">
+                          <a:solidFill>
+                            <a:srgbClr val="3A4252"/>
+                          </a:solidFill>
+                        </a:defRPr>
+                      </a:pPr>
+                      <a:r>
+                        <a:t>training scale, inference price trend, power and scaling bottlenecks</a:t>
+                      </a:r>
+                    </a:p>
+                  </a:txBody>
+                  <a:tcPr marL="50292" marR="50292" marT="32004" marB="32004">
+                    <a:solidFill>
+                      <a:srgbClr val="FFFFFF"/>
+                    </a:solidFill>
+                  </a:tcPr>
+                </a:tc>
+              </a:tr>
+            </a:tbl>
+          </a:graphicData>
+        </a:graphic>
+      </p:graphicFrame>
+      <p:sp>
+        <p:nvSpPr>
+          <p:cNvPr id="8" name="TextBox 7"/>
           <p:cNvSpPr txBox="1"/>
           <p:nvPr/>
         </p:nvSpPr>
         <p:spPr>
           <a:xfrm>
-            <a:off x="841248" y="1700784"/>
-            <a:ext cx="1234440" cy="219456"/>
+            <a:off x="841248" y="5074920"/>
+            <a:ext cx="10104120" cy="384048"/>
           </a:xfrm>
           <a:prstGeom prst="rect">
             <a:avLst/>
@@ -8726,38 +9180,38 @@
           <a:lstStyle/>
           <a:p>
             <a:pPr algn="l">
-              <a:defRPr sz="1200" b="1">
+              <a:defRPr sz="1050" b="0">
                 <a:solidFill>
-                  <a:srgbClr val="1428A0"/>
+                  <a:srgbClr val="3A4252"/>
                 </a:solidFill>
               </a:defRPr>
             </a:pPr>
             <a:r>
-              <a:t>Power</a:t>
-            </a:r>
-          </a:p>
-        </p:txBody>
-      </p:sp>
-      <p:sp>
-        <p:nvSpPr>
-          <p:cNvPr id="8" name="Rectangle 7"/>
+              <a:t>Excel tabs 07_Source_Registry, 08_Provenance_Trace, and 09_Fact_Assumption_Audit expose source IDs, formula/rule, replacement path, and evidence class for review.</a:t>
+            </a:r>
+          </a:p>
+        </p:txBody>
+      </p:sp>
+      <p:sp>
+        <p:nvSpPr>
+          <p:cNvPr id="9" name="Rectangle 8"/>
           <p:cNvSpPr/>
           <p:nvPr/>
         </p:nvSpPr>
         <p:spPr>
           <a:xfrm>
-            <a:off x="2267712" y="1801368"/>
-            <a:ext cx="731520" cy="18288"/>
+            <a:off x="658368" y="5870448"/>
+            <a:ext cx="1143000" cy="36576"/>
           </a:xfrm>
           <a:prstGeom prst="rect">
             <a:avLst/>
           </a:prstGeom>
           <a:solidFill>
-            <a:srgbClr val="E3E9F2"/>
+            <a:srgbClr val="1428A0"/>
           </a:solidFill>
           <a:ln>
             <a:solidFill>
-              <a:srgbClr val="E3E9F2"/>
+              <a:srgbClr val="1428A0"/>
             </a:solidFill>
           </a:ln>
         </p:spPr>
@@ -8785,14 +9239,14 @@
       </p:sp>
       <p:sp>
         <p:nvSpPr>
-          <p:cNvPr id="9" name="TextBox 8"/>
+          <p:cNvPr id="10" name="TextBox 9"/>
           <p:cNvSpPr txBox="1"/>
           <p:nvPr/>
         </p:nvSpPr>
         <p:spPr>
           <a:xfrm>
-            <a:off x="3218688" y="1700784"/>
-            <a:ext cx="7909560" cy="246888"/>
+            <a:off x="1947672" y="5760720"/>
+            <a:ext cx="9464040" cy="347472"/>
           </a:xfrm>
           <a:prstGeom prst="rect">
             <a:avLst/>
@@ -8806,28 +9260,28 @@
           <a:lstStyle/>
           <a:p>
             <a:pPr algn="l">
-              <a:defRPr sz="1140" b="0">
+              <a:defRPr sz="1120" b="1">
                 <a:solidFill>
-                  <a:srgbClr val="3A4252"/>
+                  <a:srgbClr val="141820"/>
                 </a:solidFill>
               </a:defRPr>
             </a:pPr>
             <a:r>
-              <a:t>Which contracted sites are energized, and when do accelerators enter production service?</a:t>
-            </a:r>
-          </a:p>
-        </p:txBody>
-      </p:sp>
-      <p:sp>
-        <p:nvSpPr>
-          <p:cNvPr id="10" name="TextBox 9"/>
+              <a:t>MLPerf and InferenceX are benchmark anchors; provider-specific production telemetry remains the replacement path.</a:t>
+            </a:r>
+          </a:p>
+        </p:txBody>
+      </p:sp>
+      <p:sp>
+        <p:nvSpPr>
+          <p:cNvPr id="11" name="TextBox 10"/>
           <p:cNvSpPr txBox="1"/>
           <p:nvPr/>
         </p:nvSpPr>
         <p:spPr>
           <a:xfrm>
-            <a:off x="841248" y="2359152"/>
-            <a:ext cx="1234440" cy="219456"/>
+            <a:off x="658368" y="6473952"/>
+            <a:ext cx="9326880" cy="164592"/>
           </a:xfrm>
           <a:prstGeom prst="rect">
             <a:avLst/>
@@ -8841,38 +9295,99 @@
           <a:lstStyle/>
           <a:p>
             <a:pPr algn="l">
-              <a:defRPr sz="1200" b="1">
+              <a:defRPr sz="720" b="0">
                 <a:solidFill>
-                  <a:srgbClr val="1428A0"/>
+                  <a:srgbClr val="747E8E"/>
                 </a:solidFill>
               </a:defRPr>
             </a:pPr>
             <a:r>
-              <a:t>Allocation</a:t>
-            </a:r>
-          </a:p>
-        </p:txBody>
-      </p:sp>
-      <p:sp>
-        <p:nvSpPr>
-          <p:cNvPr id="11" name="Rectangle 10"/>
+              <a:t>Commercial LLM model-owner basis | Compute capacity to generated output token supply</a:t>
+            </a:r>
+          </a:p>
+        </p:txBody>
+      </p:sp>
+      <p:sp>
+        <p:nvSpPr>
+          <p:cNvPr id="12" name="TextBox 11"/>
+          <p:cNvSpPr txBox="1"/>
+          <p:nvPr/>
+        </p:nvSpPr>
+        <p:spPr>
+          <a:xfrm>
+            <a:off x="10533888" y="6473952"/>
+            <a:ext cx="1005840" cy="164592"/>
+          </a:xfrm>
+          <a:prstGeom prst="rect">
+            <a:avLst/>
+          </a:prstGeom>
+          <a:noFill/>
+        </p:spPr>
+        <p:txBody>
+          <a:bodyPr wrap="none" lIns="0" rIns="0" tIns="0" bIns="0">
+            <a:spAutoFit/>
+          </a:bodyPr>
+          <a:lstStyle/>
+          <a:p>
+            <a:pPr algn="r">
+              <a:defRPr sz="720" b="0">
+                <a:solidFill>
+                  <a:srgbClr val="747E8E"/>
+                </a:solidFill>
+              </a:defRPr>
+            </a:pPr>
+            <a:r>
+              <a:t>2026-05-27</a:t>
+            </a:r>
+          </a:p>
+        </p:txBody>
+      </p:sp>
+    </p:spTree>
+  </p:cSld>
+  <p:clrMapOvr>
+    <a:masterClrMapping/>
+  </p:clrMapOvr>
+</p:sld>
+</file>
+
+<file path=ppt/slides/slide13.xml><?xml version="1.0" encoding="utf-8"?>
+<p:sld xmlns:a="http://schemas.openxmlformats.org/drawingml/2006/main" xmlns:p="http://schemas.openxmlformats.org/presentationml/2006/main" xmlns:r="http://schemas.openxmlformats.org/officeDocument/2006/relationships">
+  <p:cSld>
+    <p:bg>
+      <p:bgPr>
+        <a:solidFill>
+          <a:srgbClr val="FFFFFF"/>
+        </a:solidFill>
+        <a:effectLst/>
+      </p:bgPr>
+    </p:bg>
+    <p:spTree>
+      <p:nvGrpSpPr>
+        <p:cNvPr id="1" name=""/>
+        <p:cNvGrpSpPr/>
+        <p:nvPr/>
+      </p:nvGrpSpPr>
+      <p:grpSpPr/>
+      <p:sp>
+        <p:nvSpPr>
+          <p:cNvPr id="2" name="Rectangle 1"/>
           <p:cNvSpPr/>
           <p:nvPr/>
         </p:nvSpPr>
         <p:spPr>
           <a:xfrm>
-            <a:off x="2267712" y="2459736"/>
-            <a:ext cx="731520" cy="18288"/>
+            <a:off x="0" y="0"/>
+            <a:ext cx="12191695" cy="73152"/>
           </a:xfrm>
           <a:prstGeom prst="rect">
             <a:avLst/>
           </a:prstGeom>
           <a:solidFill>
-            <a:srgbClr val="E3E9F2"/>
+            <a:srgbClr val="1428A0"/>
           </a:solidFill>
           <a:ln>
             <a:solidFill>
-              <a:srgbClr val="E3E9F2"/>
+              <a:srgbClr val="1428A0"/>
             </a:solidFill>
           </a:ln>
         </p:spPr>
@@ -8900,14 +9415,14 @@
       </p:sp>
       <p:sp>
         <p:nvSpPr>
-          <p:cNvPr id="12" name="TextBox 11"/>
+          <p:cNvPr id="3" name="TextBox 2"/>
           <p:cNvSpPr txBox="1"/>
           <p:nvPr/>
         </p:nvSpPr>
         <p:spPr>
           <a:xfrm>
-            <a:off x="3218688" y="2359152"/>
-            <a:ext cx="7909560" cy="246888"/>
+            <a:off x="658368" y="329184"/>
+            <a:ext cx="4297680" cy="201168"/>
           </a:xfrm>
           <a:prstGeom prst="rect">
             <a:avLst/>
@@ -8921,63 +9436,98 @@
           <a:lstStyle/>
           <a:p>
             <a:pPr algn="l">
-              <a:defRPr sz="1140" b="0">
-                <a:solidFill>
-                  <a:srgbClr val="3A4252"/>
-                </a:solidFill>
-              </a:defRPr>
-            </a:pPr>
-            <a:r>
-              <a:t>What share of AI IT load is serving commercial inference versus training or experimentation?</a:t>
-            </a:r>
-          </a:p>
-        </p:txBody>
-      </p:sp>
-      <p:sp>
-        <p:nvSpPr>
-          <p:cNvPr id="13" name="TextBox 12"/>
-          <p:cNvSpPr txBox="1"/>
-          <p:nvPr/>
-        </p:nvSpPr>
-        <p:spPr>
-          <a:xfrm>
-            <a:off x="841248" y="3017520"/>
-            <a:ext cx="1234440" cy="219456"/>
-          </a:xfrm>
-          <a:prstGeom prst="rect">
-            <a:avLst/>
-          </a:prstGeom>
-          <a:noFill/>
-        </p:spPr>
-        <p:txBody>
-          <a:bodyPr wrap="none" lIns="0" rIns="0" tIns="0" bIns="0">
-            <a:spAutoFit/>
-          </a:bodyPr>
-          <a:lstStyle/>
-          <a:p>
-            <a:pPr algn="l">
-              <a:defRPr sz="1200" b="1">
+              <a:defRPr sz="750" b="1">
                 <a:solidFill>
                   <a:srgbClr val="1428A0"/>
                 </a:solidFill>
               </a:defRPr>
             </a:pPr>
             <a:r>
-              <a:t>Architecture</a:t>
-            </a:r>
-          </a:p>
-        </p:txBody>
-      </p:sp>
-      <p:sp>
-        <p:nvSpPr>
-          <p:cNvPr id="14" name="Rectangle 13"/>
+              <a:t>TOKEN SUPPLY CONSTRAINTS</a:t>
+            </a:r>
+          </a:p>
+        </p:txBody>
+      </p:sp>
+      <p:sp>
+        <p:nvSpPr>
+          <p:cNvPr id="4" name="TextBox 3"/>
+          <p:cNvSpPr txBox="1"/>
+          <p:nvPr/>
+        </p:nvSpPr>
+        <p:spPr>
+          <a:xfrm>
+            <a:off x="658368" y="658368"/>
+            <a:ext cx="10835640" cy="502920"/>
+          </a:xfrm>
+          <a:prstGeom prst="rect">
+            <a:avLst/>
+          </a:prstGeom>
+          <a:noFill/>
+        </p:spPr>
+        <p:txBody>
+          <a:bodyPr wrap="none" lIns="0" rIns="0" tIns="0" bIns="0">
+            <a:spAutoFit/>
+          </a:bodyPr>
+          <a:lstStyle/>
+          <a:p>
+            <a:pPr algn="l">
+              <a:defRPr sz="1950" b="1">
+                <a:solidFill>
+                  <a:srgbClr val="141820"/>
+                </a:solidFill>
+              </a:defRPr>
+            </a:pPr>
+            <a:r>
+              <a:t>The operating agenda is to verify the bottleneck, then update the provider model</a:t>
+            </a:r>
+          </a:p>
+        </p:txBody>
+      </p:sp>
+      <p:sp>
+        <p:nvSpPr>
+          <p:cNvPr id="5" name="TextBox 4"/>
+          <p:cNvSpPr txBox="1"/>
+          <p:nvPr/>
+        </p:nvSpPr>
+        <p:spPr>
+          <a:xfrm>
+            <a:off x="676656" y="1133856"/>
+            <a:ext cx="10424160" cy="310896"/>
+          </a:xfrm>
+          <a:prstGeom prst="rect">
+            <a:avLst/>
+          </a:prstGeom>
+          <a:noFill/>
+        </p:spPr>
+        <p:txBody>
+          <a:bodyPr wrap="none" lIns="0" rIns="0" tIns="0" bIns="0">
+            <a:spAutoFit/>
+          </a:bodyPr>
+          <a:lstStyle/>
+          <a:p>
+            <a:pPr algn="l">
+              <a:defRPr sz="900" b="0">
+                <a:solidFill>
+                  <a:srgbClr val="747E8E"/>
+                </a:solidFill>
+              </a:defRPr>
+            </a:pPr>
+            <a:r>
+              <a:t>This is the checklist that keeps the simulation tied to facts as new capacity, model, and benchmark data arrives.</a:t>
+            </a:r>
+          </a:p>
+        </p:txBody>
+      </p:sp>
+      <p:sp>
+        <p:nvSpPr>
+          <p:cNvPr id="6" name="Rectangle 5"/>
           <p:cNvSpPr/>
           <p:nvPr/>
         </p:nvSpPr>
         <p:spPr>
           <a:xfrm>
-            <a:off x="2267712" y="3118103"/>
-            <a:ext cx="731520" cy="18288"/>
+            <a:off x="658368" y="1499616"/>
+            <a:ext cx="10881360" cy="9144"/>
           </a:xfrm>
           <a:prstGeom prst="rect">
             <a:avLst/>
@@ -9015,48 +9565,13 @@
       </p:sp>
       <p:sp>
         <p:nvSpPr>
-          <p:cNvPr id="15" name="TextBox 14"/>
+          <p:cNvPr id="7" name="TextBox 6"/>
           <p:cNvSpPr txBox="1"/>
           <p:nvPr/>
         </p:nvSpPr>
         <p:spPr>
           <a:xfrm>
-            <a:off x="3218688" y="3017520"/>
-            <a:ext cx="7909560" cy="246888"/>
-          </a:xfrm>
-          <a:prstGeom prst="rect">
-            <a:avLst/>
-          </a:prstGeom>
-          <a:noFill/>
-        </p:spPr>
-        <p:txBody>
-          <a:bodyPr wrap="none" lIns="0" rIns="0" tIns="0" bIns="0">
-            <a:spAutoFit/>
-          </a:bodyPr>
-          <a:lstStyle/>
-          <a:p>
-            <a:pPr algn="l">
-              <a:defRPr sz="1140" b="0">
-                <a:solidFill>
-                  <a:srgbClr val="3A4252"/>
-                </a:solidFill>
-              </a:defRPr>
-            </a:pPr>
-            <a:r>
-              <a:t>Which model family, active parameter band, context length, and routing policy dominate traffic?</a:t>
-            </a:r>
-          </a:p>
-        </p:txBody>
-      </p:sp>
-      <p:sp>
-        <p:nvSpPr>
-          <p:cNvPr id="16" name="TextBox 15"/>
-          <p:cNvSpPr txBox="1"/>
-          <p:nvPr/>
-        </p:nvSpPr>
-        <p:spPr>
-          <a:xfrm>
-            <a:off x="841248" y="3675888"/>
+            <a:off x="841248" y="1700784"/>
             <a:ext cx="1234440" cy="219456"/>
           </a:xfrm>
           <a:prstGeom prst="rect">
@@ -9078,20 +9593,20 @@
               </a:defRPr>
             </a:pPr>
             <a:r>
-              <a:t>Efficiency</a:t>
-            </a:r>
-          </a:p>
-        </p:txBody>
-      </p:sp>
-      <p:sp>
-        <p:nvSpPr>
-          <p:cNvPr id="17" name="Rectangle 16"/>
+              <a:t>Power</a:t>
+            </a:r>
+          </a:p>
+        </p:txBody>
+      </p:sp>
+      <p:sp>
+        <p:nvSpPr>
+          <p:cNvPr id="8" name="Rectangle 7"/>
           <p:cNvSpPr/>
           <p:nvPr/>
         </p:nvSpPr>
         <p:spPr>
           <a:xfrm>
-            <a:off x="2267712" y="3776472"/>
+            <a:off x="2267712" y="1801368"/>
             <a:ext cx="731520" cy="18288"/>
           </a:xfrm>
           <a:prstGeom prst="rect">
@@ -9130,13 +9645,13 @@
       </p:sp>
       <p:sp>
         <p:nvSpPr>
-          <p:cNvPr id="18" name="TextBox 17"/>
+          <p:cNvPr id="9" name="TextBox 8"/>
           <p:cNvSpPr txBox="1"/>
           <p:nvPr/>
         </p:nvSpPr>
         <p:spPr>
           <a:xfrm>
-            <a:off x="3218688" y="3675888"/>
+            <a:off x="3218688" y="1700784"/>
             <a:ext cx="7909560" cy="246888"/>
           </a:xfrm>
           <a:prstGeom prst="rect">
@@ -9158,20 +9673,20 @@
               </a:defRPr>
             </a:pPr>
             <a:r>
-              <a:t>What output tokens/sec/MW is realistic after SLO, precision, batching, and production haircut?</a:t>
-            </a:r>
-          </a:p>
-        </p:txBody>
-      </p:sp>
-      <p:sp>
-        <p:nvSpPr>
-          <p:cNvPr id="19" name="TextBox 18"/>
+              <a:t>Which contracted sites are energized, and when do accelerators enter production service?</a:t>
+            </a:r>
+          </a:p>
+        </p:txBody>
+      </p:sp>
+      <p:sp>
+        <p:nvSpPr>
+          <p:cNvPr id="10" name="TextBox 9"/>
           <p:cNvSpPr txBox="1"/>
           <p:nvPr/>
         </p:nvSpPr>
         <p:spPr>
           <a:xfrm>
-            <a:off x="841248" y="4334256"/>
+            <a:off x="841248" y="2359152"/>
             <a:ext cx="1234440" cy="219456"/>
           </a:xfrm>
           <a:prstGeom prst="rect">
@@ -9193,20 +9708,20 @@
               </a:defRPr>
             </a:pPr>
             <a:r>
-              <a:t>Demand absorption</a:t>
-            </a:r>
-          </a:p>
-        </p:txBody>
-      </p:sp>
-      <p:sp>
-        <p:nvSpPr>
-          <p:cNvPr id="20" name="Rectangle 19"/>
+              <a:t>Allocation</a:t>
+            </a:r>
+          </a:p>
+        </p:txBody>
+      </p:sp>
+      <p:sp>
+        <p:nvSpPr>
+          <p:cNvPr id="11" name="Rectangle 10"/>
           <p:cNvSpPr/>
           <p:nvPr/>
         </p:nvSpPr>
         <p:spPr>
           <a:xfrm>
-            <a:off x="2267712" y="4434840"/>
+            <a:off x="2267712" y="2459736"/>
             <a:ext cx="731520" cy="18288"/>
           </a:xfrm>
           <a:prstGeom prst="rect">
@@ -9245,13 +9760,13 @@
       </p:sp>
       <p:sp>
         <p:nvSpPr>
-          <p:cNvPr id="21" name="TextBox 20"/>
+          <p:cNvPr id="12" name="TextBox 11"/>
           <p:cNvSpPr txBox="1"/>
           <p:nvPr/>
         </p:nvSpPr>
         <p:spPr>
           <a:xfrm>
-            <a:off x="3218688" y="4334256"/>
+            <a:off x="3218688" y="2359152"/>
             <a:ext cx="7909560" cy="246888"/>
           </a:xfrm>
           <a:prstGeom prst="rect">
@@ -9273,6 +9788,351 @@
               </a:defRPr>
             </a:pPr>
             <a:r>
+              <a:t>What share of AI IT load is serving commercial inference versus training or experimentation?</a:t>
+            </a:r>
+          </a:p>
+        </p:txBody>
+      </p:sp>
+      <p:sp>
+        <p:nvSpPr>
+          <p:cNvPr id="13" name="TextBox 12"/>
+          <p:cNvSpPr txBox="1"/>
+          <p:nvPr/>
+        </p:nvSpPr>
+        <p:spPr>
+          <a:xfrm>
+            <a:off x="841248" y="3017520"/>
+            <a:ext cx="1234440" cy="219456"/>
+          </a:xfrm>
+          <a:prstGeom prst="rect">
+            <a:avLst/>
+          </a:prstGeom>
+          <a:noFill/>
+        </p:spPr>
+        <p:txBody>
+          <a:bodyPr wrap="none" lIns="0" rIns="0" tIns="0" bIns="0">
+            <a:spAutoFit/>
+          </a:bodyPr>
+          <a:lstStyle/>
+          <a:p>
+            <a:pPr algn="l">
+              <a:defRPr sz="1200" b="1">
+                <a:solidFill>
+                  <a:srgbClr val="1428A0"/>
+                </a:solidFill>
+              </a:defRPr>
+            </a:pPr>
+            <a:r>
+              <a:t>Architecture</a:t>
+            </a:r>
+          </a:p>
+        </p:txBody>
+      </p:sp>
+      <p:sp>
+        <p:nvSpPr>
+          <p:cNvPr id="14" name="Rectangle 13"/>
+          <p:cNvSpPr/>
+          <p:nvPr/>
+        </p:nvSpPr>
+        <p:spPr>
+          <a:xfrm>
+            <a:off x="2267712" y="3118103"/>
+            <a:ext cx="731520" cy="18288"/>
+          </a:xfrm>
+          <a:prstGeom prst="rect">
+            <a:avLst/>
+          </a:prstGeom>
+          <a:solidFill>
+            <a:srgbClr val="E3E9F2"/>
+          </a:solidFill>
+          <a:ln>
+            <a:solidFill>
+              <a:srgbClr val="E3E9F2"/>
+            </a:solidFill>
+          </a:ln>
+        </p:spPr>
+        <p:style>
+          <a:lnRef idx="1">
+            <a:schemeClr val="accent1"/>
+          </a:lnRef>
+          <a:fillRef idx="3">
+            <a:schemeClr val="accent1"/>
+          </a:fillRef>
+          <a:effectRef idx="2">
+            <a:schemeClr val="accent1"/>
+          </a:effectRef>
+          <a:fontRef idx="minor">
+            <a:schemeClr val="lt1"/>
+          </a:fontRef>
+        </p:style>
+        <p:txBody>
+          <a:bodyPr rtlCol="0" anchor="ctr"/>
+          <a:lstStyle/>
+          <a:p>
+            <a:pPr algn="ctr"/>
+          </a:p>
+        </p:txBody>
+      </p:sp>
+      <p:sp>
+        <p:nvSpPr>
+          <p:cNvPr id="15" name="TextBox 14"/>
+          <p:cNvSpPr txBox="1"/>
+          <p:nvPr/>
+        </p:nvSpPr>
+        <p:spPr>
+          <a:xfrm>
+            <a:off x="3218688" y="3017520"/>
+            <a:ext cx="7909560" cy="246888"/>
+          </a:xfrm>
+          <a:prstGeom prst="rect">
+            <a:avLst/>
+          </a:prstGeom>
+          <a:noFill/>
+        </p:spPr>
+        <p:txBody>
+          <a:bodyPr wrap="none" lIns="0" rIns="0" tIns="0" bIns="0">
+            <a:spAutoFit/>
+          </a:bodyPr>
+          <a:lstStyle/>
+          <a:p>
+            <a:pPr algn="l">
+              <a:defRPr sz="1140" b="0">
+                <a:solidFill>
+                  <a:srgbClr val="3A4252"/>
+                </a:solidFill>
+              </a:defRPr>
+            </a:pPr>
+            <a:r>
+              <a:t>Which model family, active parameter band, context length, and routing policy dominate traffic?</a:t>
+            </a:r>
+          </a:p>
+        </p:txBody>
+      </p:sp>
+      <p:sp>
+        <p:nvSpPr>
+          <p:cNvPr id="16" name="TextBox 15"/>
+          <p:cNvSpPr txBox="1"/>
+          <p:nvPr/>
+        </p:nvSpPr>
+        <p:spPr>
+          <a:xfrm>
+            <a:off x="841248" y="3675888"/>
+            <a:ext cx="1234440" cy="219456"/>
+          </a:xfrm>
+          <a:prstGeom prst="rect">
+            <a:avLst/>
+          </a:prstGeom>
+          <a:noFill/>
+        </p:spPr>
+        <p:txBody>
+          <a:bodyPr wrap="none" lIns="0" rIns="0" tIns="0" bIns="0">
+            <a:spAutoFit/>
+          </a:bodyPr>
+          <a:lstStyle/>
+          <a:p>
+            <a:pPr algn="l">
+              <a:defRPr sz="1200" b="1">
+                <a:solidFill>
+                  <a:srgbClr val="1428A0"/>
+                </a:solidFill>
+              </a:defRPr>
+            </a:pPr>
+            <a:r>
+              <a:t>Efficiency</a:t>
+            </a:r>
+          </a:p>
+        </p:txBody>
+      </p:sp>
+      <p:sp>
+        <p:nvSpPr>
+          <p:cNvPr id="17" name="Rectangle 16"/>
+          <p:cNvSpPr/>
+          <p:nvPr/>
+        </p:nvSpPr>
+        <p:spPr>
+          <a:xfrm>
+            <a:off x="2267712" y="3776472"/>
+            <a:ext cx="731520" cy="18288"/>
+          </a:xfrm>
+          <a:prstGeom prst="rect">
+            <a:avLst/>
+          </a:prstGeom>
+          <a:solidFill>
+            <a:srgbClr val="E3E9F2"/>
+          </a:solidFill>
+          <a:ln>
+            <a:solidFill>
+              <a:srgbClr val="E3E9F2"/>
+            </a:solidFill>
+          </a:ln>
+        </p:spPr>
+        <p:style>
+          <a:lnRef idx="1">
+            <a:schemeClr val="accent1"/>
+          </a:lnRef>
+          <a:fillRef idx="3">
+            <a:schemeClr val="accent1"/>
+          </a:fillRef>
+          <a:effectRef idx="2">
+            <a:schemeClr val="accent1"/>
+          </a:effectRef>
+          <a:fontRef idx="minor">
+            <a:schemeClr val="lt1"/>
+          </a:fontRef>
+        </p:style>
+        <p:txBody>
+          <a:bodyPr rtlCol="0" anchor="ctr"/>
+          <a:lstStyle/>
+          <a:p>
+            <a:pPr algn="ctr"/>
+          </a:p>
+        </p:txBody>
+      </p:sp>
+      <p:sp>
+        <p:nvSpPr>
+          <p:cNvPr id="18" name="TextBox 17"/>
+          <p:cNvSpPr txBox="1"/>
+          <p:nvPr/>
+        </p:nvSpPr>
+        <p:spPr>
+          <a:xfrm>
+            <a:off x="3218688" y="3675888"/>
+            <a:ext cx="7909560" cy="246888"/>
+          </a:xfrm>
+          <a:prstGeom prst="rect">
+            <a:avLst/>
+          </a:prstGeom>
+          <a:noFill/>
+        </p:spPr>
+        <p:txBody>
+          <a:bodyPr wrap="none" lIns="0" rIns="0" tIns="0" bIns="0">
+            <a:spAutoFit/>
+          </a:bodyPr>
+          <a:lstStyle/>
+          <a:p>
+            <a:pPr algn="l">
+              <a:defRPr sz="1140" b="0">
+                <a:solidFill>
+                  <a:srgbClr val="3A4252"/>
+                </a:solidFill>
+              </a:defRPr>
+            </a:pPr>
+            <a:r>
+              <a:t>What output tokens/sec/MW is realistic after SLO, precision, batching, and production haircut?</a:t>
+            </a:r>
+          </a:p>
+        </p:txBody>
+      </p:sp>
+      <p:sp>
+        <p:nvSpPr>
+          <p:cNvPr id="19" name="TextBox 18"/>
+          <p:cNvSpPr txBox="1"/>
+          <p:nvPr/>
+        </p:nvSpPr>
+        <p:spPr>
+          <a:xfrm>
+            <a:off x="841248" y="4334256"/>
+            <a:ext cx="1234440" cy="219456"/>
+          </a:xfrm>
+          <a:prstGeom prst="rect">
+            <a:avLst/>
+          </a:prstGeom>
+          <a:noFill/>
+        </p:spPr>
+        <p:txBody>
+          <a:bodyPr wrap="none" lIns="0" rIns="0" tIns="0" bIns="0">
+            <a:spAutoFit/>
+          </a:bodyPr>
+          <a:lstStyle/>
+          <a:p>
+            <a:pPr algn="l">
+              <a:defRPr sz="1200" b="1">
+                <a:solidFill>
+                  <a:srgbClr val="1428A0"/>
+                </a:solidFill>
+              </a:defRPr>
+            </a:pPr>
+            <a:r>
+              <a:t>Demand absorption</a:t>
+            </a:r>
+          </a:p>
+        </p:txBody>
+      </p:sp>
+      <p:sp>
+        <p:nvSpPr>
+          <p:cNvPr id="20" name="Rectangle 19"/>
+          <p:cNvSpPr/>
+          <p:nvPr/>
+        </p:nvSpPr>
+        <p:spPr>
+          <a:xfrm>
+            <a:off x="2267712" y="4434840"/>
+            <a:ext cx="731520" cy="18288"/>
+          </a:xfrm>
+          <a:prstGeom prst="rect">
+            <a:avLst/>
+          </a:prstGeom>
+          <a:solidFill>
+            <a:srgbClr val="E3E9F2"/>
+          </a:solidFill>
+          <a:ln>
+            <a:solidFill>
+              <a:srgbClr val="E3E9F2"/>
+            </a:solidFill>
+          </a:ln>
+        </p:spPr>
+        <p:style>
+          <a:lnRef idx="1">
+            <a:schemeClr val="accent1"/>
+          </a:lnRef>
+          <a:fillRef idx="3">
+            <a:schemeClr val="accent1"/>
+          </a:fillRef>
+          <a:effectRef idx="2">
+            <a:schemeClr val="accent1"/>
+          </a:effectRef>
+          <a:fontRef idx="minor">
+            <a:schemeClr val="lt1"/>
+          </a:fontRef>
+        </p:style>
+        <p:txBody>
+          <a:bodyPr rtlCol="0" anchor="ctr"/>
+          <a:lstStyle/>
+          <a:p>
+            <a:pPr algn="ctr"/>
+          </a:p>
+        </p:txBody>
+      </p:sp>
+      <p:sp>
+        <p:nvSpPr>
+          <p:cNvPr id="21" name="TextBox 20"/>
+          <p:cNvSpPr txBox="1"/>
+          <p:nvPr/>
+        </p:nvSpPr>
+        <p:spPr>
+          <a:xfrm>
+            <a:off x="3218688" y="4334256"/>
+            <a:ext cx="7909560" cy="246888"/>
+          </a:xfrm>
+          <a:prstGeom prst="rect">
+            <a:avLst/>
+          </a:prstGeom>
+          <a:noFill/>
+        </p:spPr>
+        <p:txBody>
+          <a:bodyPr wrap="none" lIns="0" rIns="0" tIns="0" bIns="0">
+            <a:spAutoFit/>
+          </a:bodyPr>
+          <a:lstStyle/>
+          <a:p>
+            <a:pPr algn="l">
+              <a:defRPr sz="1140" b="0">
+                <a:solidFill>
+                  <a:srgbClr val="3A4252"/>
+                </a:solidFill>
+              </a:defRPr>
+            </a:pPr>
+            <a:r>
               <a:t>Which product surfaces can absorb the incremental token supply without idle capacity?</a:t>
             </a:r>
           </a:p>
@@ -9308,7 +10168,7 @@
               </a:defRPr>
             </a:pPr>
             <a:r>
-              <a:t>Workbook tabs: Logic, Benchmark Input, Inputs, GPU Mix Input, Calculation, Output, Checks, Aggressive View. Derived output cells use Excel formulas.</a:t>
+              <a:t>Workbook tabs: Logic, Benchmark Input, Inputs, GPU Mix Input, Calculation, Output, Checks, Aggressive View, Source Registry, Provenance Trace, Fact Audit. Derived output cells use Excel formulas.</a:t>
             </a:r>
           </a:p>
         </p:txBody>

</xml_diff>

<commit_message>
Update InferenceX workload split token capacity
</commit_message>
<xml_diff>
--- a/llm_token_capacity_project/outputs/reports/llm_token_capacity_2026_2030.pptx
+++ b/llm_token_capacity_project/outputs/reports/llm_token_capacity_2026_2030.pptx
@@ -184,31 +184,31 @@
                 <c:formatCode>General</c:formatCode>
                 <c:ptCount val="9"/>
                 <c:pt idx="0">
-                  <c:v>0.1445198616576</c:v>
+                  <c:v>0.117604700928</c:v>
                 </c:pt>
                 <c:pt idx="1">
-                  <c:v>0.1362573879264</c:v>
+                  <c:v>0.1116598239936</c:v>
                 </c:pt>
                 <c:pt idx="2">
-                  <c:v>0.121637595024</c:v>
+                  <c:v>0.0999095920416</c:v>
                 </c:pt>
                 <c:pt idx="3">
-                  <c:v>0.0920171650176</c:v>
+                  <c:v>0.0671012843904</c:v>
                 </c:pt>
                 <c:pt idx="4">
-                  <c:v>0.051255410688</c:v>
+                  <c:v>0.046128282624</c:v>
                 </c:pt>
                 <c:pt idx="5">
-                  <c:v>0.0467623253952</c:v>
+                  <c:v>0.0428970862656</c:v>
                 </c:pt>
                 <c:pt idx="6">
-                  <c:v>0.039857379696</c:v>
+                  <c:v>0.0340065541728</c:v>
                 </c:pt>
                 <c:pt idx="7">
-                  <c:v>0.0230393503872</c:v>
+                  <c:v>0.0194207386752</c:v>
                 </c:pt>
                 <c:pt idx="8">
-                  <c:v>0.0030995703648</c:v>
+                  <c:v>0.0024526805184</c:v>
                 </c:pt>
               </c:numCache>
             </c:numRef>
@@ -373,19 +373,19 @@
                 <c:formatCode>General</c:formatCode>
                 <c:ptCount val="5"/>
                 <c:pt idx="0">
-                  <c:v>0.013592069568</c:v>
+                  <c:v>0.010765760544</c:v>
                 </c:pt>
                 <c:pt idx="1">
-                  <c:v>0.0360240369408</c:v>
+                  <c:v>0.0287679216384</c:v>
                 </c:pt>
                 <c:pt idx="2">
-                  <c:v>0.0648691331328</c:v>
+                  <c:v>0.0521763078528</c:v>
                 </c:pt>
                 <c:pt idx="3">
-                  <c:v>0.10078753536</c:v>
+                  <c:v>0.08157148416</c:v>
                 </c:pt>
                 <c:pt idx="4">
-                  <c:v>0.1445198616576</c:v>
+                  <c:v>0.117604700928</c:v>
                 </c:pt>
               </c:numCache>
             </c:numRef>
@@ -436,19 +436,19 @@
                 <c:formatCode>General</c:formatCode>
                 <c:ptCount val="5"/>
                 <c:pt idx="0">
-                  <c:v>0.032008169952</c:v>
+                  <c:v>0.0261555725376</c:v>
                 </c:pt>
                 <c:pt idx="1">
-                  <c:v>0.053415075456</c:v>
+                  <c:v>0.043705626624</c:v>
                 </c:pt>
                 <c:pt idx="2">
-                  <c:v>0.0780052584096</c:v>
+                  <c:v>0.0638866912608</c:v>
                 </c:pt>
                 <c:pt idx="3">
-                  <c:v>0.105659731152</c:v>
+                  <c:v>0.086577678576</c:v>
                 </c:pt>
                 <c:pt idx="4">
-                  <c:v>0.1362573879264</c:v>
+                  <c:v>0.1116598239936</c:v>
                 </c:pt>
               </c:numCache>
             </c:numRef>
@@ -499,19 +499,19 @@
                 <c:formatCode>General</c:formatCode>
                 <c:ptCount val="5"/>
                 <c:pt idx="0">
-                  <c:v>0.02017941552</c:v>
+                  <c:v>0.016348912128</c:v>
                 </c:pt>
                 <c:pt idx="1">
-                  <c:v>0.038645008848</c:v>
+                  <c:v>0.0315036254016</c:v>
                 </c:pt>
                 <c:pt idx="2">
-                  <c:v>0.0618029473824</c:v>
+                  <c:v>0.0505847781216</c:v>
                 </c:pt>
                 <c:pt idx="3">
-                  <c:v>0.0896342936256</c:v>
+                  <c:v>0.0735476744448</c:v>
                 </c:pt>
                 <c:pt idx="4">
-                  <c:v>0.121637595024</c:v>
+                  <c:v>0.0999095920416</c:v>
                 </c:pt>
               </c:numCache>
             </c:numRef>
@@ -562,19 +562,19 @@
                 <c:formatCode>General</c:formatCode>
                 <c:ptCount val="5"/>
                 <c:pt idx="0">
-                  <c:v>0.0107266071744</c:v>
+                  <c:v>0.0077853318912</c:v>
                 </c:pt>
                 <c:pt idx="1">
-                  <c:v>0.0260620835904</c:v>
+                  <c:v>0.0189682324128</c:v>
                 </c:pt>
                 <c:pt idx="2">
-                  <c:v>0.0447821436672</c:v>
+                  <c:v>0.0326438332416</c:v>
                 </c:pt>
                 <c:pt idx="3">
-                  <c:v>0.066821594112</c:v>
+                  <c:v>0.0487398352896</c:v>
                 </c:pt>
                 <c:pt idx="4">
-                  <c:v>0.0920171650176</c:v>
+                  <c:v>0.0671012843904</c:v>
                 </c:pt>
               </c:numCache>
             </c:numRef>
@@ -625,19 +625,19 @@
                 <c:formatCode>General</c:formatCode>
                 <c:ptCount val="5"/>
                 <c:pt idx="0">
-                  <c:v>0.0105596478144</c:v>
+                  <c:v>0.0092273210208</c:v>
                 </c:pt>
                 <c:pt idx="1">
-                  <c:v>0.018960831648</c:v>
+                  <c:v>0.016739271648</c:v>
                 </c:pt>
                 <c:pt idx="2">
-                  <c:v>0.0285507597312</c:v>
+                  <c:v>0.0254148046848</c:v>
                 </c:pt>
                 <c:pt idx="3">
-                  <c:v>0.0393145031808</c:v>
+                  <c:v>0.0352253152512</c:v>
                 </c:pt>
                 <c:pt idx="4">
-                  <c:v>0.051255410688</c:v>
+                  <c:v>0.046128282624</c:v>
                 </c:pt>
               </c:numCache>
             </c:numRef>
@@ -1798,31 +1798,31 @@
                 <c:formatCode>General</c:formatCode>
                 <c:ptCount val="9"/>
                 <c:pt idx="0">
-                  <c:v>0.344032</c:v>
+                  <c:v>0.27996</c:v>
                 </c:pt>
                 <c:pt idx="1">
-                  <c:v>0.431951</c:v>
+                  <c:v>0.353974</c:v>
                 </c:pt>
                 <c:pt idx="2">
-                  <c:v>0.422395</c:v>
+                  <c:v>0.346943</c:v>
                 </c:pt>
                 <c:pt idx="3">
-                  <c:v>0.359074</c:v>
+                  <c:v>0.261846</c:v>
                 </c:pt>
                 <c:pt idx="4">
-                  <c:v>0.180864</c:v>
+                  <c:v>0.162772</c:v>
                 </c:pt>
                 <c:pt idx="5">
-                  <c:v>0.412838</c:v>
+                  <c:v>0.378714</c:v>
                 </c:pt>
                 <c:pt idx="6">
-                  <c:v>0.378435</c:v>
+                  <c:v>0.322883</c:v>
                 </c:pt>
                 <c:pt idx="7">
-                  <c:v>0.152551</c:v>
+                  <c:v>0.128591</c:v>
                 </c:pt>
                 <c:pt idx="8">
-                  <c:v>0.055107</c:v>
+                  <c:v>0.043606</c:v>
                 </c:pt>
               </c:numCache>
             </c:numRef>
@@ -1988,19 +1988,19 @@
                 <c:formatCode>General</c:formatCode>
                 <c:ptCount val="5"/>
                 <c:pt idx="0">
-                  <c:v>0.051</c:v>
+                  <c:v>0.041</c:v>
                 </c:pt>
                 <c:pt idx="1">
-                  <c:v>0.101</c:v>
+                  <c:v>0.083</c:v>
                 </c:pt>
                 <c:pt idx="2">
-                  <c:v>0.161</c:v>
+                  <c:v>0.132</c:v>
                 </c:pt>
                 <c:pt idx="3">
-                  <c:v>0.23</c:v>
+                  <c:v>0.19</c:v>
                 </c:pt>
                 <c:pt idx="4">
-                  <c:v>0.308</c:v>
+                  <c:v>0.254</c:v>
                 </c:pt>
               </c:numCache>
             </c:numRef>
@@ -2051,19 +2051,19 @@
                 <c:formatCode>General</c:formatCode>
                 <c:ptCount val="5"/>
                 <c:pt idx="0">
-                  <c:v>0.098</c:v>
+                  <c:v>0.08</c:v>
                 </c:pt>
                 <c:pt idx="1">
-                  <c:v>0.201</c:v>
+                  <c:v>0.164</c:v>
                 </c:pt>
                 <c:pt idx="2">
-                  <c:v>0.328</c:v>
+                  <c:v>0.268</c:v>
                 </c:pt>
                 <c:pt idx="3">
-                  <c:v>0.481</c:v>
+                  <c:v>0.394</c:v>
                 </c:pt>
                 <c:pt idx="4">
-                  <c:v>0.658</c:v>
+                  <c:v>0.541</c:v>
                 </c:pt>
               </c:numCache>
             </c:numRef>
@@ -2114,19 +2114,19 @@
                 <c:formatCode>General</c:formatCode>
                 <c:ptCount val="5"/>
                 <c:pt idx="0">
-                  <c:v>0.148</c:v>
+                  <c:v>0.12</c:v>
                 </c:pt>
                 <c:pt idx="1">
-                  <c:v>0.316</c:v>
+                  <c:v>0.257</c:v>
                 </c:pt>
                 <c:pt idx="2">
-                  <c:v>0.535</c:v>
+                  <c:v>0.436</c:v>
                 </c:pt>
                 <c:pt idx="3">
-                  <c:v>0.81</c:v>
+                  <c:v>0.663</c:v>
                 </c:pt>
                 <c:pt idx="4">
-                  <c:v>1.145</c:v>
+                  <c:v>0.939</c:v>
                 </c:pt>
               </c:numCache>
             </c:numRef>
@@ -5606,7 +5606,7 @@
               </a:defRPr>
             </a:pPr>
             <a:r>
-              <a:t>0.66Q</a:t>
+              <a:t>0.54Q</a:t>
             </a:r>
           </a:p>
         </p:txBody>
@@ -5711,7 +5711,7 @@
               </a:defRPr>
             </a:pPr>
             <a:r>
-              <a:t>2026-05-27</a:t>
+              <a:t>2026-07-20</a:t>
             </a:r>
           </a:p>
         </p:txBody>
@@ -6560,7 +6560,7 @@
                         </a:defRPr>
                       </a:pPr>
                       <a:r>
-                        <a:t>0.12</a:t>
+                        <a:t>0.10</a:t>
                       </a:r>
                     </a:p>
                   </a:txBody>
@@ -6700,7 +6700,7 @@
                         </a:defRPr>
                       </a:pPr>
                       <a:r>
-                        <a:t>0.14</a:t>
+                        <a:t>0.12</a:t>
                       </a:r>
                     </a:p>
                   </a:txBody>
@@ -6769,7 +6769,7 @@
                         </a:defRPr>
                       </a:pPr>
                       <a:r>
-                        <a:t>Serving efficiency</a:t>
+                        <a:t>Scale absorption</a:t>
                       </a:r>
                     </a:p>
                   </a:txBody>
@@ -6792,7 +6792,7 @@
                         </a:defRPr>
                       </a:pPr>
                       <a:r>
-                        <a:t>model routing, precision, batching, TTFT/TPOT target</a:t>
+                        <a:t>demand absorption and product surface expansion</a:t>
                       </a:r>
                     </a:p>
                   </a:txBody>
@@ -6840,7 +6840,7 @@
                         </a:defRPr>
                       </a:pPr>
                       <a:r>
-                        <a:t>0.09</a:t>
+                        <a:t>0.07</a:t>
                       </a:r>
                     </a:p>
                   </a:txBody>
@@ -6980,7 +6980,7 @@
                         </a:defRPr>
                       </a:pPr>
                       <a:r>
-                        <a:t>0.04</a:t>
+                        <a:t>0.03</a:t>
                       </a:r>
                     </a:p>
                   </a:txBody>
@@ -7120,7 +7120,7 @@
                         </a:defRPr>
                       </a:pPr>
                       <a:r>
-                        <a:t>0.05</a:t>
+                        <a:t>0.04</a:t>
                       </a:r>
                     </a:p>
                   </a:txBody>
@@ -7260,7 +7260,7 @@
                         </a:defRPr>
                       </a:pPr>
                       <a:r>
-                        <a:t>0.14</a:t>
+                        <a:t>0.11</a:t>
                       </a:r>
                     </a:p>
                   </a:txBody>
@@ -7512,7 +7512,7 @@
               </a:defRPr>
             </a:pPr>
             <a:r>
-              <a:t>2026-05-27</a:t>
+              <a:t>2026-07-20</a:t>
             </a:r>
           </a:p>
         </p:txBody>
@@ -7946,7 +7946,7 @@
                         </a:defRPr>
                       </a:pPr>
                       <a:r>
-                        <a:t>0.31</a:t>
+                        <a:t>0.25</a:t>
                       </a:r>
                     </a:p>
                   </a:txBody>
@@ -8040,7 +8040,7 @@
                         </a:defRPr>
                       </a:pPr>
                       <a:r>
-                        <a:t>0.66</a:t>
+                        <a:t>0.54</a:t>
                       </a:r>
                     </a:p>
                   </a:txBody>
@@ -8134,7 +8134,7 @@
                         </a:defRPr>
                       </a:pPr>
                       <a:r>
-                        <a:t>1.15</a:t>
+                        <a:t>0.94</a:t>
                       </a:r>
                     </a:p>
                   </a:txBody>
@@ -8328,7 +8328,7 @@
               </a:defRPr>
             </a:pPr>
             <a:r>
-              <a:t>Base growth: 6.7x, 2026-2030</a:t>
+              <a:t>Base growth: 6.8x, 2026-2030</a:t>
             </a:r>
           </a:p>
         </p:txBody>
@@ -8478,7 +8478,7 @@
               </a:defRPr>
             </a:pPr>
             <a:r>
-              <a:t>2026-05-27</a:t>
+              <a:t>2026-07-20</a:t>
             </a:r>
           </a:p>
         </p:txBody>
@@ -9337,7 +9337,7 @@
               </a:defRPr>
             </a:pPr>
             <a:r>
-              <a:t>2026-05-27</a:t>
+              <a:t>2026-07-20</a:t>
             </a:r>
           </a:p>
         </p:txBody>
@@ -10318,7 +10318,7 @@
               </a:defRPr>
             </a:pPr>
             <a:r>
-              <a:t>2026-05-27</a:t>
+              <a:t>2026-07-20</a:t>
             </a:r>
           </a:p>
         </p:txBody>
@@ -11174,7 +11174,7 @@
               </a:defRPr>
             </a:pPr>
             <a:r>
-              <a:t>2026-05-27</a:t>
+              <a:t>2026-07-20</a:t>
             </a:r>
           </a:p>
         </p:txBody>
@@ -12368,7 +12368,7 @@
               </a:defRPr>
             </a:pPr>
             <a:r>
-              <a:t>2026-05-27</a:t>
+              <a:t>2026-07-20</a:t>
             </a:r>
           </a:p>
         </p:txBody>
@@ -12802,7 +12802,7 @@
                         </a:defRPr>
                       </a:pPr>
                       <a:r>
-                        <a:t>0.14</a:t>
+                        <a:t>0.12</a:t>
                       </a:r>
                     </a:p>
                   </a:txBody>
@@ -12896,7 +12896,7 @@
                         </a:defRPr>
                       </a:pPr>
                       <a:r>
-                        <a:t>0.14</a:t>
+                        <a:t>0.11</a:t>
                       </a:r>
                     </a:p>
                   </a:txBody>
@@ -12990,7 +12990,7 @@
                         </a:defRPr>
                       </a:pPr>
                       <a:r>
-                        <a:t>0.12</a:t>
+                        <a:t>0.10</a:t>
                       </a:r>
                     </a:p>
                   </a:txBody>
@@ -13084,7 +13084,7 @@
                         </a:defRPr>
                       </a:pPr>
                       <a:r>
-                        <a:t>0.09</a:t>
+                        <a:t>0.07</a:t>
                       </a:r>
                     </a:p>
                   </a:txBody>
@@ -13489,7 +13489,7 @@
               </a:defRPr>
             </a:pPr>
             <a:r>
-              <a:t>2026-05-27</a:t>
+              <a:t>2026-07-20</a:t>
             </a:r>
           </a:p>
         </p:txBody>
@@ -13970,7 +13970,7 @@
                         </a:defRPr>
                       </a:pPr>
                       <a:r>
-                        <a:t>0.06</a:t>
+                        <a:t>0.05</a:t>
                       </a:r>
                     </a:p>
                   </a:txBody>
@@ -13993,7 +13993,7 @@
                         </a:defRPr>
                       </a:pPr>
                       <a:r>
-                        <a:t>0.14</a:t>
+                        <a:t>0.12</a:t>
                       </a:r>
                     </a:p>
                   </a:txBody>
@@ -14016,7 +14016,7 @@
                         </a:defRPr>
                       </a:pPr>
                       <a:r>
-                        <a:t>10.6x</a:t>
+                        <a:t>10.9x</a:t>
                       </a:r>
                     </a:p>
                   </a:txBody>
@@ -14087,7 +14087,7 @@
                         </a:defRPr>
                       </a:pPr>
                       <a:r>
-                        <a:t>0.08</a:t>
+                        <a:t>0.06</a:t>
                       </a:r>
                     </a:p>
                   </a:txBody>
@@ -14110,7 +14110,7 @@
                         </a:defRPr>
                       </a:pPr>
                       <a:r>
-                        <a:t>0.14</a:t>
+                        <a:t>0.11</a:t>
                       </a:r>
                     </a:p>
                   </a:txBody>
@@ -14204,7 +14204,7 @@
                         </a:defRPr>
                       </a:pPr>
                       <a:r>
-                        <a:t>0.06</a:t>
+                        <a:t>0.05</a:t>
                       </a:r>
                     </a:p>
                   </a:txBody>
@@ -14227,7 +14227,7 @@
                         </a:defRPr>
                       </a:pPr>
                       <a:r>
-                        <a:t>0.12</a:t>
+                        <a:t>0.10</a:t>
                       </a:r>
                     </a:p>
                   </a:txBody>
@@ -14250,7 +14250,7 @@
                         </a:defRPr>
                       </a:pPr>
                       <a:r>
-                        <a:t>6.0x</a:t>
+                        <a:t>6.1x</a:t>
                       </a:r>
                     </a:p>
                   </a:txBody>
@@ -14321,7 +14321,7 @@
                         </a:defRPr>
                       </a:pPr>
                       <a:r>
-                        <a:t>0.04</a:t>
+                        <a:t>0.03</a:t>
                       </a:r>
                     </a:p>
                   </a:txBody>
@@ -14344,7 +14344,7 @@
                         </a:defRPr>
                       </a:pPr>
                       <a:r>
-                        <a:t>0.09</a:t>
+                        <a:t>0.07</a:t>
                       </a:r>
                     </a:p>
                   </a:txBody>
@@ -14484,7 +14484,7 @@
                         </a:defRPr>
                       </a:pPr>
                       <a:r>
-                        <a:t>4.9x</a:t>
+                        <a:t>5.0x</a:t>
                       </a:r>
                     </a:p>
                   </a:txBody>
@@ -14532,7 +14532,7 @@
                         </a:defRPr>
                       </a:pPr>
                       <a:r>
-                        <a:t>0.01</a:t>
+                        <a:t>0.00</a:t>
                       </a:r>
                     </a:p>
                   </a:txBody>
@@ -14578,7 +14578,7 @@
                         </a:defRPr>
                       </a:pPr>
                       <a:r>
-                        <a:t>0.05</a:t>
+                        <a:t>0.04</a:t>
                       </a:r>
                     </a:p>
                   </a:txBody>
@@ -14601,7 +14601,7 @@
                         </a:defRPr>
                       </a:pPr>
                       <a:r>
-                        <a:t>9.3x</a:t>
+                        <a:t>9.4x</a:t>
                       </a:r>
                     </a:p>
                   </a:txBody>
@@ -14672,7 +14672,7 @@
                         </a:defRPr>
                       </a:pPr>
                       <a:r>
-                        <a:t>0.02</a:t>
+                        <a:t>0.01</a:t>
                       </a:r>
                     </a:p>
                   </a:txBody>
@@ -14695,7 +14695,7 @@
                         </a:defRPr>
                       </a:pPr>
                       <a:r>
-                        <a:t>0.04</a:t>
+                        <a:t>0.03</a:t>
                       </a:r>
                     </a:p>
                   </a:txBody>
@@ -14718,7 +14718,7 @@
                         </a:defRPr>
                       </a:pPr>
                       <a:r>
-                        <a:t>14.4x</a:t>
+                        <a:t>14.8x</a:t>
                       </a:r>
                     </a:p>
                   </a:txBody>
@@ -14835,7 +14835,7 @@
                         </a:defRPr>
                       </a:pPr>
                       <a:r>
-                        <a:t>8.6x</a:t>
+                        <a:t>8.8x</a:t>
                       </a:r>
                     </a:p>
                   </a:txBody>
@@ -14952,7 +14952,7 @@
                         </a:defRPr>
                       </a:pPr>
                       <a:r>
-                        <a:t>10.9x</a:t>
+                        <a:t>11.4x</a:t>
                       </a:r>
                     </a:p>
                   </a:txBody>
@@ -15112,7 +15112,7 @@
               </a:defRPr>
             </a:pPr>
             <a:r>
-              <a:t>2026-05-27</a:t>
+              <a:t>2026-07-20</a:t>
             </a:r>
           </a:p>
         </p:txBody>
@@ -16735,7 +16735,7 @@
               </a:defRPr>
             </a:pPr>
             <a:r>
-              <a:t>2026-05-27</a:t>
+              <a:t>2026-07-20</a:t>
             </a:r>
           </a:p>
         </p:txBody>
@@ -17598,7 +17598,7 @@
               </a:defRPr>
             </a:pPr>
             <a:r>
-              <a:t>2026-05-27</a:t>
+              <a:t>2026-07-20</a:t>
             </a:r>
           </a:p>
         </p:txBody>
@@ -18649,7 +18649,7 @@
               </a:defRPr>
             </a:pPr>
             <a:r>
-              <a:t>2026-05-27</a:t>
+              <a:t>2026-07-20</a:t>
             </a:r>
           </a:p>
         </p:txBody>
@@ -18989,7 +18989,7 @@
                         </a:defRPr>
                       </a:pPr>
                       <a:r>
-                        <a:t>H/B/GB</a:t>
+                        <a:t>S/L/A</a:t>
                       </a:r>
                     </a:p>
                   </a:txBody>
@@ -19083,7 +19083,7 @@
                         </a:defRPr>
                       </a:pPr>
                       <a:r>
-                        <a:t>10%/35%/55%</a:t>
+                        <a:t>35%/40%/25%</a:t>
                       </a:r>
                     </a:p>
                   </a:txBody>
@@ -19129,7 +19129,7 @@
                         </a:defRPr>
                       </a:pPr>
                       <a:r>
-                        <a:t>0.06</a:t>
+                        <a:t>0.04</a:t>
                       </a:r>
                     </a:p>
                   </a:txBody>
@@ -19177,7 +19177,7 @@
                         </a:defRPr>
                       </a:pPr>
                       <a:r>
-                        <a:t>10%/35%/55%</a:t>
+                        <a:t>45%/35%/20%</a:t>
                       </a:r>
                     </a:p>
                   </a:txBody>
@@ -19223,7 +19223,7 @@
                         </a:defRPr>
                       </a:pPr>
                       <a:r>
-                        <a:t>0.15</a:t>
+                        <a:t>0.13</a:t>
                       </a:r>
                     </a:p>
                   </a:txBody>
@@ -19271,7 +19271,7 @@
                         </a:defRPr>
                       </a:pPr>
                       <a:r>
-                        <a:t>6%/19%/30%</a:t>
+                        <a:t>70%/20%/10%</a:t>
                       </a:r>
                     </a:p>
                   </a:txBody>
@@ -19317,7 +19317,7 @@
                         </a:defRPr>
                       </a:pPr>
                       <a:r>
-                        <a:t>0.18</a:t>
+                        <a:t>0.16</a:t>
                       </a:r>
                     </a:p>
                   </a:txBody>
@@ -19342,7 +19342,7 @@
                         </a:defRPr>
                       </a:pPr>
                       <a:r>
-                        <a:t>OpenAI</a:t>
+                        <a:t>Anthropic</a:t>
                       </a:r>
                     </a:p>
                   </a:txBody>
@@ -19365,7 +19365,7 @@
                         </a:defRPr>
                       </a:pPr>
                       <a:r>
-                        <a:t>10%/35%/55%</a:t>
+                        <a:t>30%/30%/40%</a:t>
                       </a:r>
                     </a:p>
                   </a:txBody>
@@ -19411,7 +19411,7 @@
                         </a:defRPr>
                       </a:pPr>
                       <a:r>
-                        <a:t>0.34</a:t>
+                        <a:t>0.26</a:t>
                       </a:r>
                     </a:p>
                   </a:txBody>
@@ -19436,7 +19436,7 @@
                         </a:defRPr>
                       </a:pPr>
                       <a:r>
-                        <a:t>Anthropic</a:t>
+                        <a:t>OpenAI</a:t>
                       </a:r>
                     </a:p>
                   </a:txBody>
@@ -19459,7 +19459,7 @@
                         </a:defRPr>
                       </a:pPr>
                       <a:r>
-                        <a:t>2%/5%/8%</a:t>
+                        <a:t>45%/25%/30%</a:t>
                       </a:r>
                     </a:p>
                   </a:txBody>
@@ -19505,7 +19505,7 @@
                         </a:defRPr>
                       </a:pPr>
                       <a:r>
-                        <a:t>0.36</a:t>
+                        <a:t>0.28</a:t>
                       </a:r>
                     </a:p>
                   </a:txBody>
@@ -19550,7 +19550,7 @@
               </a:defRPr>
             </a:pPr>
             <a:r>
-              <a:t>Purpose-built mix remains visible, but no hardware premium is added without a comparable output-token benchmark.</a:t>
+              <a:t>S/L/A is short conversation, long conversation and agentic mix; purpose-built hardware still receives no premium without matched output-token evidence.</a:t>
             </a:r>
           </a:p>
         </p:txBody>
@@ -19630,7 +19630,7 @@
               </a:defRPr>
             </a:pPr>
             <a:r>
-              <a:t>Base TPS/MW reflects an editable GPU-generation mix and workload fit; public benchmark values define the reference layer.</a:t>
+              <a:t>Base TPS/MW now reflects GPU-generation mix, workload class mix and commercial workload fit.</a:t>
             </a:r>
           </a:p>
         </p:txBody>
@@ -19700,7 +19700,7 @@
               </a:defRPr>
             </a:pPr>
             <a:r>
-              <a:t>2026-05-27</a:t>
+              <a:t>2026-07-20</a:t>
             </a:r>
           </a:p>
         </p:txBody>

</xml_diff>

<commit_message>
Refine workload benchmark Excel logic
</commit_message>
<xml_diff>
--- a/llm_token_capacity_project/outputs/reports/llm_token_capacity_2026_2030.pptx
+++ b/llm_token_capacity_project/outputs/reports/llm_token_capacity_2026_2030.pptx
@@ -190,22 +190,22 @@
                   <c:v>0.1116598239936</c:v>
                 </c:pt>
                 <c:pt idx="2">
-                  <c:v>0.0999095920416</c:v>
+                  <c:v>0.0999098800128</c:v>
                 </c:pt>
                 <c:pt idx="3">
                   <c:v>0.0671012843904</c:v>
                 </c:pt>
                 <c:pt idx="4">
-                  <c:v>0.046128282624</c:v>
+                  <c:v>0.046127999232</c:v>
                 </c:pt>
                 <c:pt idx="5">
                   <c:v>0.0428970862656</c:v>
                 </c:pt>
                 <c:pt idx="6">
-                  <c:v>0.0340065541728</c:v>
+                  <c:v>0.0340064488512</c:v>
                 </c:pt>
                 <c:pt idx="7">
-                  <c:v>0.0194207386752</c:v>
+                  <c:v>0.019420587648</c:v>
                 </c:pt>
                 <c:pt idx="8">
                   <c:v>0.0024526805184</c:v>
@@ -379,7 +379,7 @@
                   <c:v>0.0287679216384</c:v>
                 </c:pt>
                 <c:pt idx="2">
-                  <c:v>0.0521763078528</c:v>
+                  <c:v>0.0521760946176</c:v>
                 </c:pt>
                 <c:pt idx="3">
                   <c:v>0.08157148416</c:v>
@@ -436,7 +436,7 @@
                 <c:formatCode>General</c:formatCode>
                 <c:ptCount val="5"/>
                 <c:pt idx="0">
-                  <c:v>0.0261555725376</c:v>
+                  <c:v>0.0261554946048</c:v>
                 </c:pt>
                 <c:pt idx="1">
                   <c:v>0.043705626624</c:v>
@@ -445,7 +445,7 @@
                   <c:v>0.0638866912608</c:v>
                 </c:pt>
                 <c:pt idx="3">
-                  <c:v>0.086577678576</c:v>
+                  <c:v>0.086577431904</c:v>
                 </c:pt>
                 <c:pt idx="4">
                   <c:v>0.1116598239936</c:v>
@@ -511,7 +511,7 @@
                   <c:v>0.0735476744448</c:v>
                 </c:pt>
                 <c:pt idx="4">
-                  <c:v>0.0999095920416</c:v>
+                  <c:v>0.0999098800128</c:v>
                 </c:pt>
               </c:numCache>
             </c:numRef>
@@ -637,7 +637,7 @@
                   <c:v>0.0352253152512</c:v>
                 </c:pt>
                 <c:pt idx="4">
-                  <c:v>0.046128282624</c:v>
+                  <c:v>0.046127999232</c:v>
                 </c:pt>
               </c:numCache>
             </c:numRef>
@@ -1804,22 +1804,22 @@
                   <c:v>0.353974</c:v>
                 </c:pt>
                 <c:pt idx="2">
-                  <c:v>0.346943</c:v>
+                  <c:v>0.346944</c:v>
                 </c:pt>
                 <c:pt idx="3">
                   <c:v>0.261846</c:v>
                 </c:pt>
                 <c:pt idx="4">
-                  <c:v>0.162772</c:v>
+                  <c:v>0.162771</c:v>
                 </c:pt>
                 <c:pt idx="5">
                   <c:v>0.378714</c:v>
                 </c:pt>
                 <c:pt idx="6">
-                  <c:v>0.322883</c:v>
+                  <c:v>0.322882</c:v>
                 </c:pt>
                 <c:pt idx="7">
-                  <c:v>0.128591</c:v>
+                  <c:v>0.12859</c:v>
                 </c:pt>
                 <c:pt idx="8">
                   <c:v>0.043606</c:v>

</xml_diff>

<commit_message>
Update token capacity benchmark proxy assumptions
</commit_message>
<xml_diff>
--- a/llm_token_capacity_project/outputs/reports/llm_token_capacity_2026_2030.pptx
+++ b/llm_token_capacity_project/outputs/reports/llm_token_capacity_2026_2030.pptx
@@ -148,28 +148,28 @@
               <c:strCache>
                 <c:ptCount val="9"/>
                 <c:pt idx="0">
+                  <c:v>Microsoft</c:v>
+                </c:pt>
+                <c:pt idx="1">
+                  <c:v>Meta</c:v>
+                </c:pt>
+                <c:pt idx="2">
+                  <c:v>Tencent</c:v>
+                </c:pt>
+                <c:pt idx="3">
+                  <c:v>xAI</c:v>
+                </c:pt>
+                <c:pt idx="4">
+                  <c:v>Alibaba</c:v>
+                </c:pt>
+                <c:pt idx="5">
+                  <c:v>Google</c:v>
+                </c:pt>
+                <c:pt idx="6">
                   <c:v>OpenAI</c:v>
                 </c:pt>
-                <c:pt idx="1">
-                  <c:v>Google</c:v>
-                </c:pt>
-                <c:pt idx="2">
-                  <c:v>Microsoft</c:v>
-                </c:pt>
-                <c:pt idx="3">
+                <c:pt idx="7">
                   <c:v>Anthropic</c:v>
-                </c:pt>
-                <c:pt idx="4">
-                  <c:v>Meta</c:v>
-                </c:pt>
-                <c:pt idx="5">
-                  <c:v>Tencent</c:v>
-                </c:pt>
-                <c:pt idx="6">
-                  <c:v>xAI</c:v>
-                </c:pt>
-                <c:pt idx="7">
-                  <c:v>Alibaba</c:v>
                 </c:pt>
                 <c:pt idx="8">
                   <c:v>DeepSeek</c:v>
@@ -184,31 +184,31 @@
                 <c:formatCode>General</c:formatCode>
                 <c:ptCount val="9"/>
                 <c:pt idx="0">
-                  <c:v>0.117604700928</c:v>
+                  <c:v>0.2154517006752</c:v>
                 </c:pt>
                 <c:pt idx="1">
-                  <c:v>0.1116598239936</c:v>
+                  <c:v>0.111140957952</c:v>
                 </c:pt>
                 <c:pt idx="2">
-                  <c:v>0.0999098800128</c:v>
+                  <c:v>0.0943886774016</c:v>
                 </c:pt>
                 <c:pt idx="3">
-                  <c:v>0.0671012843904</c:v>
+                  <c:v>0.0718923135168</c:v>
                 </c:pt>
                 <c:pt idx="4">
-                  <c:v>0.046127999232</c:v>
+                  <c:v>0.0468196402176</c:v>
                 </c:pt>
                 <c:pt idx="5">
-                  <c:v>0.0428970862656</c:v>
+                  <c:v>0.0196766000928</c:v>
                 </c:pt>
                 <c:pt idx="6">
-                  <c:v>0.0340064488512</c:v>
+                  <c:v>0.0185825173248</c:v>
                 </c:pt>
                 <c:pt idx="7">
-                  <c:v>0.019420587648</c:v>
+                  <c:v>0.0122926510656</c:v>
                 </c:pt>
                 <c:pt idx="8">
-                  <c:v>0.0024526805184</c:v>
+                  <c:v>0.0040192552512</c:v>
                 </c:pt>
               </c:numCache>
             </c:numRef>
@@ -338,7 +338,7 @@
               <c:strCache>
                 <c:ptCount val="1"/>
                 <c:pt idx="0">
-                  <c:v>OpenAI</c:v>
+                  <c:v>Microsoft</c:v>
                 </c:pt>
               </c:strCache>
             </c:strRef>
@@ -373,19 +373,19 @@
                 <c:formatCode>General</c:formatCode>
                 <c:ptCount val="5"/>
                 <c:pt idx="0">
-                  <c:v>0.010765760544</c:v>
+                  <c:v>0.034688068992</c:v>
                 </c:pt>
                 <c:pt idx="1">
-                  <c:v>0.0287679216384</c:v>
+                  <c:v>0.06718716288</c:v>
                 </c:pt>
                 <c:pt idx="2">
-                  <c:v>0.0521760946176</c:v>
+                  <c:v>0.1083303261216</c:v>
                 </c:pt>
                 <c:pt idx="3">
-                  <c:v>0.08157148416</c:v>
+                  <c:v>0.1580741713152</c:v>
                 </c:pt>
                 <c:pt idx="4">
-                  <c:v>0.117604700928</c:v>
+                  <c:v>0.2154517006752</c:v>
                 </c:pt>
               </c:numCache>
             </c:numRef>
@@ -401,7 +401,7 @@
               <c:strCache>
                 <c:ptCount val="1"/>
                 <c:pt idx="0">
-                  <c:v>Google</c:v>
+                  <c:v>Meta</c:v>
                 </c:pt>
               </c:strCache>
             </c:strRef>
@@ -436,19 +436,19 @@
                 <c:formatCode>General</c:formatCode>
                 <c:ptCount val="5"/>
                 <c:pt idx="0">
-                  <c:v>0.0261554946048</c:v>
+                  <c:v>0.021667972608</c:v>
                 </c:pt>
                 <c:pt idx="1">
-                  <c:v>0.043705626624</c:v>
+                  <c:v>0.039607226208</c:v>
                 </c:pt>
                 <c:pt idx="2">
-                  <c:v>0.0638866912608</c:v>
+                  <c:v>0.0605383206912</c:v>
                 </c:pt>
                 <c:pt idx="3">
-                  <c:v>0.086577431904</c:v>
+                  <c:v>0.0844137324288</c:v>
                 </c:pt>
                 <c:pt idx="4">
-                  <c:v>0.1116598239936</c:v>
+                  <c:v>0.111140957952</c:v>
                 </c:pt>
               </c:numCache>
             </c:numRef>
@@ -464,7 +464,7 @@
               <c:strCache>
                 <c:ptCount val="1"/>
                 <c:pt idx="0">
-                  <c:v>Microsoft</c:v>
+                  <c:v>Tencent</c:v>
                 </c:pt>
               </c:strCache>
             </c:strRef>
@@ -499,19 +499,19 @@
                 <c:formatCode>General</c:formatCode>
                 <c:ptCount val="5"/>
                 <c:pt idx="0">
-                  <c:v>0.016348912128</c:v>
+                  <c:v>0.0098764952832</c:v>
                 </c:pt>
                 <c:pt idx="1">
-                  <c:v>0.0315036254016</c:v>
+                  <c:v>0.0242263636992</c:v>
                 </c:pt>
                 <c:pt idx="2">
-                  <c:v>0.0505847781216</c:v>
+                  <c:v>0.042791991552</c:v>
                 </c:pt>
                 <c:pt idx="3">
-                  <c:v>0.0735476744448</c:v>
+                  <c:v>0.066048986304</c:v>
                 </c:pt>
                 <c:pt idx="4">
-                  <c:v>0.0999098800128</c:v>
+                  <c:v>0.0943886774016</c:v>
                 </c:pt>
               </c:numCache>
             </c:numRef>
@@ -527,7 +527,7 @@
               <c:strCache>
                 <c:ptCount val="1"/>
                 <c:pt idx="0">
-                  <c:v>Anthropic</c:v>
+                  <c:v>xAI</c:v>
                 </c:pt>
               </c:strCache>
             </c:strRef>
@@ -562,19 +562,19 @@
                 <c:formatCode>General</c:formatCode>
                 <c:ptCount val="5"/>
                 <c:pt idx="0">
-                  <c:v>0.0077853318912</c:v>
+                  <c:v>0.00482484816</c:v>
                 </c:pt>
                 <c:pt idx="1">
-                  <c:v>0.0189682324128</c:v>
+                  <c:v>0.0150968161152</c:v>
                 </c:pt>
                 <c:pt idx="2">
-                  <c:v>0.0326438332416</c:v>
+                  <c:v>0.0293604801408</c:v>
                 </c:pt>
                 <c:pt idx="3">
-                  <c:v>0.0487398352896</c:v>
+                  <c:v>0.048117908736</c:v>
                 </c:pt>
                 <c:pt idx="4">
-                  <c:v>0.0671012843904</c:v>
+                  <c:v>0.0718923135168</c:v>
                 </c:pt>
               </c:numCache>
             </c:numRef>
@@ -590,7 +590,7 @@
               <c:strCache>
                 <c:ptCount val="1"/>
                 <c:pt idx="0">
-                  <c:v>Meta</c:v>
+                  <c:v>Alibaba</c:v>
                 </c:pt>
               </c:strCache>
             </c:strRef>
@@ -625,19 +625,19 @@
                 <c:formatCode>General</c:formatCode>
                 <c:ptCount val="5"/>
                 <c:pt idx="0">
-                  <c:v>0.0092273210208</c:v>
+                  <c:v>0.0048673505664</c:v>
                 </c:pt>
                 <c:pt idx="1">
-                  <c:v>0.016739271648</c:v>
+                  <c:v>0.0116748238464</c:v>
                 </c:pt>
                 <c:pt idx="2">
-                  <c:v>0.0254148046848</c:v>
+                  <c:v>0.020738180736</c:v>
                 </c:pt>
                 <c:pt idx="3">
-                  <c:v>0.0352253152512</c:v>
+                  <c:v>0.0323455693824</c:v>
                 </c:pt>
                 <c:pt idx="4">
-                  <c:v>0.046127999232</c:v>
+                  <c:v>0.0468196402176</c:v>
                 </c:pt>
               </c:numCache>
             </c:numRef>
@@ -754,7 +754,7 @@
               <c:strCache>
                 <c:ptCount val="1"/>
                 <c:pt idx="0">
-                  <c:v>OpenAI</c:v>
+                  <c:v>Microsoft</c:v>
                 </c:pt>
               </c:strCache>
             </c:strRef>
@@ -789,19 +789,19 @@
                 <c:formatCode>General</c:formatCode>
                 <c:ptCount val="5"/>
                 <c:pt idx="0">
-                  <c:v>0.595</c:v>
+                  <c:v>0.71</c:v>
                 </c:pt>
                 <c:pt idx="1">
-                  <c:v>1.467</c:v>
+                  <c:v>1.247</c:v>
                 </c:pt>
                 <c:pt idx="2">
-                  <c:v>2.468</c:v>
+                  <c:v>1.863</c:v>
                 </c:pt>
                 <c:pt idx="3">
-                  <c:v>3.6</c:v>
+                  <c:v>2.559</c:v>
                 </c:pt>
                 <c:pt idx="4">
-                  <c:v>4.862</c:v>
+                  <c:v>3.333</c:v>
                 </c:pt>
               </c:numCache>
             </c:numRef>
@@ -817,7 +817,7 @@
               <c:strCache>
                 <c:ptCount val="1"/>
                 <c:pt idx="0">
-                  <c:v>Google</c:v>
+                  <c:v>Meta</c:v>
                 </c:pt>
               </c:strCache>
             </c:strRef>
@@ -852,19 +852,19 @@
                 <c:formatCode>General</c:formatCode>
                 <c:ptCount val="5"/>
                 <c:pt idx="0">
-                  <c:v>0.902</c:v>
+                  <c:v>0.673</c:v>
                 </c:pt>
                 <c:pt idx="1">
-                  <c:v>1.48</c:v>
+                  <c:v>1.21</c:v>
                 </c:pt>
                 <c:pt idx="2">
-                  <c:v>2.131</c:v>
+                  <c:v>1.824</c:v>
                 </c:pt>
                 <c:pt idx="3">
-                  <c:v>2.855</c:v>
+                  <c:v>2.514</c:v>
                 </c:pt>
                 <c:pt idx="4">
-                  <c:v>3.651</c:v>
+                  <c:v>3.28</c:v>
                 </c:pt>
               </c:numCache>
             </c:numRef>
@@ -880,7 +880,7 @@
               <c:strCache>
                 <c:ptCount val="1"/>
                 <c:pt idx="0">
-                  <c:v>Microsoft</c:v>
+                  <c:v>Tencent</c:v>
                 </c:pt>
               </c:strCache>
             </c:strRef>
@@ -915,19 +915,19 @@
                 <c:formatCode>General</c:formatCode>
                 <c:ptCount val="5"/>
                 <c:pt idx="0">
-                  <c:v>0.71</c:v>
+                  <c:v>0.184</c:v>
                 </c:pt>
                 <c:pt idx="1">
-                  <c:v>1.247</c:v>
+                  <c:v>0.416</c:v>
                 </c:pt>
                 <c:pt idx="2">
-                  <c:v>1.863</c:v>
+                  <c:v>0.681</c:v>
                 </c:pt>
                 <c:pt idx="3">
-                  <c:v>2.559</c:v>
+                  <c:v>0.98</c:v>
                 </c:pt>
                 <c:pt idx="4">
-                  <c:v>3.333</c:v>
+                  <c:v>1.311</c:v>
                 </c:pt>
               </c:numCache>
             </c:numRef>
@@ -943,7 +943,7 @@
               <c:strCache>
                 <c:ptCount val="1"/>
                 <c:pt idx="0">
-                  <c:v>Anthropic</c:v>
+                  <c:v>xAI</c:v>
                 </c:pt>
               </c:strCache>
             </c:strRef>
@@ -978,19 +978,19 @@
                 <c:formatCode>General</c:formatCode>
                 <c:ptCount val="5"/>
                 <c:pt idx="0">
-                  <c:v>0.379</c:v>
+                  <c:v>0.11</c:v>
                 </c:pt>
                 <c:pt idx="1">
-                  <c:v>0.891</c:v>
+                  <c:v>0.317</c:v>
                 </c:pt>
                 <c:pt idx="2">
-                  <c:v>1.492</c:v>
+                  <c:v>0.571</c:v>
                 </c:pt>
                 <c:pt idx="3">
-                  <c:v>2.184</c:v>
+                  <c:v>0.872</c:v>
                 </c:pt>
                 <c:pt idx="4">
-                  <c:v>2.966</c:v>
+                  <c:v>1.219</c:v>
                 </c:pt>
               </c:numCache>
             </c:numRef>
@@ -1006,7 +1006,7 @@
               <c:strCache>
                 <c:ptCount val="1"/>
                 <c:pt idx="0">
-                  <c:v>Meta</c:v>
+                  <c:v>Alibaba</c:v>
                 </c:pt>
               </c:strCache>
             </c:strRef>
@@ -1041,19 +1041,19 @@
                 <c:formatCode>General</c:formatCode>
                 <c:ptCount val="5"/>
                 <c:pt idx="0">
-                  <c:v>0.673</c:v>
+                  <c:v>0.266</c:v>
                 </c:pt>
                 <c:pt idx="1">
-                  <c:v>1.21</c:v>
+                  <c:v>0.572</c:v>
                 </c:pt>
                 <c:pt idx="2">
-                  <c:v>1.824</c:v>
+                  <c:v>0.92</c:v>
                 </c:pt>
                 <c:pt idx="3">
-                  <c:v>2.514</c:v>
+                  <c:v>1.312</c:v>
                 </c:pt>
                 <c:pt idx="4">
-                  <c:v>3.28</c:v>
+                  <c:v>1.748</c:v>
                 </c:pt>
               </c:numCache>
             </c:numRef>
@@ -1181,28 +1181,28 @@
               <c:strCache>
                 <c:ptCount val="9"/>
                 <c:pt idx="0">
+                  <c:v>Microsoft</c:v>
+                </c:pt>
+                <c:pt idx="1">
+                  <c:v>Meta</c:v>
+                </c:pt>
+                <c:pt idx="2">
+                  <c:v>Tencent</c:v>
+                </c:pt>
+                <c:pt idx="3">
+                  <c:v>xAI</c:v>
+                </c:pt>
+                <c:pt idx="4">
+                  <c:v>Alibaba</c:v>
+                </c:pt>
+                <c:pt idx="5">
+                  <c:v>Google</c:v>
+                </c:pt>
+                <c:pt idx="6">
                   <c:v>OpenAI</c:v>
                 </c:pt>
-                <c:pt idx="1">
-                  <c:v>Google</c:v>
-                </c:pt>
-                <c:pt idx="2">
-                  <c:v>Microsoft</c:v>
-                </c:pt>
-                <c:pt idx="3">
+                <c:pt idx="7">
                   <c:v>Anthropic</c:v>
-                </c:pt>
-                <c:pt idx="4">
-                  <c:v>Meta</c:v>
-                </c:pt>
-                <c:pt idx="5">
-                  <c:v>Tencent</c:v>
-                </c:pt>
-                <c:pt idx="6">
-                  <c:v>xAI</c:v>
-                </c:pt>
-                <c:pt idx="7">
-                  <c:v>Alibaba</c:v>
                 </c:pt>
                 <c:pt idx="8">
                   <c:v>DeepSeek</c:v>
@@ -1217,28 +1217,28 @@
                 <c:formatCode>General</c:formatCode>
                 <c:ptCount val="9"/>
                 <c:pt idx="0">
+                  <c:v>9.0</c:v>
+                </c:pt>
+                <c:pt idx="1">
+                  <c:v>7.0</c:v>
+                </c:pt>
+                <c:pt idx="2">
+                  <c:v>3.0</c:v>
+                </c:pt>
+                <c:pt idx="3">
+                  <c:v>3.0</c:v>
+                </c:pt>
+                <c:pt idx="4">
+                  <c:v>4.0</c:v>
+                </c:pt>
+                <c:pt idx="5">
+                  <c:v>8.0</c:v>
+                </c:pt>
+                <c:pt idx="6">
                   <c:v>12.0</c:v>
                 </c:pt>
-                <c:pt idx="1">
-                  <c:v>8.0</c:v>
-                </c:pt>
-                <c:pt idx="2">
-                  <c:v>9.0</c:v>
-                </c:pt>
-                <c:pt idx="3">
+                <c:pt idx="7">
                   <c:v>7.0</c:v>
-                </c:pt>
-                <c:pt idx="4">
-                  <c:v>7.0</c:v>
-                </c:pt>
-                <c:pt idx="5">
-                  <c:v>3.0</c:v>
-                </c:pt>
-                <c:pt idx="6">
-                  <c:v>3.0</c:v>
-                </c:pt>
-                <c:pt idx="7">
-                  <c:v>4.0</c:v>
                 </c:pt>
                 <c:pt idx="8">
                   <c:v>1.8</c:v>
@@ -1267,28 +1267,28 @@
               <c:strCache>
                 <c:ptCount val="9"/>
                 <c:pt idx="0">
+                  <c:v>Microsoft</c:v>
+                </c:pt>
+                <c:pt idx="1">
+                  <c:v>Meta</c:v>
+                </c:pt>
+                <c:pt idx="2">
+                  <c:v>Tencent</c:v>
+                </c:pt>
+                <c:pt idx="3">
+                  <c:v>xAI</c:v>
+                </c:pt>
+                <c:pt idx="4">
+                  <c:v>Alibaba</c:v>
+                </c:pt>
+                <c:pt idx="5">
+                  <c:v>Google</c:v>
+                </c:pt>
+                <c:pt idx="6">
                   <c:v>OpenAI</c:v>
                 </c:pt>
-                <c:pt idx="1">
-                  <c:v>Google</c:v>
-                </c:pt>
-                <c:pt idx="2">
-                  <c:v>Microsoft</c:v>
-                </c:pt>
-                <c:pt idx="3">
+                <c:pt idx="7">
                   <c:v>Anthropic</c:v>
-                </c:pt>
-                <c:pt idx="4">
-                  <c:v>Meta</c:v>
-                </c:pt>
-                <c:pt idx="5">
-                  <c:v>Tencent</c:v>
-                </c:pt>
-                <c:pt idx="6">
-                  <c:v>xAI</c:v>
-                </c:pt>
-                <c:pt idx="7">
-                  <c:v>Alibaba</c:v>
                 </c:pt>
                 <c:pt idx="8">
                   <c:v>DeepSeek</c:v>
@@ -1303,28 +1303,28 @@
                 <c:formatCode>General</c:formatCode>
                 <c:ptCount val="9"/>
                 <c:pt idx="0">
+                  <c:v>6.2</c:v>
+                </c:pt>
+                <c:pt idx="1">
+                  <c:v>5.8</c:v>
+                </c:pt>
+                <c:pt idx="2">
+                  <c:v>2.4</c:v>
+                </c:pt>
+                <c:pt idx="3">
+                  <c:v>2.5</c:v>
+                </c:pt>
+                <c:pt idx="4">
+                  <c:v>3.2</c:v>
+                </c:pt>
+                <c:pt idx="5">
+                  <c:v>6.8</c:v>
+                </c:pt>
+                <c:pt idx="6">
                   <c:v>8.5</c:v>
                 </c:pt>
-                <c:pt idx="1">
-                  <c:v>6.8</c:v>
-                </c:pt>
-                <c:pt idx="2">
-                  <c:v>6.2</c:v>
-                </c:pt>
-                <c:pt idx="3">
+                <c:pt idx="7">
                   <c:v>5.5</c:v>
-                </c:pt>
-                <c:pt idx="4">
-                  <c:v>5.8</c:v>
-                </c:pt>
-                <c:pt idx="5">
-                  <c:v>2.4</c:v>
-                </c:pt>
-                <c:pt idx="6">
-                  <c:v>2.5</c:v>
-                </c:pt>
-                <c:pt idx="7">
-                  <c:v>3.2</c:v>
                 </c:pt>
                 <c:pt idx="8">
                   <c:v>1.2</c:v>
@@ -1471,28 +1471,28 @@
               <c:strCache>
                 <c:ptCount val="9"/>
                 <c:pt idx="0">
+                  <c:v>Microsoft</c:v>
+                </c:pt>
+                <c:pt idx="1">
+                  <c:v>Meta</c:v>
+                </c:pt>
+                <c:pt idx="2">
+                  <c:v>Tencent</c:v>
+                </c:pt>
+                <c:pt idx="3">
+                  <c:v>xAI</c:v>
+                </c:pt>
+                <c:pt idx="4">
+                  <c:v>Alibaba</c:v>
+                </c:pt>
+                <c:pt idx="5">
+                  <c:v>Google</c:v>
+                </c:pt>
+                <c:pt idx="6">
                   <c:v>OpenAI</c:v>
                 </c:pt>
-                <c:pt idx="1">
-                  <c:v>Google</c:v>
-                </c:pt>
-                <c:pt idx="2">
-                  <c:v>Microsoft</c:v>
-                </c:pt>
-                <c:pt idx="3">
+                <c:pt idx="7">
                   <c:v>Anthropic</c:v>
-                </c:pt>
-                <c:pt idx="4">
-                  <c:v>Meta</c:v>
-                </c:pt>
-                <c:pt idx="5">
-                  <c:v>Tencent</c:v>
-                </c:pt>
-                <c:pt idx="6">
-                  <c:v>xAI</c:v>
-                </c:pt>
-                <c:pt idx="7">
-                  <c:v>Alibaba</c:v>
                 </c:pt>
                 <c:pt idx="8">
                   <c:v>DeepSeek</c:v>
@@ -1507,28 +1507,28 @@
                 <c:formatCode>General</c:formatCode>
                 <c:ptCount val="9"/>
                 <c:pt idx="0">
+                  <c:v>3.333</c:v>
+                </c:pt>
+                <c:pt idx="1">
+                  <c:v>3.28</c:v>
+                </c:pt>
+                <c:pt idx="2">
+                  <c:v>1.311</c:v>
+                </c:pt>
+                <c:pt idx="3">
+                  <c:v>1.219</c:v>
+                </c:pt>
+                <c:pt idx="4">
+                  <c:v>1.748</c:v>
+                </c:pt>
+                <c:pt idx="5">
+                  <c:v>3.651</c:v>
+                </c:pt>
+                <c:pt idx="6">
                   <c:v>4.862</c:v>
                 </c:pt>
-                <c:pt idx="1">
-                  <c:v>3.651</c:v>
-                </c:pt>
-                <c:pt idx="2">
-                  <c:v>3.333</c:v>
-                </c:pt>
-                <c:pt idx="3">
+                <c:pt idx="7">
                   <c:v>2.966</c:v>
-                </c:pt>
-                <c:pt idx="4">
-                  <c:v>3.28</c:v>
-                </c:pt>
-                <c:pt idx="5">
-                  <c:v>1.311</c:v>
-                </c:pt>
-                <c:pt idx="6">
-                  <c:v>1.219</c:v>
-                </c:pt>
-                <c:pt idx="7">
-                  <c:v>1.748</c:v>
                 </c:pt>
                 <c:pt idx="8">
                   <c:v>0.651</c:v>
@@ -1557,28 +1557,28 @@
               <c:strCache>
                 <c:ptCount val="9"/>
                 <c:pt idx="0">
+                  <c:v>Microsoft</c:v>
+                </c:pt>
+                <c:pt idx="1">
+                  <c:v>Meta</c:v>
+                </c:pt>
+                <c:pt idx="2">
+                  <c:v>Tencent</c:v>
+                </c:pt>
+                <c:pt idx="3">
+                  <c:v>xAI</c:v>
+                </c:pt>
+                <c:pt idx="4">
+                  <c:v>Alibaba</c:v>
+                </c:pt>
+                <c:pt idx="5">
+                  <c:v>Google</c:v>
+                </c:pt>
+                <c:pt idx="6">
                   <c:v>OpenAI</c:v>
                 </c:pt>
-                <c:pt idx="1">
-                  <c:v>Google</c:v>
-                </c:pt>
-                <c:pt idx="2">
-                  <c:v>Microsoft</c:v>
-                </c:pt>
-                <c:pt idx="3">
+                <c:pt idx="7">
                   <c:v>Anthropic</c:v>
-                </c:pt>
-                <c:pt idx="4">
-                  <c:v>Meta</c:v>
-                </c:pt>
-                <c:pt idx="5">
-                  <c:v>Tencent</c:v>
-                </c:pt>
-                <c:pt idx="6">
-                  <c:v>xAI</c:v>
-                </c:pt>
-                <c:pt idx="7">
-                  <c:v>Alibaba</c:v>
                 </c:pt>
                 <c:pt idx="8">
                   <c:v>DeepSeek</c:v>
@@ -1593,28 +1593,28 @@
                 <c:formatCode>General</c:formatCode>
                 <c:ptCount val="9"/>
                 <c:pt idx="0">
+                  <c:v>1.111</c:v>
+                </c:pt>
+                <c:pt idx="1">
+                  <c:v>0.925</c:v>
+                </c:pt>
+                <c:pt idx="2">
+                  <c:v>0.328</c:v>
+                </c:pt>
+                <c:pt idx="3">
+                  <c:v>0.523</c:v>
+                </c:pt>
+                <c:pt idx="4">
+                  <c:v>0.437</c:v>
+                </c:pt>
+                <c:pt idx="5">
+                  <c:v>1.42</c:v>
+                </c:pt>
+                <c:pt idx="6">
                   <c:v>1.371</c:v>
                 </c:pt>
-                <c:pt idx="1">
-                  <c:v>1.42</c:v>
-                </c:pt>
-                <c:pt idx="2">
-                  <c:v>1.111</c:v>
-                </c:pt>
-                <c:pt idx="3">
+                <c:pt idx="7">
                   <c:v>1.042</c:v>
-                </c:pt>
-                <c:pt idx="4">
-                  <c:v>0.925</c:v>
-                </c:pt>
-                <c:pt idx="5">
-                  <c:v>0.328</c:v>
-                </c:pt>
-                <c:pt idx="6">
-                  <c:v>0.523</c:v>
-                </c:pt>
-                <c:pt idx="7">
-                  <c:v>0.437</c:v>
                 </c:pt>
                 <c:pt idx="8">
                   <c:v>0.143</c:v>
@@ -1762,28 +1762,28 @@
               <c:strCache>
                 <c:ptCount val="9"/>
                 <c:pt idx="0">
+                  <c:v>Microsoft</c:v>
+                </c:pt>
+                <c:pt idx="1">
+                  <c:v>Meta</c:v>
+                </c:pt>
+                <c:pt idx="2">
+                  <c:v>Tencent</c:v>
+                </c:pt>
+                <c:pt idx="3">
+                  <c:v>xAI</c:v>
+                </c:pt>
+                <c:pt idx="4">
+                  <c:v>Alibaba</c:v>
+                </c:pt>
+                <c:pt idx="5">
+                  <c:v>Google</c:v>
+                </c:pt>
+                <c:pt idx="6">
                   <c:v>OpenAI</c:v>
                 </c:pt>
-                <c:pt idx="1">
-                  <c:v>Google</c:v>
-                </c:pt>
-                <c:pt idx="2">
-                  <c:v>Microsoft</c:v>
-                </c:pt>
-                <c:pt idx="3">
+                <c:pt idx="7">
                   <c:v>Anthropic</c:v>
-                </c:pt>
-                <c:pt idx="4">
-                  <c:v>Meta</c:v>
-                </c:pt>
-                <c:pt idx="5">
-                  <c:v>Tencent</c:v>
-                </c:pt>
-                <c:pt idx="6">
-                  <c:v>xAI</c:v>
-                </c:pt>
-                <c:pt idx="7">
-                  <c:v>Alibaba</c:v>
                 </c:pt>
                 <c:pt idx="8">
                   <c:v>DeepSeek</c:v>
@@ -1798,31 +1798,31 @@
                 <c:formatCode>General</c:formatCode>
                 <c:ptCount val="9"/>
                 <c:pt idx="0">
-                  <c:v>0.27996</c:v>
+                  <c:v>0.748171</c:v>
                 </c:pt>
                 <c:pt idx="1">
-                  <c:v>0.353974</c:v>
+                  <c:v>0.392181</c:v>
                 </c:pt>
                 <c:pt idx="2">
-                  <c:v>0.346944</c:v>
+                  <c:v>0.833304</c:v>
                 </c:pt>
                 <c:pt idx="3">
-                  <c:v>0.261846</c:v>
+                  <c:v>0.682598</c:v>
                 </c:pt>
                 <c:pt idx="4">
-                  <c:v>0.162771</c:v>
+                  <c:v>0.310008</c:v>
                 </c:pt>
                 <c:pt idx="5">
-                  <c:v>0.378714</c:v>
+                  <c:v>0.062377</c:v>
                 </c:pt>
                 <c:pt idx="6">
-                  <c:v>0.322882</c:v>
+                  <c:v>0.044236</c:v>
                 </c:pt>
                 <c:pt idx="7">
-                  <c:v>0.12859</c:v>
+                  <c:v>0.047969</c:v>
                 </c:pt>
                 <c:pt idx="8">
-                  <c:v>0.043606</c:v>
+                  <c:v>0.071458</c:v>
                 </c:pt>
               </c:numCache>
             </c:numRef>
@@ -1988,19 +1988,19 @@
                 <c:formatCode>General</c:formatCode>
                 <c:ptCount val="5"/>
                 <c:pt idx="0">
-                  <c:v>0.041</c:v>
+                  <c:v>0.047</c:v>
                 </c:pt>
                 <c:pt idx="1">
-                  <c:v>0.083</c:v>
+                  <c:v>0.094</c:v>
                 </c:pt>
                 <c:pt idx="2">
-                  <c:v>0.132</c:v>
+                  <c:v>0.152</c:v>
                 </c:pt>
                 <c:pt idx="3">
-                  <c:v>0.19</c:v>
+                  <c:v>0.22</c:v>
                 </c:pt>
                 <c:pt idx="4">
-                  <c:v>0.254</c:v>
+                  <c:v>0.296</c:v>
                 </c:pt>
               </c:numCache>
             </c:numRef>
@@ -2051,19 +2051,19 @@
                 <c:formatCode>General</c:formatCode>
                 <c:ptCount val="5"/>
                 <c:pt idx="0">
-                  <c:v>0.08</c:v>
+                  <c:v>0.085</c:v>
                 </c:pt>
                 <c:pt idx="1">
-                  <c:v>0.164</c:v>
+                  <c:v>0.177</c:v>
                 </c:pt>
                 <c:pt idx="2">
-                  <c:v>0.268</c:v>
+                  <c:v>0.291</c:v>
                 </c:pt>
                 <c:pt idx="3">
-                  <c:v>0.394</c:v>
+                  <c:v>0.43</c:v>
                 </c:pt>
                 <c:pt idx="4">
-                  <c:v>0.541</c:v>
+                  <c:v>0.594</c:v>
                 </c:pt>
               </c:numCache>
             </c:numRef>
@@ -2114,19 +2114,19 @@
                 <c:formatCode>General</c:formatCode>
                 <c:ptCount val="5"/>
                 <c:pt idx="0">
-                  <c:v>0.12</c:v>
+                  <c:v>0.124</c:v>
                 </c:pt>
                 <c:pt idx="1">
-                  <c:v>0.257</c:v>
+                  <c:v>0.267</c:v>
                 </c:pt>
                 <c:pt idx="2">
-                  <c:v>0.436</c:v>
+                  <c:v>0.456</c:v>
                 </c:pt>
                 <c:pt idx="3">
-                  <c:v>0.663</c:v>
+                  <c:v>0.696</c:v>
                 </c:pt>
                 <c:pt idx="4">
-                  <c:v>0.939</c:v>
+                  <c:v>0.992</c:v>
                 </c:pt>
               </c:numCache>
             </c:numRef>
@@ -5606,7 +5606,7 @@
               </a:defRPr>
             </a:pPr>
             <a:r>
-              <a:t>0.54Q</a:t>
+              <a:t>0.59Q</a:t>
             </a:r>
           </a:p>
         </p:txBody>
@@ -5711,7 +5711,7 @@
               </a:defRPr>
             </a:pPr>
             <a:r>
-              <a:t>2026-07-20</a:t>
+              <a:t>2026-07-22</a:t>
             </a:r>
           </a:p>
         </p:txBody>
@@ -6117,7 +6117,7 @@
                         </a:defRPr>
                       </a:pPr>
                       <a:r>
-                        <a:t>DeepSeek</a:t>
+                        <a:t>OpenAI</a:t>
                       </a:r>
                     </a:p>
                   </a:txBody>
@@ -6140,7 +6140,7 @@
                         </a:defRPr>
                       </a:pPr>
                       <a:r>
-                        <a:t>0.00</a:t>
+                        <a:t>0.02</a:t>
                       </a:r>
                     </a:p>
                   </a:txBody>
@@ -6163,7 +6163,7 @@
                         </a:defRPr>
                       </a:pPr>
                       <a:r>
-                        <a:t>0.7</a:t>
+                        <a:t>4.9</a:t>
                       </a:r>
                     </a:p>
                   </a:txBody>
@@ -6186,7 +6186,7 @@
                         </a:defRPr>
                       </a:pPr>
                       <a:r>
-                        <a:t>33%</a:t>
+                        <a:t>29%</a:t>
                       </a:r>
                     </a:p>
                   </a:txBody>
@@ -6209,7 +6209,7 @@
                         </a:defRPr>
                       </a:pPr>
                       <a:r>
-                        <a:t>Deployment gap</a:t>
+                        <a:t>Serving efficiency</a:t>
                       </a:r>
                     </a:p>
                   </a:txBody>
@@ -6232,7 +6232,7 @@
                         </a:defRPr>
                       </a:pPr>
                       <a:r>
-                        <a:t>site energization, rack deployment, accelerator delivery</a:t>
+                        <a:t>model routing, precision, batching, TTFT/TPOT target</a:t>
                       </a:r>
                     </a:p>
                   </a:txBody>
@@ -6257,7 +6257,7 @@
                         </a:defRPr>
                       </a:pPr>
                       <a:r>
-                        <a:t>Alibaba</a:t>
+                        <a:t>DeepSeek</a:t>
                       </a:r>
                     </a:p>
                   </a:txBody>
@@ -6280,7 +6280,7 @@
                         </a:defRPr>
                       </a:pPr>
                       <a:r>
-                        <a:t>0.02</a:t>
+                        <a:t>0.00</a:t>
                       </a:r>
                     </a:p>
                   </a:txBody>
@@ -6303,7 +6303,7 @@
                         </a:defRPr>
                       </a:pPr>
                       <a:r>
-                        <a:t>1.7</a:t>
+                        <a:t>0.7</a:t>
                       </a:r>
                     </a:p>
                   </a:txBody>
@@ -6326,7 +6326,7 @@
                         </a:defRPr>
                       </a:pPr>
                       <a:r>
-                        <a:t>20%</a:t>
+                        <a:t>33%</a:t>
                       </a:r>
                     </a:p>
                   </a:txBody>
@@ -6349,7 +6349,7 @@
                         </a:defRPr>
                       </a:pPr>
                       <a:r>
-                        <a:t>Serving efficiency</a:t>
+                        <a:t>Deployment gap</a:t>
                       </a:r>
                     </a:p>
                   </a:txBody>
@@ -6372,7 +6372,7 @@
                         </a:defRPr>
                       </a:pPr>
                       <a:r>
-                        <a:t>model routing, precision, batching, TTFT/TPOT target</a:t>
+                        <a:t>site energization, rack deployment, accelerator delivery</a:t>
                       </a:r>
                     </a:p>
                   </a:txBody>
@@ -6397,7 +6397,7 @@
                         </a:defRPr>
                       </a:pPr>
                       <a:r>
-                        <a:t>Meta</a:t>
+                        <a:t>Anthropic</a:t>
                       </a:r>
                     </a:p>
                   </a:txBody>
@@ -6420,7 +6420,7 @@
                         </a:defRPr>
                       </a:pPr>
                       <a:r>
-                        <a:t>0.05</a:t>
+                        <a:t>0.01</a:t>
                       </a:r>
                     </a:p>
                   </a:txBody>
@@ -6443,7 +6443,7 @@
                         </a:defRPr>
                       </a:pPr>
                       <a:r>
-                        <a:t>3.3</a:t>
+                        <a:t>3.0</a:t>
                       </a:r>
                     </a:p>
                   </a:txBody>
@@ -6466,7 +6466,7 @@
                         </a:defRPr>
                       </a:pPr>
                       <a:r>
-                        <a:t>17%</a:t>
+                        <a:t>21%</a:t>
                       </a:r>
                     </a:p>
                   </a:txBody>
@@ -6489,7 +6489,7 @@
                         </a:defRPr>
                       </a:pPr>
                       <a:r>
-                        <a:t>Serving efficiency</a:t>
+                        <a:t>Training allocation</a:t>
                       </a:r>
                     </a:p>
                   </a:txBody>
@@ -6512,7 +6512,7 @@
                         </a:defRPr>
                       </a:pPr>
                       <a:r>
-                        <a:t>model routing, precision, batching, TTFT/TPOT target</a:t>
+                        <a:t>training cadence, launch schedule, commercial serving ramp</a:t>
                       </a:r>
                     </a:p>
                   </a:txBody>
@@ -6537,7 +6537,7 @@
                         </a:defRPr>
                       </a:pPr>
                       <a:r>
-                        <a:t>Microsoft</a:t>
+                        <a:t>Google</a:t>
                       </a:r>
                     </a:p>
                   </a:txBody>
@@ -6560,7 +6560,7 @@
                         </a:defRPr>
                       </a:pPr>
                       <a:r>
-                        <a:t>0.10</a:t>
+                        <a:t>0.02</a:t>
                       </a:r>
                     </a:p>
                   </a:txBody>
@@ -6583,7 +6583,7 @@
                         </a:defRPr>
                       </a:pPr>
                       <a:r>
-                        <a:t>3.3</a:t>
+                        <a:t>3.7</a:t>
                       </a:r>
                     </a:p>
                   </a:txBody>
@@ -6606,7 +6606,7 @@
                         </a:defRPr>
                       </a:pPr>
                       <a:r>
-                        <a:t>31%</a:t>
+                        <a:t>15%</a:t>
                       </a:r>
                     </a:p>
                   </a:txBody>
@@ -6677,7 +6677,7 @@
                         </a:defRPr>
                       </a:pPr>
                       <a:r>
-                        <a:t>OpenAI</a:t>
+                        <a:t>Microsoft</a:t>
                       </a:r>
                     </a:p>
                   </a:txBody>
@@ -6700,7 +6700,7 @@
                         </a:defRPr>
                       </a:pPr>
                       <a:r>
-                        <a:t>0.12</a:t>
+                        <a:t>0.22</a:t>
                       </a:r>
                     </a:p>
                   </a:txBody>
@@ -6723,7 +6723,7 @@
                         </a:defRPr>
                       </a:pPr>
                       <a:r>
-                        <a:t>4.9</a:t>
+                        <a:t>3.3</a:t>
                       </a:r>
                     </a:p>
                   </a:txBody>
@@ -6746,7 +6746,7 @@
                         </a:defRPr>
                       </a:pPr>
                       <a:r>
-                        <a:t>29%</a:t>
+                        <a:t>31%</a:t>
                       </a:r>
                     </a:p>
                   </a:txBody>
@@ -6769,7 +6769,7 @@
                         </a:defRPr>
                       </a:pPr>
                       <a:r>
-                        <a:t>Scale absorption</a:t>
+                        <a:t>Training allocation</a:t>
                       </a:r>
                     </a:p>
                   </a:txBody>
@@ -6792,7 +6792,7 @@
                         </a:defRPr>
                       </a:pPr>
                       <a:r>
-                        <a:t>demand absorption and product surface expansion</a:t>
+                        <a:t>training cadence, launch schedule, commercial serving ramp</a:t>
                       </a:r>
                     </a:p>
                   </a:txBody>
@@ -6817,7 +6817,7 @@
                         </a:defRPr>
                       </a:pPr>
                       <a:r>
-                        <a:t>Anthropic</a:t>
+                        <a:t>xAI</a:t>
                       </a:r>
                     </a:p>
                   </a:txBody>
@@ -6863,7 +6863,7 @@
                         </a:defRPr>
                       </a:pPr>
                       <a:r>
-                        <a:t>3.0</a:t>
+                        <a:t>1.2</a:t>
                       </a:r>
                     </a:p>
                   </a:txBody>
@@ -6886,7 +6886,7 @@
                         </a:defRPr>
                       </a:pPr>
                       <a:r>
-                        <a:t>21%</a:t>
+                        <a:t>17%</a:t>
                       </a:r>
                     </a:p>
                   </a:txBody>
@@ -6957,7 +6957,7 @@
                         </a:defRPr>
                       </a:pPr>
                       <a:r>
-                        <a:t>xAI</a:t>
+                        <a:t>Tencent</a:t>
                       </a:r>
                     </a:p>
                   </a:txBody>
@@ -6980,7 +6980,7 @@
                         </a:defRPr>
                       </a:pPr>
                       <a:r>
-                        <a:t>0.03</a:t>
+                        <a:t>0.09</a:t>
                       </a:r>
                     </a:p>
                   </a:txBody>
@@ -7003,7 +7003,7 @@
                         </a:defRPr>
                       </a:pPr>
                       <a:r>
-                        <a:t>1.2</a:t>
+                        <a:t>1.3</a:t>
                       </a:r>
                     </a:p>
                   </a:txBody>
@@ -7026,7 +7026,7 @@
                         </a:defRPr>
                       </a:pPr>
                       <a:r>
-                        <a:t>17%</a:t>
+                        <a:t>20%</a:t>
                       </a:r>
                     </a:p>
                   </a:txBody>
@@ -7049,7 +7049,7 @@
                         </a:defRPr>
                       </a:pPr>
                       <a:r>
-                        <a:t>Training allocation</a:t>
+                        <a:t>Scale absorption</a:t>
                       </a:r>
                     </a:p>
                   </a:txBody>
@@ -7072,7 +7072,7 @@
                         </a:defRPr>
                       </a:pPr>
                       <a:r>
-                        <a:t>training cadence, launch schedule, commercial serving ramp</a:t>
+                        <a:t>demand absorption and product surface expansion</a:t>
                       </a:r>
                     </a:p>
                   </a:txBody>
@@ -7097,7 +7097,7 @@
                         </a:defRPr>
                       </a:pPr>
                       <a:r>
-                        <a:t>Tencent</a:t>
+                        <a:t>Alibaba</a:t>
                       </a:r>
                     </a:p>
                   </a:txBody>
@@ -7120,7 +7120,7 @@
                         </a:defRPr>
                       </a:pPr>
                       <a:r>
-                        <a:t>0.04</a:t>
+                        <a:t>0.05</a:t>
                       </a:r>
                     </a:p>
                   </a:txBody>
@@ -7143,7 +7143,7 @@
                         </a:defRPr>
                       </a:pPr>
                       <a:r>
-                        <a:t>1.3</a:t>
+                        <a:t>1.7</a:t>
                       </a:r>
                     </a:p>
                   </a:txBody>
@@ -7237,7 +7237,7 @@
                         </a:defRPr>
                       </a:pPr>
                       <a:r>
-                        <a:t>Google</a:t>
+                        <a:t>Meta</a:t>
                       </a:r>
                     </a:p>
                   </a:txBody>
@@ -7283,7 +7283,7 @@
                         </a:defRPr>
                       </a:pPr>
                       <a:r>
-                        <a:t>3.7</a:t>
+                        <a:t>3.3</a:t>
                       </a:r>
                     </a:p>
                   </a:txBody>
@@ -7306,7 +7306,7 @@
                         </a:defRPr>
                       </a:pPr>
                       <a:r>
-                        <a:t>15%</a:t>
+                        <a:t>17%</a:t>
                       </a:r>
                     </a:p>
                   </a:txBody>
@@ -7329,7 +7329,7 @@
                         </a:defRPr>
                       </a:pPr>
                       <a:r>
-                        <a:t>Training allocation</a:t>
+                        <a:t>Scale absorption</a:t>
                       </a:r>
                     </a:p>
                   </a:txBody>
@@ -7352,7 +7352,7 @@
                         </a:defRPr>
                       </a:pPr>
                       <a:r>
-                        <a:t>training cadence, launch schedule, commercial serving ramp</a:t>
+                        <a:t>demand absorption and product surface expansion</a:t>
                       </a:r>
                     </a:p>
                   </a:txBody>
@@ -7512,7 +7512,7 @@
               </a:defRPr>
             </a:pPr>
             <a:r>
-              <a:t>2026-07-20</a:t>
+              <a:t>2026-07-22</a:t>
             </a:r>
           </a:p>
         </p:txBody>
@@ -7946,7 +7946,7 @@
                         </a:defRPr>
                       </a:pPr>
                       <a:r>
-                        <a:t>0.25</a:t>
+                        <a:t>0.30</a:t>
                       </a:r>
                     </a:p>
                   </a:txBody>
@@ -8040,7 +8040,7 @@
                         </a:defRPr>
                       </a:pPr>
                       <a:r>
-                        <a:t>0.54</a:t>
+                        <a:t>0.59</a:t>
                       </a:r>
                     </a:p>
                   </a:txBody>
@@ -8134,7 +8134,7 @@
                         </a:defRPr>
                       </a:pPr>
                       <a:r>
-                        <a:t>0.94</a:t>
+                        <a:t>0.99</a:t>
                       </a:r>
                     </a:p>
                   </a:txBody>
@@ -8328,7 +8328,7 @@
               </a:defRPr>
             </a:pPr>
             <a:r>
-              <a:t>Base growth: 6.8x, 2026-2030</a:t>
+              <a:t>Base growth: 7.0x, 2026-2030</a:t>
             </a:r>
           </a:p>
         </p:txBody>
@@ -8478,7 +8478,7 @@
               </a:defRPr>
             </a:pPr>
             <a:r>
-              <a:t>2026-07-20</a:t>
+              <a:t>2026-07-22</a:t>
             </a:r>
           </a:p>
         </p:txBody>
@@ -9337,7 +9337,7 @@
               </a:defRPr>
             </a:pPr>
             <a:r>
-              <a:t>2026-07-20</a:t>
+              <a:t>2026-07-22</a:t>
             </a:r>
           </a:p>
         </p:txBody>
@@ -10318,7 +10318,7 @@
               </a:defRPr>
             </a:pPr>
             <a:r>
-              <a:t>2026-07-20</a:t>
+              <a:t>2026-07-22</a:t>
             </a:r>
           </a:p>
         </p:txBody>
@@ -10989,7 +10989,7 @@
               </a:defRPr>
             </a:pPr>
             <a:r>
-              <a:t>Top 3 providers account for 61% of modeled 2030 generated-token supply.</a:t>
+              <a:t>Top 3 providers account for 71% of modeled 2030 generated-token supply.</a:t>
             </a:r>
           </a:p>
         </p:txBody>
@@ -11174,7 +11174,7 @@
               </a:defRPr>
             </a:pPr>
             <a:r>
-              <a:t>2026-07-20</a:t>
+              <a:t>2026-07-22</a:t>
             </a:r>
           </a:p>
         </p:txBody>
@@ -12368,7 +12368,7 @@
               </a:defRPr>
             </a:pPr>
             <a:r>
-              <a:t>2026-07-20</a:t>
+              <a:t>2026-07-22</a:t>
             </a:r>
           </a:p>
         </p:txBody>
@@ -12779,7 +12779,7 @@
                         </a:defRPr>
                       </a:pPr>
                       <a:r>
-                        <a:t>OpenAI</a:t>
+                        <a:t>Microsoft</a:t>
                       </a:r>
                     </a:p>
                   </a:txBody>
@@ -12802,7 +12802,7 @@
                         </a:defRPr>
                       </a:pPr>
                       <a:r>
-                        <a:t>0.12</a:t>
+                        <a:t>0.22</a:t>
                       </a:r>
                     </a:p>
                   </a:txBody>
@@ -12825,7 +12825,7 @@
                         </a:defRPr>
                       </a:pPr>
                       <a:r>
-                        <a:t>4.9</a:t>
+                        <a:t>3.3</a:t>
                       </a:r>
                     </a:p>
                   </a:txBody>
@@ -12848,7 +12848,7 @@
                         </a:defRPr>
                       </a:pPr>
                       <a:r>
-                        <a:t>8.5</a:t>
+                        <a:t>6.2</a:t>
                       </a:r>
                     </a:p>
                   </a:txBody>
@@ -12873,7 +12873,7 @@
                         </a:defRPr>
                       </a:pPr>
                       <a:r>
-                        <a:t>Google</a:t>
+                        <a:t>Meta</a:t>
                       </a:r>
                     </a:p>
                   </a:txBody>
@@ -12919,7 +12919,7 @@
                         </a:defRPr>
                       </a:pPr>
                       <a:r>
-                        <a:t>3.7</a:t>
+                        <a:t>3.3</a:t>
                       </a:r>
                     </a:p>
                   </a:txBody>
@@ -12942,7 +12942,7 @@
                         </a:defRPr>
                       </a:pPr>
                       <a:r>
-                        <a:t>6.8</a:t>
+                        <a:t>5.8</a:t>
                       </a:r>
                     </a:p>
                   </a:txBody>
@@ -12967,7 +12967,7 @@
                         </a:defRPr>
                       </a:pPr>
                       <a:r>
-                        <a:t>Microsoft</a:t>
+                        <a:t>Tencent</a:t>
                       </a:r>
                     </a:p>
                   </a:txBody>
@@ -12990,7 +12990,7 @@
                         </a:defRPr>
                       </a:pPr>
                       <a:r>
-                        <a:t>0.10</a:t>
+                        <a:t>0.09</a:t>
                       </a:r>
                     </a:p>
                   </a:txBody>
@@ -13013,7 +13013,7 @@
                         </a:defRPr>
                       </a:pPr>
                       <a:r>
-                        <a:t>3.3</a:t>
+                        <a:t>1.3</a:t>
                       </a:r>
                     </a:p>
                   </a:txBody>
@@ -13036,7 +13036,7 @@
                         </a:defRPr>
                       </a:pPr>
                       <a:r>
-                        <a:t>6.2</a:t>
+                        <a:t>2.4</a:t>
                       </a:r>
                     </a:p>
                   </a:txBody>
@@ -13061,7 +13061,7 @@
                         </a:defRPr>
                       </a:pPr>
                       <a:r>
-                        <a:t>Anthropic</a:t>
+                        <a:t>xAI</a:t>
                       </a:r>
                     </a:p>
                   </a:txBody>
@@ -13107,7 +13107,7 @@
                         </a:defRPr>
                       </a:pPr>
                       <a:r>
-                        <a:t>3.0</a:t>
+                        <a:t>1.2</a:t>
                       </a:r>
                     </a:p>
                   </a:txBody>
@@ -13130,7 +13130,7 @@
                         </a:defRPr>
                       </a:pPr>
                       <a:r>
-                        <a:t>5.5</a:t>
+                        <a:t>2.5</a:t>
                       </a:r>
                     </a:p>
                   </a:txBody>
@@ -13155,7 +13155,7 @@
                         </a:defRPr>
                       </a:pPr>
                       <a:r>
-                        <a:t>Meta</a:t>
+                        <a:t>Alibaba</a:t>
                       </a:r>
                     </a:p>
                   </a:txBody>
@@ -13201,7 +13201,7 @@
                         </a:defRPr>
                       </a:pPr>
                       <a:r>
-                        <a:t>3.3</a:t>
+                        <a:t>1.7</a:t>
                       </a:r>
                     </a:p>
                   </a:txBody>
@@ -13224,7 +13224,7 @@
                         </a:defRPr>
                       </a:pPr>
                       <a:r>
-                        <a:t>5.8</a:t>
+                        <a:t>3.2</a:t>
                       </a:r>
                     </a:p>
                   </a:txBody>
@@ -13304,7 +13304,7 @@
               </a:defRPr>
             </a:pPr>
             <a:r>
-              <a:t>61%</a:t>
+              <a:t>71%</a:t>
             </a:r>
           </a:p>
         </p:txBody>
@@ -13489,7 +13489,7 @@
               </a:defRPr>
             </a:pPr>
             <a:r>
-              <a:t>2026-07-20</a:t>
+              <a:t>2026-07-22</a:t>
             </a:r>
           </a:p>
         </p:txBody>
@@ -13924,7 +13924,7 @@
                         </a:defRPr>
                       </a:pPr>
                       <a:r>
-                        <a:t>OpenAI</a:t>
+                        <a:t>Microsoft</a:t>
                       </a:r>
                     </a:p>
                   </a:txBody>
@@ -13947,7 +13947,7 @@
                         </a:defRPr>
                       </a:pPr>
                       <a:r>
-                        <a:t>0.01</a:t>
+                        <a:t>0.03</a:t>
                       </a:r>
                     </a:p>
                   </a:txBody>
@@ -13970,7 +13970,7 @@
                         </a:defRPr>
                       </a:pPr>
                       <a:r>
-                        <a:t>0.05</a:t>
+                        <a:t>0.11</a:t>
                       </a:r>
                     </a:p>
                   </a:txBody>
@@ -13993,7 +13993,7 @@
                         </a:defRPr>
                       </a:pPr>
                       <a:r>
-                        <a:t>0.12</a:t>
+                        <a:t>0.22</a:t>
                       </a:r>
                     </a:p>
                   </a:txBody>
@@ -14016,7 +14016,7 @@
                         </a:defRPr>
                       </a:pPr>
                       <a:r>
-                        <a:t>10.9x</a:t>
+                        <a:t>6.2x</a:t>
                       </a:r>
                     </a:p>
                   </a:txBody>
@@ -14041,7 +14041,7 @@
                         </a:defRPr>
                       </a:pPr>
                       <a:r>
-                        <a:t>Google</a:t>
+                        <a:t>Meta</a:t>
                       </a:r>
                     </a:p>
                   </a:txBody>
@@ -14064,7 +14064,7 @@
                         </a:defRPr>
                       </a:pPr>
                       <a:r>
-                        <a:t>0.03</a:t>
+                        <a:t>0.02</a:t>
                       </a:r>
                     </a:p>
                   </a:txBody>
@@ -14133,7 +14133,7 @@
                         </a:defRPr>
                       </a:pPr>
                       <a:r>
-                        <a:t>4.3x</a:t>
+                        <a:t>5.1x</a:t>
                       </a:r>
                     </a:p>
                   </a:txBody>
@@ -14158,7 +14158,7 @@
                         </a:defRPr>
                       </a:pPr>
                       <a:r>
-                        <a:t>Microsoft</a:t>
+                        <a:t>Tencent</a:t>
                       </a:r>
                     </a:p>
                   </a:txBody>
@@ -14181,7 +14181,7 @@
                         </a:defRPr>
                       </a:pPr>
                       <a:r>
-                        <a:t>0.02</a:t>
+                        <a:t>0.01</a:t>
                       </a:r>
                     </a:p>
                   </a:txBody>
@@ -14204,7 +14204,7 @@
                         </a:defRPr>
                       </a:pPr>
                       <a:r>
-                        <a:t>0.05</a:t>
+                        <a:t>0.04</a:t>
                       </a:r>
                     </a:p>
                   </a:txBody>
@@ -14227,7 +14227,7 @@
                         </a:defRPr>
                       </a:pPr>
                       <a:r>
-                        <a:t>0.10</a:t>
+                        <a:t>0.09</a:t>
                       </a:r>
                     </a:p>
                   </a:txBody>
@@ -14250,7 +14250,7 @@
                         </a:defRPr>
                       </a:pPr>
                       <a:r>
-                        <a:t>6.1x</a:t>
+                        <a:t>9.6x</a:t>
                       </a:r>
                     </a:p>
                   </a:txBody>
@@ -14275,7 +14275,7 @@
                         </a:defRPr>
                       </a:pPr>
                       <a:r>
-                        <a:t>Anthropic</a:t>
+                        <a:t>xAI</a:t>
                       </a:r>
                     </a:p>
                   </a:txBody>
@@ -14298,7 +14298,7 @@
                         </a:defRPr>
                       </a:pPr>
                       <a:r>
-                        <a:t>0.01</a:t>
+                        <a:t>0.00</a:t>
                       </a:r>
                     </a:p>
                   </a:txBody>
@@ -14367,7 +14367,7 @@
                         </a:defRPr>
                       </a:pPr>
                       <a:r>
-                        <a:t>8.6x</a:t>
+                        <a:t>14.9x</a:t>
                       </a:r>
                     </a:p>
                   </a:txBody>
@@ -14392,7 +14392,7 @@
                         </a:defRPr>
                       </a:pPr>
                       <a:r>
-                        <a:t>Meta</a:t>
+                        <a:t>Alibaba</a:t>
                       </a:r>
                     </a:p>
                   </a:txBody>
@@ -14415,7 +14415,7 @@
                         </a:defRPr>
                       </a:pPr>
                       <a:r>
-                        <a:t>0.01</a:t>
+                        <a:t>0.00</a:t>
                       </a:r>
                     </a:p>
                   </a:txBody>
@@ -14438,7 +14438,7 @@
                         </a:defRPr>
                       </a:pPr>
                       <a:r>
-                        <a:t>0.03</a:t>
+                        <a:t>0.02</a:t>
                       </a:r>
                     </a:p>
                   </a:txBody>
@@ -14484,7 +14484,7 @@
                         </a:defRPr>
                       </a:pPr>
                       <a:r>
-                        <a:t>5.0x</a:t>
+                        <a:t>9.6x</a:t>
                       </a:r>
                     </a:p>
                   </a:txBody>
@@ -14509,7 +14509,7 @@
                         </a:defRPr>
                       </a:pPr>
                       <a:r>
-                        <a:t>Tencent</a:t>
+                        <a:t>Google</a:t>
                       </a:r>
                     </a:p>
                   </a:txBody>
@@ -14555,6 +14555,29 @@
                         </a:defRPr>
                       </a:pPr>
                       <a:r>
+                        <a:t>0.01</a:t>
+                      </a:r>
+                    </a:p>
+                  </a:txBody>
+                  <a:tcPr marL="50292" marR="50292" marT="32004" marB="32004">
+                    <a:solidFill>
+                      <a:srgbClr val="F7F9FC"/>
+                    </a:solidFill>
+                  </a:tcPr>
+                </a:tc>
+                <a:tc>
+                  <a:txBody>
+                    <a:bodyPr/>
+                    <a:lstStyle/>
+                    <a:p>
+                      <a:pPr>
+                        <a:defRPr sz="650" b="0">
+                          <a:solidFill>
+                            <a:srgbClr val="3A4252"/>
+                          </a:solidFill>
+                        </a:defRPr>
+                      </a:pPr>
+                      <a:r>
                         <a:t>0.02</a:t>
                       </a:r>
                     </a:p>
@@ -14578,30 +14601,7 @@
                         </a:defRPr>
                       </a:pPr>
                       <a:r>
-                        <a:t>0.04</a:t>
-                      </a:r>
-                    </a:p>
-                  </a:txBody>
-                  <a:tcPr marL="50292" marR="50292" marT="32004" marB="32004">
-                    <a:solidFill>
-                      <a:srgbClr val="F7F9FC"/>
-                    </a:solidFill>
-                  </a:tcPr>
-                </a:tc>
-                <a:tc>
-                  <a:txBody>
-                    <a:bodyPr/>
-                    <a:lstStyle/>
-                    <a:p>
-                      <a:pPr>
-                        <a:defRPr sz="650" b="0">
-                          <a:solidFill>
-                            <a:srgbClr val="3A4252"/>
-                          </a:solidFill>
-                        </a:defRPr>
-                      </a:pPr>
-                      <a:r>
-                        <a:t>9.4x</a:t>
+                        <a:t>4.0x</a:t>
                       </a:r>
                     </a:p>
                   </a:txBody>
@@ -14626,7 +14626,7 @@
                         </a:defRPr>
                       </a:pPr>
                       <a:r>
-                        <a:t>xAI</a:t>
+                        <a:t>OpenAI</a:t>
                       </a:r>
                     </a:p>
                   </a:txBody>
@@ -14695,7 +14695,7 @@
                         </a:defRPr>
                       </a:pPr>
                       <a:r>
-                        <a:t>0.03</a:t>
+                        <a:t>0.02</a:t>
                       </a:r>
                     </a:p>
                   </a:txBody>
@@ -14718,7 +14718,7 @@
                         </a:defRPr>
                       </a:pPr>
                       <a:r>
-                        <a:t>14.8x</a:t>
+                        <a:t>7.6x</a:t>
                       </a:r>
                     </a:p>
                   </a:txBody>
@@ -14743,7 +14743,7 @@
                         </a:defRPr>
                       </a:pPr>
                       <a:r>
-                        <a:t>Alibaba</a:t>
+                        <a:t>Anthropic</a:t>
                       </a:r>
                     </a:p>
                   </a:txBody>
@@ -14812,7 +14812,7 @@
                         </a:defRPr>
                       </a:pPr>
                       <a:r>
-                        <a:t>0.02</a:t>
+                        <a:t>0.01</a:t>
                       </a:r>
                     </a:p>
                   </a:txBody>
@@ -14835,7 +14835,7 @@
                         </a:defRPr>
                       </a:pPr>
                       <a:r>
-                        <a:t>8.8x</a:t>
+                        <a:t>7.7x</a:t>
                       </a:r>
                     </a:p>
                   </a:txBody>
@@ -14952,7 +14952,7 @@
                         </a:defRPr>
                       </a:pPr>
                       <a:r>
-                        <a:t>11.4x</a:t>
+                        <a:t>11.2x</a:t>
                       </a:r>
                     </a:p>
                   </a:txBody>
@@ -15112,7 +15112,7 @@
               </a:defRPr>
             </a:pPr>
             <a:r>
-              <a:t>2026-07-20</a:t>
+              <a:t>2026-07-22</a:t>
             </a:r>
           </a:p>
         </p:txBody>
@@ -15547,7 +15547,7 @@
                         </a:defRPr>
                       </a:pPr>
                       <a:r>
-                        <a:t>OpenAI</a:t>
+                        <a:t>Microsoft</a:t>
                       </a:r>
                     </a:p>
                   </a:txBody>
@@ -15570,7 +15570,7 @@
                         </a:defRPr>
                       </a:pPr>
                       <a:r>
-                        <a:t>0.6</a:t>
+                        <a:t>0.7</a:t>
                       </a:r>
                     </a:p>
                   </a:txBody>
@@ -15593,7 +15593,7 @@
                         </a:defRPr>
                       </a:pPr>
                       <a:r>
-                        <a:t>2.5</a:t>
+                        <a:t>1.9</a:t>
                       </a:r>
                     </a:p>
                   </a:txBody>
@@ -15616,7 +15616,7 @@
                         </a:defRPr>
                       </a:pPr>
                       <a:r>
-                        <a:t>4.9</a:t>
+                        <a:t>3.3</a:t>
                       </a:r>
                     </a:p>
                   </a:txBody>
@@ -15639,7 +15639,7 @@
                         </a:defRPr>
                       </a:pPr>
                       <a:r>
-                        <a:t>78%</a:t>
+                        <a:t>75%</a:t>
                       </a:r>
                     </a:p>
                   </a:txBody>
@@ -15664,7 +15664,7 @@
                         </a:defRPr>
                       </a:pPr>
                       <a:r>
-                        <a:t>Google</a:t>
+                        <a:t>Meta</a:t>
                       </a:r>
                     </a:p>
                   </a:txBody>
@@ -15687,7 +15687,7 @@
                         </a:defRPr>
                       </a:pPr>
                       <a:r>
-                        <a:t>0.9</a:t>
+                        <a:t>0.7</a:t>
                       </a:r>
                     </a:p>
                   </a:txBody>
@@ -15710,7 +15710,7 @@
                         </a:defRPr>
                       </a:pPr>
                       <a:r>
-                        <a:t>2.1</a:t>
+                        <a:t>1.8</a:t>
                       </a:r>
                     </a:p>
                   </a:txBody>
@@ -15733,7 +15733,7 @@
                         </a:defRPr>
                       </a:pPr>
                       <a:r>
-                        <a:t>3.7</a:t>
+                        <a:t>3.3</a:t>
                       </a:r>
                     </a:p>
                   </a:txBody>
@@ -15756,7 +15756,7 @@
                         </a:defRPr>
                       </a:pPr>
                       <a:r>
-                        <a:t>72%</a:t>
+                        <a:t>78%</a:t>
                       </a:r>
                     </a:p>
                   </a:txBody>
@@ -15781,7 +15781,7 @@
                         </a:defRPr>
                       </a:pPr>
                       <a:r>
-                        <a:t>Microsoft</a:t>
+                        <a:t>Tencent</a:t>
                       </a:r>
                     </a:p>
                   </a:txBody>
@@ -15804,6 +15804,29 @@
                         </a:defRPr>
                       </a:pPr>
                       <a:r>
+                        <a:t>0.2</a:t>
+                      </a:r>
+                    </a:p>
+                  </a:txBody>
+                  <a:tcPr marL="50292" marR="50292" marT="32004" marB="32004">
+                    <a:solidFill>
+                      <a:srgbClr val="FFFFFF"/>
+                    </a:solidFill>
+                  </a:tcPr>
+                </a:tc>
+                <a:tc>
+                  <a:txBody>
+                    <a:bodyPr/>
+                    <a:lstStyle/>
+                    <a:p>
+                      <a:pPr>
+                        <a:defRPr sz="650" b="0">
+                          <a:solidFill>
+                            <a:srgbClr val="3A4252"/>
+                          </a:solidFill>
+                        </a:defRPr>
+                      </a:pPr>
+                      <a:r>
                         <a:t>0.7</a:t>
                       </a:r>
                     </a:p>
@@ -15827,7 +15850,7 @@
                         </a:defRPr>
                       </a:pPr>
                       <a:r>
-                        <a:t>1.9</a:t>
+                        <a:t>1.3</a:t>
                       </a:r>
                     </a:p>
                   </a:txBody>
@@ -15850,30 +15873,7 @@
                         </a:defRPr>
                       </a:pPr>
                       <a:r>
-                        <a:t>3.3</a:t>
-                      </a:r>
-                    </a:p>
-                  </a:txBody>
-                  <a:tcPr marL="50292" marR="50292" marT="32004" marB="32004">
-                    <a:solidFill>
-                      <a:srgbClr val="FFFFFF"/>
-                    </a:solidFill>
-                  </a:tcPr>
-                </a:tc>
-                <a:tc>
-                  <a:txBody>
-                    <a:bodyPr/>
-                    <a:lstStyle/>
-                    <a:p>
-                      <a:pPr>
-                        <a:defRPr sz="650" b="0">
-                          <a:solidFill>
-                            <a:srgbClr val="3A4252"/>
-                          </a:solidFill>
-                        </a:defRPr>
-                      </a:pPr>
-                      <a:r>
-                        <a:t>75%</a:t>
+                        <a:t>80%</a:t>
                       </a:r>
                     </a:p>
                   </a:txBody>
@@ -15898,7 +15898,7 @@
                         </a:defRPr>
                       </a:pPr>
                       <a:r>
-                        <a:t>Anthropic</a:t>
+                        <a:t>xAI</a:t>
                       </a:r>
                     </a:p>
                   </a:txBody>
@@ -15921,7 +15921,7 @@
                         </a:defRPr>
                       </a:pPr>
                       <a:r>
-                        <a:t>0.4</a:t>
+                        <a:t>0.1</a:t>
                       </a:r>
                     </a:p>
                   </a:txBody>
@@ -15944,7 +15944,7 @@
                         </a:defRPr>
                       </a:pPr>
                       <a:r>
-                        <a:t>1.5</a:t>
+                        <a:t>0.6</a:t>
                       </a:r>
                     </a:p>
                   </a:txBody>
@@ -15967,7 +15967,7 @@
                         </a:defRPr>
                       </a:pPr>
                       <a:r>
-                        <a:t>3.0</a:t>
+                        <a:t>1.2</a:t>
                       </a:r>
                     </a:p>
                   </a:txBody>
@@ -15990,7 +15990,7 @@
                         </a:defRPr>
                       </a:pPr>
                       <a:r>
-                        <a:t>74%</a:t>
+                        <a:t>70%</a:t>
                       </a:r>
                     </a:p>
                   </a:txBody>
@@ -16015,7 +16015,7 @@
                         </a:defRPr>
                       </a:pPr>
                       <a:r>
-                        <a:t>Meta</a:t>
+                        <a:t>Alibaba</a:t>
                       </a:r>
                     </a:p>
                   </a:txBody>
@@ -16038,7 +16038,7 @@
                         </a:defRPr>
                       </a:pPr>
                       <a:r>
-                        <a:t>0.7</a:t>
+                        <a:t>0.3</a:t>
                       </a:r>
                     </a:p>
                   </a:txBody>
@@ -16061,7 +16061,7 @@
                         </a:defRPr>
                       </a:pPr>
                       <a:r>
-                        <a:t>1.8</a:t>
+                        <a:t>0.9</a:t>
                       </a:r>
                     </a:p>
                   </a:txBody>
@@ -16084,7 +16084,7 @@
                         </a:defRPr>
                       </a:pPr>
                       <a:r>
-                        <a:t>3.3</a:t>
+                        <a:t>1.7</a:t>
                       </a:r>
                     </a:p>
                   </a:txBody>
@@ -16107,7 +16107,7 @@
                         </a:defRPr>
                       </a:pPr>
                       <a:r>
-                        <a:t>78%</a:t>
+                        <a:t>80%</a:t>
                       </a:r>
                     </a:p>
                   </a:txBody>
@@ -16132,7 +16132,7 @@
                         </a:defRPr>
                       </a:pPr>
                       <a:r>
-                        <a:t>Tencent</a:t>
+                        <a:t>Google</a:t>
                       </a:r>
                     </a:p>
                   </a:txBody>
@@ -16155,7 +16155,7 @@
                         </a:defRPr>
                       </a:pPr>
                       <a:r>
-                        <a:t>0.2</a:t>
+                        <a:t>0.9</a:t>
                       </a:r>
                     </a:p>
                   </a:txBody>
@@ -16178,7 +16178,7 @@
                         </a:defRPr>
                       </a:pPr>
                       <a:r>
-                        <a:t>0.7</a:t>
+                        <a:t>2.1</a:t>
                       </a:r>
                     </a:p>
                   </a:txBody>
@@ -16201,7 +16201,7 @@
                         </a:defRPr>
                       </a:pPr>
                       <a:r>
-                        <a:t>1.3</a:t>
+                        <a:t>3.7</a:t>
                       </a:r>
                     </a:p>
                   </a:txBody>
@@ -16224,7 +16224,7 @@
                         </a:defRPr>
                       </a:pPr>
                       <a:r>
-                        <a:t>80%</a:t>
+                        <a:t>72%</a:t>
                       </a:r>
                     </a:p>
                   </a:txBody>
@@ -16249,7 +16249,7 @@
                         </a:defRPr>
                       </a:pPr>
                       <a:r>
-                        <a:t>xAI</a:t>
+                        <a:t>OpenAI</a:t>
                       </a:r>
                     </a:p>
                   </a:txBody>
@@ -16272,7 +16272,7 @@
                         </a:defRPr>
                       </a:pPr>
                       <a:r>
-                        <a:t>0.1</a:t>
+                        <a:t>0.6</a:t>
                       </a:r>
                     </a:p>
                   </a:txBody>
@@ -16295,7 +16295,7 @@
                         </a:defRPr>
                       </a:pPr>
                       <a:r>
-                        <a:t>0.6</a:t>
+                        <a:t>2.5</a:t>
                       </a:r>
                     </a:p>
                   </a:txBody>
@@ -16318,7 +16318,7 @@
                         </a:defRPr>
                       </a:pPr>
                       <a:r>
-                        <a:t>1.2</a:t>
+                        <a:t>4.9</a:t>
                       </a:r>
                     </a:p>
                   </a:txBody>
@@ -16341,7 +16341,7 @@
                         </a:defRPr>
                       </a:pPr>
                       <a:r>
-                        <a:t>70%</a:t>
+                        <a:t>78%</a:t>
                       </a:r>
                     </a:p>
                   </a:txBody>
@@ -16366,7 +16366,7 @@
                         </a:defRPr>
                       </a:pPr>
                       <a:r>
-                        <a:t>Alibaba</a:t>
+                        <a:t>Anthropic</a:t>
                       </a:r>
                     </a:p>
                   </a:txBody>
@@ -16389,7 +16389,7 @@
                         </a:defRPr>
                       </a:pPr>
                       <a:r>
-                        <a:t>0.3</a:t>
+                        <a:t>0.4</a:t>
                       </a:r>
                     </a:p>
                   </a:txBody>
@@ -16412,7 +16412,7 @@
                         </a:defRPr>
                       </a:pPr>
                       <a:r>
-                        <a:t>0.9</a:t>
+                        <a:t>1.5</a:t>
                       </a:r>
                     </a:p>
                   </a:txBody>
@@ -16435,7 +16435,7 @@
                         </a:defRPr>
                       </a:pPr>
                       <a:r>
-                        <a:t>1.7</a:t>
+                        <a:t>3.0</a:t>
                       </a:r>
                     </a:p>
                   </a:txBody>
@@ -16458,7 +16458,7 @@
                         </a:defRPr>
                       </a:pPr>
                       <a:r>
-                        <a:t>80%</a:t>
+                        <a:t>74%</a:t>
                       </a:r>
                     </a:p>
                   </a:txBody>
@@ -16735,7 +16735,7 @@
               </a:defRPr>
             </a:pPr>
             <a:r>
-              <a:t>2026-07-20</a:t>
+              <a:t>2026-07-22</a:t>
             </a:r>
           </a:p>
         </p:txBody>
@@ -17598,7 +17598,7 @@
               </a:defRPr>
             </a:pPr>
             <a:r>
-              <a:t>2026-07-20</a:t>
+              <a:t>2026-07-22</a:t>
             </a:r>
           </a:p>
         </p:txBody>
@@ -18009,7 +18009,7 @@
                         </a:defRPr>
                       </a:pPr>
                       <a:r>
-                        <a:t>OpenAI</a:t>
+                        <a:t>Microsoft</a:t>
                       </a:r>
                     </a:p>
                   </a:txBody>
@@ -18032,7 +18032,7 @@
                         </a:defRPr>
                       </a:pPr>
                       <a:r>
-                        <a:t>4.9</a:t>
+                        <a:t>3.3</a:t>
                       </a:r>
                     </a:p>
                   </a:txBody>
@@ -18055,7 +18055,7 @@
                         </a:defRPr>
                       </a:pPr>
                       <a:r>
-                        <a:t>1.4</a:t>
+                        <a:t>1.1</a:t>
                       </a:r>
                     </a:p>
                   </a:txBody>
@@ -18078,7 +18078,7 @@
                         </a:defRPr>
                       </a:pPr>
                       <a:r>
-                        <a:t>78%</a:t>
+                        <a:t>75%</a:t>
                       </a:r>
                     </a:p>
                   </a:txBody>
@@ -18103,7 +18103,7 @@
                         </a:defRPr>
                       </a:pPr>
                       <a:r>
-                        <a:t>Google</a:t>
+                        <a:t>Meta</a:t>
                       </a:r>
                     </a:p>
                   </a:txBody>
@@ -18126,7 +18126,7 @@
                         </a:defRPr>
                       </a:pPr>
                       <a:r>
-                        <a:t>3.7</a:t>
+                        <a:t>3.3</a:t>
                       </a:r>
                     </a:p>
                   </a:txBody>
@@ -18149,7 +18149,7 @@
                         </a:defRPr>
                       </a:pPr>
                       <a:r>
-                        <a:t>1.4</a:t>
+                        <a:t>0.9</a:t>
                       </a:r>
                     </a:p>
                   </a:txBody>
@@ -18172,7 +18172,7 @@
                         </a:defRPr>
                       </a:pPr>
                       <a:r>
-                        <a:t>72%</a:t>
+                        <a:t>78%</a:t>
                       </a:r>
                     </a:p>
                   </a:txBody>
@@ -18197,7 +18197,7 @@
                         </a:defRPr>
                       </a:pPr>
                       <a:r>
-                        <a:t>Microsoft</a:t>
+                        <a:t>Tencent</a:t>
                       </a:r>
                     </a:p>
                   </a:txBody>
@@ -18220,7 +18220,7 @@
                         </a:defRPr>
                       </a:pPr>
                       <a:r>
-                        <a:t>3.3</a:t>
+                        <a:t>1.3</a:t>
                       </a:r>
                     </a:p>
                   </a:txBody>
@@ -18243,7 +18243,7 @@
                         </a:defRPr>
                       </a:pPr>
                       <a:r>
-                        <a:t>1.1</a:t>
+                        <a:t>0.3</a:t>
                       </a:r>
                     </a:p>
                   </a:txBody>
@@ -18266,7 +18266,7 @@
                         </a:defRPr>
                       </a:pPr>
                       <a:r>
-                        <a:t>75%</a:t>
+                        <a:t>80%</a:t>
                       </a:r>
                     </a:p>
                   </a:txBody>
@@ -18291,7 +18291,7 @@
                         </a:defRPr>
                       </a:pPr>
                       <a:r>
-                        <a:t>Anthropic</a:t>
+                        <a:t>xAI</a:t>
                       </a:r>
                     </a:p>
                   </a:txBody>
@@ -18314,7 +18314,7 @@
                         </a:defRPr>
                       </a:pPr>
                       <a:r>
-                        <a:t>3.0</a:t>
+                        <a:t>1.2</a:t>
                       </a:r>
                     </a:p>
                   </a:txBody>
@@ -18337,7 +18337,7 @@
                         </a:defRPr>
                       </a:pPr>
                       <a:r>
-                        <a:t>1.0</a:t>
+                        <a:t>0.5</a:t>
                       </a:r>
                     </a:p>
                   </a:txBody>
@@ -18360,7 +18360,7 @@
                         </a:defRPr>
                       </a:pPr>
                       <a:r>
-                        <a:t>74%</a:t>
+                        <a:t>70%</a:t>
                       </a:r>
                     </a:p>
                   </a:txBody>
@@ -18385,7 +18385,7 @@
                         </a:defRPr>
                       </a:pPr>
                       <a:r>
-                        <a:t>Meta</a:t>
+                        <a:t>Alibaba</a:t>
                       </a:r>
                     </a:p>
                   </a:txBody>
@@ -18408,7 +18408,7 @@
                         </a:defRPr>
                       </a:pPr>
                       <a:r>
-                        <a:t>3.3</a:t>
+                        <a:t>1.7</a:t>
                       </a:r>
                     </a:p>
                   </a:txBody>
@@ -18431,7 +18431,7 @@
                         </a:defRPr>
                       </a:pPr>
                       <a:r>
-                        <a:t>0.9</a:t>
+                        <a:t>0.4</a:t>
                       </a:r>
                     </a:p>
                   </a:txBody>
@@ -18454,7 +18454,7 @@
                         </a:defRPr>
                       </a:pPr>
                       <a:r>
-                        <a:t>78%</a:t>
+                        <a:t>80%</a:t>
                       </a:r>
                     </a:p>
                   </a:txBody>
@@ -18649,7 +18649,7 @@
               </a:defRPr>
             </a:pPr>
             <a:r>
-              <a:t>2026-07-20</a:t>
+              <a:t>2026-07-22</a:t>
             </a:r>
           </a:p>
         </p:txBody>
@@ -19060,7 +19060,7 @@
                         </a:defRPr>
                       </a:pPr>
                       <a:r>
-                        <a:t>DeepSeek</a:t>
+                        <a:t>OpenAI</a:t>
                       </a:r>
                     </a:p>
                   </a:txBody>
@@ -19083,7 +19083,7 @@
                         </a:defRPr>
                       </a:pPr>
                       <a:r>
-                        <a:t>35%/40%/25%</a:t>
+                        <a:t>45%/25%/30%</a:t>
                       </a:r>
                     </a:p>
                   </a:txBody>
@@ -19106,7 +19106,7 @@
                         </a:defRPr>
                       </a:pPr>
                       <a:r>
-                        <a:t>85%</a:t>
+                        <a:t>50%</a:t>
                       </a:r>
                     </a:p>
                   </a:txBody>
@@ -19154,7 +19154,7 @@
                         </a:defRPr>
                       </a:pPr>
                       <a:r>
-                        <a:t>Alibaba</a:t>
+                        <a:t>Anthropic</a:t>
                       </a:r>
                     </a:p>
                   </a:txBody>
@@ -19177,7 +19177,7 @@
                         </a:defRPr>
                       </a:pPr>
                       <a:r>
-                        <a:t>45%/35%/20%</a:t>
+                        <a:t>30%/30%/40%</a:t>
                       </a:r>
                     </a:p>
                   </a:txBody>
@@ -19200,7 +19200,7 @@
                         </a:defRPr>
                       </a:pPr>
                       <a:r>
-                        <a:t>90%</a:t>
+                        <a:t>50%</a:t>
                       </a:r>
                     </a:p>
                   </a:txBody>
@@ -19223,7 +19223,7 @@
                         </a:defRPr>
                       </a:pPr>
                       <a:r>
-                        <a:t>0.13</a:t>
+                        <a:t>0.05</a:t>
                       </a:r>
                     </a:p>
                   </a:txBody>
@@ -19248,7 +19248,7 @@
                         </a:defRPr>
                       </a:pPr>
                       <a:r>
-                        <a:t>Meta</a:t>
+                        <a:t>Google</a:t>
                       </a:r>
                     </a:p>
                   </a:txBody>
@@ -19271,7 +19271,7 @@
                         </a:defRPr>
                       </a:pPr>
                       <a:r>
-                        <a:t>70%/20%/10%</a:t>
+                        <a:t>40%/40%/20%</a:t>
                       </a:r>
                     </a:p>
                   </a:txBody>
@@ -19294,7 +19294,7 @@
                         </a:defRPr>
                       </a:pPr>
                       <a:r>
-                        <a:t>90%</a:t>
+                        <a:t>60%</a:t>
                       </a:r>
                     </a:p>
                   </a:txBody>
@@ -19317,7 +19317,7 @@
                         </a:defRPr>
                       </a:pPr>
                       <a:r>
-                        <a:t>0.16</a:t>
+                        <a:t>0.06</a:t>
                       </a:r>
                     </a:p>
                   </a:txBody>
@@ -19342,7 +19342,7 @@
                         </a:defRPr>
                       </a:pPr>
                       <a:r>
-                        <a:t>Anthropic</a:t>
+                        <a:t>DeepSeek</a:t>
                       </a:r>
                     </a:p>
                   </a:txBody>
@@ -19365,7 +19365,7 @@
                         </a:defRPr>
                       </a:pPr>
                       <a:r>
-                        <a:t>30%/30%/40%</a:t>
+                        <a:t>35%/40%/25%</a:t>
                       </a:r>
                     </a:p>
                   </a:txBody>
@@ -19388,7 +19388,7 @@
                         </a:defRPr>
                       </a:pPr>
                       <a:r>
-                        <a:t>50%</a:t>
+                        <a:t>85%</a:t>
                       </a:r>
                     </a:p>
                   </a:txBody>
@@ -19411,7 +19411,7 @@
                         </a:defRPr>
                       </a:pPr>
                       <a:r>
-                        <a:t>0.26</a:t>
+                        <a:t>0.07</a:t>
                       </a:r>
                     </a:p>
                   </a:txBody>
@@ -19436,7 +19436,7 @@
                         </a:defRPr>
                       </a:pPr>
                       <a:r>
-                        <a:t>OpenAI</a:t>
+                        <a:t>Alibaba</a:t>
                       </a:r>
                     </a:p>
                   </a:txBody>
@@ -19459,7 +19459,7 @@
                         </a:defRPr>
                       </a:pPr>
                       <a:r>
-                        <a:t>45%/25%/30%</a:t>
+                        <a:t>45%/35%/20%</a:t>
                       </a:r>
                     </a:p>
                   </a:txBody>
@@ -19482,7 +19482,7 @@
                         </a:defRPr>
                       </a:pPr>
                       <a:r>
-                        <a:t>50%</a:t>
+                        <a:t>90%</a:t>
                       </a:r>
                     </a:p>
                   </a:txBody>
@@ -19505,7 +19505,7 @@
                         </a:defRPr>
                       </a:pPr>
                       <a:r>
-                        <a:t>0.28</a:t>
+                        <a:t>0.31</a:t>
                       </a:r>
                     </a:p>
                   </a:txBody>
@@ -19700,7 +19700,7 @@
               </a:defRPr>
             </a:pPr>
             <a:r>
-              <a:t>2026-07-20</a:t>
+              <a:t>2026-07-22</a:t>
             </a:r>
           </a:p>
         </p:txBody>

</xml_diff>

<commit_message>
Add long-context guardrail for DeepSeek V4 proxy
</commit_message>
<xml_diff>
--- a/llm_token_capacity_project/outputs/reports/llm_token_capacity_2026_2030.pptx
+++ b/llm_token_capacity_project/outputs/reports/llm_token_capacity_2026_2030.pptx
@@ -163,10 +163,10 @@
                   <c:v>Alibaba</c:v>
                 </c:pt>
                 <c:pt idx="5">
+                  <c:v>OpenAI</c:v>
+                </c:pt>
+                <c:pt idx="6">
                   <c:v>Google</c:v>
-                </c:pt>
-                <c:pt idx="6">
-                  <c:v>OpenAI</c:v>
                 </c:pt>
                 <c:pt idx="7">
                   <c:v>Anthropic</c:v>
@@ -199,13 +199,13 @@
                   <c:v>0.0468196402176</c:v>
                 </c:pt>
                 <c:pt idx="5">
-                  <c:v>0.0196766000928</c:v>
+                  <c:v>0.0154789899264</c:v>
                 </c:pt>
                 <c:pt idx="6">
-                  <c:v>0.0185825173248</c:v>
+                  <c:v>0.014575200912</c:v>
                 </c:pt>
                 <c:pt idx="7">
-                  <c:v>0.0122926510656</c:v>
+                  <c:v>0.0088364400768</c:v>
                 </c:pt>
                 <c:pt idx="8">
                   <c:v>0.0040192552512</c:v>
@@ -1196,10 +1196,10 @@
                   <c:v>Alibaba</c:v>
                 </c:pt>
                 <c:pt idx="5">
+                  <c:v>OpenAI</c:v>
+                </c:pt>
+                <c:pt idx="6">
                   <c:v>Google</c:v>
-                </c:pt>
-                <c:pt idx="6">
-                  <c:v>OpenAI</c:v>
                 </c:pt>
                 <c:pt idx="7">
                   <c:v>Anthropic</c:v>
@@ -1232,10 +1232,10 @@
                   <c:v>4.0</c:v>
                 </c:pt>
                 <c:pt idx="5">
+                  <c:v>12.0</c:v>
+                </c:pt>
+                <c:pt idx="6">
                   <c:v>8.0</c:v>
-                </c:pt>
-                <c:pt idx="6">
-                  <c:v>12.0</c:v>
                 </c:pt>
                 <c:pt idx="7">
                   <c:v>7.0</c:v>
@@ -1282,10 +1282,10 @@
                   <c:v>Alibaba</c:v>
                 </c:pt>
                 <c:pt idx="5">
+                  <c:v>OpenAI</c:v>
+                </c:pt>
+                <c:pt idx="6">
                   <c:v>Google</c:v>
-                </c:pt>
-                <c:pt idx="6">
-                  <c:v>OpenAI</c:v>
                 </c:pt>
                 <c:pt idx="7">
                   <c:v>Anthropic</c:v>
@@ -1318,10 +1318,10 @@
                   <c:v>3.2</c:v>
                 </c:pt>
                 <c:pt idx="5">
+                  <c:v>8.5</c:v>
+                </c:pt>
+                <c:pt idx="6">
                   <c:v>6.8</c:v>
-                </c:pt>
-                <c:pt idx="6">
-                  <c:v>8.5</c:v>
                 </c:pt>
                 <c:pt idx="7">
                   <c:v>5.5</c:v>
@@ -1486,10 +1486,10 @@
                   <c:v>Alibaba</c:v>
                 </c:pt>
                 <c:pt idx="5">
+                  <c:v>OpenAI</c:v>
+                </c:pt>
+                <c:pt idx="6">
                   <c:v>Google</c:v>
-                </c:pt>
-                <c:pt idx="6">
-                  <c:v>OpenAI</c:v>
                 </c:pt>
                 <c:pt idx="7">
                   <c:v>Anthropic</c:v>
@@ -1522,10 +1522,10 @@
                   <c:v>1.748</c:v>
                 </c:pt>
                 <c:pt idx="5">
+                  <c:v>4.862</c:v>
+                </c:pt>
+                <c:pt idx="6">
                   <c:v>3.651</c:v>
-                </c:pt>
-                <c:pt idx="6">
-                  <c:v>4.862</c:v>
                 </c:pt>
                 <c:pt idx="7">
                   <c:v>2.966</c:v>
@@ -1572,10 +1572,10 @@
                   <c:v>Alibaba</c:v>
                 </c:pt>
                 <c:pt idx="5">
+                  <c:v>OpenAI</c:v>
+                </c:pt>
+                <c:pt idx="6">
                   <c:v>Google</c:v>
-                </c:pt>
-                <c:pt idx="6">
-                  <c:v>OpenAI</c:v>
                 </c:pt>
                 <c:pt idx="7">
                   <c:v>Anthropic</c:v>
@@ -1608,10 +1608,10 @@
                   <c:v>0.437</c:v>
                 </c:pt>
                 <c:pt idx="5">
+                  <c:v>1.371</c:v>
+                </c:pt>
+                <c:pt idx="6">
                   <c:v>1.42</c:v>
-                </c:pt>
-                <c:pt idx="6">
-                  <c:v>1.371</c:v>
                 </c:pt>
                 <c:pt idx="7">
                   <c:v>1.042</c:v>
@@ -1777,10 +1777,10 @@
                   <c:v>Alibaba</c:v>
                 </c:pt>
                 <c:pt idx="5">
+                  <c:v>OpenAI</c:v>
+                </c:pt>
+                <c:pt idx="6">
                   <c:v>Google</c:v>
-                </c:pt>
-                <c:pt idx="6">
-                  <c:v>OpenAI</c:v>
                 </c:pt>
                 <c:pt idx="7">
                   <c:v>Anthropic</c:v>
@@ -1813,13 +1813,13 @@
                   <c:v>0.310008</c:v>
                 </c:pt>
                 <c:pt idx="5">
-                  <c:v>0.062377</c:v>
+                  <c:v>0.036848</c:v>
                 </c:pt>
                 <c:pt idx="6">
-                  <c:v>0.044236</c:v>
+                  <c:v>0.046205</c:v>
                 </c:pt>
                 <c:pt idx="7">
-                  <c:v>0.047969</c:v>
+                  <c:v>0.034482</c:v>
                 </c:pt>
                 <c:pt idx="8">
                   <c:v>0.071458</c:v>
@@ -1988,19 +1988,19 @@
                 <c:formatCode>General</c:formatCode>
                 <c:ptCount val="5"/>
                 <c:pt idx="0">
-                  <c:v>0.047</c:v>
+                  <c:v>0.046</c:v>
                 </c:pt>
                 <c:pt idx="1">
-                  <c:v>0.094</c:v>
+                  <c:v>0.092</c:v>
                 </c:pt>
                 <c:pt idx="2">
-                  <c:v>0.152</c:v>
+                  <c:v>0.149</c:v>
                 </c:pt>
                 <c:pt idx="3">
-                  <c:v>0.22</c:v>
+                  <c:v>0.216</c:v>
                 </c:pt>
                 <c:pt idx="4">
-                  <c:v>0.296</c:v>
+                  <c:v>0.291</c:v>
                 </c:pt>
               </c:numCache>
             </c:numRef>
@@ -2051,19 +2051,19 @@
                 <c:formatCode>General</c:formatCode>
                 <c:ptCount val="5"/>
                 <c:pt idx="0">
-                  <c:v>0.085</c:v>
+                  <c:v>0.083</c:v>
                 </c:pt>
                 <c:pt idx="1">
-                  <c:v>0.177</c:v>
+                  <c:v>0.172</c:v>
                 </c:pt>
                 <c:pt idx="2">
-                  <c:v>0.291</c:v>
+                  <c:v>0.285</c:v>
                 </c:pt>
                 <c:pt idx="3">
-                  <c:v>0.43</c:v>
+                  <c:v>0.421</c:v>
                 </c:pt>
                 <c:pt idx="4">
-                  <c:v>0.594</c:v>
+                  <c:v>0.583</c:v>
                 </c:pt>
               </c:numCache>
             </c:numRef>
@@ -2114,19 +2114,19 @@
                 <c:formatCode>General</c:formatCode>
                 <c:ptCount val="5"/>
                 <c:pt idx="0">
-                  <c:v>0.124</c:v>
+                  <c:v>0.12</c:v>
                 </c:pt>
                 <c:pt idx="1">
-                  <c:v>0.267</c:v>
+                  <c:v>0.259</c:v>
                 </c:pt>
                 <c:pt idx="2">
-                  <c:v>0.456</c:v>
+                  <c:v>0.444</c:v>
                 </c:pt>
                 <c:pt idx="3">
-                  <c:v>0.696</c:v>
+                  <c:v>0.68</c:v>
                 </c:pt>
                 <c:pt idx="4">
-                  <c:v>0.992</c:v>
+                  <c:v>0.971</c:v>
                 </c:pt>
               </c:numCache>
             </c:numRef>
@@ -5606,7 +5606,7 @@
               </a:defRPr>
             </a:pPr>
             <a:r>
-              <a:t>0.59Q</a:t>
+              <a:t>0.58Q</a:t>
             </a:r>
           </a:p>
         </p:txBody>
@@ -6560,7 +6560,7 @@
                         </a:defRPr>
                       </a:pPr>
                       <a:r>
-                        <a:t>0.02</a:t>
+                        <a:t>0.01</a:t>
                       </a:r>
                     </a:p>
                   </a:txBody>
@@ -7946,7 +7946,7 @@
                         </a:defRPr>
                       </a:pPr>
                       <a:r>
-                        <a:t>0.30</a:t>
+                        <a:t>0.29</a:t>
                       </a:r>
                     </a:p>
                   </a:txBody>
@@ -8040,7 +8040,7 @@
                         </a:defRPr>
                       </a:pPr>
                       <a:r>
-                        <a:t>0.59</a:t>
+                        <a:t>0.58</a:t>
                       </a:r>
                     </a:p>
                   </a:txBody>
@@ -8134,7 +8134,7 @@
                         </a:defRPr>
                       </a:pPr>
                       <a:r>
-                        <a:t>0.99</a:t>
+                        <a:t>0.97</a:t>
                       </a:r>
                     </a:p>
                   </a:txBody>
@@ -10989,7 +10989,7 @@
               </a:defRPr>
             </a:pPr>
             <a:r>
-              <a:t>Top 3 providers account for 71% of modeled 2030 generated-token supply.</a:t>
+              <a:t>Top 3 providers account for 72% of modeled 2030 generated-token supply.</a:t>
             </a:r>
           </a:p>
         </p:txBody>
@@ -13304,7 +13304,7 @@
               </a:defRPr>
             </a:pPr>
             <a:r>
-              <a:t>71%</a:t>
+              <a:t>72%</a:t>
             </a:r>
           </a:p>
         </p:txBody>
@@ -14509,7 +14509,7 @@
                         </a:defRPr>
                       </a:pPr>
                       <a:r>
-                        <a:t>Google</a:t>
+                        <a:t>OpenAI</a:t>
                       </a:r>
                     </a:p>
                   </a:txBody>
@@ -14601,7 +14601,7 @@
                         </a:defRPr>
                       </a:pPr>
                       <a:r>
-                        <a:t>4.0x</a:t>
+                        <a:t>8.2x</a:t>
                       </a:r>
                     </a:p>
                   </a:txBody>
@@ -14626,7 +14626,7 @@
                         </a:defRPr>
                       </a:pPr>
                       <a:r>
-                        <a:t>OpenAI</a:t>
+                        <a:t>Google</a:t>
                       </a:r>
                     </a:p>
                   </a:txBody>
@@ -14695,7 +14695,7 @@
                         </a:defRPr>
                       </a:pPr>
                       <a:r>
-                        <a:t>0.02</a:t>
+                        <a:t>0.01</a:t>
                       </a:r>
                     </a:p>
                   </a:txBody>
@@ -14718,7 +14718,7 @@
                         </a:defRPr>
                       </a:pPr>
                       <a:r>
-                        <a:t>7.6x</a:t>
+                        <a:t>4.0x</a:t>
                       </a:r>
                     </a:p>
                   </a:txBody>
@@ -14789,6 +14789,29 @@
                         </a:defRPr>
                       </a:pPr>
                       <a:r>
+                        <a:t>0.00</a:t>
+                      </a:r>
+                    </a:p>
+                  </a:txBody>
+                  <a:tcPr marL="50292" marR="50292" marT="32004" marB="32004">
+                    <a:solidFill>
+                      <a:srgbClr val="F7F9FC"/>
+                    </a:solidFill>
+                  </a:tcPr>
+                </a:tc>
+                <a:tc>
+                  <a:txBody>
+                    <a:bodyPr/>
+                    <a:lstStyle/>
+                    <a:p>
+                      <a:pPr>
+                        <a:defRPr sz="650" b="0">
+                          <a:solidFill>
+                            <a:srgbClr val="3A4252"/>
+                          </a:solidFill>
+                        </a:defRPr>
+                      </a:pPr>
+                      <a:r>
                         <a:t>0.01</a:t>
                       </a:r>
                     </a:p>
@@ -14812,30 +14835,7 @@
                         </a:defRPr>
                       </a:pPr>
                       <a:r>
-                        <a:t>0.01</a:t>
-                      </a:r>
-                    </a:p>
-                  </a:txBody>
-                  <a:tcPr marL="50292" marR="50292" marT="32004" marB="32004">
-                    <a:solidFill>
-                      <a:srgbClr val="F7F9FC"/>
-                    </a:solidFill>
-                  </a:tcPr>
-                </a:tc>
-                <a:tc>
-                  <a:txBody>
-                    <a:bodyPr/>
-                    <a:lstStyle/>
-                    <a:p>
-                      <a:pPr>
-                        <a:defRPr sz="650" b="0">
-                          <a:solidFill>
-                            <a:srgbClr val="3A4252"/>
-                          </a:solidFill>
-                        </a:defRPr>
-                      </a:pPr>
-                      <a:r>
-                        <a:t>7.7x</a:t>
+                        <a:t>7.8x</a:t>
                       </a:r>
                     </a:p>
                   </a:txBody>
@@ -16132,7 +16132,7 @@
                         </a:defRPr>
                       </a:pPr>
                       <a:r>
-                        <a:t>Google</a:t>
+                        <a:t>OpenAI</a:t>
                       </a:r>
                     </a:p>
                   </a:txBody>
@@ -16155,7 +16155,7 @@
                         </a:defRPr>
                       </a:pPr>
                       <a:r>
-                        <a:t>0.9</a:t>
+                        <a:t>0.6</a:t>
                       </a:r>
                     </a:p>
                   </a:txBody>
@@ -16178,7 +16178,7 @@
                         </a:defRPr>
                       </a:pPr>
                       <a:r>
-                        <a:t>2.1</a:t>
+                        <a:t>2.5</a:t>
                       </a:r>
                     </a:p>
                   </a:txBody>
@@ -16201,7 +16201,7 @@
                         </a:defRPr>
                       </a:pPr>
                       <a:r>
-                        <a:t>3.7</a:t>
+                        <a:t>4.9</a:t>
                       </a:r>
                     </a:p>
                   </a:txBody>
@@ -16224,7 +16224,7 @@
                         </a:defRPr>
                       </a:pPr>
                       <a:r>
-                        <a:t>72%</a:t>
+                        <a:t>78%</a:t>
                       </a:r>
                     </a:p>
                   </a:txBody>
@@ -16249,7 +16249,7 @@
                         </a:defRPr>
                       </a:pPr>
                       <a:r>
-                        <a:t>OpenAI</a:t>
+                        <a:t>Google</a:t>
                       </a:r>
                     </a:p>
                   </a:txBody>
@@ -16272,7 +16272,7 @@
                         </a:defRPr>
                       </a:pPr>
                       <a:r>
-                        <a:t>0.6</a:t>
+                        <a:t>0.9</a:t>
                       </a:r>
                     </a:p>
                   </a:txBody>
@@ -16295,7 +16295,7 @@
                         </a:defRPr>
                       </a:pPr>
                       <a:r>
-                        <a:t>2.5</a:t>
+                        <a:t>2.1</a:t>
                       </a:r>
                     </a:p>
                   </a:txBody>
@@ -16318,7 +16318,7 @@
                         </a:defRPr>
                       </a:pPr>
                       <a:r>
-                        <a:t>4.9</a:t>
+                        <a:t>3.7</a:t>
                       </a:r>
                     </a:p>
                   </a:txBody>
@@ -16341,7 +16341,7 @@
                         </a:defRPr>
                       </a:pPr>
                       <a:r>
-                        <a:t>78%</a:t>
+                        <a:t>72%</a:t>
                       </a:r>
                     </a:p>
                   </a:txBody>
@@ -19060,7 +19060,7 @@
                         </a:defRPr>
                       </a:pPr>
                       <a:r>
-                        <a:t>OpenAI</a:t>
+                        <a:t>Anthropic</a:t>
                       </a:r>
                     </a:p>
                   </a:txBody>
@@ -19083,7 +19083,7 @@
                         </a:defRPr>
                       </a:pPr>
                       <a:r>
-                        <a:t>45%/25%/30%</a:t>
+                        <a:t>30%/30%/40%</a:t>
                       </a:r>
                     </a:p>
                   </a:txBody>
@@ -19129,7 +19129,7 @@
                         </a:defRPr>
                       </a:pPr>
                       <a:r>
-                        <a:t>0.04</a:t>
+                        <a:t>0.03</a:t>
                       </a:r>
                     </a:p>
                   </a:txBody>
@@ -19154,7 +19154,7 @@
                         </a:defRPr>
                       </a:pPr>
                       <a:r>
-                        <a:t>Anthropic</a:t>
+                        <a:t>OpenAI</a:t>
                       </a:r>
                     </a:p>
                   </a:txBody>
@@ -19177,7 +19177,7 @@
                         </a:defRPr>
                       </a:pPr>
                       <a:r>
-                        <a:t>30%/30%/40%</a:t>
+                        <a:t>45%/25%/30%</a:t>
                       </a:r>
                     </a:p>
                   </a:txBody>
@@ -19223,7 +19223,7 @@
                         </a:defRPr>
                       </a:pPr>
                       <a:r>
-                        <a:t>0.05</a:t>
+                        <a:t>0.04</a:t>
                       </a:r>
                     </a:p>
                   </a:txBody>
@@ -19317,7 +19317,7 @@
                         </a:defRPr>
                       </a:pPr>
                       <a:r>
-                        <a:t>0.06</a:t>
+                        <a:t>0.05</a:t>
                       </a:r>
                     </a:p>
                   </a:txBody>

</xml_diff>

<commit_message>
Use frontier composite benchmark proxy
</commit_message>
<xml_diff>
--- a/llm_token_capacity_project/outputs/reports/llm_token_capacity_2026_2030.pptx
+++ b/llm_token_capacity_project/outputs/reports/llm_token_capacity_2026_2030.pptx
@@ -199,13 +199,13 @@
                   <c:v>0.0468196402176</c:v>
                 </c:pt>
                 <c:pt idx="5">
-                  <c:v>0.0154789899264</c:v>
+                  <c:v>0.015656262336</c:v>
                 </c:pt>
                 <c:pt idx="6">
-                  <c:v>0.014575200912</c:v>
+                  <c:v>0.0142748959392</c:v>
                 </c:pt>
                 <c:pt idx="7">
-                  <c:v>0.0088364400768</c:v>
+                  <c:v>0.00854635104</c:v>
                 </c:pt>
                 <c:pt idx="8">
                   <c:v>0.0040192552512</c:v>
@@ -1813,13 +1813,13 @@
                   <c:v>0.310008</c:v>
                 </c:pt>
                 <c:pt idx="5">
-                  <c:v>0.036848</c:v>
+                  <c:v>0.03727</c:v>
                 </c:pt>
                 <c:pt idx="6">
-                  <c:v>0.046205</c:v>
+                  <c:v>0.045253</c:v>
                 </c:pt>
                 <c:pt idx="7">
-                  <c:v>0.034482</c:v>
+                  <c:v>0.03335</c:v>
                 </c:pt>
                 <c:pt idx="8">
                   <c:v>0.071458</c:v>
@@ -1997,7 +1997,7 @@
                   <c:v>0.149</c:v>
                 </c:pt>
                 <c:pt idx="3">
-                  <c:v>0.216</c:v>
+                  <c:v>0.215</c:v>
                 </c:pt>
                 <c:pt idx="4">
                   <c:v>0.291</c:v>
@@ -2063,7 +2063,7 @@
                   <c:v>0.421</c:v>
                 </c:pt>
                 <c:pt idx="4">
-                  <c:v>0.583</c:v>
+                  <c:v>0.582</c:v>
                 </c:pt>
               </c:numCache>
             </c:numRef>
@@ -2117,10 +2117,10 @@
                   <c:v>0.12</c:v>
                 </c:pt>
                 <c:pt idx="1">
-                  <c:v>0.259</c:v>
+                  <c:v>0.26</c:v>
                 </c:pt>
                 <c:pt idx="2">
-                  <c:v>0.444</c:v>
+                  <c:v>0.445</c:v>
                 </c:pt>
                 <c:pt idx="3">
                   <c:v>0.68</c:v>
@@ -14601,7 +14601,7 @@
                         </a:defRPr>
                       </a:pPr>
                       <a:r>
-                        <a:t>8.2x</a:t>
+                        <a:t>7.7x</a:t>
                       </a:r>
                     </a:p>
                   </a:txBody>
@@ -14835,7 +14835,7 @@
                         </a:defRPr>
                       </a:pPr>
                       <a:r>
-                        <a:t>7.8x</a:t>
+                        <a:t>7.7x</a:t>
                       </a:r>
                     </a:p>
                   </a:txBody>

</xml_diff>

<commit_message>
Use Kimi-derived agentic workload ratio
</commit_message>
<xml_diff>
--- a/llm_token_capacity_project/outputs/reports/llm_token_capacity_2026_2030.pptx
+++ b/llm_token_capacity_project/outputs/reports/llm_token_capacity_2026_2030.pptx
@@ -184,31 +184,31 @@
                 <c:formatCode>General</c:formatCode>
                 <c:ptCount val="9"/>
                 <c:pt idx="0">
-                  <c:v>0.2154517006752</c:v>
+                  <c:v>0.1934722988352</c:v>
                 </c:pt>
                 <c:pt idx="1">
-                  <c:v>0.111140957952</c:v>
+                  <c:v>0.108158823936</c:v>
                 </c:pt>
                 <c:pt idx="2">
-                  <c:v>0.0943886774016</c:v>
+                  <c:v>0.091018996272</c:v>
                 </c:pt>
                 <c:pt idx="3">
-                  <c:v>0.0718923135168</c:v>
+                  <c:v>0.0661481787744</c:v>
                 </c:pt>
                 <c:pt idx="4">
-                  <c:v>0.0468196402176</c:v>
+                  <c:v>0.0437791606272</c:v>
                 </c:pt>
                 <c:pt idx="5">
-                  <c:v>0.015656262336</c:v>
+                  <c:v>0.0135126104256</c:v>
                 </c:pt>
                 <c:pt idx="6">
-                  <c:v>0.0142748959392</c:v>
+                  <c:v>0.0130566419424</c:v>
                 </c:pt>
                 <c:pt idx="7">
-                  <c:v>0.00854635104</c:v>
+                  <c:v>0.0068914084608</c:v>
                 </c:pt>
                 <c:pt idx="8">
-                  <c:v>0.0040192552512</c:v>
+                  <c:v>0.0036246867552</c:v>
                 </c:pt>
               </c:numCache>
             </c:numRef>
@@ -373,19 +373,19 @@
                 <c:formatCode>General</c:formatCode>
                 <c:ptCount val="5"/>
                 <c:pt idx="0">
-                  <c:v>0.034688068992</c:v>
+                  <c:v>0.031177045152</c:v>
                 </c:pt>
                 <c:pt idx="1">
-                  <c:v>0.06718716288</c:v>
+                  <c:v>0.0603662005728</c:v>
                 </c:pt>
                 <c:pt idx="2">
-                  <c:v>0.1083303261216</c:v>
+                  <c:v>0.0973088538912</c:v>
                 </c:pt>
                 <c:pt idx="3">
-                  <c:v>0.1580741713152</c:v>
+                  <c:v>0.1419663267648</c:v>
                 </c:pt>
                 <c:pt idx="4">
-                  <c:v>0.2154517006752</c:v>
+                  <c:v>0.1934722988352</c:v>
                 </c:pt>
               </c:numCache>
             </c:numRef>
@@ -436,19 +436,19 @@
                 <c:formatCode>General</c:formatCode>
                 <c:ptCount val="5"/>
                 <c:pt idx="0">
-                  <c:v>0.021667972608</c:v>
+                  <c:v>0.0211369142304</c:v>
                 </c:pt>
                 <c:pt idx="1">
-                  <c:v>0.039607226208</c:v>
+                  <c:v>0.038606321952</c:v>
                 </c:pt>
                 <c:pt idx="2">
-                  <c:v>0.0605383206912</c:v>
+                  <c:v>0.0589702643712</c:v>
                 </c:pt>
                 <c:pt idx="3">
-                  <c:v>0.0844137324288</c:v>
+                  <c:v>0.0821829898368</c:v>
                 </c:pt>
                 <c:pt idx="4">
-                  <c:v>0.111140957952</c:v>
+                  <c:v>0.108158823936</c:v>
                 </c:pt>
               </c:numCache>
             </c:numRef>
@@ -499,19 +499,19 @@
                 <c:formatCode>General</c:formatCode>
                 <c:ptCount val="5"/>
                 <c:pt idx="0">
-                  <c:v>0.0098764952832</c:v>
+                  <c:v>0.0095277178368</c:v>
                 </c:pt>
                 <c:pt idx="1">
-                  <c:v>0.0242263636992</c:v>
+                  <c:v>0.02336795136</c:v>
                 </c:pt>
                 <c:pt idx="2">
-                  <c:v>0.042791991552</c:v>
+                  <c:v>0.0412714307808</c:v>
                 </c:pt>
                 <c:pt idx="3">
-                  <c:v>0.066048986304</c:v>
+                  <c:v>0.063696120768</c:v>
                 </c:pt>
                 <c:pt idx="4">
-                  <c:v>0.0943886774016</c:v>
+                  <c:v>0.091018996272</c:v>
                 </c:pt>
               </c:numCache>
             </c:numRef>
@@ -562,19 +562,19 @@
                 <c:formatCode>General</c:formatCode>
                 <c:ptCount val="5"/>
                 <c:pt idx="0">
-                  <c:v>0.00482484816</c:v>
+                  <c:v>0.004442568768</c:v>
                 </c:pt>
                 <c:pt idx="1">
-                  <c:v>0.0150968161152</c:v>
+                  <c:v>0.0138975701184</c:v>
                 </c:pt>
                 <c:pt idx="2">
-                  <c:v>0.0293604801408</c:v>
+                  <c:v>0.0270229176</c:v>
                 </c:pt>
                 <c:pt idx="3">
-                  <c:v>0.048117908736</c:v>
+                  <c:v>0.0442797470208</c:v>
                 </c:pt>
                 <c:pt idx="4">
-                  <c:v>0.0718923135168</c:v>
+                  <c:v>0.0661481787744</c:v>
                 </c:pt>
               </c:numCache>
             </c:numRef>
@@ -625,19 +625,19 @@
                 <c:formatCode>General</c:formatCode>
                 <c:ptCount val="5"/>
                 <c:pt idx="0">
-                  <c:v>0.0048673505664</c:v>
+                  <c:v>0.0045301298112</c:v>
                 </c:pt>
                 <c:pt idx="1">
-                  <c:v>0.0116748238464</c:v>
+                  <c:v>0.01088246016</c:v>
                 </c:pt>
                 <c:pt idx="2">
-                  <c:v>0.020738180736</c:v>
+                  <c:v>0.019354851072</c:v>
                 </c:pt>
                 <c:pt idx="3">
-                  <c:v>0.0323455693824</c:v>
+                  <c:v>0.0302188824576</c:v>
                 </c:pt>
                 <c:pt idx="4">
-                  <c:v>0.0468196402176</c:v>
+                  <c:v>0.0437791606272</c:v>
                 </c:pt>
               </c:numCache>
             </c:numRef>
@@ -1798,31 +1798,31 @@
                 <c:formatCode>General</c:formatCode>
                 <c:ptCount val="9"/>
                 <c:pt idx="0">
-                  <c:v>0.748171</c:v>
+                  <c:v>0.671846</c:v>
                 </c:pt>
                 <c:pt idx="1">
-                  <c:v>0.392181</c:v>
+                  <c:v>0.381658</c:v>
                 </c:pt>
                 <c:pt idx="2">
-                  <c:v>0.833304</c:v>
+                  <c:v>0.803555</c:v>
                 </c:pt>
                 <c:pt idx="3">
-                  <c:v>0.682598</c:v>
+                  <c:v>0.628059</c:v>
                 </c:pt>
                 <c:pt idx="4">
-                  <c:v>0.310008</c:v>
+                  <c:v>0.289876</c:v>
                 </c:pt>
                 <c:pt idx="5">
-                  <c:v>0.03727</c:v>
+                  <c:v>0.032167</c:v>
                 </c:pt>
                 <c:pt idx="6">
-                  <c:v>0.045253</c:v>
+                  <c:v>0.041391</c:v>
                 </c:pt>
                 <c:pt idx="7">
-                  <c:v>0.03335</c:v>
+                  <c:v>0.026892</c:v>
                 </c:pt>
                 <c:pt idx="8">
-                  <c:v>0.071458</c:v>
+                  <c:v>0.064443</c:v>
                 </c:pt>
               </c:numCache>
             </c:numRef>
@@ -1988,19 +1988,19 @@
                 <c:formatCode>General</c:formatCode>
                 <c:ptCount val="5"/>
                 <c:pt idx="0">
-                  <c:v>0.046</c:v>
+                  <c:v>0.043</c:v>
                 </c:pt>
                 <c:pt idx="1">
-                  <c:v>0.092</c:v>
+                  <c:v>0.086</c:v>
                 </c:pt>
                 <c:pt idx="2">
-                  <c:v>0.149</c:v>
+                  <c:v>0.139</c:v>
                 </c:pt>
                 <c:pt idx="3">
-                  <c:v>0.215</c:v>
+                  <c:v>0.2</c:v>
                 </c:pt>
                 <c:pt idx="4">
-                  <c:v>0.291</c:v>
+                  <c:v>0.271</c:v>
                 </c:pt>
               </c:numCache>
             </c:numRef>
@@ -2051,19 +2051,19 @@
                 <c:formatCode>General</c:formatCode>
                 <c:ptCount val="5"/>
                 <c:pt idx="0">
-                  <c:v>0.083</c:v>
+                  <c:v>0.077</c:v>
                 </c:pt>
                 <c:pt idx="1">
-                  <c:v>0.172</c:v>
+                  <c:v>0.16</c:v>
                 </c:pt>
                 <c:pt idx="2">
-                  <c:v>0.285</c:v>
+                  <c:v>0.264</c:v>
                 </c:pt>
                 <c:pt idx="3">
-                  <c:v>0.421</c:v>
+                  <c:v>0.391</c:v>
                 </c:pt>
                 <c:pt idx="4">
-                  <c:v>0.582</c:v>
+                  <c:v>0.54</c:v>
                 </c:pt>
               </c:numCache>
             </c:numRef>
@@ -2114,19 +2114,19 @@
                 <c:formatCode>General</c:formatCode>
                 <c:ptCount val="5"/>
                 <c:pt idx="0">
-                  <c:v>0.12</c:v>
+                  <c:v>0.111</c:v>
                 </c:pt>
                 <c:pt idx="1">
-                  <c:v>0.26</c:v>
+                  <c:v>0.24</c:v>
                 </c:pt>
                 <c:pt idx="2">
-                  <c:v>0.445</c:v>
+                  <c:v>0.411</c:v>
                 </c:pt>
                 <c:pt idx="3">
-                  <c:v>0.68</c:v>
+                  <c:v>0.629</c:v>
                 </c:pt>
                 <c:pt idx="4">
-                  <c:v>0.971</c:v>
+                  <c:v>0.898</c:v>
                 </c:pt>
               </c:numCache>
             </c:numRef>
@@ -5606,7 +5606,7 @@
               </a:defRPr>
             </a:pPr>
             <a:r>
-              <a:t>0.58Q</a:t>
+              <a:t>0.54Q</a:t>
             </a:r>
           </a:p>
         </p:txBody>
@@ -5711,7 +5711,7 @@
               </a:defRPr>
             </a:pPr>
             <a:r>
-              <a:t>2026-07-22</a:t>
+              <a:t>2026-07-23</a:t>
             </a:r>
           </a:p>
         </p:txBody>
@@ -6140,7 +6140,7 @@
                         </a:defRPr>
                       </a:pPr>
                       <a:r>
-                        <a:t>0.02</a:t>
+                        <a:t>0.01</a:t>
                       </a:r>
                     </a:p>
                   </a:txBody>
@@ -6700,7 +6700,7 @@
                         </a:defRPr>
                       </a:pPr>
                       <a:r>
-                        <a:t>0.22</a:t>
+                        <a:t>0.19</a:t>
                       </a:r>
                     </a:p>
                   </a:txBody>
@@ -7120,7 +7120,7 @@
                         </a:defRPr>
                       </a:pPr>
                       <a:r>
-                        <a:t>0.05</a:t>
+                        <a:t>0.04</a:t>
                       </a:r>
                     </a:p>
                   </a:txBody>
@@ -7512,7 +7512,7 @@
               </a:defRPr>
             </a:pPr>
             <a:r>
-              <a:t>2026-07-22</a:t>
+              <a:t>2026-07-23</a:t>
             </a:r>
           </a:p>
         </p:txBody>
@@ -7946,7 +7946,7 @@
                         </a:defRPr>
                       </a:pPr>
                       <a:r>
-                        <a:t>0.29</a:t>
+                        <a:t>0.27</a:t>
                       </a:r>
                     </a:p>
                   </a:txBody>
@@ -8040,7 +8040,7 @@
                         </a:defRPr>
                       </a:pPr>
                       <a:r>
-                        <a:t>0.58</a:t>
+                        <a:t>0.54</a:t>
                       </a:r>
                     </a:p>
                   </a:txBody>
@@ -8134,7 +8134,7 @@
                         </a:defRPr>
                       </a:pPr>
                       <a:r>
-                        <a:t>0.97</a:t>
+                        <a:t>0.90</a:t>
                       </a:r>
                     </a:p>
                   </a:txBody>
@@ -8478,7 +8478,7 @@
               </a:defRPr>
             </a:pPr>
             <a:r>
-              <a:t>2026-07-22</a:t>
+              <a:t>2026-07-23</a:t>
             </a:r>
           </a:p>
         </p:txBody>
@@ -9337,7 +9337,7 @@
               </a:defRPr>
             </a:pPr>
             <a:r>
-              <a:t>2026-07-22</a:t>
+              <a:t>2026-07-23</a:t>
             </a:r>
           </a:p>
         </p:txBody>
@@ -10318,7 +10318,7 @@
               </a:defRPr>
             </a:pPr>
             <a:r>
-              <a:t>2026-07-22</a:t>
+              <a:t>2026-07-23</a:t>
             </a:r>
           </a:p>
         </p:txBody>
@@ -10989,7 +10989,7 @@
               </a:defRPr>
             </a:pPr>
             <a:r>
-              <a:t>Top 3 providers account for 72% of modeled 2030 generated-token supply.</a:t>
+              <a:t>Top 3 providers account for 73% of modeled 2030 generated-token supply.</a:t>
             </a:r>
           </a:p>
         </p:txBody>
@@ -11174,7 +11174,7 @@
               </a:defRPr>
             </a:pPr>
             <a:r>
-              <a:t>2026-07-22</a:t>
+              <a:t>2026-07-23</a:t>
             </a:r>
           </a:p>
         </p:txBody>
@@ -12368,7 +12368,7 @@
               </a:defRPr>
             </a:pPr>
             <a:r>
-              <a:t>2026-07-22</a:t>
+              <a:t>2026-07-23</a:t>
             </a:r>
           </a:p>
         </p:txBody>
@@ -12802,7 +12802,7 @@
                         </a:defRPr>
                       </a:pPr>
                       <a:r>
-                        <a:t>0.22</a:t>
+                        <a:t>0.19</a:t>
                       </a:r>
                     </a:p>
                   </a:txBody>
@@ -13178,7 +13178,7 @@
                         </a:defRPr>
                       </a:pPr>
                       <a:r>
-                        <a:t>0.05</a:t>
+                        <a:t>0.04</a:t>
                       </a:r>
                     </a:p>
                   </a:txBody>
@@ -13304,7 +13304,7 @@
               </a:defRPr>
             </a:pPr>
             <a:r>
-              <a:t>72%</a:t>
+              <a:t>73%</a:t>
             </a:r>
           </a:p>
         </p:txBody>
@@ -13489,7 +13489,7 @@
               </a:defRPr>
             </a:pPr>
             <a:r>
-              <a:t>2026-07-22</a:t>
+              <a:t>2026-07-23</a:t>
             </a:r>
           </a:p>
         </p:txBody>
@@ -13970,7 +13970,7 @@
                         </a:defRPr>
                       </a:pPr>
                       <a:r>
-                        <a:t>0.11</a:t>
+                        <a:t>0.10</a:t>
                       </a:r>
                     </a:p>
                   </a:txBody>
@@ -13993,7 +13993,7 @@
                         </a:defRPr>
                       </a:pPr>
                       <a:r>
-                        <a:t>0.22</a:t>
+                        <a:t>0.19</a:t>
                       </a:r>
                     </a:p>
                   </a:txBody>
@@ -14461,7 +14461,7 @@
                         </a:defRPr>
                       </a:pPr>
                       <a:r>
-                        <a:t>0.05</a:t>
+                        <a:t>0.04</a:t>
                       </a:r>
                     </a:p>
                   </a:txBody>
@@ -14484,7 +14484,7 @@
                         </a:defRPr>
                       </a:pPr>
                       <a:r>
-                        <a:t>9.6x</a:t>
+                        <a:t>9.7x</a:t>
                       </a:r>
                     </a:p>
                   </a:txBody>
@@ -14578,7 +14578,7 @@
                         </a:defRPr>
                       </a:pPr>
                       <a:r>
-                        <a:t>0.02</a:t>
+                        <a:t>0.01</a:t>
                       </a:r>
                     </a:p>
                   </a:txBody>
@@ -14601,7 +14601,7 @@
                         </a:defRPr>
                       </a:pPr>
                       <a:r>
-                        <a:t>7.7x</a:t>
+                        <a:t>7.5x</a:t>
                       </a:r>
                     </a:p>
                   </a:txBody>
@@ -15112,7 +15112,7 @@
               </a:defRPr>
             </a:pPr>
             <a:r>
-              <a:t>2026-07-22</a:t>
+              <a:t>2026-07-23</a:t>
             </a:r>
           </a:p>
         </p:txBody>
@@ -16735,7 +16735,7 @@
               </a:defRPr>
             </a:pPr>
             <a:r>
-              <a:t>2026-07-22</a:t>
+              <a:t>2026-07-23</a:t>
             </a:r>
           </a:p>
         </p:txBody>
@@ -17598,7 +17598,7 @@
               </a:defRPr>
             </a:pPr>
             <a:r>
-              <a:t>2026-07-22</a:t>
+              <a:t>2026-07-23</a:t>
             </a:r>
           </a:p>
         </p:txBody>
@@ -18649,7 +18649,7 @@
               </a:defRPr>
             </a:pPr>
             <a:r>
-              <a:t>2026-07-22</a:t>
+              <a:t>2026-07-23</a:t>
             </a:r>
           </a:p>
         </p:txBody>
@@ -19223,7 +19223,7 @@
                         </a:defRPr>
                       </a:pPr>
                       <a:r>
-                        <a:t>0.04</a:t>
+                        <a:t>0.03</a:t>
                       </a:r>
                     </a:p>
                   </a:txBody>
@@ -19317,7 +19317,7 @@
                         </a:defRPr>
                       </a:pPr>
                       <a:r>
-                        <a:t>0.05</a:t>
+                        <a:t>0.04</a:t>
                       </a:r>
                     </a:p>
                   </a:txBody>
@@ -19411,7 +19411,7 @@
                         </a:defRPr>
                       </a:pPr>
                       <a:r>
-                        <a:t>0.07</a:t>
+                        <a:t>0.06</a:t>
                       </a:r>
                     </a:p>
                   </a:txBody>
@@ -19505,7 +19505,7 @@
                         </a:defRPr>
                       </a:pPr>
                       <a:r>
-                        <a:t>0.31</a:t>
+                        <a:t>0.29</a:t>
                       </a:r>
                     </a:p>
                   </a:txBody>
@@ -19700,7 +19700,7 @@
               </a:defRPr>
             </a:pPr>
             <a:r>
-              <a:t>2026-07-22</a:t>
+              <a:t>2026-07-23</a:t>
             </a:r>
           </a:p>
         </p:txBody>

</xml_diff>

<commit_message>
Add interactivity-aware InferenceX serving profiles
</commit_message>
<xml_diff>
--- a/llm_token_capacity_project/outputs/reports/llm_token_capacity_2026_2030.pptx
+++ b/llm_token_capacity_project/outputs/reports/llm_token_capacity_2026_2030.pptx
@@ -184,31 +184,31 @@
                 <c:formatCode>General</c:formatCode>
                 <c:ptCount val="9"/>
                 <c:pt idx="0">
-                  <c:v>0.1934722988352</c:v>
+                  <c:v>0.4831356176064</c:v>
                 </c:pt>
                 <c:pt idx="1">
-                  <c:v>0.108158823936</c:v>
+                  <c:v>0.237028502016</c:v>
                 </c:pt>
                 <c:pt idx="2">
-                  <c:v>0.091018996272</c:v>
+                  <c:v>0.2305701679392</c:v>
                 </c:pt>
                 <c:pt idx="3">
-                  <c:v>0.0661481787744</c:v>
+                  <c:v>0.1638686135808</c:v>
                 </c:pt>
                 <c:pt idx="4">
-                  <c:v>0.0437791606272</c:v>
+                  <c:v>0.086238041472</c:v>
                 </c:pt>
                 <c:pt idx="5">
-                  <c:v>0.0135126104256</c:v>
+                  <c:v>0.0517341382272</c:v>
                 </c:pt>
                 <c:pt idx="6">
-                  <c:v>0.0130566419424</c:v>
+                  <c:v>0.0342435993984</c:v>
                 </c:pt>
                 <c:pt idx="7">
-                  <c:v>0.0068914084608</c:v>
+                  <c:v>0.0190656662976</c:v>
                 </c:pt>
                 <c:pt idx="8">
-                  <c:v>0.0036246867552</c:v>
+                  <c:v>0.0088044739776</c:v>
                 </c:pt>
               </c:numCache>
             </c:numRef>
@@ -373,19 +373,19 @@
                 <c:formatCode>General</c:formatCode>
                 <c:ptCount val="5"/>
                 <c:pt idx="0">
-                  <c:v>0.031177045152</c:v>
+                  <c:v>0.074391378048</c:v>
                 </c:pt>
                 <c:pt idx="1">
-                  <c:v>0.0603662005728</c:v>
+                  <c:v>0.1465981659648</c:v>
                 </c:pt>
                 <c:pt idx="2">
-                  <c:v>0.0973088538912</c:v>
+                  <c:v>0.2392598855232</c:v>
                 </c:pt>
                 <c:pt idx="3">
-                  <c:v>0.1419663267648</c:v>
+                  <c:v>0.3522462844896</c:v>
                 </c:pt>
                 <c:pt idx="4">
-                  <c:v>0.1934722988352</c:v>
+                  <c:v>0.4831356176064</c:v>
                 </c:pt>
               </c:numCache>
             </c:numRef>
@@ -436,19 +436,19 @@
                 <c:formatCode>General</c:formatCode>
                 <c:ptCount val="5"/>
                 <c:pt idx="0">
-                  <c:v>0.0211369142304</c:v>
+                  <c:v>0.04372378704</c:v>
                 </c:pt>
                 <c:pt idx="1">
-                  <c:v>0.038606321952</c:v>
+                  <c:v>0.08142095808</c:v>
                 </c:pt>
                 <c:pt idx="2">
-                  <c:v>0.0589702643712</c:v>
+                  <c:v>0.1263363277824</c:v>
                 </c:pt>
                 <c:pt idx="3">
-                  <c:v>0.0821829898368</c:v>
+                  <c:v>0.1783386388224</c:v>
                 </c:pt>
                 <c:pt idx="4">
-                  <c:v>0.108158823936</c:v>
+                  <c:v>0.237028502016</c:v>
                 </c:pt>
               </c:numCache>
             </c:numRef>
@@ -499,19 +499,19 @@
                 <c:formatCode>General</c:formatCode>
                 <c:ptCount val="5"/>
                 <c:pt idx="0">
-                  <c:v>0.0095277178368</c:v>
+                  <c:v>0.022510683648</c:v>
                 </c:pt>
                 <c:pt idx="1">
-                  <c:v>0.02336795136</c:v>
+                  <c:v>0.056436397056</c:v>
                 </c:pt>
                 <c:pt idx="2">
-                  <c:v>0.0412714307808</c:v>
+                  <c:v>0.1015419574368</c:v>
                 </c:pt>
                 <c:pt idx="3">
-                  <c:v>0.063696120768</c:v>
+                  <c:v>0.159182259264</c:v>
                 </c:pt>
                 <c:pt idx="4">
-                  <c:v>0.091018996272</c:v>
+                  <c:v>0.2305701679392</c:v>
                 </c:pt>
               </c:numCache>
             </c:numRef>
@@ -562,19 +562,19 @@
                 <c:formatCode>General</c:formatCode>
                 <c:ptCount val="5"/>
                 <c:pt idx="0">
-                  <c:v>0.004442568768</c:v>
+                  <c:v>0.010520177184</c:v>
                 </c:pt>
                 <c:pt idx="1">
-                  <c:v>0.0138975701184</c:v>
+                  <c:v>0.0333777445632</c:v>
                 </c:pt>
                 <c:pt idx="2">
-                  <c:v>0.0270229176</c:v>
+                  <c:v>0.0656840174976</c:v>
                 </c:pt>
                 <c:pt idx="3">
-                  <c:v>0.0442797470208</c:v>
+                  <c:v>0.1087278494976</c:v>
                 </c:pt>
                 <c:pt idx="4">
-                  <c:v>0.0661481787744</c:v>
+                  <c:v>0.1638686135808</c:v>
                 </c:pt>
               </c:numCache>
             </c:numRef>
@@ -625,19 +625,19 @@
                 <c:formatCode>General</c:formatCode>
                 <c:ptCount val="5"/>
                 <c:pt idx="0">
-                  <c:v>0.0045301298112</c:v>
+                  <c:v>0.0082845116928</c:v>
                 </c:pt>
                 <c:pt idx="1">
-                  <c:v>0.01088246016</c:v>
+                  <c:v>0.0204044645376</c:v>
                 </c:pt>
                 <c:pt idx="2">
-                  <c:v>0.019354851072</c:v>
+                  <c:v>0.037020820608</c:v>
                 </c:pt>
                 <c:pt idx="3">
-                  <c:v>0.0302188824576</c:v>
+                  <c:v>0.0587349190656</c:v>
                 </c:pt>
                 <c:pt idx="4">
-                  <c:v>0.0437791606272</c:v>
+                  <c:v>0.086238041472</c:v>
                 </c:pt>
               </c:numCache>
             </c:numRef>
@@ -1798,31 +1798,31 @@
                 <c:formatCode>General</c:formatCode>
                 <c:ptCount val="9"/>
                 <c:pt idx="0">
-                  <c:v>0.671846</c:v>
+                  <c:v>1.677722</c:v>
                 </c:pt>
                 <c:pt idx="1">
-                  <c:v>0.381658</c:v>
+                  <c:v>0.836398</c:v>
                 </c:pt>
                 <c:pt idx="2">
-                  <c:v>0.803555</c:v>
+                  <c:v>2.035573</c:v>
                 </c:pt>
                 <c:pt idx="3">
-                  <c:v>0.628059</c:v>
+                  <c:v>1.555888</c:v>
                 </c:pt>
                 <c:pt idx="4">
-                  <c:v>0.289876</c:v>
+                  <c:v>0.57101</c:v>
                 </c:pt>
                 <c:pt idx="5">
-                  <c:v>0.032167</c:v>
+                  <c:v>0.123154</c:v>
                 </c:pt>
                 <c:pt idx="6">
-                  <c:v>0.041391</c:v>
+                  <c:v>0.108556</c:v>
                 </c:pt>
                 <c:pt idx="7">
-                  <c:v>0.026892</c:v>
+                  <c:v>0.074399</c:v>
                 </c:pt>
                 <c:pt idx="8">
-                  <c:v>0.064443</c:v>
+                  <c:v>0.156534</c:v>
                 </c:pt>
               </c:numCache>
             </c:numRef>
@@ -1988,19 +1988,19 @@
                 <c:formatCode>General</c:formatCode>
                 <c:ptCount val="5"/>
                 <c:pt idx="0">
-                  <c:v>0.043</c:v>
+                  <c:v>0.105</c:v>
                 </c:pt>
                 <c:pt idx="1">
-                  <c:v>0.086</c:v>
+                  <c:v>0.213</c:v>
                 </c:pt>
                 <c:pt idx="2">
-                  <c:v>0.139</c:v>
+                  <c:v>0.341</c:v>
                 </c:pt>
                 <c:pt idx="3">
-                  <c:v>0.2</c:v>
+                  <c:v>0.488</c:v>
                 </c:pt>
                 <c:pt idx="4">
-                  <c:v>0.271</c:v>
+                  <c:v>0.653</c:v>
                 </c:pt>
               </c:numCache>
             </c:numRef>
@@ -2051,19 +2051,19 @@
                 <c:formatCode>General</c:formatCode>
                 <c:ptCount val="5"/>
                 <c:pt idx="0">
-                  <c:v>0.077</c:v>
+                  <c:v>0.195</c:v>
                 </c:pt>
                 <c:pt idx="1">
-                  <c:v>0.16</c:v>
+                  <c:v>0.403</c:v>
                 </c:pt>
                 <c:pt idx="2">
-                  <c:v>0.264</c:v>
+                  <c:v>0.659</c:v>
                 </c:pt>
                 <c:pt idx="3">
-                  <c:v>0.391</c:v>
+                  <c:v>0.963</c:v>
                 </c:pt>
                 <c:pt idx="4">
-                  <c:v>0.54</c:v>
+                  <c:v>1.315</c:v>
                 </c:pt>
               </c:numCache>
             </c:numRef>
@@ -2114,19 +2114,19 @@
                 <c:formatCode>General</c:formatCode>
                 <c:ptCount val="5"/>
                 <c:pt idx="0">
-                  <c:v>0.111</c:v>
+                  <c:v>0.286</c:v>
                 </c:pt>
                 <c:pt idx="1">
-                  <c:v>0.24</c:v>
+                  <c:v>0.615</c:v>
                 </c:pt>
                 <c:pt idx="2">
-                  <c:v>0.411</c:v>
+                  <c:v>1.038</c:v>
                 </c:pt>
                 <c:pt idx="3">
-                  <c:v>0.629</c:v>
+                  <c:v>1.566</c:v>
                 </c:pt>
                 <c:pt idx="4">
-                  <c:v>0.898</c:v>
+                  <c:v>2.203</c:v>
                 </c:pt>
               </c:numCache>
             </c:numRef>
@@ -5606,7 +5606,7 @@
               </a:defRPr>
             </a:pPr>
             <a:r>
-              <a:t>0.54Q</a:t>
+              <a:t>1.31Q</a:t>
             </a:r>
           </a:p>
         </p:txBody>
@@ -6117,7 +6117,7 @@
                         </a:defRPr>
                       </a:pPr>
                       <a:r>
-                        <a:t>OpenAI</a:t>
+                        <a:t>Anthropic</a:t>
                       </a:r>
                     </a:p>
                   </a:txBody>
@@ -6140,7 +6140,7 @@
                         </a:defRPr>
                       </a:pPr>
                       <a:r>
-                        <a:t>0.01</a:t>
+                        <a:t>0.02</a:t>
                       </a:r>
                     </a:p>
                   </a:txBody>
@@ -6163,7 +6163,7 @@
                         </a:defRPr>
                       </a:pPr>
                       <a:r>
-                        <a:t>4.9</a:t>
+                        <a:t>3.0</a:t>
                       </a:r>
                     </a:p>
                   </a:txBody>
@@ -6186,7 +6186,7 @@
                         </a:defRPr>
                       </a:pPr>
                       <a:r>
-                        <a:t>29%</a:t>
+                        <a:t>21%</a:t>
                       </a:r>
                     </a:p>
                   </a:txBody>
@@ -6209,7 +6209,7 @@
                         </a:defRPr>
                       </a:pPr>
                       <a:r>
-                        <a:t>Serving efficiency</a:t>
+                        <a:t>Training allocation</a:t>
                       </a:r>
                     </a:p>
                   </a:txBody>
@@ -6232,7 +6232,7 @@
                         </a:defRPr>
                       </a:pPr>
                       <a:r>
-                        <a:t>model routing, precision, batching, TTFT/TPOT target</a:t>
+                        <a:t>training cadence, launch schedule, commercial serving ramp</a:t>
                       </a:r>
                     </a:p>
                   </a:txBody>
@@ -6280,7 +6280,7 @@
                         </a:defRPr>
                       </a:pPr>
                       <a:r>
-                        <a:t>0.00</a:t>
+                        <a:t>0.01</a:t>
                       </a:r>
                     </a:p>
                   </a:txBody>
@@ -6397,7 +6397,7 @@
                         </a:defRPr>
                       </a:pPr>
                       <a:r>
-                        <a:t>Anthropic</a:t>
+                        <a:t>OpenAI</a:t>
                       </a:r>
                     </a:p>
                   </a:txBody>
@@ -6420,7 +6420,7 @@
                         </a:defRPr>
                       </a:pPr>
                       <a:r>
-                        <a:t>0.01</a:t>
+                        <a:t>0.05</a:t>
                       </a:r>
                     </a:p>
                   </a:txBody>
@@ -6443,7 +6443,7 @@
                         </a:defRPr>
                       </a:pPr>
                       <a:r>
-                        <a:t>3.0</a:t>
+                        <a:t>4.9</a:t>
                       </a:r>
                     </a:p>
                   </a:txBody>
@@ -6466,7 +6466,7 @@
                         </a:defRPr>
                       </a:pPr>
                       <a:r>
-                        <a:t>21%</a:t>
+                        <a:t>29%</a:t>
                       </a:r>
                     </a:p>
                   </a:txBody>
@@ -6489,7 +6489,7 @@
                         </a:defRPr>
                       </a:pPr>
                       <a:r>
-                        <a:t>Training allocation</a:t>
+                        <a:t>Serving efficiency</a:t>
                       </a:r>
                     </a:p>
                   </a:txBody>
@@ -6512,7 +6512,7 @@
                         </a:defRPr>
                       </a:pPr>
                       <a:r>
-                        <a:t>training cadence, launch schedule, commercial serving ramp</a:t>
+                        <a:t>model routing, precision, batching, TTFT/TPOT target</a:t>
                       </a:r>
                     </a:p>
                   </a:txBody>
@@ -6560,7 +6560,7 @@
                         </a:defRPr>
                       </a:pPr>
                       <a:r>
-                        <a:t>0.01</a:t>
+                        <a:t>0.03</a:t>
                       </a:r>
                     </a:p>
                   </a:txBody>
@@ -6700,7 +6700,7 @@
                         </a:defRPr>
                       </a:pPr>
                       <a:r>
-                        <a:t>0.19</a:t>
+                        <a:t>0.48</a:t>
                       </a:r>
                     </a:p>
                   </a:txBody>
@@ -6840,7 +6840,7 @@
                         </a:defRPr>
                       </a:pPr>
                       <a:r>
-                        <a:t>0.07</a:t>
+                        <a:t>0.16</a:t>
                       </a:r>
                     </a:p>
                   </a:txBody>
@@ -6980,7 +6980,7 @@
                         </a:defRPr>
                       </a:pPr>
                       <a:r>
-                        <a:t>0.09</a:t>
+                        <a:t>0.23</a:t>
                       </a:r>
                     </a:p>
                   </a:txBody>
@@ -7120,7 +7120,7 @@
                         </a:defRPr>
                       </a:pPr>
                       <a:r>
-                        <a:t>0.04</a:t>
+                        <a:t>0.09</a:t>
                       </a:r>
                     </a:p>
                   </a:txBody>
@@ -7260,7 +7260,7 @@
                         </a:defRPr>
                       </a:pPr>
                       <a:r>
-                        <a:t>0.11</a:t>
+                        <a:t>0.24</a:t>
                       </a:r>
                     </a:p>
                   </a:txBody>
@@ -7946,7 +7946,7 @@
                         </a:defRPr>
                       </a:pPr>
                       <a:r>
-                        <a:t>0.27</a:t>
+                        <a:t>0.65</a:t>
                       </a:r>
                     </a:p>
                   </a:txBody>
@@ -8040,7 +8040,7 @@
                         </a:defRPr>
                       </a:pPr>
                       <a:r>
-                        <a:t>0.54</a:t>
+                        <a:t>1.31</a:t>
                       </a:r>
                     </a:p>
                   </a:txBody>
@@ -8134,7 +8134,7 @@
                         </a:defRPr>
                       </a:pPr>
                       <a:r>
-                        <a:t>0.90</a:t>
+                        <a:t>2.20</a:t>
                       </a:r>
                     </a:p>
                   </a:txBody>
@@ -8328,7 +8328,7 @@
               </a:defRPr>
             </a:pPr>
             <a:r>
-              <a:t>Base growth: 7.0x, 2026-2030</a:t>
+              <a:t>Base growth: 6.8x, 2026-2030</a:t>
             </a:r>
           </a:p>
         </p:txBody>
@@ -10989,7 +10989,7 @@
               </a:defRPr>
             </a:pPr>
             <a:r>
-              <a:t>Top 3 providers account for 73% of modeled 2030 generated-token supply.</a:t>
+              <a:t>Top 3 providers account for 72% of modeled 2030 generated-token supply.</a:t>
             </a:r>
           </a:p>
         </p:txBody>
@@ -12802,7 +12802,7 @@
                         </a:defRPr>
                       </a:pPr>
                       <a:r>
-                        <a:t>0.19</a:t>
+                        <a:t>0.48</a:t>
                       </a:r>
                     </a:p>
                   </a:txBody>
@@ -12896,7 +12896,7 @@
                         </a:defRPr>
                       </a:pPr>
                       <a:r>
-                        <a:t>0.11</a:t>
+                        <a:t>0.24</a:t>
                       </a:r>
                     </a:p>
                   </a:txBody>
@@ -12990,7 +12990,7 @@
                         </a:defRPr>
                       </a:pPr>
                       <a:r>
-                        <a:t>0.09</a:t>
+                        <a:t>0.23</a:t>
                       </a:r>
                     </a:p>
                   </a:txBody>
@@ -13084,7 +13084,7 @@
                         </a:defRPr>
                       </a:pPr>
                       <a:r>
-                        <a:t>0.07</a:t>
+                        <a:t>0.16</a:t>
                       </a:r>
                     </a:p>
                   </a:txBody>
@@ -13178,7 +13178,7 @@
                         </a:defRPr>
                       </a:pPr>
                       <a:r>
-                        <a:t>0.04</a:t>
+                        <a:t>0.09</a:t>
                       </a:r>
                     </a:p>
                   </a:txBody>
@@ -13304,7 +13304,7 @@
               </a:defRPr>
             </a:pPr>
             <a:r>
-              <a:t>73%</a:t>
+              <a:t>72%</a:t>
             </a:r>
           </a:p>
         </p:txBody>
@@ -13947,7 +13947,7 @@
                         </a:defRPr>
                       </a:pPr>
                       <a:r>
-                        <a:t>0.03</a:t>
+                        <a:t>0.07</a:t>
                       </a:r>
                     </a:p>
                   </a:txBody>
@@ -13970,7 +13970,7 @@
                         </a:defRPr>
                       </a:pPr>
                       <a:r>
-                        <a:t>0.10</a:t>
+                        <a:t>0.24</a:t>
                       </a:r>
                     </a:p>
                   </a:txBody>
@@ -13993,7 +13993,7 @@
                         </a:defRPr>
                       </a:pPr>
                       <a:r>
-                        <a:t>0.19</a:t>
+                        <a:t>0.48</a:t>
                       </a:r>
                     </a:p>
                   </a:txBody>
@@ -14016,7 +14016,7 @@
                         </a:defRPr>
                       </a:pPr>
                       <a:r>
-                        <a:t>6.2x</a:t>
+                        <a:t>6.5x</a:t>
                       </a:r>
                     </a:p>
                   </a:txBody>
@@ -14064,7 +14064,7 @@
                         </a:defRPr>
                       </a:pPr>
                       <a:r>
-                        <a:t>0.02</a:t>
+                        <a:t>0.04</a:t>
                       </a:r>
                     </a:p>
                   </a:txBody>
@@ -14087,7 +14087,7 @@
                         </a:defRPr>
                       </a:pPr>
                       <a:r>
-                        <a:t>0.06</a:t>
+                        <a:t>0.13</a:t>
                       </a:r>
                     </a:p>
                   </a:txBody>
@@ -14110,7 +14110,7 @@
                         </a:defRPr>
                       </a:pPr>
                       <a:r>
-                        <a:t>0.11</a:t>
+                        <a:t>0.24</a:t>
                       </a:r>
                     </a:p>
                   </a:txBody>
@@ -14133,7 +14133,7 @@
                         </a:defRPr>
                       </a:pPr>
                       <a:r>
-                        <a:t>5.1x</a:t>
+                        <a:t>5.4x</a:t>
                       </a:r>
                     </a:p>
                   </a:txBody>
@@ -14181,7 +14181,7 @@
                         </a:defRPr>
                       </a:pPr>
                       <a:r>
-                        <a:t>0.01</a:t>
+                        <a:t>0.02</a:t>
                       </a:r>
                     </a:p>
                   </a:txBody>
@@ -14204,7 +14204,7 @@
                         </a:defRPr>
                       </a:pPr>
                       <a:r>
-                        <a:t>0.04</a:t>
+                        <a:t>0.10</a:t>
                       </a:r>
                     </a:p>
                   </a:txBody>
@@ -14227,7 +14227,7 @@
                         </a:defRPr>
                       </a:pPr>
                       <a:r>
-                        <a:t>0.09</a:t>
+                        <a:t>0.23</a:t>
                       </a:r>
                     </a:p>
                   </a:txBody>
@@ -14250,7 +14250,7 @@
                         </a:defRPr>
                       </a:pPr>
                       <a:r>
-                        <a:t>9.6x</a:t>
+                        <a:t>10.2x</a:t>
                       </a:r>
                     </a:p>
                   </a:txBody>
@@ -14298,7 +14298,7 @@
                         </a:defRPr>
                       </a:pPr>
                       <a:r>
-                        <a:t>0.00</a:t>
+                        <a:t>0.01</a:t>
                       </a:r>
                     </a:p>
                   </a:txBody>
@@ -14321,7 +14321,7 @@
                         </a:defRPr>
                       </a:pPr>
                       <a:r>
-                        <a:t>0.03</a:t>
+                        <a:t>0.07</a:t>
                       </a:r>
                     </a:p>
                   </a:txBody>
@@ -14344,7 +14344,7 @@
                         </a:defRPr>
                       </a:pPr>
                       <a:r>
-                        <a:t>0.07</a:t>
+                        <a:t>0.16</a:t>
                       </a:r>
                     </a:p>
                   </a:txBody>
@@ -14367,7 +14367,7 @@
                         </a:defRPr>
                       </a:pPr>
                       <a:r>
-                        <a:t>14.9x</a:t>
+                        <a:t>15.6x</a:t>
                       </a:r>
                     </a:p>
                   </a:txBody>
@@ -14415,7 +14415,7 @@
                         </a:defRPr>
                       </a:pPr>
                       <a:r>
-                        <a:t>0.00</a:t>
+                        <a:t>0.01</a:t>
                       </a:r>
                     </a:p>
                   </a:txBody>
@@ -14438,7 +14438,7 @@
                         </a:defRPr>
                       </a:pPr>
                       <a:r>
-                        <a:t>0.02</a:t>
+                        <a:t>0.04</a:t>
                       </a:r>
                     </a:p>
                   </a:txBody>
@@ -14461,7 +14461,7 @@
                         </a:defRPr>
                       </a:pPr>
                       <a:r>
-                        <a:t>0.04</a:t>
+                        <a:t>0.09</a:t>
                       </a:r>
                     </a:p>
                   </a:txBody>
@@ -14484,7 +14484,7 @@
                         </a:defRPr>
                       </a:pPr>
                       <a:r>
-                        <a:t>9.7x</a:t>
+                        <a:t>10.4x</a:t>
                       </a:r>
                     </a:p>
                   </a:txBody>
@@ -14532,7 +14532,7 @@
                         </a:defRPr>
                       </a:pPr>
                       <a:r>
-                        <a:t>0.00</a:t>
+                        <a:t>0.02</a:t>
                       </a:r>
                     </a:p>
                   </a:txBody>
@@ -14555,7 +14555,7 @@
                         </a:defRPr>
                       </a:pPr>
                       <a:r>
-                        <a:t>0.01</a:t>
+                        <a:t>0.05</a:t>
                       </a:r>
                     </a:p>
                   </a:txBody>
@@ -14578,7 +14578,7 @@
                         </a:defRPr>
                       </a:pPr>
                       <a:r>
-                        <a:t>0.01</a:t>
+                        <a:t>0.05</a:t>
                       </a:r>
                     </a:p>
                   </a:txBody>
@@ -14601,7 +14601,7 @@
                         </a:defRPr>
                       </a:pPr>
                       <a:r>
-                        <a:t>7.5x</a:t>
+                        <a:t>3.1x</a:t>
                       </a:r>
                     </a:p>
                   </a:txBody>
@@ -14649,7 +14649,7 @@
                         </a:defRPr>
                       </a:pPr>
                       <a:r>
-                        <a:t>0.00</a:t>
+                        <a:t>0.01</a:t>
                       </a:r>
                     </a:p>
                   </a:txBody>
@@ -14672,7 +14672,7 @@
                         </a:defRPr>
                       </a:pPr>
                       <a:r>
-                        <a:t>0.01</a:t>
+                        <a:t>0.02</a:t>
                       </a:r>
                     </a:p>
                   </a:txBody>
@@ -14695,7 +14695,7 @@
                         </a:defRPr>
                       </a:pPr>
                       <a:r>
-                        <a:t>0.01</a:t>
+                        <a:t>0.03</a:t>
                       </a:r>
                     </a:p>
                   </a:txBody>
@@ -14718,7 +14718,7 @@
                         </a:defRPr>
                       </a:pPr>
                       <a:r>
-                        <a:t>4.0x</a:t>
+                        <a:t>2.6x</a:t>
                       </a:r>
                     </a:p>
                   </a:txBody>
@@ -14789,7 +14789,7 @@
                         </a:defRPr>
                       </a:pPr>
                       <a:r>
-                        <a:t>0.00</a:t>
+                        <a:t>0.01</a:t>
                       </a:r>
                     </a:p>
                   </a:txBody>
@@ -14812,7 +14812,7 @@
                         </a:defRPr>
                       </a:pPr>
                       <a:r>
-                        <a:t>0.01</a:t>
+                        <a:t>0.02</a:t>
                       </a:r>
                     </a:p>
                   </a:txBody>
@@ -14835,7 +14835,7 @@
                         </a:defRPr>
                       </a:pPr>
                       <a:r>
-                        <a:t>7.7x</a:t>
+                        <a:t>4.0x</a:t>
                       </a:r>
                     </a:p>
                   </a:txBody>
@@ -14929,7 +14929,7 @@
                         </a:defRPr>
                       </a:pPr>
                       <a:r>
-                        <a:t>0.00</a:t>
+                        <a:t>0.01</a:t>
                       </a:r>
                     </a:p>
                   </a:txBody>
@@ -14952,7 +14952,7 @@
                         </a:defRPr>
                       </a:pPr>
                       <a:r>
-                        <a:t>11.2x</a:t>
+                        <a:t>14.0x</a:t>
                       </a:r>
                     </a:p>
                   </a:txBody>
@@ -19129,7 +19129,7 @@
                         </a:defRPr>
                       </a:pPr>
                       <a:r>
-                        <a:t>0.03</a:t>
+                        <a:t>0.07</a:t>
                       </a:r>
                     </a:p>
                   </a:txBody>
@@ -19154,7 +19154,7 @@
                         </a:defRPr>
                       </a:pPr>
                       <a:r>
-                        <a:t>OpenAI</a:t>
+                        <a:t>Google</a:t>
                       </a:r>
                     </a:p>
                   </a:txBody>
@@ -19177,7 +19177,7 @@
                         </a:defRPr>
                       </a:pPr>
                       <a:r>
-                        <a:t>45%/25%/30%</a:t>
+                        <a:t>40%/40%/20%</a:t>
                       </a:r>
                     </a:p>
                   </a:txBody>
@@ -19200,7 +19200,7 @@
                         </a:defRPr>
                       </a:pPr>
                       <a:r>
-                        <a:t>50%</a:t>
+                        <a:t>60%</a:t>
                       </a:r>
                     </a:p>
                   </a:txBody>
@@ -19223,7 +19223,7 @@
                         </a:defRPr>
                       </a:pPr>
                       <a:r>
-                        <a:t>0.03</a:t>
+                        <a:t>0.11</a:t>
                       </a:r>
                     </a:p>
                   </a:txBody>
@@ -19248,7 +19248,7 @@
                         </a:defRPr>
                       </a:pPr>
                       <a:r>
-                        <a:t>Google</a:t>
+                        <a:t>OpenAI</a:t>
                       </a:r>
                     </a:p>
                   </a:txBody>
@@ -19271,7 +19271,7 @@
                         </a:defRPr>
                       </a:pPr>
                       <a:r>
-                        <a:t>40%/40%/20%</a:t>
+                        <a:t>45%/25%/30%</a:t>
                       </a:r>
                     </a:p>
                   </a:txBody>
@@ -19294,7 +19294,7 @@
                         </a:defRPr>
                       </a:pPr>
                       <a:r>
-                        <a:t>60%</a:t>
+                        <a:t>50%</a:t>
                       </a:r>
                     </a:p>
                   </a:txBody>
@@ -19317,7 +19317,7 @@
                         </a:defRPr>
                       </a:pPr>
                       <a:r>
-                        <a:t>0.04</a:t>
+                        <a:t>0.12</a:t>
                       </a:r>
                     </a:p>
                   </a:txBody>
@@ -19411,7 +19411,7 @@
                         </a:defRPr>
                       </a:pPr>
                       <a:r>
-                        <a:t>0.06</a:t>
+                        <a:t>0.16</a:t>
                       </a:r>
                     </a:p>
                   </a:txBody>
@@ -19505,7 +19505,7 @@
                         </a:defRPr>
                       </a:pPr>
                       <a:r>
-                        <a:t>0.29</a:t>
+                        <a:t>0.57</a:t>
                       </a:r>
                     </a:p>
                   </a:txBody>

</xml_diff>

<commit_message>
Update token capacity GPU mix methodology
</commit_message>
<xml_diff>
--- a/llm_token_capacity_project/outputs/reports/llm_token_capacity_2026_2030.pptx
+++ b/llm_token_capacity_project/outputs/reports/llm_token_capacity_2026_2030.pptx
@@ -160,16 +160,16 @@
                   <c:v>xAI</c:v>
                 </c:pt>
                 <c:pt idx="4">
+                  <c:v>OpenAI</c:v>
+                </c:pt>
+                <c:pt idx="5">
+                  <c:v>Google</c:v>
+                </c:pt>
+                <c:pt idx="6">
+                  <c:v>Anthropic</c:v>
+                </c:pt>
+                <c:pt idx="7">
                   <c:v>Alibaba</c:v>
-                </c:pt>
-                <c:pt idx="5">
-                  <c:v>OpenAI</c:v>
-                </c:pt>
-                <c:pt idx="6">
-                  <c:v>Google</c:v>
-                </c:pt>
-                <c:pt idx="7">
-                  <c:v>Anthropic</c:v>
                 </c:pt>
                 <c:pt idx="8">
                   <c:v>DeepSeek</c:v>
@@ -184,28 +184,28 @@
                 <c:formatCode>General</c:formatCode>
                 <c:ptCount val="9"/>
                 <c:pt idx="0">
-                  <c:v>0.4831356176064</c:v>
+                  <c:v>0.4936059624672</c:v>
                 </c:pt>
                 <c:pt idx="1">
-                  <c:v>0.237028502016</c:v>
+                  <c:v>0.240019987968</c:v>
                 </c:pt>
                 <c:pt idx="2">
                   <c:v>0.2305701679392</c:v>
                 </c:pt>
                 <c:pt idx="3">
-                  <c:v>0.1638686135808</c:v>
+                  <c:v>0.1743765496128</c:v>
                 </c:pt>
                 <c:pt idx="4">
-                  <c:v>0.086238041472</c:v>
+                  <c:v>0.0414590596992</c:v>
                 </c:pt>
                 <c:pt idx="5">
-                  <c:v>0.0517341382272</c:v>
+                  <c:v>0.0323625925152</c:v>
                 </c:pt>
                 <c:pt idx="6">
-                  <c:v>0.0342435993984</c:v>
+                  <c:v>0.02410147872</c:v>
                 </c:pt>
                 <c:pt idx="7">
-                  <c:v>0.0190656662976</c:v>
+                  <c:v>0.0226438101504</c:v>
                 </c:pt>
                 <c:pt idx="8">
                   <c:v>0.0088044739776</c:v>
@@ -373,19 +373,19 @@
                 <c:formatCode>General</c:formatCode>
                 <c:ptCount val="5"/>
                 <c:pt idx="0">
-                  <c:v>0.074391378048</c:v>
+                  <c:v>0.101332129248</c:v>
                 </c:pt>
                 <c:pt idx="1">
-                  <c:v>0.1465981659648</c:v>
+                  <c:v>0.1832039646912</c:v>
                 </c:pt>
                 <c:pt idx="2">
-                  <c:v>0.2392598855232</c:v>
+                  <c:v>0.2759039628192</c:v>
                 </c:pt>
                 <c:pt idx="3">
-                  <c:v>0.3522462844896</c:v>
+                  <c:v>0.3789791953056</c:v>
                 </c:pt>
                 <c:pt idx="4">
-                  <c:v>0.4831356176064</c:v>
+                  <c:v>0.4936059624672</c:v>
                 </c:pt>
               </c:numCache>
             </c:numRef>
@@ -436,19 +436,19 @@
                 <c:formatCode>General</c:formatCode>
                 <c:ptCount val="5"/>
                 <c:pt idx="0">
-                  <c:v>0.04372378704</c:v>
+                  <c:v>0.0492480036288</c:v>
                 </c:pt>
                 <c:pt idx="1">
-                  <c:v>0.08142095808</c:v>
+                  <c:v>0.088543958976</c:v>
                 </c:pt>
                 <c:pt idx="2">
-                  <c:v>0.1263363277824</c:v>
+                  <c:v>0.1334745298944</c:v>
                 </c:pt>
                 <c:pt idx="3">
-                  <c:v>0.1783386388224</c:v>
+                  <c:v>0.1839665395584</c:v>
                 </c:pt>
                 <c:pt idx="4">
-                  <c:v>0.237028502016</c:v>
+                  <c:v>0.240019987968</c:v>
                 </c:pt>
               </c:numCache>
             </c:numRef>
@@ -562,19 +562,19 @@
                 <c:formatCode>General</c:formatCode>
                 <c:ptCount val="5"/>
                 <c:pt idx="0">
-                  <c:v>0.010520177184</c:v>
+                  <c:v>0.015735373632</c:v>
                 </c:pt>
                 <c:pt idx="1">
-                  <c:v>0.0333777445632</c:v>
+                  <c:v>0.0453464858304</c:v>
                 </c:pt>
                 <c:pt idx="2">
-                  <c:v>0.0656840174976</c:v>
+                  <c:v>0.0816808940352</c:v>
                 </c:pt>
                 <c:pt idx="3">
-                  <c:v>0.1087278494976</c:v>
+                  <c:v>0.1247385982464</c:v>
                 </c:pt>
                 <c:pt idx="4">
-                  <c:v>0.1638686135808</c:v>
+                  <c:v>0.1743765496128</c:v>
                 </c:pt>
               </c:numCache>
             </c:numRef>
@@ -590,7 +590,7 @@
               <c:strCache>
                 <c:ptCount val="1"/>
                 <c:pt idx="0">
-                  <c:v>Alibaba</c:v>
+                  <c:v>OpenAI</c:v>
                 </c:pt>
               </c:strCache>
             </c:strRef>
@@ -625,19 +625,19 @@
                 <c:formatCode>General</c:formatCode>
                 <c:ptCount val="5"/>
                 <c:pt idx="0">
-                  <c:v>0.0082845116928</c:v>
+                  <c:v>0.0055662012</c:v>
                 </c:pt>
                 <c:pt idx="1">
-                  <c:v>0.0204044645376</c:v>
+                  <c:v>0.0128343299904</c:v>
                 </c:pt>
                 <c:pt idx="2">
-                  <c:v>0.037020820608</c:v>
+                  <c:v>0.0301847219712</c:v>
                 </c:pt>
                 <c:pt idx="3">
-                  <c:v>0.0587349190656</c:v>
+                  <c:v>0.03697830144</c:v>
                 </c:pt>
                 <c:pt idx="4">
-                  <c:v>0.086238041472</c:v>
+                  <c:v>0.0414590596992</c:v>
                 </c:pt>
               </c:numCache>
             </c:numRef>
@@ -1006,7 +1006,7 @@
               <c:strCache>
                 <c:ptCount val="1"/>
                 <c:pt idx="0">
-                  <c:v>Alibaba</c:v>
+                  <c:v>OpenAI</c:v>
                 </c:pt>
               </c:strCache>
             </c:strRef>
@@ -1041,19 +1041,19 @@
                 <c:formatCode>General</c:formatCode>
                 <c:ptCount val="5"/>
                 <c:pt idx="0">
-                  <c:v>0.266</c:v>
+                  <c:v>0.595</c:v>
                 </c:pt>
                 <c:pt idx="1">
-                  <c:v>0.572</c:v>
+                  <c:v>1.467</c:v>
                 </c:pt>
                 <c:pt idx="2">
-                  <c:v>0.92</c:v>
+                  <c:v>2.468</c:v>
                 </c:pt>
                 <c:pt idx="3">
-                  <c:v>1.312</c:v>
+                  <c:v>3.6</c:v>
                 </c:pt>
                 <c:pt idx="4">
-                  <c:v>1.748</c:v>
+                  <c:v>4.862</c:v>
                 </c:pt>
               </c:numCache>
             </c:numRef>
@@ -1193,16 +1193,16 @@
                   <c:v>xAI</c:v>
                 </c:pt>
                 <c:pt idx="4">
+                  <c:v>OpenAI</c:v>
+                </c:pt>
+                <c:pt idx="5">
+                  <c:v>Google</c:v>
+                </c:pt>
+                <c:pt idx="6">
+                  <c:v>Anthropic</c:v>
+                </c:pt>
+                <c:pt idx="7">
                   <c:v>Alibaba</c:v>
-                </c:pt>
-                <c:pt idx="5">
-                  <c:v>OpenAI</c:v>
-                </c:pt>
-                <c:pt idx="6">
-                  <c:v>Google</c:v>
-                </c:pt>
-                <c:pt idx="7">
-                  <c:v>Anthropic</c:v>
                 </c:pt>
                 <c:pt idx="8">
                   <c:v>DeepSeek</c:v>
@@ -1229,16 +1229,16 @@
                   <c:v>3.0</c:v>
                 </c:pt>
                 <c:pt idx="4">
+                  <c:v>12.0</c:v>
+                </c:pt>
+                <c:pt idx="5">
+                  <c:v>8.0</c:v>
+                </c:pt>
+                <c:pt idx="6">
+                  <c:v>7.0</c:v>
+                </c:pt>
+                <c:pt idx="7">
                   <c:v>4.0</c:v>
-                </c:pt>
-                <c:pt idx="5">
-                  <c:v>12.0</c:v>
-                </c:pt>
-                <c:pt idx="6">
-                  <c:v>8.0</c:v>
-                </c:pt>
-                <c:pt idx="7">
-                  <c:v>7.0</c:v>
                 </c:pt>
                 <c:pt idx="8">
                   <c:v>1.8</c:v>
@@ -1279,16 +1279,16 @@
                   <c:v>xAI</c:v>
                 </c:pt>
                 <c:pt idx="4">
+                  <c:v>OpenAI</c:v>
+                </c:pt>
+                <c:pt idx="5">
+                  <c:v>Google</c:v>
+                </c:pt>
+                <c:pt idx="6">
+                  <c:v>Anthropic</c:v>
+                </c:pt>
+                <c:pt idx="7">
                   <c:v>Alibaba</c:v>
-                </c:pt>
-                <c:pt idx="5">
-                  <c:v>OpenAI</c:v>
-                </c:pt>
-                <c:pt idx="6">
-                  <c:v>Google</c:v>
-                </c:pt>
-                <c:pt idx="7">
-                  <c:v>Anthropic</c:v>
                 </c:pt>
                 <c:pt idx="8">
                   <c:v>DeepSeek</c:v>
@@ -1315,16 +1315,16 @@
                   <c:v>2.5</c:v>
                 </c:pt>
                 <c:pt idx="4">
+                  <c:v>8.5</c:v>
+                </c:pt>
+                <c:pt idx="5">
+                  <c:v>6.8</c:v>
+                </c:pt>
+                <c:pt idx="6">
+                  <c:v>5.5</c:v>
+                </c:pt>
+                <c:pt idx="7">
                   <c:v>3.2</c:v>
-                </c:pt>
-                <c:pt idx="5">
-                  <c:v>8.5</c:v>
-                </c:pt>
-                <c:pt idx="6">
-                  <c:v>6.8</c:v>
-                </c:pt>
-                <c:pt idx="7">
-                  <c:v>5.5</c:v>
                 </c:pt>
                 <c:pt idx="8">
                   <c:v>1.2</c:v>
@@ -1483,16 +1483,16 @@
                   <c:v>xAI</c:v>
                 </c:pt>
                 <c:pt idx="4">
+                  <c:v>OpenAI</c:v>
+                </c:pt>
+                <c:pt idx="5">
+                  <c:v>Google</c:v>
+                </c:pt>
+                <c:pt idx="6">
+                  <c:v>Anthropic</c:v>
+                </c:pt>
+                <c:pt idx="7">
                   <c:v>Alibaba</c:v>
-                </c:pt>
-                <c:pt idx="5">
-                  <c:v>OpenAI</c:v>
-                </c:pt>
-                <c:pt idx="6">
-                  <c:v>Google</c:v>
-                </c:pt>
-                <c:pt idx="7">
-                  <c:v>Anthropic</c:v>
                 </c:pt>
                 <c:pt idx="8">
                   <c:v>DeepSeek</c:v>
@@ -1519,16 +1519,16 @@
                   <c:v>1.219</c:v>
                 </c:pt>
                 <c:pt idx="4">
+                  <c:v>4.862</c:v>
+                </c:pt>
+                <c:pt idx="5">
+                  <c:v>3.651</c:v>
+                </c:pt>
+                <c:pt idx="6">
+                  <c:v>2.966</c:v>
+                </c:pt>
+                <c:pt idx="7">
                   <c:v>1.748</c:v>
-                </c:pt>
-                <c:pt idx="5">
-                  <c:v>4.862</c:v>
-                </c:pt>
-                <c:pt idx="6">
-                  <c:v>3.651</c:v>
-                </c:pt>
-                <c:pt idx="7">
-                  <c:v>2.966</c:v>
                 </c:pt>
                 <c:pt idx="8">
                   <c:v>0.651</c:v>
@@ -1569,16 +1569,16 @@
                   <c:v>xAI</c:v>
                 </c:pt>
                 <c:pt idx="4">
+                  <c:v>OpenAI</c:v>
+                </c:pt>
+                <c:pt idx="5">
+                  <c:v>Google</c:v>
+                </c:pt>
+                <c:pt idx="6">
+                  <c:v>Anthropic</c:v>
+                </c:pt>
+                <c:pt idx="7">
                   <c:v>Alibaba</c:v>
-                </c:pt>
-                <c:pt idx="5">
-                  <c:v>OpenAI</c:v>
-                </c:pt>
-                <c:pt idx="6">
-                  <c:v>Google</c:v>
-                </c:pt>
-                <c:pt idx="7">
-                  <c:v>Anthropic</c:v>
                 </c:pt>
                 <c:pt idx="8">
                   <c:v>DeepSeek</c:v>
@@ -1605,16 +1605,16 @@
                   <c:v>0.523</c:v>
                 </c:pt>
                 <c:pt idx="4">
+                  <c:v>1.371</c:v>
+                </c:pt>
+                <c:pt idx="5">
+                  <c:v>1.42</c:v>
+                </c:pt>
+                <c:pt idx="6">
+                  <c:v>1.042</c:v>
+                </c:pt>
+                <c:pt idx="7">
                   <c:v>0.437</c:v>
-                </c:pt>
-                <c:pt idx="5">
-                  <c:v>1.371</c:v>
-                </c:pt>
-                <c:pt idx="6">
-                  <c:v>1.42</c:v>
-                </c:pt>
-                <c:pt idx="7">
-                  <c:v>1.042</c:v>
                 </c:pt>
                 <c:pt idx="8">
                   <c:v>0.143</c:v>
@@ -1774,16 +1774,16 @@
                   <c:v>xAI</c:v>
                 </c:pt>
                 <c:pt idx="4">
+                  <c:v>OpenAI</c:v>
+                </c:pt>
+                <c:pt idx="5">
+                  <c:v>Google</c:v>
+                </c:pt>
+                <c:pt idx="6">
+                  <c:v>Anthropic</c:v>
+                </c:pt>
+                <c:pt idx="7">
                   <c:v>Alibaba</c:v>
-                </c:pt>
-                <c:pt idx="5">
-                  <c:v>OpenAI</c:v>
-                </c:pt>
-                <c:pt idx="6">
-                  <c:v>Google</c:v>
-                </c:pt>
-                <c:pt idx="7">
-                  <c:v>Anthropic</c:v>
                 </c:pt>
                 <c:pt idx="8">
                   <c:v>DeepSeek</c:v>
@@ -1798,28 +1798,28 @@
                 <c:formatCode>General</c:formatCode>
                 <c:ptCount val="9"/>
                 <c:pt idx="0">
-                  <c:v>1.677722</c:v>
+                  <c:v>1.714081</c:v>
                 </c:pt>
                 <c:pt idx="1">
-                  <c:v>0.836398</c:v>
+                  <c:v>0.846954</c:v>
                 </c:pt>
                 <c:pt idx="2">
                   <c:v>2.035573</c:v>
                 </c:pt>
                 <c:pt idx="3">
-                  <c:v>1.555888</c:v>
+                  <c:v>1.655658</c:v>
                 </c:pt>
                 <c:pt idx="4">
-                  <c:v>0.57101</c:v>
+                  <c:v>0.098694</c:v>
                 </c:pt>
                 <c:pt idx="5">
-                  <c:v>0.123154</c:v>
+                  <c:v>0.102593</c:v>
                 </c:pt>
                 <c:pt idx="6">
-                  <c:v>0.108556</c:v>
+                  <c:v>0.09405</c:v>
                 </c:pt>
                 <c:pt idx="7">
-                  <c:v>0.074399</c:v>
+                  <c:v>0.149932</c:v>
                 </c:pt>
                 <c:pt idx="8">
                   <c:v>0.156534</c:v>
@@ -1988,19 +1988,19 @@
                 <c:formatCode>General</c:formatCode>
                 <c:ptCount val="5"/>
                 <c:pt idx="0">
-                  <c:v>0.105</c:v>
+                  <c:v>0.114</c:v>
                 </c:pt>
                 <c:pt idx="1">
-                  <c:v>0.213</c:v>
+                  <c:v>0.221</c:v>
                 </c:pt>
                 <c:pt idx="2">
-                  <c:v>0.341</c:v>
+                  <c:v>0.346</c:v>
                 </c:pt>
                 <c:pt idx="3">
-                  <c:v>0.488</c:v>
+                  <c:v>0.479</c:v>
                 </c:pt>
                 <c:pt idx="4">
-                  <c:v>0.653</c:v>
+                  <c:v>0.626</c:v>
                 </c:pt>
               </c:numCache>
             </c:numRef>
@@ -2051,19 +2051,19 @@
                 <c:formatCode>General</c:formatCode>
                 <c:ptCount val="5"/>
                 <c:pt idx="0">
-                  <c:v>0.195</c:v>
+                  <c:v>0.21</c:v>
                 </c:pt>
                 <c:pt idx="1">
-                  <c:v>0.403</c:v>
+                  <c:v>0.418</c:v>
                 </c:pt>
                 <c:pt idx="2">
-                  <c:v>0.659</c:v>
+                  <c:v>0.671</c:v>
                 </c:pt>
                 <c:pt idx="3">
-                  <c:v>0.963</c:v>
+                  <c:v>0.951</c:v>
                 </c:pt>
                 <c:pt idx="4">
-                  <c:v>1.315</c:v>
+                  <c:v>1.268</c:v>
                 </c:pt>
               </c:numCache>
             </c:numRef>
@@ -2114,19 +2114,19 @@
                 <c:formatCode>General</c:formatCode>
                 <c:ptCount val="5"/>
                 <c:pt idx="0">
-                  <c:v>0.286</c:v>
+                  <c:v>0.309</c:v>
                 </c:pt>
                 <c:pt idx="1">
-                  <c:v>0.615</c:v>
+                  <c:v>0.639</c:v>
                 </c:pt>
                 <c:pt idx="2">
-                  <c:v>1.038</c:v>
+                  <c:v>1.062</c:v>
                 </c:pt>
                 <c:pt idx="3">
-                  <c:v>1.566</c:v>
+                  <c:v>1.555</c:v>
                 </c:pt>
                 <c:pt idx="4">
-                  <c:v>2.203</c:v>
+                  <c:v>2.14</c:v>
                 </c:pt>
               </c:numCache>
             </c:numRef>
@@ -5606,7 +5606,7 @@
               </a:defRPr>
             </a:pPr>
             <a:r>
-              <a:t>1.31Q</a:t>
+              <a:t>1.27Q</a:t>
             </a:r>
           </a:p>
         </p:txBody>
@@ -5711,7 +5711,7 @@
               </a:defRPr>
             </a:pPr>
             <a:r>
-              <a:t>2026-07-23</a:t>
+              <a:t>2026-07-30</a:t>
             </a:r>
           </a:p>
         </p:txBody>
@@ -6117,7 +6117,7 @@
                         </a:defRPr>
                       </a:pPr>
                       <a:r>
-                        <a:t>Anthropic</a:t>
+                        <a:t>OpenAI</a:t>
                       </a:r>
                     </a:p>
                   </a:txBody>
@@ -6140,7 +6140,7 @@
                         </a:defRPr>
                       </a:pPr>
                       <a:r>
-                        <a:t>0.02</a:t>
+                        <a:t>0.04</a:t>
                       </a:r>
                     </a:p>
                   </a:txBody>
@@ -6163,7 +6163,7 @@
                         </a:defRPr>
                       </a:pPr>
                       <a:r>
-                        <a:t>3.0</a:t>
+                        <a:t>4.9</a:t>
                       </a:r>
                     </a:p>
                   </a:txBody>
@@ -6186,7 +6186,7 @@
                         </a:defRPr>
                       </a:pPr>
                       <a:r>
-                        <a:t>21%</a:t>
+                        <a:t>29%</a:t>
                       </a:r>
                     </a:p>
                   </a:txBody>
@@ -6209,7 +6209,7 @@
                         </a:defRPr>
                       </a:pPr>
                       <a:r>
-                        <a:t>Training allocation</a:t>
+                        <a:t>Serving efficiency</a:t>
                       </a:r>
                     </a:p>
                   </a:txBody>
@@ -6232,7 +6232,7 @@
                         </a:defRPr>
                       </a:pPr>
                       <a:r>
-                        <a:t>training cadence, launch schedule, commercial serving ramp</a:t>
+                        <a:t>model routing, precision, batching, TTFT/TPOT target</a:t>
                       </a:r>
                     </a:p>
                   </a:txBody>
@@ -6257,7 +6257,7 @@
                         </a:defRPr>
                       </a:pPr>
                       <a:r>
-                        <a:t>DeepSeek</a:t>
+                        <a:t>Anthropic</a:t>
                       </a:r>
                     </a:p>
                   </a:txBody>
@@ -6280,7 +6280,7 @@
                         </a:defRPr>
                       </a:pPr>
                       <a:r>
-                        <a:t>0.01</a:t>
+                        <a:t>0.02</a:t>
                       </a:r>
                     </a:p>
                   </a:txBody>
@@ -6303,7 +6303,7 @@
                         </a:defRPr>
                       </a:pPr>
                       <a:r>
-                        <a:t>0.7</a:t>
+                        <a:t>3.0</a:t>
                       </a:r>
                     </a:p>
                   </a:txBody>
@@ -6326,7 +6326,7 @@
                         </a:defRPr>
                       </a:pPr>
                       <a:r>
-                        <a:t>33%</a:t>
+                        <a:t>21%</a:t>
                       </a:r>
                     </a:p>
                   </a:txBody>
@@ -6349,7 +6349,7 @@
                         </a:defRPr>
                       </a:pPr>
                       <a:r>
-                        <a:t>Deployment gap</a:t>
+                        <a:t>Training allocation</a:t>
                       </a:r>
                     </a:p>
                   </a:txBody>
@@ -6372,7 +6372,7 @@
                         </a:defRPr>
                       </a:pPr>
                       <a:r>
-                        <a:t>site energization, rack deployment, accelerator delivery</a:t>
+                        <a:t>training cadence, launch schedule, commercial serving ramp</a:t>
                       </a:r>
                     </a:p>
                   </a:txBody>
@@ -6397,7 +6397,7 @@
                         </a:defRPr>
                       </a:pPr>
                       <a:r>
-                        <a:t>OpenAI</a:t>
+                        <a:t>Google</a:t>
                       </a:r>
                     </a:p>
                   </a:txBody>
@@ -6420,7 +6420,7 @@
                         </a:defRPr>
                       </a:pPr>
                       <a:r>
-                        <a:t>0.05</a:t>
+                        <a:t>0.03</a:t>
                       </a:r>
                     </a:p>
                   </a:txBody>
@@ -6443,7 +6443,7 @@
                         </a:defRPr>
                       </a:pPr>
                       <a:r>
-                        <a:t>4.9</a:t>
+                        <a:t>3.7</a:t>
                       </a:r>
                     </a:p>
                   </a:txBody>
@@ -6466,7 +6466,7 @@
                         </a:defRPr>
                       </a:pPr>
                       <a:r>
-                        <a:t>29%</a:t>
+                        <a:t>15%</a:t>
                       </a:r>
                     </a:p>
                   </a:txBody>
@@ -6489,7 +6489,7 @@
                         </a:defRPr>
                       </a:pPr>
                       <a:r>
-                        <a:t>Serving efficiency</a:t>
+                        <a:t>Training allocation</a:t>
                       </a:r>
                     </a:p>
                   </a:txBody>
@@ -6512,7 +6512,7 @@
                         </a:defRPr>
                       </a:pPr>
                       <a:r>
-                        <a:t>model routing, precision, batching, TTFT/TPOT target</a:t>
+                        <a:t>training cadence, launch schedule, commercial serving ramp</a:t>
                       </a:r>
                     </a:p>
                   </a:txBody>
@@ -6537,7 +6537,7 @@
                         </a:defRPr>
                       </a:pPr>
                       <a:r>
-                        <a:t>Google</a:t>
+                        <a:t>Microsoft</a:t>
                       </a:r>
                     </a:p>
                   </a:txBody>
@@ -6560,7 +6560,7 @@
                         </a:defRPr>
                       </a:pPr>
                       <a:r>
-                        <a:t>0.03</a:t>
+                        <a:t>0.49</a:t>
                       </a:r>
                     </a:p>
                   </a:txBody>
@@ -6583,7 +6583,7 @@
                         </a:defRPr>
                       </a:pPr>
                       <a:r>
-                        <a:t>3.7</a:t>
+                        <a:t>3.3</a:t>
                       </a:r>
                     </a:p>
                   </a:txBody>
@@ -6606,7 +6606,7 @@
                         </a:defRPr>
                       </a:pPr>
                       <a:r>
-                        <a:t>15%</a:t>
+                        <a:t>31%</a:t>
                       </a:r>
                     </a:p>
                   </a:txBody>
@@ -6677,7 +6677,7 @@
                         </a:defRPr>
                       </a:pPr>
                       <a:r>
-                        <a:t>Microsoft</a:t>
+                        <a:t>DeepSeek</a:t>
                       </a:r>
                     </a:p>
                   </a:txBody>
@@ -6700,7 +6700,7 @@
                         </a:defRPr>
                       </a:pPr>
                       <a:r>
-                        <a:t>0.48</a:t>
+                        <a:t>0.01</a:t>
                       </a:r>
                     </a:p>
                   </a:txBody>
@@ -6723,7 +6723,7 @@
                         </a:defRPr>
                       </a:pPr>
                       <a:r>
-                        <a:t>3.3</a:t>
+                        <a:t>0.7</a:t>
                       </a:r>
                     </a:p>
                   </a:txBody>
@@ -6746,7 +6746,7 @@
                         </a:defRPr>
                       </a:pPr>
                       <a:r>
-                        <a:t>31%</a:t>
+                        <a:t>33%</a:t>
                       </a:r>
                     </a:p>
                   </a:txBody>
@@ -6769,7 +6769,7 @@
                         </a:defRPr>
                       </a:pPr>
                       <a:r>
-                        <a:t>Training allocation</a:t>
+                        <a:t>Deployment gap</a:t>
                       </a:r>
                     </a:p>
                   </a:txBody>
@@ -6792,7 +6792,7 @@
                         </a:defRPr>
                       </a:pPr>
                       <a:r>
-                        <a:t>training cadence, launch schedule, commercial serving ramp</a:t>
+                        <a:t>site energization, rack deployment, accelerator delivery</a:t>
                       </a:r>
                     </a:p>
                   </a:txBody>
@@ -6817,7 +6817,7 @@
                         </a:defRPr>
                       </a:pPr>
                       <a:r>
-                        <a:t>xAI</a:t>
+                        <a:t>Alibaba</a:t>
                       </a:r>
                     </a:p>
                   </a:txBody>
@@ -6840,7 +6840,7 @@
                         </a:defRPr>
                       </a:pPr>
                       <a:r>
-                        <a:t>0.16</a:t>
+                        <a:t>0.02</a:t>
                       </a:r>
                     </a:p>
                   </a:txBody>
@@ -6863,7 +6863,7 @@
                         </a:defRPr>
                       </a:pPr>
                       <a:r>
-                        <a:t>1.2</a:t>
+                        <a:t>1.7</a:t>
                       </a:r>
                     </a:p>
                   </a:txBody>
@@ -6886,7 +6886,7 @@
                         </a:defRPr>
                       </a:pPr>
                       <a:r>
-                        <a:t>17%</a:t>
+                        <a:t>20%</a:t>
                       </a:r>
                     </a:p>
                   </a:txBody>
@@ -6909,7 +6909,7 @@
                         </a:defRPr>
                       </a:pPr>
                       <a:r>
-                        <a:t>Training allocation</a:t>
+                        <a:t>Serving efficiency</a:t>
                       </a:r>
                     </a:p>
                   </a:txBody>
@@ -6932,7 +6932,7 @@
                         </a:defRPr>
                       </a:pPr>
                       <a:r>
-                        <a:t>training cadence, launch schedule, commercial serving ramp</a:t>
+                        <a:t>model routing, precision, batching, TTFT/TPOT target</a:t>
                       </a:r>
                     </a:p>
                   </a:txBody>
@@ -6957,7 +6957,7 @@
                         </a:defRPr>
                       </a:pPr>
                       <a:r>
-                        <a:t>Tencent</a:t>
+                        <a:t>xAI</a:t>
                       </a:r>
                     </a:p>
                   </a:txBody>
@@ -6980,7 +6980,7 @@
                         </a:defRPr>
                       </a:pPr>
                       <a:r>
-                        <a:t>0.23</a:t>
+                        <a:t>0.17</a:t>
                       </a:r>
                     </a:p>
                   </a:txBody>
@@ -7003,7 +7003,7 @@
                         </a:defRPr>
                       </a:pPr>
                       <a:r>
-                        <a:t>1.3</a:t>
+                        <a:t>1.2</a:t>
                       </a:r>
                     </a:p>
                   </a:txBody>
@@ -7026,7 +7026,7 @@
                         </a:defRPr>
                       </a:pPr>
                       <a:r>
-                        <a:t>20%</a:t>
+                        <a:t>17%</a:t>
                       </a:r>
                     </a:p>
                   </a:txBody>
@@ -7049,7 +7049,7 @@
                         </a:defRPr>
                       </a:pPr>
                       <a:r>
-                        <a:t>Scale absorption</a:t>
+                        <a:t>Training allocation</a:t>
                       </a:r>
                     </a:p>
                   </a:txBody>
@@ -7072,7 +7072,7 @@
                         </a:defRPr>
                       </a:pPr>
                       <a:r>
-                        <a:t>demand absorption and product surface expansion</a:t>
+                        <a:t>training cadence, launch schedule, commercial serving ramp</a:t>
                       </a:r>
                     </a:p>
                   </a:txBody>
@@ -7097,7 +7097,7 @@
                         </a:defRPr>
                       </a:pPr>
                       <a:r>
-                        <a:t>Alibaba</a:t>
+                        <a:t>Tencent</a:t>
                       </a:r>
                     </a:p>
                   </a:txBody>
@@ -7120,7 +7120,7 @@
                         </a:defRPr>
                       </a:pPr>
                       <a:r>
-                        <a:t>0.09</a:t>
+                        <a:t>0.23</a:t>
                       </a:r>
                     </a:p>
                   </a:txBody>
@@ -7143,7 +7143,7 @@
                         </a:defRPr>
                       </a:pPr>
                       <a:r>
-                        <a:t>1.7</a:t>
+                        <a:t>1.3</a:t>
                       </a:r>
                     </a:p>
                   </a:txBody>
@@ -7512,7 +7512,7 @@
               </a:defRPr>
             </a:pPr>
             <a:r>
-              <a:t>2026-07-23</a:t>
+              <a:t>2026-07-30</a:t>
             </a:r>
           </a:p>
         </p:txBody>
@@ -7946,7 +7946,7 @@
                         </a:defRPr>
                       </a:pPr>
                       <a:r>
-                        <a:t>0.65</a:t>
+                        <a:t>0.63</a:t>
                       </a:r>
                     </a:p>
                   </a:txBody>
@@ -8040,7 +8040,7 @@
                         </a:defRPr>
                       </a:pPr>
                       <a:r>
-                        <a:t>1.31</a:t>
+                        <a:t>1.27</a:t>
                       </a:r>
                     </a:p>
                   </a:txBody>
@@ -8134,7 +8134,7 @@
                         </a:defRPr>
                       </a:pPr>
                       <a:r>
-                        <a:t>2.20</a:t>
+                        <a:t>2.14</a:t>
                       </a:r>
                     </a:p>
                   </a:txBody>
@@ -8328,7 +8328,7 @@
               </a:defRPr>
             </a:pPr>
             <a:r>
-              <a:t>Base growth: 6.8x, 2026-2030</a:t>
+              <a:t>Base growth: 6.0x, 2026-2030</a:t>
             </a:r>
           </a:p>
         </p:txBody>
@@ -8478,7 +8478,7 @@
               </a:defRPr>
             </a:pPr>
             <a:r>
-              <a:t>2026-07-23</a:t>
+              <a:t>2026-07-30</a:t>
             </a:r>
           </a:p>
         </p:txBody>
@@ -9337,7 +9337,7 @@
               </a:defRPr>
             </a:pPr>
             <a:r>
-              <a:t>2026-07-23</a:t>
+              <a:t>2026-07-30</a:t>
             </a:r>
           </a:p>
         </p:txBody>
@@ -10318,7 +10318,7 @@
               </a:defRPr>
             </a:pPr>
             <a:r>
-              <a:t>2026-07-23</a:t>
+              <a:t>2026-07-30</a:t>
             </a:r>
           </a:p>
         </p:txBody>
@@ -10989,7 +10989,7 @@
               </a:defRPr>
             </a:pPr>
             <a:r>
-              <a:t>Top 3 providers account for 72% of modeled 2030 generated-token supply.</a:t>
+              <a:t>Top 3 providers account for 76% of modeled 2030 generated-token supply.</a:t>
             </a:r>
           </a:p>
         </p:txBody>
@@ -11174,7 +11174,7 @@
               </a:defRPr>
             </a:pPr>
             <a:r>
-              <a:t>2026-07-23</a:t>
+              <a:t>2026-07-30</a:t>
             </a:r>
           </a:p>
         </p:txBody>
@@ -12368,7 +12368,7 @@
               </a:defRPr>
             </a:pPr>
             <a:r>
-              <a:t>2026-07-23</a:t>
+              <a:t>2026-07-30</a:t>
             </a:r>
           </a:p>
         </p:txBody>
@@ -12802,7 +12802,7 @@
                         </a:defRPr>
                       </a:pPr>
                       <a:r>
-                        <a:t>0.48</a:t>
+                        <a:t>0.49</a:t>
                       </a:r>
                     </a:p>
                   </a:txBody>
@@ -13084,7 +13084,7 @@
                         </a:defRPr>
                       </a:pPr>
                       <a:r>
-                        <a:t>0.16</a:t>
+                        <a:t>0.17</a:t>
                       </a:r>
                     </a:p>
                   </a:txBody>
@@ -13155,7 +13155,7 @@
                         </a:defRPr>
                       </a:pPr>
                       <a:r>
-                        <a:t>Alibaba</a:t>
+                        <a:t>OpenAI</a:t>
                       </a:r>
                     </a:p>
                   </a:txBody>
@@ -13178,7 +13178,7 @@
                         </a:defRPr>
                       </a:pPr>
                       <a:r>
-                        <a:t>0.09</a:t>
+                        <a:t>0.04</a:t>
                       </a:r>
                     </a:p>
                   </a:txBody>
@@ -13201,7 +13201,7 @@
                         </a:defRPr>
                       </a:pPr>
                       <a:r>
-                        <a:t>1.7</a:t>
+                        <a:t>4.9</a:t>
                       </a:r>
                     </a:p>
                   </a:txBody>
@@ -13224,7 +13224,7 @@
                         </a:defRPr>
                       </a:pPr>
                       <a:r>
-                        <a:t>3.2</a:t>
+                        <a:t>8.5</a:t>
                       </a:r>
                     </a:p>
                   </a:txBody>
@@ -13304,7 +13304,7 @@
               </a:defRPr>
             </a:pPr>
             <a:r>
-              <a:t>72%</a:t>
+              <a:t>76%</a:t>
             </a:r>
           </a:p>
         </p:txBody>
@@ -13489,7 +13489,7 @@
               </a:defRPr>
             </a:pPr>
             <a:r>
-              <a:t>2026-07-23</a:t>
+              <a:t>2026-07-30</a:t>
             </a:r>
           </a:p>
         </p:txBody>
@@ -13947,7 +13947,7 @@
                         </a:defRPr>
                       </a:pPr>
                       <a:r>
-                        <a:t>0.07</a:t>
+                        <a:t>0.10</a:t>
                       </a:r>
                     </a:p>
                   </a:txBody>
@@ -13970,7 +13970,7 @@
                         </a:defRPr>
                       </a:pPr>
                       <a:r>
-                        <a:t>0.24</a:t>
+                        <a:t>0.28</a:t>
                       </a:r>
                     </a:p>
                   </a:txBody>
@@ -13993,7 +13993,7 @@
                         </a:defRPr>
                       </a:pPr>
                       <a:r>
-                        <a:t>0.48</a:t>
+                        <a:t>0.49</a:t>
                       </a:r>
                     </a:p>
                   </a:txBody>
@@ -14016,7 +14016,7 @@
                         </a:defRPr>
                       </a:pPr>
                       <a:r>
-                        <a:t>6.5x</a:t>
+                        <a:t>4.9x</a:t>
                       </a:r>
                     </a:p>
                   </a:txBody>
@@ -14064,7 +14064,7 @@
                         </a:defRPr>
                       </a:pPr>
                       <a:r>
-                        <a:t>0.04</a:t>
+                        <a:t>0.05</a:t>
                       </a:r>
                     </a:p>
                   </a:txBody>
@@ -14133,7 +14133,7 @@
                         </a:defRPr>
                       </a:pPr>
                       <a:r>
-                        <a:t>5.4x</a:t>
+                        <a:t>4.9x</a:t>
                       </a:r>
                     </a:p>
                   </a:txBody>
@@ -14298,7 +14298,7 @@
                         </a:defRPr>
                       </a:pPr>
                       <a:r>
-                        <a:t>0.01</a:t>
+                        <a:t>0.02</a:t>
                       </a:r>
                     </a:p>
                   </a:txBody>
@@ -14321,7 +14321,7 @@
                         </a:defRPr>
                       </a:pPr>
                       <a:r>
-                        <a:t>0.07</a:t>
+                        <a:t>0.08</a:t>
                       </a:r>
                     </a:p>
                   </a:txBody>
@@ -14344,7 +14344,7 @@
                         </a:defRPr>
                       </a:pPr>
                       <a:r>
-                        <a:t>0.16</a:t>
+                        <a:t>0.17</a:t>
                       </a:r>
                     </a:p>
                   </a:txBody>
@@ -14367,7 +14367,7 @@
                         </a:defRPr>
                       </a:pPr>
                       <a:r>
-                        <a:t>15.6x</a:t>
+                        <a:t>11.1x</a:t>
                       </a:r>
                     </a:p>
                   </a:txBody>
@@ -14392,7 +14392,7 @@
                         </a:defRPr>
                       </a:pPr>
                       <a:r>
-                        <a:t>Alibaba</a:t>
+                        <a:t>OpenAI</a:t>
                       </a:r>
                     </a:p>
                   </a:txBody>
@@ -14438,6 +14438,29 @@
                         </a:defRPr>
                       </a:pPr>
                       <a:r>
+                        <a:t>0.03</a:t>
+                      </a:r>
+                    </a:p>
+                  </a:txBody>
+                  <a:tcPr marL="50292" marR="50292" marT="32004" marB="32004">
+                    <a:solidFill>
+                      <a:srgbClr val="FFFFFF"/>
+                    </a:solidFill>
+                  </a:tcPr>
+                </a:tc>
+                <a:tc>
+                  <a:txBody>
+                    <a:bodyPr/>
+                    <a:lstStyle/>
+                    <a:p>
+                      <a:pPr>
+                        <a:defRPr sz="650" b="0">
+                          <a:solidFill>
+                            <a:srgbClr val="3A4252"/>
+                          </a:solidFill>
+                        </a:defRPr>
+                      </a:pPr>
+                      <a:r>
                         <a:t>0.04</a:t>
                       </a:r>
                     </a:p>
@@ -14461,30 +14484,7 @@
                         </a:defRPr>
                       </a:pPr>
                       <a:r>
-                        <a:t>0.09</a:t>
-                      </a:r>
-                    </a:p>
-                  </a:txBody>
-                  <a:tcPr marL="50292" marR="50292" marT="32004" marB="32004">
-                    <a:solidFill>
-                      <a:srgbClr val="FFFFFF"/>
-                    </a:solidFill>
-                  </a:tcPr>
-                </a:tc>
-                <a:tc>
-                  <a:txBody>
-                    <a:bodyPr/>
-                    <a:lstStyle/>
-                    <a:p>
-                      <a:pPr>
-                        <a:defRPr sz="650" b="0">
-                          <a:solidFill>
-                            <a:srgbClr val="3A4252"/>
-                          </a:solidFill>
-                        </a:defRPr>
-                      </a:pPr>
-                      <a:r>
-                        <a:t>10.4x</a:t>
+                        <a:t>7.4x</a:t>
                       </a:r>
                     </a:p>
                   </a:txBody>
@@ -14509,7 +14509,7 @@
                         </a:defRPr>
                       </a:pPr>
                       <a:r>
-                        <a:t>OpenAI</a:t>
+                        <a:t>Google</a:t>
                       </a:r>
                     </a:p>
                   </a:txBody>
@@ -14532,6 +14532,29 @@
                         </a:defRPr>
                       </a:pPr>
                       <a:r>
+                        <a:t>0.01</a:t>
+                      </a:r>
+                    </a:p>
+                  </a:txBody>
+                  <a:tcPr marL="50292" marR="50292" marT="32004" marB="32004">
+                    <a:solidFill>
+                      <a:srgbClr val="F7F9FC"/>
+                    </a:solidFill>
+                  </a:tcPr>
+                </a:tc>
+                <a:tc>
+                  <a:txBody>
+                    <a:bodyPr/>
+                    <a:lstStyle/>
+                    <a:p>
+                      <a:pPr>
+                        <a:defRPr sz="650" b="0">
+                          <a:solidFill>
+                            <a:srgbClr val="3A4252"/>
+                          </a:solidFill>
+                        </a:defRPr>
+                      </a:pPr>
+                      <a:r>
                         <a:t>0.02</a:t>
                       </a:r>
                     </a:p>
@@ -14555,7 +14578,7 @@
                         </a:defRPr>
                       </a:pPr>
                       <a:r>
-                        <a:t>0.05</a:t>
+                        <a:t>0.03</a:t>
                       </a:r>
                     </a:p>
                   </a:txBody>
@@ -14578,30 +14601,7 @@
                         </a:defRPr>
                       </a:pPr>
                       <a:r>
-                        <a:t>0.05</a:t>
-                      </a:r>
-                    </a:p>
-                  </a:txBody>
-                  <a:tcPr marL="50292" marR="50292" marT="32004" marB="32004">
-                    <a:solidFill>
-                      <a:srgbClr val="F7F9FC"/>
-                    </a:solidFill>
-                  </a:tcPr>
-                </a:tc>
-                <a:tc>
-                  <a:txBody>
-                    <a:bodyPr/>
-                    <a:lstStyle/>
-                    <a:p>
-                      <a:pPr>
-                        <a:defRPr sz="650" b="0">
-                          <a:solidFill>
-                            <a:srgbClr val="3A4252"/>
-                          </a:solidFill>
-                        </a:defRPr>
-                      </a:pPr>
-                      <a:r>
-                        <a:t>3.1x</a:t>
+                        <a:t>4.1x</a:t>
                       </a:r>
                     </a:p>
                   </a:txBody>
@@ -14626,7 +14626,7 @@
                         </a:defRPr>
                       </a:pPr>
                       <a:r>
-                        <a:t>Google</a:t>
+                        <a:t>Anthropic</a:t>
                       </a:r>
                     </a:p>
                   </a:txBody>
@@ -14649,6 +14649,29 @@
                         </a:defRPr>
                       </a:pPr>
                       <a:r>
+                        <a:t>0.00</a:t>
+                      </a:r>
+                    </a:p>
+                  </a:txBody>
+                  <a:tcPr marL="50292" marR="50292" marT="32004" marB="32004">
+                    <a:solidFill>
+                      <a:srgbClr val="FFFFFF"/>
+                    </a:solidFill>
+                  </a:tcPr>
+                </a:tc>
+                <a:tc>
+                  <a:txBody>
+                    <a:bodyPr/>
+                    <a:lstStyle/>
+                    <a:p>
+                      <a:pPr>
+                        <a:defRPr sz="650" b="0">
+                          <a:solidFill>
+                            <a:srgbClr val="3A4252"/>
+                          </a:solidFill>
+                        </a:defRPr>
+                      </a:pPr>
+                      <a:r>
                         <a:t>0.01</a:t>
                       </a:r>
                     </a:p>
@@ -14695,30 +14718,7 @@
                         </a:defRPr>
                       </a:pPr>
                       <a:r>
-                        <a:t>0.03</a:t>
-                      </a:r>
-                    </a:p>
-                  </a:txBody>
-                  <a:tcPr marL="50292" marR="50292" marT="32004" marB="32004">
-                    <a:solidFill>
-                      <a:srgbClr val="FFFFFF"/>
-                    </a:solidFill>
-                  </a:tcPr>
-                </a:tc>
-                <a:tc>
-                  <a:txBody>
-                    <a:bodyPr/>
-                    <a:lstStyle/>
-                    <a:p>
-                      <a:pPr>
-                        <a:defRPr sz="650" b="0">
-                          <a:solidFill>
-                            <a:srgbClr val="3A4252"/>
-                          </a:solidFill>
-                        </a:defRPr>
-                      </a:pPr>
-                      <a:r>
-                        <a:t>2.6x</a:t>
+                        <a:t>6.0x</a:t>
                       </a:r>
                     </a:p>
                   </a:txBody>
@@ -14743,7 +14743,7 @@
                         </a:defRPr>
                       </a:pPr>
                       <a:r>
-                        <a:t>Anthropic</a:t>
+                        <a:t>Alibaba</a:t>
                       </a:r>
                     </a:p>
                   </a:txBody>
@@ -14835,7 +14835,7 @@
                         </a:defRPr>
                       </a:pPr>
                       <a:r>
-                        <a:t>4.0x</a:t>
+                        <a:t>6.6x</a:t>
                       </a:r>
                     </a:p>
                   </a:txBody>
@@ -15112,7 +15112,7 @@
               </a:defRPr>
             </a:pPr>
             <a:r>
-              <a:t>2026-07-23</a:t>
+              <a:t>2026-07-30</a:t>
             </a:r>
           </a:p>
         </p:txBody>
@@ -16015,7 +16015,7 @@
                         </a:defRPr>
                       </a:pPr>
                       <a:r>
-                        <a:t>Alibaba</a:t>
+                        <a:t>OpenAI</a:t>
                       </a:r>
                     </a:p>
                   </a:txBody>
@@ -16038,7 +16038,7 @@
                         </a:defRPr>
                       </a:pPr>
                       <a:r>
-                        <a:t>0.3</a:t>
+                        <a:t>0.6</a:t>
                       </a:r>
                     </a:p>
                   </a:txBody>
@@ -16061,7 +16061,7 @@
                         </a:defRPr>
                       </a:pPr>
                       <a:r>
-                        <a:t>0.9</a:t>
+                        <a:t>2.5</a:t>
                       </a:r>
                     </a:p>
                   </a:txBody>
@@ -16084,7 +16084,7 @@
                         </a:defRPr>
                       </a:pPr>
                       <a:r>
-                        <a:t>1.7</a:t>
+                        <a:t>4.9</a:t>
                       </a:r>
                     </a:p>
                   </a:txBody>
@@ -16107,7 +16107,7 @@
                         </a:defRPr>
                       </a:pPr>
                       <a:r>
-                        <a:t>80%</a:t>
+                        <a:t>78%</a:t>
                       </a:r>
                     </a:p>
                   </a:txBody>
@@ -16132,7 +16132,7 @@
                         </a:defRPr>
                       </a:pPr>
                       <a:r>
-                        <a:t>OpenAI</a:t>
+                        <a:t>Google</a:t>
                       </a:r>
                     </a:p>
                   </a:txBody>
@@ -16155,7 +16155,7 @@
                         </a:defRPr>
                       </a:pPr>
                       <a:r>
-                        <a:t>0.6</a:t>
+                        <a:t>0.9</a:t>
                       </a:r>
                     </a:p>
                   </a:txBody>
@@ -16178,7 +16178,7 @@
                         </a:defRPr>
                       </a:pPr>
                       <a:r>
-                        <a:t>2.5</a:t>
+                        <a:t>2.1</a:t>
                       </a:r>
                     </a:p>
                   </a:txBody>
@@ -16201,7 +16201,7 @@
                         </a:defRPr>
                       </a:pPr>
                       <a:r>
-                        <a:t>4.9</a:t>
+                        <a:t>3.7</a:t>
                       </a:r>
                     </a:p>
                   </a:txBody>
@@ -16224,7 +16224,7 @@
                         </a:defRPr>
                       </a:pPr>
                       <a:r>
-                        <a:t>78%</a:t>
+                        <a:t>72%</a:t>
                       </a:r>
                     </a:p>
                   </a:txBody>
@@ -16249,7 +16249,7 @@
                         </a:defRPr>
                       </a:pPr>
                       <a:r>
-                        <a:t>Google</a:t>
+                        <a:t>Anthropic</a:t>
                       </a:r>
                     </a:p>
                   </a:txBody>
@@ -16272,7 +16272,7 @@
                         </a:defRPr>
                       </a:pPr>
                       <a:r>
-                        <a:t>0.9</a:t>
+                        <a:t>0.4</a:t>
                       </a:r>
                     </a:p>
                   </a:txBody>
@@ -16295,7 +16295,7 @@
                         </a:defRPr>
                       </a:pPr>
                       <a:r>
-                        <a:t>2.1</a:t>
+                        <a:t>1.5</a:t>
                       </a:r>
                     </a:p>
                   </a:txBody>
@@ -16318,7 +16318,7 @@
                         </a:defRPr>
                       </a:pPr>
                       <a:r>
-                        <a:t>3.7</a:t>
+                        <a:t>3.0</a:t>
                       </a:r>
                     </a:p>
                   </a:txBody>
@@ -16341,7 +16341,7 @@
                         </a:defRPr>
                       </a:pPr>
                       <a:r>
-                        <a:t>72%</a:t>
+                        <a:t>74%</a:t>
                       </a:r>
                     </a:p>
                   </a:txBody>
@@ -16366,7 +16366,7 @@
                         </a:defRPr>
                       </a:pPr>
                       <a:r>
-                        <a:t>Anthropic</a:t>
+                        <a:t>Alibaba</a:t>
                       </a:r>
                     </a:p>
                   </a:txBody>
@@ -16389,7 +16389,7 @@
                         </a:defRPr>
                       </a:pPr>
                       <a:r>
-                        <a:t>0.4</a:t>
+                        <a:t>0.3</a:t>
                       </a:r>
                     </a:p>
                   </a:txBody>
@@ -16412,7 +16412,7 @@
                         </a:defRPr>
                       </a:pPr>
                       <a:r>
-                        <a:t>1.5</a:t>
+                        <a:t>0.9</a:t>
                       </a:r>
                     </a:p>
                   </a:txBody>
@@ -16435,7 +16435,7 @@
                         </a:defRPr>
                       </a:pPr>
                       <a:r>
-                        <a:t>3.0</a:t>
+                        <a:t>1.7</a:t>
                       </a:r>
                     </a:p>
                   </a:txBody>
@@ -16458,7 +16458,7 @@
                         </a:defRPr>
                       </a:pPr>
                       <a:r>
-                        <a:t>74%</a:t>
+                        <a:t>80%</a:t>
                       </a:r>
                     </a:p>
                   </a:txBody>
@@ -16735,7 +16735,7 @@
               </a:defRPr>
             </a:pPr>
             <a:r>
-              <a:t>2026-07-23</a:t>
+              <a:t>2026-07-30</a:t>
             </a:r>
           </a:p>
         </p:txBody>
@@ -17598,7 +17598,7 @@
               </a:defRPr>
             </a:pPr>
             <a:r>
-              <a:t>2026-07-23</a:t>
+              <a:t>2026-07-30</a:t>
             </a:r>
           </a:p>
         </p:txBody>
@@ -18385,7 +18385,7 @@
                         </a:defRPr>
                       </a:pPr>
                       <a:r>
-                        <a:t>Alibaba</a:t>
+                        <a:t>OpenAI</a:t>
                       </a:r>
                     </a:p>
                   </a:txBody>
@@ -18408,7 +18408,7 @@
                         </a:defRPr>
                       </a:pPr>
                       <a:r>
-                        <a:t>1.7</a:t>
+                        <a:t>4.9</a:t>
                       </a:r>
                     </a:p>
                   </a:txBody>
@@ -18431,7 +18431,7 @@
                         </a:defRPr>
                       </a:pPr>
                       <a:r>
-                        <a:t>0.4</a:t>
+                        <a:t>1.4</a:t>
                       </a:r>
                     </a:p>
                   </a:txBody>
@@ -18454,7 +18454,7 @@
                         </a:defRPr>
                       </a:pPr>
                       <a:r>
-                        <a:t>80%</a:t>
+                        <a:t>78%</a:t>
                       </a:r>
                     </a:p>
                   </a:txBody>
@@ -18649,7 +18649,7 @@
               </a:defRPr>
             </a:pPr>
             <a:r>
-              <a:t>2026-07-23</a:t>
+              <a:t>2026-07-30</a:t>
             </a:r>
           </a:p>
         </p:txBody>
@@ -19129,7 +19129,7 @@
                         </a:defRPr>
                       </a:pPr>
                       <a:r>
-                        <a:t>0.07</a:t>
+                        <a:t>0.09</a:t>
                       </a:r>
                     </a:p>
                   </a:txBody>
@@ -19154,7 +19154,7 @@
                         </a:defRPr>
                       </a:pPr>
                       <a:r>
-                        <a:t>Google</a:t>
+                        <a:t>OpenAI</a:t>
                       </a:r>
                     </a:p>
                   </a:txBody>
@@ -19177,7 +19177,7 @@
                         </a:defRPr>
                       </a:pPr>
                       <a:r>
-                        <a:t>40%/40%/20%</a:t>
+                        <a:t>45%/25%/30%</a:t>
                       </a:r>
                     </a:p>
                   </a:txBody>
@@ -19200,7 +19200,7 @@
                         </a:defRPr>
                       </a:pPr>
                       <a:r>
-                        <a:t>60%</a:t>
+                        <a:t>50%</a:t>
                       </a:r>
                     </a:p>
                   </a:txBody>
@@ -19223,7 +19223,7 @@
                         </a:defRPr>
                       </a:pPr>
                       <a:r>
-                        <a:t>0.11</a:t>
+                        <a:t>0.10</a:t>
                       </a:r>
                     </a:p>
                   </a:txBody>
@@ -19248,7 +19248,7 @@
                         </a:defRPr>
                       </a:pPr>
                       <a:r>
-                        <a:t>OpenAI</a:t>
+                        <a:t>Google</a:t>
                       </a:r>
                     </a:p>
                   </a:txBody>
@@ -19271,7 +19271,7 @@
                         </a:defRPr>
                       </a:pPr>
                       <a:r>
-                        <a:t>45%/25%/30%</a:t>
+                        <a:t>40%/40%/20%</a:t>
                       </a:r>
                     </a:p>
                   </a:txBody>
@@ -19294,7 +19294,7 @@
                         </a:defRPr>
                       </a:pPr>
                       <a:r>
-                        <a:t>50%</a:t>
+                        <a:t>60%</a:t>
                       </a:r>
                     </a:p>
                   </a:txBody>
@@ -19317,7 +19317,7 @@
                         </a:defRPr>
                       </a:pPr>
                       <a:r>
-                        <a:t>0.12</a:t>
+                        <a:t>0.10</a:t>
                       </a:r>
                     </a:p>
                   </a:txBody>
@@ -19342,7 +19342,7 @@
                         </a:defRPr>
                       </a:pPr>
                       <a:r>
-                        <a:t>DeepSeek</a:t>
+                        <a:t>Alibaba</a:t>
                       </a:r>
                     </a:p>
                   </a:txBody>
@@ -19365,7 +19365,7 @@
                         </a:defRPr>
                       </a:pPr>
                       <a:r>
-                        <a:t>35%/40%/25%</a:t>
+                        <a:t>45%/35%/20%</a:t>
                       </a:r>
                     </a:p>
                   </a:txBody>
@@ -19388,7 +19388,7 @@
                         </a:defRPr>
                       </a:pPr>
                       <a:r>
-                        <a:t>85%</a:t>
+                        <a:t>90%</a:t>
                       </a:r>
                     </a:p>
                   </a:txBody>
@@ -19411,7 +19411,7 @@
                         </a:defRPr>
                       </a:pPr>
                       <a:r>
-                        <a:t>0.16</a:t>
+                        <a:t>0.15</a:t>
                       </a:r>
                     </a:p>
                   </a:txBody>
@@ -19436,7 +19436,7 @@
                         </a:defRPr>
                       </a:pPr>
                       <a:r>
-                        <a:t>Alibaba</a:t>
+                        <a:t>DeepSeek</a:t>
                       </a:r>
                     </a:p>
                   </a:txBody>
@@ -19459,7 +19459,7 @@
                         </a:defRPr>
                       </a:pPr>
                       <a:r>
-                        <a:t>45%/35%/20%</a:t>
+                        <a:t>35%/40%/25%</a:t>
                       </a:r>
                     </a:p>
                   </a:txBody>
@@ -19482,7 +19482,7 @@
                         </a:defRPr>
                       </a:pPr>
                       <a:r>
-                        <a:t>90%</a:t>
+                        <a:t>85%</a:t>
                       </a:r>
                     </a:p>
                   </a:txBody>
@@ -19505,7 +19505,7 @@
                         </a:defRPr>
                       </a:pPr>
                       <a:r>
-                        <a:t>0.57</a:t>
+                        <a:t>0.16</a:t>
                       </a:r>
                     </a:p>
                   </a:txBody>
@@ -19700,7 +19700,7 @@
               </a:defRPr>
             </a:pPr>
             <a:r>
-              <a:t>2026-07-23</a:t>
+              <a:t>2026-07-30</a:t>
             </a:r>
           </a:p>
         </p:txBody>

</xml_diff>

<commit_message>
Refine CSP accelerator mix model
</commit_message>
<xml_diff>
--- a/llm_token_capacity_project/outputs/reports/llm_token_capacity_2026_2030.pptx
+++ b/llm_token_capacity_project/outputs/reports/llm_token_capacity_2026_2030.pptx
@@ -184,25 +184,25 @@
                 <c:formatCode>General</c:formatCode>
                 <c:ptCount val="9"/>
                 <c:pt idx="0">
-                  <c:v>0.4936059624672</c:v>
+                  <c:v>0.483970158144</c:v>
                 </c:pt>
                 <c:pt idx="1">
-                  <c:v>0.240019987968</c:v>
+                  <c:v>0.2359450944</c:v>
                 </c:pt>
                 <c:pt idx="2">
                   <c:v>0.2305701679392</c:v>
                 </c:pt>
                 <c:pt idx="3">
-                  <c:v>0.1743765496128</c:v>
+                  <c:v>0.1434707686656</c:v>
                 </c:pt>
                 <c:pt idx="4">
-                  <c:v>0.0414590596992</c:v>
+                  <c:v>0.0362307838464</c:v>
                 </c:pt>
                 <c:pt idx="5">
-                  <c:v>0.0323625925152</c:v>
+                  <c:v>0.0317531500704</c:v>
                 </c:pt>
                 <c:pt idx="6">
-                  <c:v>0.02410147872</c:v>
+                  <c:v>0.0251741931264</c:v>
                 </c:pt>
                 <c:pt idx="7">
                   <c:v>0.0226438101504</c:v>
@@ -373,19 +373,19 @@
                 <c:formatCode>General</c:formatCode>
                 <c:ptCount val="5"/>
                 <c:pt idx="0">
-                  <c:v>0.101332129248</c:v>
+                  <c:v>0.09524974896</c:v>
                 </c:pt>
                 <c:pt idx="1">
-                  <c:v>0.1832039646912</c:v>
+                  <c:v>0.1727906008896</c:v>
                 </c:pt>
                 <c:pt idx="2">
-                  <c:v>0.2759039628192</c:v>
+                  <c:v>0.270517973184</c:v>
                 </c:pt>
                 <c:pt idx="3">
-                  <c:v>0.3789791953056</c:v>
+                  <c:v>0.371581048512</c:v>
                 </c:pt>
                 <c:pt idx="4">
-                  <c:v>0.4936059624672</c:v>
+                  <c:v>0.483970158144</c:v>
                 </c:pt>
               </c:numCache>
             </c:numRef>
@@ -436,19 +436,19 @@
                 <c:formatCode>General</c:formatCode>
                 <c:ptCount val="5"/>
                 <c:pt idx="0">
-                  <c:v>0.0492480036288</c:v>
+                  <c:v>0.0481762925856</c:v>
                 </c:pt>
                 <c:pt idx="1">
-                  <c:v>0.088543958976</c:v>
+                  <c:v>0.086694784704</c:v>
                 </c:pt>
                 <c:pt idx="2">
-                  <c:v>0.1334745298944</c:v>
+                  <c:v>0.13120849152</c:v>
                 </c:pt>
                 <c:pt idx="3">
-                  <c:v>0.1839665395584</c:v>
+                  <c:v>0.18084328272</c:v>
                 </c:pt>
                 <c:pt idx="4">
-                  <c:v>0.240019987968</c:v>
+                  <c:v>0.2359450944</c:v>
                 </c:pt>
               </c:numCache>
             </c:numRef>
@@ -562,19 +562,19 @@
                 <c:formatCode>General</c:formatCode>
                 <c:ptCount val="5"/>
                 <c:pt idx="0">
-                  <c:v>0.015735373632</c:v>
+                  <c:v>0.012946500864</c:v>
                 </c:pt>
                 <c:pt idx="1">
-                  <c:v>0.0453464858304</c:v>
+                  <c:v>0.0373094615808</c:v>
                 </c:pt>
                 <c:pt idx="2">
-                  <c:v>0.0816808940352</c:v>
+                  <c:v>0.0672041090304</c:v>
                 </c:pt>
                 <c:pt idx="3">
-                  <c:v>0.1247385982464</c:v>
+                  <c:v>0.1026304432128</c:v>
                 </c:pt>
                 <c:pt idx="4">
-                  <c:v>0.1743765496128</c:v>
+                  <c:v>0.1434707686656</c:v>
                 </c:pt>
               </c:numCache>
             </c:numRef>
@@ -625,19 +625,19 @@
                 <c:formatCode>General</c:formatCode>
                 <c:ptCount val="5"/>
                 <c:pt idx="0">
-                  <c:v>0.0055662012</c:v>
+                  <c:v>0.00572530896</c:v>
                 </c:pt>
                 <c:pt idx="1">
-                  <c:v>0.0128343299904</c:v>
+                  <c:v>0.012802896288</c:v>
                 </c:pt>
                 <c:pt idx="2">
-                  <c:v>0.0301847219712</c:v>
+                  <c:v>0.0202142704896</c:v>
                 </c:pt>
                 <c:pt idx="3">
-                  <c:v>0.03697830144</c:v>
+                  <c:v>0.02807073792</c:v>
                 </c:pt>
                 <c:pt idx="4">
-                  <c:v>0.0414590596992</c:v>
+                  <c:v>0.0362307838464</c:v>
                 </c:pt>
               </c:numCache>
             </c:numRef>
@@ -1798,25 +1798,25 @@
                 <c:formatCode>General</c:formatCode>
                 <c:ptCount val="9"/>
                 <c:pt idx="0">
-                  <c:v>1.714081</c:v>
+                  <c:v>1.68062</c:v>
                 </c:pt>
                 <c:pt idx="1">
-                  <c:v>0.846954</c:v>
+                  <c:v>0.832575</c:v>
                 </c:pt>
                 <c:pt idx="2">
                   <c:v>2.035573</c:v>
                 </c:pt>
                 <c:pt idx="3">
-                  <c:v>1.655658</c:v>
+                  <c:v>1.362216</c:v>
                 </c:pt>
                 <c:pt idx="4">
-                  <c:v>0.098694</c:v>
+                  <c:v>0.086248</c:v>
                 </c:pt>
                 <c:pt idx="5">
-                  <c:v>0.102593</c:v>
+                  <c:v>0.100661</c:v>
                 </c:pt>
                 <c:pt idx="6">
-                  <c:v>0.09405</c:v>
+                  <c:v>0.098236</c:v>
                 </c:pt>
                 <c:pt idx="7">
                   <c:v>0.149932</c:v>
@@ -1988,19 +1988,19 @@
                 <c:formatCode>General</c:formatCode>
                 <c:ptCount val="5"/>
                 <c:pt idx="0">
-                  <c:v>0.114</c:v>
+                  <c:v>0.109</c:v>
                 </c:pt>
                 <c:pt idx="1">
-                  <c:v>0.221</c:v>
+                  <c:v>0.21</c:v>
                 </c:pt>
                 <c:pt idx="2">
-                  <c:v>0.346</c:v>
+                  <c:v>0.33</c:v>
                 </c:pt>
                 <c:pt idx="3">
-                  <c:v>0.479</c:v>
+                  <c:v>0.46</c:v>
                 </c:pt>
                 <c:pt idx="4">
-                  <c:v>0.626</c:v>
+                  <c:v>0.603</c:v>
                 </c:pt>
               </c:numCache>
             </c:numRef>
@@ -2051,19 +2051,19 @@
                 <c:formatCode>General</c:formatCode>
                 <c:ptCount val="5"/>
                 <c:pt idx="0">
-                  <c:v>0.21</c:v>
+                  <c:v>0.2</c:v>
                 </c:pt>
                 <c:pt idx="1">
-                  <c:v>0.418</c:v>
+                  <c:v>0.397</c:v>
                 </c:pt>
                 <c:pt idx="2">
-                  <c:v>0.671</c:v>
+                  <c:v>0.638</c:v>
                 </c:pt>
                 <c:pt idx="3">
-                  <c:v>0.951</c:v>
+                  <c:v>0.909</c:v>
                 </c:pt>
                 <c:pt idx="4">
-                  <c:v>1.268</c:v>
+                  <c:v>1.219</c:v>
                 </c:pt>
               </c:numCache>
             </c:numRef>
@@ -2114,19 +2114,19 @@
                 <c:formatCode>General</c:formatCode>
                 <c:ptCount val="5"/>
                 <c:pt idx="0">
-                  <c:v>0.309</c:v>
+                  <c:v>0.294</c:v>
                 </c:pt>
                 <c:pt idx="1">
-                  <c:v>0.639</c:v>
+                  <c:v>0.606</c:v>
                 </c:pt>
                 <c:pt idx="2">
-                  <c:v>1.062</c:v>
+                  <c:v>1.007</c:v>
                 </c:pt>
                 <c:pt idx="3">
-                  <c:v>1.555</c:v>
+                  <c:v>1.484</c:v>
                 </c:pt>
                 <c:pt idx="4">
-                  <c:v>2.14</c:v>
+                  <c:v>2.054</c:v>
                 </c:pt>
               </c:numCache>
             </c:numRef>
@@ -5606,7 +5606,7 @@
               </a:defRPr>
             </a:pPr>
             <a:r>
-              <a:t>1.27Q</a:t>
+              <a:t>1.22Q</a:t>
             </a:r>
           </a:p>
         </p:txBody>
@@ -5711,7 +5711,7 @@
               </a:defRPr>
             </a:pPr>
             <a:r>
-              <a:t>2026-07-30</a:t>
+              <a:t>2026-07-31</a:t>
             </a:r>
           </a:p>
         </p:txBody>
@@ -6280,7 +6280,7 @@
                         </a:defRPr>
                       </a:pPr>
                       <a:r>
-                        <a:t>0.02</a:t>
+                        <a:t>0.03</a:t>
                       </a:r>
                     </a:p>
                   </a:txBody>
@@ -6560,7 +6560,7 @@
                         </a:defRPr>
                       </a:pPr>
                       <a:r>
-                        <a:t>0.49</a:t>
+                        <a:t>0.48</a:t>
                       </a:r>
                     </a:p>
                   </a:txBody>
@@ -6980,7 +6980,7 @@
                         </a:defRPr>
                       </a:pPr>
                       <a:r>
-                        <a:t>0.17</a:t>
+                        <a:t>0.14</a:t>
                       </a:r>
                     </a:p>
                   </a:txBody>
@@ -7512,7 +7512,7 @@
               </a:defRPr>
             </a:pPr>
             <a:r>
-              <a:t>2026-07-30</a:t>
+              <a:t>2026-07-31</a:t>
             </a:r>
           </a:p>
         </p:txBody>
@@ -7946,7 +7946,7 @@
                         </a:defRPr>
                       </a:pPr>
                       <a:r>
-                        <a:t>0.63</a:t>
+                        <a:t>0.60</a:t>
                       </a:r>
                     </a:p>
                   </a:txBody>
@@ -8040,7 +8040,7 @@
                         </a:defRPr>
                       </a:pPr>
                       <a:r>
-                        <a:t>1.27</a:t>
+                        <a:t>1.22</a:t>
                       </a:r>
                     </a:p>
                   </a:txBody>
@@ -8134,7 +8134,7 @@
                         </a:defRPr>
                       </a:pPr>
                       <a:r>
-                        <a:t>2.14</a:t>
+                        <a:t>2.05</a:t>
                       </a:r>
                     </a:p>
                   </a:txBody>
@@ -8328,7 +8328,7 @@
               </a:defRPr>
             </a:pPr>
             <a:r>
-              <a:t>Base growth: 6.0x, 2026-2030</a:t>
+              <a:t>Base growth: 6.1x, 2026-2030</a:t>
             </a:r>
           </a:p>
         </p:txBody>
@@ -8478,7 +8478,7 @@
               </a:defRPr>
             </a:pPr>
             <a:r>
-              <a:t>2026-07-30</a:t>
+              <a:t>2026-07-31</a:t>
             </a:r>
           </a:p>
         </p:txBody>
@@ -9337,7 +9337,7 @@
               </a:defRPr>
             </a:pPr>
             <a:r>
-              <a:t>2026-07-30</a:t>
+              <a:t>2026-07-31</a:t>
             </a:r>
           </a:p>
         </p:txBody>
@@ -10318,7 +10318,7 @@
               </a:defRPr>
             </a:pPr>
             <a:r>
-              <a:t>2026-07-30</a:t>
+              <a:t>2026-07-31</a:t>
             </a:r>
           </a:p>
         </p:txBody>
@@ -10989,7 +10989,7 @@
               </a:defRPr>
             </a:pPr>
             <a:r>
-              <a:t>Top 3 providers account for 76% of modeled 2030 generated-token supply.</a:t>
+              <a:t>Top 3 providers account for 78% of modeled 2030 generated-token supply.</a:t>
             </a:r>
           </a:p>
         </p:txBody>
@@ -11174,7 +11174,7 @@
               </a:defRPr>
             </a:pPr>
             <a:r>
-              <a:t>2026-07-30</a:t>
+              <a:t>2026-07-31</a:t>
             </a:r>
           </a:p>
         </p:txBody>
@@ -12368,7 +12368,7 @@
               </a:defRPr>
             </a:pPr>
             <a:r>
-              <a:t>2026-07-30</a:t>
+              <a:t>2026-07-31</a:t>
             </a:r>
           </a:p>
         </p:txBody>
@@ -12802,7 +12802,7 @@
                         </a:defRPr>
                       </a:pPr>
                       <a:r>
-                        <a:t>0.49</a:t>
+                        <a:t>0.48</a:t>
                       </a:r>
                     </a:p>
                   </a:txBody>
@@ -13084,7 +13084,7 @@
                         </a:defRPr>
                       </a:pPr>
                       <a:r>
-                        <a:t>0.17</a:t>
+                        <a:t>0.14</a:t>
                       </a:r>
                     </a:p>
                   </a:txBody>
@@ -13304,7 +13304,7 @@
               </a:defRPr>
             </a:pPr>
             <a:r>
-              <a:t>76%</a:t>
+              <a:t>78%</a:t>
             </a:r>
           </a:p>
         </p:txBody>
@@ -13489,7 +13489,7 @@
               </a:defRPr>
             </a:pPr>
             <a:r>
-              <a:t>2026-07-30</a:t>
+              <a:t>2026-07-31</a:t>
             </a:r>
           </a:p>
         </p:txBody>
@@ -13970,7 +13970,7 @@
                         </a:defRPr>
                       </a:pPr>
                       <a:r>
-                        <a:t>0.28</a:t>
+                        <a:t>0.27</a:t>
                       </a:r>
                     </a:p>
                   </a:txBody>
@@ -13993,7 +13993,7 @@
                         </a:defRPr>
                       </a:pPr>
                       <a:r>
-                        <a:t>0.49</a:t>
+                        <a:t>0.48</a:t>
                       </a:r>
                     </a:p>
                   </a:txBody>
@@ -14016,7 +14016,7 @@
                         </a:defRPr>
                       </a:pPr>
                       <a:r>
-                        <a:t>4.9x</a:t>
+                        <a:t>5.1x</a:t>
                       </a:r>
                     </a:p>
                   </a:txBody>
@@ -14298,7 +14298,7 @@
                         </a:defRPr>
                       </a:pPr>
                       <a:r>
-                        <a:t>0.02</a:t>
+                        <a:t>0.01</a:t>
                       </a:r>
                     </a:p>
                   </a:txBody>
@@ -14321,7 +14321,7 @@
                         </a:defRPr>
                       </a:pPr>
                       <a:r>
-                        <a:t>0.08</a:t>
+                        <a:t>0.07</a:t>
                       </a:r>
                     </a:p>
                   </a:txBody>
@@ -14344,7 +14344,7 @@
                         </a:defRPr>
                       </a:pPr>
                       <a:r>
-                        <a:t>0.17</a:t>
+                        <a:t>0.14</a:t>
                       </a:r>
                     </a:p>
                   </a:txBody>
@@ -14438,7 +14438,7 @@
                         </a:defRPr>
                       </a:pPr>
                       <a:r>
-                        <a:t>0.03</a:t>
+                        <a:t>0.02</a:t>
                       </a:r>
                     </a:p>
                   </a:txBody>
@@ -14484,7 +14484,7 @@
                         </a:defRPr>
                       </a:pPr>
                       <a:r>
-                        <a:t>7.4x</a:t>
+                        <a:t>6.3x</a:t>
                       </a:r>
                     </a:p>
                   </a:txBody>
@@ -14601,7 +14601,7 @@
                         </a:defRPr>
                       </a:pPr>
                       <a:r>
-                        <a:t>4.1x</a:t>
+                        <a:t>4.0x</a:t>
                       </a:r>
                     </a:p>
                   </a:txBody>
@@ -14695,7 +14695,7 @@
                         </a:defRPr>
                       </a:pPr>
                       <a:r>
-                        <a:t>0.02</a:t>
+                        <a:t>0.03</a:t>
                       </a:r>
                     </a:p>
                   </a:txBody>
@@ -14718,7 +14718,7 @@
                         </a:defRPr>
                       </a:pPr>
                       <a:r>
-                        <a:t>6.0x</a:t>
+                        <a:t>6.8x</a:t>
                       </a:r>
                     </a:p>
                   </a:txBody>
@@ -15112,7 +15112,7 @@
               </a:defRPr>
             </a:pPr>
             <a:r>
-              <a:t>2026-07-30</a:t>
+              <a:t>2026-07-31</a:t>
             </a:r>
           </a:p>
         </p:txBody>
@@ -16735,7 +16735,7 @@
               </a:defRPr>
             </a:pPr>
             <a:r>
-              <a:t>2026-07-30</a:t>
+              <a:t>2026-07-31</a:t>
             </a:r>
           </a:p>
         </p:txBody>
@@ -17598,7 +17598,7 @@
               </a:defRPr>
             </a:pPr>
             <a:r>
-              <a:t>2026-07-30</a:t>
+              <a:t>2026-07-31</a:t>
             </a:r>
           </a:p>
         </p:txBody>
@@ -18649,7 +18649,7 @@
               </a:defRPr>
             </a:pPr>
             <a:r>
-              <a:t>2026-07-30</a:t>
+              <a:t>2026-07-31</a:t>
             </a:r>
           </a:p>
         </p:txBody>
@@ -19060,7 +19060,7 @@
                         </a:defRPr>
                       </a:pPr>
                       <a:r>
-                        <a:t>Anthropic</a:t>
+                        <a:t>OpenAI</a:t>
                       </a:r>
                     </a:p>
                   </a:txBody>
@@ -19083,7 +19083,7 @@
                         </a:defRPr>
                       </a:pPr>
                       <a:r>
-                        <a:t>30%/30%/40%</a:t>
+                        <a:t>45%/25%/30%</a:t>
                       </a:r>
                     </a:p>
                   </a:txBody>
@@ -19154,7 +19154,7 @@
                         </a:defRPr>
                       </a:pPr>
                       <a:r>
-                        <a:t>OpenAI</a:t>
+                        <a:t>Anthropic</a:t>
                       </a:r>
                     </a:p>
                   </a:txBody>
@@ -19177,7 +19177,7 @@
                         </a:defRPr>
                       </a:pPr>
                       <a:r>
-                        <a:t>45%/25%/30%</a:t>
+                        <a:t>30%/30%/40%</a:t>
                       </a:r>
                     </a:p>
                   </a:txBody>
@@ -19700,7 +19700,7 @@
               </a:defRPr>
             </a:pPr>
             <a:r>
-              <a:t>2026-07-30</a:t>
+              <a:t>2026-07-31</a:t>
             </a:r>
           </a:p>
         </p:txBody>

</xml_diff>